<commit_message>
docs: put the actual spoken script in every slide's notes
The notes were being written but silently lost: pptxgenjs drops a note
whose text contains a newline, so only the one single-line note out of
twenty-one survived. Line breaks now go in as vertical tabs, which is
how PowerPoint represents a soft break inside a paragraph.

The script itself is now word-for-word rather than a summary — timings
per slide adding to five minutes, stage directions in brackets, and for
the Q&A pages a note on how to answer and which trap to avoid. It also
ships as docs/路演讲稿.md for whoever would rather hold paper.
</commit_message>
<xml_diff>
--- a/docs/第二单_SecondOrder_路演.pptx
+++ b/docs/第二单_SecondOrder_路演.pptx
@@ -476,362 +476,40 @@
 </p:notesMaster>
 </file>
 
-<file path=ppt/notesSlides/notesSlide1.xml><?xml version="1.0" encoding="utf-8"?>
-<p:notes xmlns:a="http://schemas.openxmlformats.org/drawingml/2006/main" xmlns:r="http://schemas.openxmlformats.org/officeDocument/2006/relationships" xmlns:p="http://schemas.openxmlformats.org/presentationml/2006/main">
-  <p:cSld>
-    <p:spTree>
-      <p:nvGrpSpPr>
-        <p:cNvPr id="1" name=""/>
-        <p:cNvGrpSpPr/>
-        <p:nvPr/>
-      </p:nvGrpSpPr>
-      <p:grpSpPr>
-        <a:xfrm>
-          <a:off x="0" y="0"/>
-          <a:ext cx="0" cy="0"/>
-          <a:chOff x="0" y="0"/>
-          <a:chExt cx="0" cy="0"/>
-        </a:xfrm>
-      </p:grpSpPr>
-      <p:sp>
-        <p:nvSpPr>
-          <p:cNvPr id="2" name="Slide Image Placeholder 1"/>
-          <p:cNvSpPr>
-            <a:spLocks noGrp="1" noRot="1" noChangeAspect="1"/>
-          </p:cNvSpPr>
-          <p:nvPr>
-            <p:ph type="sldImg"/>
-          </p:nvPr>
-        </p:nvSpPr>
-        <p:spPr/>
-      </p:sp>
-      <p:sp>
-        <p:nvSpPr>
-          <p:cNvPr id="3" name="Notes Placeholder 2"/>
-          <p:cNvSpPr>
-            <a:spLocks noGrp="1"/>
-          </p:cNvSpPr>
-          <p:nvPr>
-            <p:ph type="body" idx="1"/>
-          </p:nvPr>
-        </p:nvSpPr>
-        <p:spPr/>
-        <p:txBody>
-          <a:bodyPr/>
-          <a:lstStyle/>
-          <a:p>
-            <a:r>
-              <a:rPr lang="en-US" dirty="0"/>
-              <a:t>（0:00–0:20）开场，指着大标题。
-「扫码验茅台真假，大家都会。这次扫的不是酒，是买家。」停一拍。
-我们做的是贵州白酒出海的首单决策副驾。</a:t>
-            </a:r>
-            <a:endParaRPr lang="en-US" dirty="0"/>
-          </a:p>
-        </p:txBody>
-      </p:sp>
-      <p:sp>
-        <p:nvSpPr>
-          <p:cNvPr id="4" name="Slide Number Placeholder 3"/>
-          <p:cNvSpPr>
-            <a:spLocks noGrp="1"/>
-          </p:cNvSpPr>
-          <p:nvPr>
-            <p:ph type="sldNum" sz="quarter" idx="10"/>
-          </p:nvPr>
-        </p:nvSpPr>
-        <p:spPr/>
-        <p:txBody>
-          <a:bodyPr/>
-          <a:lstStyle/>
-          <a:p>
-            <a:fld id="{F7021451-1387-4CA6-816F-3879F97B5CBC}" type="slidenum">
-              <a:rPr lang="en-US"/>
-              <a:t>1</a:t>
-            </a:fld>
-            <a:endParaRPr lang="en-US"/>
-          </a:p>
-        </p:txBody>
-      </p:sp>
-    </p:spTree>
-    <p:extLst>
-      <p:ext uri="{BB962C8B-B14F-4D97-AF65-F5344CB8AC3E}">
-        <p14:creationId xmlns:p14="http://schemas.microsoft.com/office/powerpoint/2010/main" val="1024086991"/>
-      </p:ext>
-    </p:extLst>
-  </p:cSld>
-  <p:clrMapOvr>
-    <a:masterClrMapping/>
-  </p:clrMapOvr>
-</p:notes>
+<file path=ppt/notesSlides/notesSlide1.xml><?xml version="1.0" encoding="UTF-8" standalone="yes"?>
+<p:notes xmlns:a="http://schemas.openxmlformats.org/drawingml/2006/main" xmlns:r="http://schemas.openxmlformats.org/officeDocument/2006/relationships" xmlns:p="http://schemas.openxmlformats.org/presentationml/2006/main"><p:cSld><p:spTree><p:nvGrpSpPr><p:cNvPr id="1" name=""/><p:cNvGrpSpPr/><p:nvPr/></p:nvGrpSpPr><p:grpSpPr><a:xfrm><a:off x="0" y="0"/><a:ext cx="0" cy="0"/><a:chOff x="0" y="0"/><a:chExt cx="0" cy="0"/></a:xfrm></p:grpSpPr><p:sp><p:nvSpPr><p:cNvPr id="2" name="Slide Image Placeholder 1"/><p:cNvSpPr><a:spLocks noGrp="1" noRot="1" noChangeAspect="1"/></p:cNvSpPr><p:nvPr><p:ph type="sldImg"/></p:nvPr></p:nvSpPr><p:spPr/></p:sp><p:sp><p:nvSpPr><p:cNvPr id="3" name="Notes Placeholder 2"/><p:cNvSpPr><a:spLocks noGrp="1"/></p:cNvSpPr><p:nvPr><p:ph type="body" idx="1"/></p:nvPr></p:nvSpPr><p:spPr/><p:txBody><a:bodyPr/><a:lstStyle/><a:p><a:r><a:rPr lang="en-US" dirty="0"/><a:t>（0:00–0:20）+[停两秒，让大家先看到标题]+各位评委好。+扫码验茅台真假，大家都会。+[停一拍]+我们做的这个东西，扫的不是酒，是买家。+它叫「第二单」，是给贵州中小酒企外贸专员用的首单决策副驾。</a:t></a:r><a:endParaRPr lang="en-US" dirty="0"/></a:p></p:txBody></p:sp><p:sp><p:nvSpPr><p:cNvPr id="4" name="Slide Number Placeholder 3"/><p:cNvSpPr><a:spLocks noGrp="1"/></p:cNvSpPr><p:nvPr><p:ph type="sldNum" sz="quarter" idx="10"/></p:nvPr></p:nvSpPr><p:spPr/><p:txBody><a:bodyPr/><a:lstStyle/><a:p><a:fld id="{F7021451-1387-4CA6-816F-3879F97B5CBC}" type="slidenum"><a:rPr lang="en-US"/><a:t>1</a:t></a:fld><a:endParaRPr lang="en-US"/></a:p></p:txBody></p:sp></p:spTree><p:extLst><p:ext uri="{BB962C8B-B14F-4D97-AF65-F5344CB8AC3E}"><p14:creationId xmlns:p14="http://schemas.microsoft.com/office/powerpoint/2010/main" val="1024086991"/></p:ext></p:extLst></p:cSld><p:clrMapOvr><a:masterClrMapping/></p:clrMapOvr></p:notes>
 </file>
 
-<file path=ppt/notesSlides/notesSlide10.xml><?xml version="1.0" encoding="utf-8"?>
-<p:notes xmlns:a="http://schemas.openxmlformats.org/drawingml/2006/main" xmlns:r="http://schemas.openxmlformats.org/officeDocument/2006/relationships" xmlns:p="http://schemas.openxmlformats.org/presentationml/2006/main">
-  <p:cSld>
-    <p:spTree>
-      <p:nvGrpSpPr>
-        <p:cNvPr id="1" name=""/>
-        <p:cNvGrpSpPr/>
-        <p:nvPr/>
-      </p:nvGrpSpPr>
-      <p:grpSpPr>
-        <a:xfrm>
-          <a:off x="0" y="0"/>
-          <a:ext cx="0" cy="0"/>
-          <a:chOff x="0" y="0"/>
-          <a:chExt cx="0" cy="0"/>
-        </a:xfrm>
-      </p:grpSpPr>
-      <p:sp>
-        <p:nvSpPr>
-          <p:cNvPr id="2" name="Slide Image Placeholder 1"/>
-          <p:cNvSpPr>
-            <a:spLocks noGrp="1" noRot="1" noChangeAspect="1"/>
-          </p:cNvSpPr>
-          <p:nvPr>
-            <p:ph type="sldImg"/>
-          </p:nvPr>
-        </p:nvSpPr>
-        <p:spPr/>
-      </p:sp>
-      <p:sp>
-        <p:nvSpPr>
-          <p:cNvPr id="3" name="Notes Placeholder 2"/>
-          <p:cNvSpPr>
-            <a:spLocks noGrp="1"/>
-          </p:cNvSpPr>
-          <p:nvPr>
-            <p:ph type="body" idx="1"/>
-          </p:nvPr>
-        </p:nvSpPr>
-        <p:spPr/>
-        <p:txBody>
-          <a:bodyPr/>
-          <a:lstStyle/>
-          <a:p>
-            <a:r>
-              <a:rPr lang="en-US" dirty="0"/>
-              <a:t>（4:00–4:25）技术主张：规则算账，模型说人话。
-税则、牌照、条款、去留判定全是可审计的纯函数，每条带来源与生效日期。模型只负责读懂对话和写成人话。
-模型挂了主链路照样跑完——现场断网也能演示。</a:t>
-            </a:r>
-            <a:endParaRPr lang="en-US" dirty="0"/>
-          </a:p>
-        </p:txBody>
-      </p:sp>
-      <p:sp>
-        <p:nvSpPr>
-          <p:cNvPr id="4" name="Slide Number Placeholder 3"/>
-          <p:cNvSpPr>
-            <a:spLocks noGrp="1"/>
-          </p:cNvSpPr>
-          <p:nvPr>
-            <p:ph type="sldNum" sz="quarter" idx="10"/>
-          </p:nvPr>
-        </p:nvSpPr>
-        <p:spPr/>
-        <p:txBody>
-          <a:bodyPr/>
-          <a:lstStyle/>
-          <a:p>
-            <a:fld id="{F7021451-1387-4CA6-816F-3879F97B5CBC}" type="slidenum">
-              <a:rPr lang="en-US"/>
-              <a:t>10</a:t>
-            </a:fld>
-            <a:endParaRPr lang="en-US"/>
-          </a:p>
-        </p:txBody>
-      </p:sp>
-    </p:spTree>
-    <p:extLst>
-      <p:ext uri="{BB962C8B-B14F-4D97-AF65-F5344CB8AC3E}">
-        <p14:creationId xmlns:p14="http://schemas.microsoft.com/office/powerpoint/2010/main" val="1024086991"/>
-      </p:ext>
-    </p:extLst>
-  </p:cSld>
-  <p:clrMapOvr>
-    <a:masterClrMapping/>
-  </p:clrMapOvr>
-</p:notes>
+<file path=ppt/notesSlides/notesSlide10.xml><?xml version="1.0" encoding="UTF-8" standalone="yes"?>
+<p:notes xmlns:a="http://schemas.openxmlformats.org/drawingml/2006/main" xmlns:r="http://schemas.openxmlformats.org/officeDocument/2006/relationships" xmlns:p="http://schemas.openxmlformats.org/presentationml/2006/main"><p:cSld><p:spTree><p:nvGrpSpPr><p:cNvPr id="1" name=""/><p:cNvGrpSpPr/><p:nvPr/></p:nvGrpSpPr><p:grpSpPr><a:xfrm><a:off x="0" y="0"/><a:ext cx="0" cy="0"/><a:chOff x="0" y="0"/><a:chExt cx="0" cy="0"/></a:xfrm></p:grpSpPr><p:sp><p:nvSpPr><p:cNvPr id="2" name="Slide Image Placeholder 1"/><p:cNvSpPr><a:spLocks noGrp="1" noRot="1" noChangeAspect="1"/></p:cNvSpPr><p:nvPr><p:ph type="sldImg"/></p:nvPr></p:nvSpPr><p:spPr/></p:sp><p:sp><p:nvSpPr><p:cNvPr id="3" name="Notes Placeholder 2"/><p:cNvSpPr><a:spLocks noGrp="1"/></p:cNvSpPr><p:nvPr><p:ph type="body" idx="1"/></p:nvPr></p:nvSpPr><p:spPr/><p:txBody><a:bodyPr/><a:lstStyle/><a:p><a:r><a:rPr lang="en-US" dirty="0"/><a:t>（4:05–4:30）+技术上我们只坚持一件事：规则算账，模型说人话。+税则、牌照、风险评分、合同条款，全部是可审计的纯函数，+同样输入永远同样输出，每一条都带来源和生效日期。+模型只负责它真正擅长的两件事——读懂对话，和写成人话。+所以模型挂了，主链路照样跑完。现场断网也能演示。</a:t></a:r><a:endParaRPr lang="en-US" dirty="0"/></a:p></p:txBody></p:sp><p:sp><p:nvSpPr><p:cNvPr id="4" name="Slide Number Placeholder 3"/><p:cNvSpPr><a:spLocks noGrp="1"/></p:cNvSpPr><p:nvPr><p:ph type="sldNum" sz="quarter" idx="10"/></p:nvPr></p:nvSpPr><p:spPr/><p:txBody><a:bodyPr/><a:lstStyle/><a:p><a:fld id="{F7021451-1387-4CA6-816F-3879F97B5CBC}" type="slidenum"><a:rPr lang="en-US"/><a:t>10</a:t></a:fld><a:endParaRPr lang="en-US"/></a:p></p:txBody></p:sp></p:spTree><p:extLst><p:ext uri="{BB962C8B-B14F-4D97-AF65-F5344CB8AC3E}"><p14:creationId xmlns:p14="http://schemas.microsoft.com/office/powerpoint/2010/main" val="1024086991"/></p:ext></p:extLst></p:cSld><p:clrMapOvr><a:masterClrMapping/></p:clrMapOvr></p:notes>
 </file>
 
-<file path=ppt/notesSlides/notesSlide11.xml><?xml version="1.0" encoding="utf-8"?>
-<p:notes xmlns:a="http://schemas.openxmlformats.org/drawingml/2006/main" xmlns:r="http://schemas.openxmlformats.org/officeDocument/2006/relationships" xmlns:p="http://schemas.openxmlformats.org/presentationml/2006/main">
-  <p:cSld>
-    <p:spTree>
-      <p:nvGrpSpPr>
-        <p:cNvPr id="1" name=""/>
-        <p:cNvGrpSpPr/>
-        <p:nvPr/>
-      </p:nvGrpSpPr>
-      <p:grpSpPr>
-        <a:xfrm>
-          <a:off x="0" y="0"/>
-          <a:ext cx="0" cy="0"/>
-          <a:chOff x="0" y="0"/>
-          <a:chExt cx="0" cy="0"/>
-        </a:xfrm>
-      </p:grpSpPr>
-      <p:sp>
-        <p:nvSpPr>
-          <p:cNvPr id="2" name="Slide Image Placeholder 1"/>
-          <p:cNvSpPr>
-            <a:spLocks noGrp="1" noRot="1" noChangeAspect="1"/>
-          </p:cNvSpPr>
-          <p:nvPr>
-            <p:ph type="sldImg"/>
-          </p:nvPr>
-        </p:nvSpPr>
-        <p:spPr/>
-      </p:sp>
-      <p:sp>
-        <p:nvSpPr>
-          <p:cNvPr id="3" name="Notes Placeholder 2"/>
-          <p:cNvSpPr>
-            <a:spLocks noGrp="1"/>
-          </p:cNvSpPr>
-          <p:nvPr>
-            <p:ph type="body" idx="1"/>
-          </p:nvPr>
-        </p:nvSpPr>
-        <p:spPr/>
-        <p:txBody>
-          <a:bodyPr/>
-          <a:lstStyle/>
-          <a:p>
-            <a:r>
-              <a:rPr lang="en-US" dirty="0"/>
-              <a:t>（4:25–4:45）一百天怎么落地。第三步是设计来证伪自己的：拿报关单回来验落地价，误差超过 20% 就得重做税则模型。</a:t>
-            </a:r>
-            <a:endParaRPr lang="en-US" dirty="0"/>
-          </a:p>
-        </p:txBody>
-      </p:sp>
-      <p:sp>
-        <p:nvSpPr>
-          <p:cNvPr id="4" name="Slide Number Placeholder 3"/>
-          <p:cNvSpPr>
-            <a:spLocks noGrp="1"/>
-          </p:cNvSpPr>
-          <p:nvPr>
-            <p:ph type="sldNum" sz="quarter" idx="10"/>
-          </p:nvPr>
-        </p:nvSpPr>
-        <p:spPr/>
-        <p:txBody>
-          <a:bodyPr/>
-          <a:lstStyle/>
-          <a:p>
-            <a:fld id="{F7021451-1387-4CA6-816F-3879F97B5CBC}" type="slidenum">
-              <a:rPr lang="en-US"/>
-              <a:t>11</a:t>
-            </a:fld>
-            <a:endParaRPr lang="en-US"/>
-          </a:p>
-        </p:txBody>
-      </p:sp>
-    </p:spTree>
-    <p:extLst>
-      <p:ext uri="{BB962C8B-B14F-4D97-AF65-F5344CB8AC3E}">
-        <p14:creationId xmlns:p14="http://schemas.microsoft.com/office/powerpoint/2010/main" val="1024086991"/>
-      </p:ext>
-    </p:extLst>
-  </p:cSld>
-  <p:clrMapOvr>
-    <a:masterClrMapping/>
-  </p:clrMapOvr>
-</p:notes>
+<file path=ppt/notesSlides/notesSlide11.xml><?xml version="1.0" encoding="UTF-8" standalone="yes"?>
+<p:notes xmlns:a="http://schemas.openxmlformats.org/drawingml/2006/main" xmlns:r="http://schemas.openxmlformats.org/officeDocument/2006/relationships" xmlns:p="http://schemas.openxmlformats.org/presentationml/2006/main"><p:cSld><p:spTree><p:nvGrpSpPr><p:cNvPr id="1" name=""/><p:cNvGrpSpPr/><p:nvPr/></p:nvGrpSpPr><p:grpSpPr><a:xfrm><a:off x="0" y="0"/><a:ext cx="0" cy="0"/><a:chOff x="0" y="0"/><a:chExt cx="0" cy="0"/></a:xfrm></p:grpSpPr><p:sp><p:nvSpPr><p:cNvPr id="2" name="Slide Image Placeholder 1"/><p:cNvSpPr><a:spLocks noGrp="1" noRot="1" noChangeAspect="1"/></p:cNvSpPr><p:nvPr><p:ph type="sldImg"/></p:nvPr></p:nvSpPr><p:spPr/></p:sp><p:sp><p:nvSpPr><p:cNvPr id="3" name="Notes Placeholder 2"/><p:cNvSpPr><a:spLocks noGrp="1"/></p:cNvSpPr><p:nvPr><p:ph type="body" idx="1"/></p:nvPr></p:nvSpPr><p:spPr/><p:txBody><a:bodyPr/><a:lstStyle/><a:p><a:r><a:rPr lang="en-US" dirty="0"/><a:t>（4:30–4:48）+接下来一百天，第三步是设计来证伪我们自己的：+跟三家走完一次首单，拿报关单回来验落地价。+误差百分之五以内这工具就能用，+差到百分之二十，税则模型就得重做。</a:t></a:r><a:endParaRPr lang="en-US" dirty="0"/></a:p></p:txBody></p:sp><p:sp><p:nvSpPr><p:cNvPr id="4" name="Slide Number Placeholder 3"/><p:cNvSpPr><a:spLocks noGrp="1"/></p:cNvSpPr><p:nvPr><p:ph type="sldNum" sz="quarter" idx="10"/></p:nvPr></p:nvSpPr><p:spPr/><p:txBody><a:bodyPr/><a:lstStyle/><a:p><a:fld id="{F7021451-1387-4CA6-816F-3879F97B5CBC}" type="slidenum"><a:rPr lang="en-US"/><a:t>11</a:t></a:fld><a:endParaRPr lang="en-US"/></a:p></p:txBody></p:sp></p:spTree><p:extLst><p:ext uri="{BB962C8B-B14F-4D97-AF65-F5344CB8AC3E}"><p14:creationId xmlns:p14="http://schemas.microsoft.com/office/powerpoint/2010/main" val="1024086991"/></p:ext></p:extLst></p:cSld><p:clrMapOvr><a:masterClrMapping/></p:clrMapOvr></p:notes>
 </file>
 
-<file path=ppt/notesSlides/notesSlide12.xml><?xml version="1.0" encoding="utf-8"?>
-<p:notes xmlns:a="http://schemas.openxmlformats.org/drawingml/2006/main" xmlns:r="http://schemas.openxmlformats.org/officeDocument/2006/relationships" xmlns:p="http://schemas.openxmlformats.org/presentationml/2006/main">
-  <p:cSld>
-    <p:spTree>
-      <p:nvGrpSpPr>
-        <p:cNvPr id="1" name=""/>
-        <p:cNvGrpSpPr/>
-        <p:nvPr/>
-      </p:nvGrpSpPr>
-      <p:grpSpPr>
-        <a:xfrm>
-          <a:off x="0" y="0"/>
-          <a:ext cx="0" cy="0"/>
-          <a:chOff x="0" y="0"/>
-          <a:chExt cx="0" cy="0"/>
-        </a:xfrm>
-      </p:grpSpPr>
-      <p:sp>
-        <p:nvSpPr>
-          <p:cNvPr id="2" name="Slide Image Placeholder 1"/>
-          <p:cNvSpPr>
-            <a:spLocks noGrp="1" noRot="1" noChangeAspect="1"/>
-          </p:cNvSpPr>
-          <p:nvPr>
-            <p:ph type="sldImg"/>
-          </p:nvPr>
-        </p:nvSpPr>
-        <p:spPr/>
-      </p:sp>
-      <p:sp>
-        <p:nvSpPr>
-          <p:cNvPr id="3" name="Notes Placeholder 2"/>
-          <p:cNvSpPr>
-            <a:spLocks noGrp="1"/>
-          </p:cNvSpPr>
-          <p:nvPr>
-            <p:ph type="body" idx="1"/>
-          </p:nvPr>
-        </p:nvSpPr>
-        <p:spPr/>
-        <p:txBody>
-          <a:bodyPr/>
-          <a:lstStyle/>
-          <a:p>
-            <a:r>
-              <a:rPr lang="en-US" dirty="0"/>
-              <a:t>（4:45–5:00）收尾。
-出海不缺第一单，缺的是第二单。货在他仓里没动，他就不会再下单——而你到那时才知道，已经晚了九十天。
-谢谢。</a:t>
-            </a:r>
-            <a:endParaRPr lang="en-US" dirty="0"/>
-          </a:p>
-        </p:txBody>
-      </p:sp>
-      <p:sp>
-        <p:nvSpPr>
-          <p:cNvPr id="4" name="Slide Number Placeholder 3"/>
-          <p:cNvSpPr>
-            <a:spLocks noGrp="1"/>
-          </p:cNvSpPr>
-          <p:nvPr>
-            <p:ph type="sldNum" sz="quarter" idx="10"/>
-          </p:nvPr>
-        </p:nvSpPr>
-        <p:spPr/>
-        <p:txBody>
-          <a:bodyPr/>
-          <a:lstStyle/>
-          <a:p>
-            <a:fld id="{F7021451-1387-4CA6-816F-3879F97B5CBC}" type="slidenum">
-              <a:rPr lang="en-US"/>
-              <a:t>12</a:t>
-            </a:fld>
-            <a:endParaRPr lang="en-US"/>
-          </a:p>
-        </p:txBody>
-      </p:sp>
-    </p:spTree>
-    <p:extLst>
-      <p:ext uri="{BB962C8B-B14F-4D97-AF65-F5344CB8AC3E}">
-        <p14:creationId xmlns:p14="http://schemas.microsoft.com/office/powerpoint/2010/main" val="1024086991"/>
-      </p:ext>
-    </p:extLst>
-  </p:cSld>
-  <p:clrMapOvr>
-    <a:masterClrMapping/>
-  </p:clrMapOvr>
-</p:notes>
+<file path=ppt/notesSlides/notesSlide12.xml><?xml version="1.0" encoding="UTF-8" standalone="yes"?>
+<p:notes xmlns:a="http://schemas.openxmlformats.org/drawingml/2006/main" xmlns:r="http://schemas.openxmlformats.org/officeDocument/2006/relationships" xmlns:p="http://schemas.openxmlformats.org/presentationml/2006/main"><p:cSld><p:spTree><p:nvGrpSpPr><p:cNvPr id="1" name=""/><p:cNvGrpSpPr/><p:nvPr/></p:nvGrpSpPr><p:grpSpPr><a:xfrm><a:off x="0" y="0"/><a:ext cx="0" cy="0"/><a:chOff x="0" y="0"/><a:chExt cx="0" cy="0"/></a:xfrm></p:grpSpPr><p:sp><p:nvSpPr><p:cNvPr id="2" name="Slide Image Placeholder 1"/><p:cNvSpPr><a:spLocks noGrp="1" noRot="1" noChangeAspect="1"/></p:cNvSpPr><p:nvPr><p:ph type="sldImg"/></p:nvPr></p:nvSpPr><p:spPr/></p:sp><p:sp><p:nvSpPr><p:cNvPr id="3" name="Notes Placeholder 2"/><p:cNvSpPr><a:spLocks noGrp="1"/></p:cNvSpPr><p:nvPr><p:ph type="body" idx="1"/></p:nvPr></p:nvSpPr><p:spPr/><p:txBody><a:bodyPr/><a:lstStyle/><a:p><a:r><a:rPr lang="en-US" dirty="0"/><a:t>（4:48–5:00）+最后一句话。+出海不缺第一单。缺的是第二单。+货在他仓里没动，他就不会再下单——+而你到那时才知道，已经晚了九十天。+谢谢。</a:t></a:r><a:endParaRPr lang="en-US" dirty="0"/></a:p></p:txBody></p:sp><p:sp><p:nvSpPr><p:cNvPr id="4" name="Slide Number Placeholder 3"/><p:cNvSpPr><a:spLocks noGrp="1"/></p:cNvSpPr><p:nvPr><p:ph type="sldNum" sz="quarter" idx="10"/></p:nvPr></p:nvSpPr><p:spPr/><p:txBody><a:bodyPr/><a:lstStyle/><a:p><a:fld id="{F7021451-1387-4CA6-816F-3879F97B5CBC}" type="slidenum"><a:rPr lang="en-US"/><a:t>12</a:t></a:fld><a:endParaRPr lang="en-US"/></a:p></p:txBody></p:sp></p:spTree><p:extLst><p:ext uri="{BB962C8B-B14F-4D97-AF65-F5344CB8AC3E}"><p14:creationId xmlns:p14="http://schemas.microsoft.com/office/powerpoint/2010/main" val="1024086991"/></p:ext></p:extLst></p:cSld><p:clrMapOvr><a:masterClrMapping/></p:clrMapOvr></p:notes>
 </file>
 
 <file path=ppt/notesSlides/notesSlide13.xml><?xml version="1.0" encoding="utf-8"?>
@@ -880,7 +558,7 @@
           <a:p>
             <a:r>
               <a:rPr lang="en-US" dirty="0"/>
-              <a:t/>
+              <a:t>以下不参与五分钟路演。评委提问时直接跳到对应页。</a:t>
             </a:r>
             <a:endParaRPr lang="en-US" dirty="0"/>
           </a:p>
@@ -922,356 +600,24 @@
 </p:notes>
 </file>
 
-<file path=ppt/notesSlides/notesSlide14.xml><?xml version="1.0" encoding="utf-8"?>
-<p:notes xmlns:a="http://schemas.openxmlformats.org/drawingml/2006/main" xmlns:r="http://schemas.openxmlformats.org/officeDocument/2006/relationships" xmlns:p="http://schemas.openxmlformats.org/presentationml/2006/main">
-  <p:cSld>
-    <p:spTree>
-      <p:nvGrpSpPr>
-        <p:cNvPr id="1" name=""/>
-        <p:cNvGrpSpPr/>
-        <p:nvPr/>
-      </p:nvGrpSpPr>
-      <p:grpSpPr>
-        <a:xfrm>
-          <a:off x="0" y="0"/>
-          <a:ext cx="0" cy="0"/>
-          <a:chOff x="0" y="0"/>
-          <a:chExt cx="0" cy="0"/>
-        </a:xfrm>
-      </p:grpSpPr>
-      <p:sp>
-        <p:nvSpPr>
-          <p:cNvPr id="2" name="Slide Image Placeholder 1"/>
-          <p:cNvSpPr>
-            <a:spLocks noGrp="1" noRot="1" noChangeAspect="1"/>
-          </p:cNvSpPr>
-          <p:nvPr>
-            <p:ph type="sldImg"/>
-          </p:nvPr>
-        </p:nvSpPr>
-        <p:spPr/>
-      </p:sp>
-      <p:sp>
-        <p:nvSpPr>
-          <p:cNvPr id="3" name="Notes Placeholder 2"/>
-          <p:cNvSpPr>
-            <a:spLocks noGrp="1"/>
-          </p:cNvSpPr>
-          <p:nvPr>
-            <p:ph type="body" idx="1"/>
-          </p:nvPr>
-        </p:nvSpPr>
-        <p:spPr/>
-        <p:txBody>
-          <a:bodyPr/>
-          <a:lstStyle/>
-          <a:p>
-            <a:r>
-              <a:rPr lang="en-US" dirty="0"/>
-              <a:t/>
-            </a:r>
-            <a:endParaRPr lang="en-US" dirty="0"/>
-          </a:p>
-        </p:txBody>
-      </p:sp>
-      <p:sp>
-        <p:nvSpPr>
-          <p:cNvPr id="4" name="Slide Number Placeholder 3"/>
-          <p:cNvSpPr>
-            <a:spLocks noGrp="1"/>
-          </p:cNvSpPr>
-          <p:nvPr>
-            <p:ph type="sldNum" sz="quarter" idx="10"/>
-          </p:nvPr>
-        </p:nvSpPr>
-        <p:spPr/>
-        <p:txBody>
-          <a:bodyPr/>
-          <a:lstStyle/>
-          <a:p>
-            <a:fld id="{F7021451-1387-4CA6-816F-3879F97B5CBC}" type="slidenum">
-              <a:rPr lang="en-US"/>
-              <a:t>14</a:t>
-            </a:fld>
-            <a:endParaRPr lang="en-US"/>
-          </a:p>
-        </p:txBody>
-      </p:sp>
-    </p:spTree>
-    <p:extLst>
-      <p:ext uri="{BB962C8B-B14F-4D97-AF65-F5344CB8AC3E}">
-        <p14:creationId xmlns:p14="http://schemas.microsoft.com/office/powerpoint/2010/main" val="1024086991"/>
-      </p:ext>
-    </p:extLst>
-  </p:cSld>
-  <p:clrMapOvr>
-    <a:masterClrMapping/>
-  </p:clrMapOvr>
-</p:notes>
+<file path=ppt/notesSlides/notesSlide14.xml><?xml version="1.0" encoding="UTF-8" standalone="yes"?>
+<p:notes xmlns:a="http://schemas.openxmlformats.org/drawingml/2006/main" xmlns:r="http://schemas.openxmlformats.org/officeDocument/2006/relationships" xmlns:p="http://schemas.openxmlformats.org/presentationml/2006/main"><p:cSld><p:spTree><p:nvGrpSpPr><p:cNvPr id="1" name=""/><p:cNvGrpSpPr/><p:nvPr/></p:nvGrpSpPr><p:grpSpPr><a:xfrm><a:off x="0" y="0"/><a:ext cx="0" cy="0"/><a:chOff x="0" y="0"/><a:chExt cx="0" cy="0"/></a:xfrm></p:grpSpPr><p:sp><p:nvSpPr><p:cNvPr id="2" name="Slide Image Placeholder 1"/><p:cNvSpPr><a:spLocks noGrp="1" noRot="1" noChangeAspect="1"/></p:cNvSpPr><p:nvPr><p:ph type="sldImg"/></p:nvPr></p:nvSpPr><p:spPr/></p:sp><p:sp><p:nvSpPr><p:cNvPr id="3" name="Notes Placeholder 2"/><p:cNvSpPr><a:spLocks noGrp="1"/></p:cNvSpPr><p:nvPr><p:ph type="body" idx="1"/></p:nvPr></p:nvSpPr><p:spPr/><p:txBody><a:bodyPr/><a:lstStyle/><a:p><a:r><a:rPr lang="en-US" dirty="0"/><a:t>怎么答：不要辩护「我们的数字很准」，直接说「不保证对，保证可查」，然后当场演示 ⓘ 弹出的来源与生效日期。+如果被追问日本／欧盟：坦白说没收，因为公开资料表述不够明确，收一条不确定的税率会毁掉整个规则库的可信度。</a:t></a:r><a:endParaRPr lang="en-US" dirty="0"/></a:p></p:txBody></p:sp><p:sp><p:nvSpPr><p:cNvPr id="4" name="Slide Number Placeholder 3"/><p:cNvSpPr><a:spLocks noGrp="1"/></p:cNvSpPr><p:nvPr><p:ph type="sldNum" sz="quarter" idx="10"/></p:nvPr></p:nvSpPr><p:spPr/><p:txBody><a:bodyPr/><a:lstStyle/><a:p><a:fld id="{F7021451-1387-4CA6-816F-3879F97B5CBC}" type="slidenum"><a:rPr lang="en-US"/><a:t>14</a:t></a:fld><a:endParaRPr lang="en-US"/></a:p></p:txBody></p:sp></p:spTree><p:extLst><p:ext uri="{BB962C8B-B14F-4D97-AF65-F5344CB8AC3E}"><p14:creationId xmlns:p14="http://schemas.microsoft.com/office/powerpoint/2010/main" val="1024086991"/></p:ext></p:extLst></p:cSld><p:clrMapOvr><a:masterClrMapping/></p:clrMapOvr></p:notes>
 </file>
 
-<file path=ppt/notesSlides/notesSlide15.xml><?xml version="1.0" encoding="utf-8"?>
-<p:notes xmlns:a="http://schemas.openxmlformats.org/drawingml/2006/main" xmlns:r="http://schemas.openxmlformats.org/officeDocument/2006/relationships" xmlns:p="http://schemas.openxmlformats.org/presentationml/2006/main">
-  <p:cSld>
-    <p:spTree>
-      <p:nvGrpSpPr>
-        <p:cNvPr id="1" name=""/>
-        <p:cNvGrpSpPr/>
-        <p:nvPr/>
-      </p:nvGrpSpPr>
-      <p:grpSpPr>
-        <a:xfrm>
-          <a:off x="0" y="0"/>
-          <a:ext cx="0" cy="0"/>
-          <a:chOff x="0" y="0"/>
-          <a:chExt cx="0" cy="0"/>
-        </a:xfrm>
-      </p:grpSpPr>
-      <p:sp>
-        <p:nvSpPr>
-          <p:cNvPr id="2" name="Slide Image Placeholder 1"/>
-          <p:cNvSpPr>
-            <a:spLocks noGrp="1" noRot="1" noChangeAspect="1"/>
-          </p:cNvSpPr>
-          <p:nvPr>
-            <p:ph type="sldImg"/>
-          </p:nvPr>
-        </p:nvSpPr>
-        <p:spPr/>
-      </p:sp>
-      <p:sp>
-        <p:nvSpPr>
-          <p:cNvPr id="3" name="Notes Placeholder 2"/>
-          <p:cNvSpPr>
-            <a:spLocks noGrp="1"/>
-          </p:cNvSpPr>
-          <p:nvPr>
-            <p:ph type="body" idx="1"/>
-          </p:nvPr>
-        </p:nvSpPr>
-        <p:spPr/>
-        <p:txBody>
-          <a:bodyPr/>
-          <a:lstStyle/>
-          <a:p>
-            <a:r>
-              <a:rPr lang="en-US" dirty="0"/>
-              <a:t/>
-            </a:r>
-            <a:endParaRPr lang="en-US" dirty="0"/>
-          </a:p>
-        </p:txBody>
-      </p:sp>
-      <p:sp>
-        <p:nvSpPr>
-          <p:cNvPr id="4" name="Slide Number Placeholder 3"/>
-          <p:cNvSpPr>
-            <a:spLocks noGrp="1"/>
-          </p:cNvSpPr>
-          <p:nvPr>
-            <p:ph type="sldNum" sz="quarter" idx="10"/>
-          </p:nvPr>
-        </p:nvSpPr>
-        <p:spPr/>
-        <p:txBody>
-          <a:bodyPr/>
-          <a:lstStyle/>
-          <a:p>
-            <a:fld id="{F7021451-1387-4CA6-816F-3879F97B5CBC}" type="slidenum">
-              <a:rPr lang="en-US"/>
-              <a:t>15</a:t>
-            </a:fld>
-            <a:endParaRPr lang="en-US"/>
-          </a:p>
-        </p:txBody>
-      </p:sp>
-    </p:spTree>
-    <p:extLst>
-      <p:ext uri="{BB962C8B-B14F-4D97-AF65-F5344CB8AC3E}">
-        <p14:creationId xmlns:p14="http://schemas.microsoft.com/office/powerpoint/2010/main" val="1024086991"/>
-      </p:ext>
-    </p:extLst>
-  </p:cSld>
-  <p:clrMapOvr>
-    <a:masterClrMapping/>
-  </p:clrMapOvr>
-</p:notes>
+<file path=ppt/notesSlides/notesSlide15.xml><?xml version="1.0" encoding="UTF-8" standalone="yes"?>
+<p:notes xmlns:a="http://schemas.openxmlformats.org/drawingml/2006/main" xmlns:r="http://schemas.openxmlformats.org/officeDocument/2006/relationships" xmlns:p="http://schemas.openxmlformats.org/presentationml/2006/main"><p:cSld><p:spTree><p:nvGrpSpPr><p:cNvPr id="1" name=""/><p:cNvGrpSpPr/><p:nvPr/></p:nvGrpSpPr><p:grpSpPr><a:xfrm><a:off x="0" y="0"/><a:ext cx="0" cy="0"/><a:chOff x="0" y="0"/><a:chExt cx="0" cy="0"/></a:xfrm></p:grpSpPr><p:sp><p:nvSpPr><p:cNvPr id="2" name="Slide Image Placeholder 1"/><p:cNvSpPr><a:spLocks noGrp="1" noRot="1" noChangeAspect="1"/></p:cNvSpPr><p:nvPr><p:ph type="sldImg"/></p:nvPr></p:nvSpPr><p:spPr/></p:sp><p:sp><p:nvSpPr><p:cNvPr id="3" name="Notes Placeholder 2"/><p:cNvSpPr><a:spLocks noGrp="1"/></p:cNvSpPr><p:nvPr><p:ph type="body" idx="1"/></p:nvPr></p:nvSpPr><p:spPr/><p:txBody><a:bodyPr/><a:lstStyle/><a:p><a:r><a:rPr lang="en-US" dirty="0"/><a:t>怎么答：这题几乎一定会被问。三个字回答——细节、稳定、可追溯。+最有杀伤力的是当场对比：让评委用手机问通用模型「白酒出口新加坡税负多少」，多半会得到一个区间；我们给的是按纯酒精量算出来的具体数字，附税则出处。</a:t></a:r><a:endParaRPr lang="en-US" dirty="0"/></a:p></p:txBody></p:sp><p:sp><p:nvSpPr><p:cNvPr id="4" name="Slide Number Placeholder 3"/><p:cNvSpPr><a:spLocks noGrp="1"/></p:cNvSpPr><p:nvPr><p:ph type="sldNum" sz="quarter" idx="10"/></p:nvPr></p:nvSpPr><p:spPr/><p:txBody><a:bodyPr/><a:lstStyle/><a:p><a:fld id="{F7021451-1387-4CA6-816F-3879F97B5CBC}" type="slidenum"><a:rPr lang="en-US"/><a:t>15</a:t></a:fld><a:endParaRPr lang="en-US"/></a:p></p:txBody></p:sp></p:spTree><p:extLst><p:ext uri="{BB962C8B-B14F-4D97-AF65-F5344CB8AC3E}"><p14:creationId xmlns:p14="http://schemas.microsoft.com/office/powerpoint/2010/main" val="1024086991"/></p:ext></p:extLst></p:cSld><p:clrMapOvr><a:masterClrMapping/></p:clrMapOvr></p:notes>
 </file>
 
-<file path=ppt/notesSlides/notesSlide16.xml><?xml version="1.0" encoding="utf-8"?>
-<p:notes xmlns:a="http://schemas.openxmlformats.org/drawingml/2006/main" xmlns:r="http://schemas.openxmlformats.org/officeDocument/2006/relationships" xmlns:p="http://schemas.openxmlformats.org/presentationml/2006/main">
-  <p:cSld>
-    <p:spTree>
-      <p:nvGrpSpPr>
-        <p:cNvPr id="1" name=""/>
-        <p:cNvGrpSpPr/>
-        <p:nvPr/>
-      </p:nvGrpSpPr>
-      <p:grpSpPr>
-        <a:xfrm>
-          <a:off x="0" y="0"/>
-          <a:ext cx="0" cy="0"/>
-          <a:chOff x="0" y="0"/>
-          <a:chExt cx="0" cy="0"/>
-        </a:xfrm>
-      </p:grpSpPr>
-      <p:sp>
-        <p:nvSpPr>
-          <p:cNvPr id="2" name="Slide Image Placeholder 1"/>
-          <p:cNvSpPr>
-            <a:spLocks noGrp="1" noRot="1" noChangeAspect="1"/>
-          </p:cNvSpPr>
-          <p:nvPr>
-            <p:ph type="sldImg"/>
-          </p:nvPr>
-        </p:nvSpPr>
-        <p:spPr/>
-      </p:sp>
-      <p:sp>
-        <p:nvSpPr>
-          <p:cNvPr id="3" name="Notes Placeholder 2"/>
-          <p:cNvSpPr>
-            <a:spLocks noGrp="1"/>
-          </p:cNvSpPr>
-          <p:nvPr>
-            <p:ph type="body" idx="1"/>
-          </p:nvPr>
-        </p:nvSpPr>
-        <p:spPr/>
-        <p:txBody>
-          <a:bodyPr/>
-          <a:lstStyle/>
-          <a:p>
-            <a:r>
-              <a:rPr lang="en-US" dirty="0"/>
-              <a:t/>
-            </a:r>
-            <a:endParaRPr lang="en-US" dirty="0"/>
-          </a:p>
-        </p:txBody>
-      </p:sp>
-      <p:sp>
-        <p:nvSpPr>
-          <p:cNvPr id="4" name="Slide Number Placeholder 3"/>
-          <p:cNvSpPr>
-            <a:spLocks noGrp="1"/>
-          </p:cNvSpPr>
-          <p:nvPr>
-            <p:ph type="sldNum" sz="quarter" idx="10"/>
-          </p:nvPr>
-        </p:nvSpPr>
-        <p:spPr/>
-        <p:txBody>
-          <a:bodyPr/>
-          <a:lstStyle/>
-          <a:p>
-            <a:fld id="{F7021451-1387-4CA6-816F-3879F97B5CBC}" type="slidenum">
-              <a:rPr lang="en-US"/>
-              <a:t>16</a:t>
-            </a:fld>
-            <a:endParaRPr lang="en-US"/>
-          </a:p>
-        </p:txBody>
-      </p:sp>
-    </p:spTree>
-    <p:extLst>
-      <p:ext uri="{BB962C8B-B14F-4D97-AF65-F5344CB8AC3E}">
-        <p14:creationId xmlns:p14="http://schemas.microsoft.com/office/powerpoint/2010/main" val="1024086991"/>
-      </p:ext>
-    </p:extLst>
-  </p:cSld>
-  <p:clrMapOvr>
-    <a:masterClrMapping/>
-  </p:clrMapOvr>
-</p:notes>
+<file path=ppt/notesSlides/notesSlide16.xml><?xml version="1.0" encoding="UTF-8" standalone="yes"?>
+<p:notes xmlns:a="http://schemas.openxmlformats.org/drawingml/2006/main" xmlns:r="http://schemas.openxmlformats.org/officeDocument/2006/relationships" xmlns:p="http://schemas.openxmlformats.org/presentationml/2006/main"><p:cSld><p:spTree><p:nvGrpSpPr><p:cNvPr id="1" name=""/><p:cNvGrpSpPr/><p:nvPr/></p:nvGrpSpPr><p:grpSpPr><a:xfrm><a:off x="0" y="0"/><a:ext cx="0" cy="0"/><a:chOff x="0" y="0"/><a:chExt cx="0" cy="0"/></a:xfrm></p:grpSpPr><p:sp><p:nvSpPr><p:cNvPr id="2" name="Slide Image Placeholder 1"/><p:cNvSpPr><a:spLocks noGrp="1" noRot="1" noChangeAspect="1"/></p:cNvSpPr><p:nvPr><p:ph type="sldImg"/></p:nvPr></p:nvSpPr><p:spPr/></p:sp><p:sp><p:nvSpPr><p:cNvPr id="3" name="Notes Placeholder 2"/><p:cNvSpPr><a:spLocks noGrp="1"/></p:cNvSpPr><p:nvPr><p:ph type="body" idx="1"/></p:nvPr></p:nvSpPr><p:spPr/><p:txBody><a:bodyPr/><a:lstStyle/><a:p><a:r><a:rPr lang="en-US" dirty="0"/><a:t>怎么答：不要硬编商业模式。先承认「现在谈还太早」，再给唯一现实的入口——产区服务平台。+如果评委追问「那你们靠什么活」：中小酒企不会为网页付费，会为「少亏一柜」付费，所以第一步是把误差验出来。</a:t></a:r><a:endParaRPr lang="en-US" dirty="0"/></a:p></p:txBody></p:sp><p:sp><p:nvSpPr><p:cNvPr id="4" name="Slide Number Placeholder 3"/><p:cNvSpPr><a:spLocks noGrp="1"/></p:cNvSpPr><p:nvPr><p:ph type="sldNum" sz="quarter" idx="10"/></p:nvPr></p:nvSpPr><p:spPr/><p:txBody><a:bodyPr/><a:lstStyle/><a:p><a:fld id="{F7021451-1387-4CA6-816F-3879F97B5CBC}" type="slidenum"><a:rPr lang="en-US"/><a:t>16</a:t></a:fld><a:endParaRPr lang="en-US"/></a:p></p:txBody></p:sp></p:spTree><p:extLst><p:ext uri="{BB962C8B-B14F-4D97-AF65-F5344CB8AC3E}"><p14:creationId xmlns:p14="http://schemas.microsoft.com/office/powerpoint/2010/main" val="1024086991"/></p:ext></p:extLst></p:cSld><p:clrMapOvr><a:masterClrMapping/></p:clrMapOvr></p:notes>
 </file>
 
-<file path=ppt/notesSlides/notesSlide17.xml><?xml version="1.0" encoding="utf-8"?>
-<p:notes xmlns:a="http://schemas.openxmlformats.org/drawingml/2006/main" xmlns:r="http://schemas.openxmlformats.org/officeDocument/2006/relationships" xmlns:p="http://schemas.openxmlformats.org/presentationml/2006/main">
-  <p:cSld>
-    <p:spTree>
-      <p:nvGrpSpPr>
-        <p:cNvPr id="1" name=""/>
-        <p:cNvGrpSpPr/>
-        <p:nvPr/>
-      </p:nvGrpSpPr>
-      <p:grpSpPr>
-        <a:xfrm>
-          <a:off x="0" y="0"/>
-          <a:ext cx="0" cy="0"/>
-          <a:chOff x="0" y="0"/>
-          <a:chExt cx="0" cy="0"/>
-        </a:xfrm>
-      </p:grpSpPr>
-      <p:sp>
-        <p:nvSpPr>
-          <p:cNvPr id="2" name="Slide Image Placeholder 1"/>
-          <p:cNvSpPr>
-            <a:spLocks noGrp="1" noRot="1" noChangeAspect="1"/>
-          </p:cNvSpPr>
-          <p:nvPr>
-            <p:ph type="sldImg"/>
-          </p:nvPr>
-        </p:nvSpPr>
-        <p:spPr/>
-      </p:sp>
-      <p:sp>
-        <p:nvSpPr>
-          <p:cNvPr id="3" name="Notes Placeholder 2"/>
-          <p:cNvSpPr>
-            <a:spLocks noGrp="1"/>
-          </p:cNvSpPr>
-          <p:nvPr>
-            <p:ph type="body" idx="1"/>
-          </p:nvPr>
-        </p:nvSpPr>
-        <p:spPr/>
-        <p:txBody>
-          <a:bodyPr/>
-          <a:lstStyle/>
-          <a:p>
-            <a:r>
-              <a:rPr lang="en-US" dirty="0"/>
-              <a:t/>
-            </a:r>
-            <a:endParaRPr lang="en-US" dirty="0"/>
-          </a:p>
-        </p:txBody>
-      </p:sp>
-      <p:sp>
-        <p:nvSpPr>
-          <p:cNvPr id="4" name="Slide Number Placeholder 3"/>
-          <p:cNvSpPr>
-            <a:spLocks noGrp="1"/>
-          </p:cNvSpPr>
-          <p:nvPr>
-            <p:ph type="sldNum" sz="quarter" idx="10"/>
-          </p:nvPr>
-        </p:nvSpPr>
-        <p:spPr/>
-        <p:txBody>
-          <a:bodyPr/>
-          <a:lstStyle/>
-          <a:p>
-            <a:fld id="{F7021451-1387-4CA6-816F-3879F97B5CBC}" type="slidenum">
-              <a:rPr lang="en-US"/>
-              <a:t>17</a:t>
-            </a:fld>
-            <a:endParaRPr lang="en-US"/>
-          </a:p>
-        </p:txBody>
-      </p:sp>
-    </p:spTree>
-    <p:extLst>
-      <p:ext uri="{BB962C8B-B14F-4D97-AF65-F5344CB8AC3E}">
-        <p14:creationId xmlns:p14="http://schemas.microsoft.com/office/powerpoint/2010/main" val="1024086991"/>
-      </p:ext>
-    </p:extLst>
-  </p:cSld>
-  <p:clrMapOvr>
-    <a:masterClrMapping/>
-  </p:clrMapOvr>
-</p:notes>
+<file path=ppt/notesSlides/notesSlide17.xml><?xml version="1.0" encoding="UTF-8" standalone="yes"?>
+<p:notes xmlns:a="http://schemas.openxmlformats.org/drawingml/2006/main" xmlns:r="http://schemas.openxmlformats.org/officeDocument/2006/relationships" xmlns:p="http://schemas.openxmlformats.org/presentationml/2006/main"><p:cSld><p:spTree><p:nvGrpSpPr><p:cNvPr id="1" name=""/><p:cNvGrpSpPr/><p:nvPr/></p:nvGrpSpPr><p:grpSpPr><a:xfrm><a:off x="0" y="0"/><a:ext cx="0" cy="0"/><a:chOff x="0" y="0"/><a:chExt cx="0" cy="0"/></a:xfrm></p:grpSpPr><p:sp><p:nvSpPr><p:cNvPr id="2" name="Slide Image Placeholder 1"/><p:cNvSpPr><a:spLocks noGrp="1" noRot="1" noChangeAspect="1"/></p:cNvSpPr><p:nvPr><p:ph type="sldImg"/></p:nvPr></p:nvSpPr><p:spPr/></p:sp><p:sp><p:nvSpPr><p:cNvPr id="3" name="Notes Placeholder 2"/><p:cNvSpPr><a:spLocks noGrp="1"/></p:cNvSpPr><p:nvPr><p:ph type="body" idx="1"/></p:nvPr></p:nvSpPr><p:spPr/><p:txBody><a:bodyPr/><a:lstStyle/><a:p><a:r><a:rPr lang="en-US" dirty="0"/><a:t>怎么答：分两层——官方公开资料（税则牌照）和团队自建数据库（品项与用法，每条标注证据强度）。+强调五十六支贵州白酒是逐支核过的，不是抓的。</a:t></a:r><a:endParaRPr lang="en-US" dirty="0"/></a:p></p:txBody></p:sp><p:sp><p:nvSpPr><p:cNvPr id="4" name="Slide Number Placeholder 3"/><p:cNvSpPr><a:spLocks noGrp="1"/></p:cNvSpPr><p:nvPr><p:ph type="sldNum" sz="quarter" idx="10"/></p:nvPr></p:nvSpPr><p:spPr/><p:txBody><a:bodyPr/><a:lstStyle/><a:p><a:fld id="{F7021451-1387-4CA6-816F-3879F97B5CBC}" type="slidenum"><a:rPr lang="en-US"/><a:t>17</a:t></a:fld><a:endParaRPr lang="en-US"/></a:p></p:txBody></p:sp></p:spTree><p:extLst><p:ext uri="{BB962C8B-B14F-4D97-AF65-F5344CB8AC3E}"><p14:creationId xmlns:p14="http://schemas.microsoft.com/office/powerpoint/2010/main" val="1024086991"/></p:ext></p:extLst></p:cSld><p:clrMapOvr><a:masterClrMapping/></p:clrMapOvr></p:notes>
 </file>
 
 <file path=ppt/notesSlides/notesSlide18.xml><?xml version="1.0" encoding="utf-8"?>
@@ -1320,7 +666,7 @@
           <a:p>
             <a:r>
               <a:rPr lang="en-US" dirty="0"/>
-              <a:t/>
+              <a:t>怎么答：承认网页不是终态。但要说清楚为什么先做网页——规则库、信号权重、落地价误差这三件事没验完之前，做成机器人只是把还没校准的答案推给更多人。</a:t>
             </a:r>
             <a:endParaRPr lang="en-US" dirty="0"/>
           </a:p>
@@ -1362,270 +708,26 @@
 </p:notes>
 </file>
 
-<file path=ppt/notesSlides/notesSlide19.xml><?xml version="1.0" encoding="utf-8"?>
-<p:notes xmlns:a="http://schemas.openxmlformats.org/drawingml/2006/main" xmlns:r="http://schemas.openxmlformats.org/officeDocument/2006/relationships" xmlns:p="http://schemas.openxmlformats.org/presentationml/2006/main">
-  <p:cSld>
-    <p:spTree>
-      <p:nvGrpSpPr>
-        <p:cNvPr id="1" name=""/>
-        <p:cNvGrpSpPr/>
-        <p:nvPr/>
-      </p:nvGrpSpPr>
-      <p:grpSpPr>
-        <a:xfrm>
-          <a:off x="0" y="0"/>
-          <a:ext cx="0" cy="0"/>
-          <a:chOff x="0" y="0"/>
-          <a:chExt cx="0" cy="0"/>
-        </a:xfrm>
-      </p:grpSpPr>
-      <p:sp>
-        <p:nvSpPr>
-          <p:cNvPr id="2" name="Slide Image Placeholder 1"/>
-          <p:cNvSpPr>
-            <a:spLocks noGrp="1" noRot="1" noChangeAspect="1"/>
-          </p:cNvSpPr>
-          <p:nvPr>
-            <p:ph type="sldImg"/>
-          </p:nvPr>
-        </p:nvSpPr>
-        <p:spPr/>
-      </p:sp>
-      <p:sp>
-        <p:nvSpPr>
-          <p:cNvPr id="3" name="Notes Placeholder 2"/>
-          <p:cNvSpPr>
-            <a:spLocks noGrp="1"/>
-          </p:cNvSpPr>
-          <p:nvPr>
-            <p:ph type="body" idx="1"/>
-          </p:nvPr>
-        </p:nvSpPr>
-        <p:spPr/>
-        <p:txBody>
-          <a:bodyPr/>
-          <a:lstStyle/>
-          <a:p>
-            <a:r>
-              <a:rPr lang="en-US" dirty="0"/>
-              <a:t/>
-            </a:r>
-            <a:endParaRPr lang="en-US" dirty="0"/>
-          </a:p>
-        </p:txBody>
-      </p:sp>
-      <p:sp>
-        <p:nvSpPr>
-          <p:cNvPr id="4" name="Slide Number Placeholder 3"/>
-          <p:cNvSpPr>
-            <a:spLocks noGrp="1"/>
-          </p:cNvSpPr>
-          <p:nvPr>
-            <p:ph type="sldNum" sz="quarter" idx="10"/>
-          </p:nvPr>
-        </p:nvSpPr>
-        <p:spPr/>
-        <p:txBody>
-          <a:bodyPr/>
-          <a:lstStyle/>
-          <a:p>
-            <a:fld id="{F7021451-1387-4CA6-816F-3879F97B5CBC}" type="slidenum">
-              <a:rPr lang="en-US"/>
-              <a:t>19</a:t>
-            </a:fld>
-            <a:endParaRPr lang="en-US"/>
-          </a:p>
-        </p:txBody>
-      </p:sp>
-    </p:spTree>
-    <p:extLst>
-      <p:ext uri="{BB962C8B-B14F-4D97-AF65-F5344CB8AC3E}">
-        <p14:creationId xmlns:p14="http://schemas.microsoft.com/office/powerpoint/2010/main" val="1024086991"/>
-      </p:ext>
-    </p:extLst>
-  </p:cSld>
-  <p:clrMapOvr>
-    <a:masterClrMapping/>
-  </p:clrMapOvr>
-</p:notes>
+<file path=ppt/notesSlides/notesSlide19.xml><?xml version="1.0" encoding="UTF-8" standalone="yes"?>
+<p:notes xmlns:a="http://schemas.openxmlformats.org/drawingml/2006/main" xmlns:r="http://schemas.openxmlformats.org/officeDocument/2006/relationships" xmlns:p="http://schemas.openxmlformats.org/presentationml/2006/main"><p:cSld><p:spTree><p:nvGrpSpPr><p:cNvPr id="1" name=""/><p:cNvGrpSpPr/><p:nvPr/></p:nvGrpSpPr><p:grpSpPr><a:xfrm><a:off x="0" y="0"/><a:ext cx="0" cy="0"/><a:chOff x="0" y="0"/><a:chExt cx="0" cy="0"/></a:xfrm></p:grpSpPr><p:sp><p:nvSpPr><p:cNvPr id="2" name="Slide Image Placeholder 1"/><p:cNvSpPr><a:spLocks noGrp="1" noRot="1" noChangeAspect="1"/></p:cNvSpPr><p:nvPr><p:ph type="sldImg"/></p:nvPr></p:nvSpPr><p:spPr/></p:sp><p:sp><p:nvSpPr><p:cNvPr id="3" name="Notes Placeholder 2"/><p:cNvSpPr><a:spLocks noGrp="1"/></p:cNvSpPr><p:nvPr><p:ph type="body" idx="1"/></p:nvPr></p:nvSpPr><p:spPr/><p:txBody><a:bodyPr/><a:lstStyle/><a:p><a:r><a:rPr lang="en-US" dirty="0"/><a:t>怎么答：主动说，不等被问。这一页的作用是把可信度拉起来——一个肯讲自己边界的团队，前面说的话才值得信。+最重要的一条是「信号权重还没用真实案例校准」，这也正好是一百天计划的第二步。</a:t></a:r><a:endParaRPr lang="en-US" dirty="0"/></a:p></p:txBody></p:sp><p:sp><p:nvSpPr><p:cNvPr id="4" name="Slide Number Placeholder 3"/><p:cNvSpPr><a:spLocks noGrp="1"/></p:cNvSpPr><p:nvPr><p:ph type="sldNum" sz="quarter" idx="10"/></p:nvPr></p:nvSpPr><p:spPr/><p:txBody><a:bodyPr/><a:lstStyle/><a:p><a:fld id="{F7021451-1387-4CA6-816F-3879F97B5CBC}" type="slidenum"><a:rPr lang="en-US"/><a:t>19</a:t></a:fld><a:endParaRPr lang="en-US"/></a:p></p:txBody></p:sp></p:spTree><p:extLst><p:ext uri="{BB962C8B-B14F-4D97-AF65-F5344CB8AC3E}"><p14:creationId xmlns:p14="http://schemas.microsoft.com/office/powerpoint/2010/main" val="1024086991"/></p:ext></p:extLst></p:cSld><p:clrMapOvr><a:masterClrMapping/></p:clrMapOvr></p:notes>
 </file>
 
-<file path=ppt/notesSlides/notesSlide2.xml><?xml version="1.0" encoding="utf-8"?>
-<p:notes xmlns:a="http://schemas.openxmlformats.org/drawingml/2006/main" xmlns:r="http://schemas.openxmlformats.org/officeDocument/2006/relationships" xmlns:p="http://schemas.openxmlformats.org/presentationml/2006/main">
-  <p:cSld>
-    <p:spTree>
-      <p:nvGrpSpPr>
-        <p:cNvPr id="1" name=""/>
-        <p:cNvGrpSpPr/>
-        <p:nvPr/>
-      </p:nvGrpSpPr>
-      <p:grpSpPr>
-        <a:xfrm>
-          <a:off x="0" y="0"/>
-          <a:ext cx="0" cy="0"/>
-          <a:chOff x="0" y="0"/>
-          <a:chExt cx="0" cy="0"/>
-        </a:xfrm>
-      </p:grpSpPr>
-      <p:sp>
-        <p:nvSpPr>
-          <p:cNvPr id="2" name="Slide Image Placeholder 1"/>
-          <p:cNvSpPr>
-            <a:spLocks noGrp="1" noRot="1" noChangeAspect="1"/>
-          </p:cNvSpPr>
-          <p:nvPr>
-            <p:ph type="sldImg"/>
-          </p:nvPr>
-        </p:nvSpPr>
-        <p:spPr/>
-      </p:sp>
-      <p:sp>
-        <p:nvSpPr>
-          <p:cNvPr id="3" name="Notes Placeholder 2"/>
-          <p:cNvSpPr>
-            <a:spLocks noGrp="1"/>
-          </p:cNvSpPr>
-          <p:nvPr>
-            <p:ph type="body" idx="1"/>
-          </p:nvPr>
-        </p:nvSpPr>
-        <p:spPr/>
-        <p:txBody>
-          <a:bodyPr/>
-          <a:lstStyle/>
-          <a:p>
-            <a:r>
-              <a:rPr lang="en-US" dirty="0"/>
-              <a:t>（0:20–0:55）遵义综保区 2025 年工作总结的一组罕见诚实数字。
-89 家完成出口备案，35 家有意向，11 家真的出了海，最后 5 家「建立初步联系」。转化率 5.6%。
-注意最后一级的措辞——是「建立初步联系」，不是签约，更不是复购。公开资料在这里就断了。</a:t>
-            </a:r>
-            <a:endParaRPr lang="en-US" dirty="0"/>
-          </a:p>
-        </p:txBody>
-      </p:sp>
-      <p:sp>
-        <p:nvSpPr>
-          <p:cNvPr id="4" name="Slide Number Placeholder 3"/>
-          <p:cNvSpPr>
-            <a:spLocks noGrp="1"/>
-          </p:cNvSpPr>
-          <p:nvPr>
-            <p:ph type="sldNum" sz="quarter" idx="10"/>
-          </p:nvPr>
-        </p:nvSpPr>
-        <p:spPr/>
-        <p:txBody>
-          <a:bodyPr/>
-          <a:lstStyle/>
-          <a:p>
-            <a:fld id="{F7021451-1387-4CA6-816F-3879F97B5CBC}" type="slidenum">
-              <a:rPr lang="en-US"/>
-              <a:t>2</a:t>
-            </a:fld>
-            <a:endParaRPr lang="en-US"/>
-          </a:p>
-        </p:txBody>
-      </p:sp>
-    </p:spTree>
-    <p:extLst>
-      <p:ext uri="{BB962C8B-B14F-4D97-AF65-F5344CB8AC3E}">
-        <p14:creationId xmlns:p14="http://schemas.microsoft.com/office/powerpoint/2010/main" val="1024086991"/>
-      </p:ext>
-    </p:extLst>
-  </p:cSld>
-  <p:clrMapOvr>
-    <a:masterClrMapping/>
-  </p:clrMapOvr>
-</p:notes>
+<file path=ppt/notesSlides/notesSlide2.xml><?xml version="1.0" encoding="UTF-8" standalone="yes"?>
+<p:notes xmlns:a="http://schemas.openxmlformats.org/drawingml/2006/main" xmlns:r="http://schemas.openxmlformats.org/officeDocument/2006/relationships" xmlns:p="http://schemas.openxmlformats.org/presentationml/2006/main"><p:cSld><p:spTree><p:nvGrpSpPr><p:cNvPr id="1" name=""/><p:cNvGrpSpPr/><p:nvPr/></p:nvGrpSpPr><p:grpSpPr><a:xfrm><a:off x="0" y="0"/><a:ext cx="0" cy="0"/><a:chOff x="0" y="0"/><a:chExt cx="0" cy="0"/></a:xfrm></p:grpSpPr><p:sp><p:nvSpPr><p:cNvPr id="2" name="Slide Image Placeholder 1"/><p:cNvSpPr><a:spLocks noGrp="1" noRot="1" noChangeAspect="1"/></p:cNvSpPr><p:nvPr><p:ph type="sldImg"/></p:nvPr></p:nvSpPr><p:spPr/></p:sp><p:sp><p:nvSpPr><p:cNvPr id="3" name="Notes Placeholder 2"/><p:cNvSpPr><a:spLocks noGrp="1"/></p:cNvSpPr><p:nvPr><p:ph type="body" idx="1"/></p:nvPr></p:nvSpPr><p:spPr/><p:txBody><a:bodyPr/><a:lstStyle/><a:p><a:r><a:rPr lang="en-US" dirty="0"/><a:t>（0:20–0:55）+先说我们为什么做这个。+遵义综合保税区二〇二五年的工作总结里，有一组很诚实的数字：+八十九家酒企完成出口备案，三十五家有意向，十一家真的出了海，+最后——五家和东南亚经销商「建立初步联系」。+转化率百分之五点六。+[指最后一级]+请注意最后一级的措辞，是「建立初步联系」，不是签约，更不是复购。+公开资料在这里就断了。</a:t></a:r><a:endParaRPr lang="en-US" dirty="0"/></a:p></p:txBody></p:sp><p:sp><p:nvSpPr><p:cNvPr id="4" name="Slide Number Placeholder 3"/><p:cNvSpPr><a:spLocks noGrp="1"/></p:cNvSpPr><p:nvPr><p:ph type="sldNum" sz="quarter" idx="10"/></p:nvPr></p:nvSpPr><p:spPr/><p:txBody><a:bodyPr/><a:lstStyle/><a:p><a:fld id="{F7021451-1387-4CA6-816F-3879F97B5CBC}" type="slidenum"><a:rPr lang="en-US"/><a:t>2</a:t></a:fld><a:endParaRPr lang="en-US"/></a:p></p:txBody></p:sp></p:spTree><p:extLst><p:ext uri="{BB962C8B-B14F-4D97-AF65-F5344CB8AC3E}"><p14:creationId xmlns:p14="http://schemas.microsoft.com/office/powerpoint/2010/main" val="1024086991"/></p:ext></p:extLst></p:cSld><p:clrMapOvr><a:masterClrMapping/></p:clrMapOvr></p:notes>
 </file>
 
-<file path=ppt/notesSlides/notesSlide20.xml><?xml version="1.0" encoding="utf-8"?>
-<p:notes xmlns:a="http://schemas.openxmlformats.org/drawingml/2006/main" xmlns:r="http://schemas.openxmlformats.org/officeDocument/2006/relationships" xmlns:p="http://schemas.openxmlformats.org/presentationml/2006/main">
-  <p:cSld>
-    <p:spTree>
-      <p:nvGrpSpPr>
-        <p:cNvPr id="1" name=""/>
-        <p:cNvGrpSpPr/>
-        <p:nvPr/>
-      </p:nvGrpSpPr>
-      <p:grpSpPr>
-        <a:xfrm>
-          <a:off x="0" y="0"/>
-          <a:ext cx="0" cy="0"/>
-          <a:chOff x="0" y="0"/>
-          <a:chExt cx="0" cy="0"/>
-        </a:xfrm>
-      </p:grpSpPr>
-      <p:sp>
-        <p:nvSpPr>
-          <p:cNvPr id="2" name="Slide Image Placeholder 1"/>
-          <p:cNvSpPr>
-            <a:spLocks noGrp="1" noRot="1" noChangeAspect="1"/>
-          </p:cNvSpPr>
-          <p:nvPr>
-            <p:ph type="sldImg"/>
-          </p:nvPr>
-        </p:nvSpPr>
-        <p:spPr/>
-      </p:sp>
-      <p:sp>
-        <p:nvSpPr>
-          <p:cNvPr id="3" name="Notes Placeholder 2"/>
-          <p:cNvSpPr>
-            <a:spLocks noGrp="1"/>
-          </p:cNvSpPr>
-          <p:nvPr>
-            <p:ph type="body" idx="1"/>
-          </p:nvPr>
-        </p:nvSpPr>
-        <p:spPr/>
-        <p:txBody>
-          <a:bodyPr/>
-          <a:lstStyle/>
-          <a:p>
-            <a:r>
-              <a:rPr lang="en-US" dirty="0"/>
-              <a:t/>
-            </a:r>
-            <a:endParaRPr lang="en-US" dirty="0"/>
-          </a:p>
-        </p:txBody>
-      </p:sp>
-      <p:sp>
-        <p:nvSpPr>
-          <p:cNvPr id="4" name="Slide Number Placeholder 3"/>
-          <p:cNvSpPr>
-            <a:spLocks noGrp="1"/>
-          </p:cNvSpPr>
-          <p:nvPr>
-            <p:ph type="sldNum" sz="quarter" idx="10"/>
-          </p:nvPr>
-        </p:nvSpPr>
-        <p:spPr/>
-        <p:txBody>
-          <a:bodyPr/>
-          <a:lstStyle/>
-          <a:p>
-            <a:fld id="{F7021451-1387-4CA6-816F-3879F97B5CBC}" type="slidenum">
-              <a:rPr lang="en-US"/>
-              <a:t>20</a:t>
-            </a:fld>
-            <a:endParaRPr lang="en-US"/>
-          </a:p>
-        </p:txBody>
-      </p:sp>
-    </p:spTree>
-    <p:extLst>
-      <p:ext uri="{BB962C8B-B14F-4D97-AF65-F5344CB8AC3E}">
-        <p14:creationId xmlns:p14="http://schemas.microsoft.com/office/powerpoint/2010/main" val="1024086991"/>
-      </p:ext>
-    </p:extLst>
-  </p:cSld>
-  <p:clrMapOvr>
-    <a:masterClrMapping/>
-  </p:clrMapOvr>
-</p:notes>
+<file path=ppt/notesSlides/notesSlide20.xml><?xml version="1.0" encoding="UTF-8" standalone="yes"?>
+<p:notes xmlns:a="http://schemas.openxmlformats.org/drawingml/2006/main" xmlns:r="http://schemas.openxmlformats.org/officeDocument/2006/relationships" xmlns:p="http://schemas.openxmlformats.org/presentationml/2006/main"><p:cSld><p:spTree><p:nvGrpSpPr><p:cNvPr id="1" name=""/><p:cNvGrpSpPr/><p:nvPr/></p:nvGrpSpPr><p:grpSpPr><a:xfrm><a:off x="0" y="0"/><a:ext cx="0" cy="0"/><a:chOff x="0" y="0"/><a:chExt cx="0" cy="0"/></a:xfrm></p:grpSpPr><p:sp><p:nvSpPr><p:cNvPr id="2" name="Slide Image Placeholder 1"/><p:cNvSpPr><a:spLocks noGrp="1" noRot="1" noChangeAspect="1"/></p:cNvSpPr><p:nvPr><p:ph type="sldImg"/></p:nvPr></p:nvSpPr><p:spPr/></p:sp><p:sp><p:nvSpPr><p:cNvPr id="3" name="Notes Placeholder 2"/><p:cNvSpPr><a:spLocks noGrp="1"/></p:cNvSpPr><p:nvPr><p:ph type="body" idx="1"/></p:nvPr></p:nvSpPr><p:spPr/><p:txBody><a:bodyPr/><a:lstStyle/><a:p><a:r><a:rPr lang="en-US" dirty="0"/><a:t>技术选型。如果评委是技术背景，重点讲那条分界线：规则是纯函数、模型只做抽取与措辞。+另外可以提「刻意没引入」那一行——不用图表库、不用组件库、不用数据库，税则是编译期常量，比数据库更适合审计与 diff。</a:t></a:r><a:endParaRPr lang="en-US" dirty="0"/></a:p></p:txBody></p:sp><p:sp><p:nvSpPr><p:cNvPr id="4" name="Slide Number Placeholder 3"/><p:cNvSpPr><a:spLocks noGrp="1"/></p:cNvSpPr><p:nvPr><p:ph type="sldNum" sz="quarter" idx="10"/></p:nvPr></p:nvSpPr><p:spPr/><p:txBody><a:bodyPr/><a:lstStyle/><a:p><a:fld id="{F7021451-1387-4CA6-816F-3879F97B5CBC}" type="slidenum"><a:rPr lang="en-US"/><a:t>20</a:t></a:fld><a:endParaRPr lang="en-US"/></a:p></p:txBody></p:sp></p:spTree><p:extLst><p:ext uri="{BB962C8B-B14F-4D97-AF65-F5344CB8AC3E}"><p14:creationId xmlns:p14="http://schemas.microsoft.com/office/powerpoint/2010/main" val="1024086991"/></p:ext></p:extLst></p:cSld><p:clrMapOvr><a:masterClrMapping/></p:clrMapOvr></p:notes>
 </file>
 
 <file path=ppt/notesSlides/notesSlide21.xml><?xml version="1.0" encoding="utf-8"?>
@@ -1674,7 +776,7 @@
           <a:p>
             <a:r>
               <a:rPr lang="en-US" dirty="0"/>
-              <a:t/>
+              <a:t>线上体验可以直接让评委扫码打开自己点。仓库是公开的，Topic 是 #Guikesong。</a:t>
             </a:r>
             <a:endParaRPr lang="en-US" dirty="0"/>
           </a:p>
@@ -1716,628 +818,76 @@
 </p:notes>
 </file>
 
-<file path=ppt/notesSlides/notesSlide3.xml><?xml version="1.0" encoding="utf-8"?>
-<p:notes xmlns:a="http://schemas.openxmlformats.org/drawingml/2006/main" xmlns:r="http://schemas.openxmlformats.org/officeDocument/2006/relationships" xmlns:p="http://schemas.openxmlformats.org/presentationml/2006/main">
-  <p:cSld>
-    <p:spTree>
-      <p:nvGrpSpPr>
-        <p:cNvPr id="1" name=""/>
-        <p:cNvGrpSpPr/>
-        <p:nvPr/>
-      </p:nvGrpSpPr>
-      <p:grpSpPr>
-        <a:xfrm>
-          <a:off x="0" y="0"/>
-          <a:ext cx="0" cy="0"/>
-          <a:chOff x="0" y="0"/>
-          <a:chExt cx="0" cy="0"/>
-        </a:xfrm>
-      </p:grpSpPr>
-      <p:sp>
-        <p:nvSpPr>
-          <p:cNvPr id="2" name="Slide Image Placeholder 1"/>
-          <p:cNvSpPr>
-            <a:spLocks noGrp="1" noRot="1" noChangeAspect="1"/>
-          </p:cNvSpPr>
-          <p:nvPr>
-            <p:ph type="sldImg"/>
-          </p:nvPr>
-        </p:nvSpPr>
-        <p:spPr/>
-      </p:sp>
-      <p:sp>
-        <p:nvSpPr>
-          <p:cNvPr id="3" name="Notes Placeholder 2"/>
-          <p:cNvSpPr>
-            <a:spLocks noGrp="1"/>
-          </p:cNvSpPr>
-          <p:nvPr>
-            <p:ph type="body" idx="1"/>
-          </p:nvPr>
-        </p:nvSpPr>
-        <p:spPr/>
-        <p:txBody>
-          <a:bodyPr/>
-          <a:lstStyle/>
-          <a:p>
-            <a:r>
-              <a:rPr lang="en-US" dirty="0"/>
-              <a:t>（0:55–1:20）中小酒企没有海外团队。展会散场，手上十几张名片，他真正的问题只有三个，而市面上的工具一个都没答。</a:t>
-            </a:r>
-            <a:endParaRPr lang="en-US" dirty="0"/>
-          </a:p>
-        </p:txBody>
-      </p:sp>
-      <p:sp>
-        <p:nvSpPr>
-          <p:cNvPr id="4" name="Slide Number Placeholder 3"/>
-          <p:cNvSpPr>
-            <a:spLocks noGrp="1"/>
-          </p:cNvSpPr>
-          <p:nvPr>
-            <p:ph type="sldNum" sz="quarter" idx="10"/>
-          </p:nvPr>
-        </p:nvSpPr>
-        <p:spPr/>
-        <p:txBody>
-          <a:bodyPr/>
-          <a:lstStyle/>
-          <a:p>
-            <a:fld id="{F7021451-1387-4CA6-816F-3879F97B5CBC}" type="slidenum">
-              <a:rPr lang="en-US"/>
-              <a:t>3</a:t>
-            </a:fld>
-            <a:endParaRPr lang="en-US"/>
-          </a:p>
-        </p:txBody>
-      </p:sp>
-    </p:spTree>
-    <p:extLst>
-      <p:ext uri="{BB962C8B-B14F-4D97-AF65-F5344CB8AC3E}">
-        <p14:creationId xmlns:p14="http://schemas.microsoft.com/office/powerpoint/2010/main" val="1024086991"/>
-      </p:ext>
-    </p:extLst>
-  </p:cSld>
-  <p:clrMapOvr>
-    <a:masterClrMapping/>
-  </p:clrMapOvr>
-</p:notes>
+<file path=ppt/notesSlides/notesSlide3.xml><?xml version="1.0" encoding="UTF-8" standalone="yes"?>
+<p:notes xmlns:a="http://schemas.openxmlformats.org/drawingml/2006/main" xmlns:r="http://schemas.openxmlformats.org/officeDocument/2006/relationships" xmlns:p="http://schemas.openxmlformats.org/presentationml/2006/main"><p:cSld><p:spTree><p:nvGrpSpPr><p:cNvPr id="1" name=""/><p:cNvGrpSpPr/><p:nvPr/></p:nvGrpSpPr><p:grpSpPr><a:xfrm><a:off x="0" y="0"/><a:ext cx="0" cy="0"/><a:chOff x="0" y="0"/><a:chExt cx="0" cy="0"/></a:xfrm></p:grpSpPr><p:sp><p:nvSpPr><p:cNvPr id="2" name="Slide Image Placeholder 1"/><p:cNvSpPr><a:spLocks noGrp="1" noRot="1" noChangeAspect="1"/></p:cNvSpPr><p:nvPr><p:ph type="sldImg"/></p:nvPr></p:nvSpPr><p:spPr/></p:sp><p:sp><p:nvSpPr><p:cNvPr id="3" name="Notes Placeholder 2"/><p:cNvSpPr><a:spLocks noGrp="1"/></p:cNvSpPr><p:nvPr><p:ph type="body" idx="1"/></p:nvPr></p:nvSpPr><p:spPr/><p:txBody><a:bodyPr/><a:lstStyle/><a:p><a:r><a:rPr lang="en-US" dirty="0"/><a:t>（0:55–1:20）+卡住的地方不在酿酒，在酿完之后。+中小酒企没有海外团队。展会散场，业务员手上十几张名片，+他真正的问题只有三个：+这个买家是真想卖酒，还是在做税差？+这瓶酒到他货架上要卖多少钱？+第一份合同该写死哪几条？+这三个问题，市面上的工具一个都没答。</a:t></a:r><a:endParaRPr lang="en-US" dirty="0"/></a:p></p:txBody></p:sp><p:sp><p:nvSpPr><p:cNvPr id="4" name="Slide Number Placeholder 3"/><p:cNvSpPr><a:spLocks noGrp="1"/></p:cNvSpPr><p:nvPr><p:ph type="sldNum" sz="quarter" idx="10"/></p:nvPr></p:nvSpPr><p:spPr/><p:txBody><a:bodyPr/><a:lstStyle/><a:p><a:fld id="{F7021451-1387-4CA6-816F-3879F97B5CBC}" type="slidenum"><a:rPr lang="en-US"/><a:t>3</a:t></a:fld><a:endParaRPr lang="en-US"/></a:p></p:txBody></p:sp></p:spTree><p:extLst><p:ext uri="{BB962C8B-B14F-4D97-AF65-F5344CB8AC3E}"><p14:creationId xmlns:p14="http://schemas.microsoft.com/office/powerpoint/2010/main" val="1024086991"/></p:ext></p:extLst></p:cSld><p:clrMapOvr><a:masterClrMapping/></p:clrMapOvr></p:notes>
 </file>
 
-<file path=ppt/notesSlides/notesSlide4.xml><?xml version="1.0" encoding="utf-8"?>
-<p:notes xmlns:a="http://schemas.openxmlformats.org/drawingml/2006/main" xmlns:r="http://schemas.openxmlformats.org/officeDocument/2006/relationships" xmlns:p="http://schemas.openxmlformats.org/presentationml/2006/main">
-  <p:cSld>
-    <p:spTree>
-      <p:nvGrpSpPr>
-        <p:cNvPr id="1" name=""/>
-        <p:cNvGrpSpPr/>
-        <p:nvPr/>
-      </p:nvGrpSpPr>
-      <p:grpSpPr>
-        <a:xfrm>
-          <a:off x="0" y="0"/>
-          <a:ext cx="0" cy="0"/>
-          <a:chOff x="0" y="0"/>
-          <a:chExt cx="0" cy="0"/>
-        </a:xfrm>
-      </p:grpSpPr>
-      <p:sp>
-        <p:nvSpPr>
-          <p:cNvPr id="2" name="Slide Image Placeholder 1"/>
-          <p:cNvSpPr>
-            <a:spLocks noGrp="1" noRot="1" noChangeAspect="1"/>
-          </p:cNvSpPr>
-          <p:nvPr>
-            <p:ph type="sldImg"/>
-          </p:nvPr>
-        </p:nvSpPr>
-        <p:spPr/>
-      </p:sp>
-      <p:sp>
-        <p:nvSpPr>
-          <p:cNvPr id="3" name="Notes Placeholder 2"/>
-          <p:cNvSpPr>
-            <a:spLocks noGrp="1"/>
-          </p:cNvSpPr>
-          <p:nvPr>
-            <p:ph type="body" idx="1"/>
-          </p:nvPr>
-        </p:nvSpPr>
-        <p:spPr/>
-        <p:txBody>
-          <a:bodyPr/>
-          <a:lstStyle/>
-          <a:p>
-            <a:r>
-              <a:rPr lang="en-US" dirty="0"/>
-              <a:t>（1:20–1:50）这是最关键的一页。
-套利型买家要的从来不是这瓶酒，是那 33%——消费税 20% 从价出口免征，加增值税退税 13%。
-他把货囤进自贸仓，转手就走，酒根本没上过货架。</a:t>
-            </a:r>
-            <a:endParaRPr lang="en-US" dirty="0"/>
-          </a:p>
-        </p:txBody>
-      </p:sp>
-      <p:sp>
-        <p:nvSpPr>
-          <p:cNvPr id="4" name="Slide Number Placeholder 3"/>
-          <p:cNvSpPr>
-            <a:spLocks noGrp="1"/>
-          </p:cNvSpPr>
-          <p:nvPr>
-            <p:ph type="sldNum" sz="quarter" idx="10"/>
-          </p:nvPr>
-        </p:nvSpPr>
-        <p:spPr/>
-        <p:txBody>
-          <a:bodyPr/>
-          <a:lstStyle/>
-          <a:p>
-            <a:fld id="{F7021451-1387-4CA6-816F-3879F97B5CBC}" type="slidenum">
-              <a:rPr lang="en-US"/>
-              <a:t>4</a:t>
-            </a:fld>
-            <a:endParaRPr lang="en-US"/>
-          </a:p>
-        </p:txBody>
-      </p:sp>
-    </p:spTree>
-    <p:extLst>
-      <p:ext uri="{BB962C8B-B14F-4D97-AF65-F5344CB8AC3E}">
-        <p14:creationId xmlns:p14="http://schemas.microsoft.com/office/powerpoint/2010/main" val="1024086991"/>
-      </p:ext>
-    </p:extLst>
-  </p:cSld>
-  <p:clrMapOvr>
-    <a:masterClrMapping/>
-  </p:clrMapOvr>
-</p:notes>
+<file path=ppt/notesSlides/notesSlide4.xml><?xml version="1.0" encoding="UTF-8" standalone="yes"?>
+<p:notes xmlns:a="http://schemas.openxmlformats.org/drawingml/2006/main" xmlns:r="http://schemas.openxmlformats.org/officeDocument/2006/relationships" xmlns:p="http://schemas.openxmlformats.org/presentationml/2006/main"><p:cSld><p:spTree><p:nvGrpSpPr><p:cNvPr id="1" name=""/><p:cNvGrpSpPr/><p:nvPr/></p:nvGrpSpPr><p:grpSpPr><a:xfrm><a:off x="0" y="0"/><a:ext cx="0" cy="0"/><a:chOff x="0" y="0"/><a:chExt cx="0" cy="0"/></a:xfrm></p:grpSpPr><p:sp><p:nvSpPr><p:cNvPr id="2" name="Slide Image Placeholder 1"/><p:cNvSpPr><a:spLocks noGrp="1" noRot="1" noChangeAspect="1"/></p:cNvSpPr><p:nvPr><p:ph type="sldImg"/></p:nvPr></p:nvSpPr><p:spPr/></p:sp><p:sp><p:nvSpPr><p:cNvPr id="3" name="Notes Placeholder 2"/><p:cNvSpPr><a:spLocks noGrp="1"/></p:cNvSpPr><p:nvPr><p:ph type="body" idx="1"/></p:nvPr></p:nvSpPr><p:spPr/><p:txBody><a:bodyPr/><a:lstStyle/><a:p><a:r><a:rPr lang="en-US" dirty="0"/><a:t>（1:20–1:55）+先说第一个问题，也是最要命的一个。+[指瓶子]+套利型买家要的，从来不是这瓶酒。+白酒出口，消费税百分之二十从价免征，再加增值税退税百分之十三。+他要的是这百分之三十三。+货囤进自贸仓，转手就走，酒根本没上过货架。+[停一拍]+而你以为你签下了第一个海外经销商。</a:t></a:r><a:endParaRPr lang="en-US" dirty="0"/></a:p></p:txBody></p:sp><p:sp><p:nvSpPr><p:cNvPr id="4" name="Slide Number Placeholder 3"/><p:cNvSpPr><a:spLocks noGrp="1"/></p:cNvSpPr><p:nvPr><p:ph type="sldNum" sz="quarter" idx="10"/></p:nvPr></p:nvSpPr><p:spPr/><p:txBody><a:bodyPr/><a:lstStyle/><a:p><a:fld id="{F7021451-1387-4CA6-816F-3879F97B5CBC}" type="slidenum"><a:rPr lang="en-US"/><a:t>4</a:t></a:fld><a:endParaRPr lang="en-US"/></a:p></p:txBody></p:sp></p:spTree><p:extLst><p:ext uri="{BB962C8B-B14F-4D97-AF65-F5344CB8AC3E}"><p14:creationId xmlns:p14="http://schemas.microsoft.com/office/powerpoint/2010/main" val="1024086991"/></p:ext></p:extLst></p:cSld><p:clrMapOvr><a:masterClrMapping/></p:clrMapOvr></p:notes>
 </file>
 
-<file path=ppt/notesSlides/notesSlide5.xml><?xml version="1.0" encoding="utf-8"?>
-<p:notes xmlns:a="http://schemas.openxmlformats.org/drawingml/2006/main" xmlns:r="http://schemas.openxmlformats.org/officeDocument/2006/relationships" xmlns:p="http://schemas.openxmlformats.org/presentationml/2006/main">
-  <p:cSld>
-    <p:spTree>
-      <p:nvGrpSpPr>
-        <p:cNvPr id="1" name=""/>
-        <p:cNvGrpSpPr/>
-        <p:nvPr/>
-      </p:nvGrpSpPr>
-      <p:grpSpPr>
-        <a:xfrm>
-          <a:off x="0" y="0"/>
-          <a:ext cx="0" cy="0"/>
-          <a:chOff x="0" y="0"/>
-          <a:chExt cx="0" cy="0"/>
-        </a:xfrm>
-      </p:grpSpPr>
-      <p:sp>
-        <p:nvSpPr>
-          <p:cNvPr id="2" name="Slide Image Placeholder 1"/>
-          <p:cNvSpPr>
-            <a:spLocks noGrp="1" noRot="1" noChangeAspect="1"/>
-          </p:cNvSpPr>
-          <p:nvPr>
-            <p:ph type="sldImg"/>
-          </p:nvPr>
-        </p:nvSpPr>
-        <p:spPr/>
-      </p:sp>
-      <p:sp>
-        <p:nvSpPr>
-          <p:cNvPr id="3" name="Notes Placeholder 2"/>
-          <p:cNvSpPr>
-            <a:spLocks noGrp="1"/>
-          </p:cNvSpPr>
-          <p:nvPr>
-            <p:ph type="body" idx="1"/>
-          </p:nvPr>
-        </p:nvSpPr>
-        <p:spPr/>
-        <p:txBody>
-          <a:bodyPr/>
-          <a:lstStyle/>
-          <a:p>
-            <a:r>
-              <a:rPr lang="en-US" dirty="0"/>
-              <a:t>（1:50–2:15）判断错了代价多少：一柜货值 261 万，卖不掉折价倒回国内亏 78 万。
-更贵的是当地价格体系被打乱，之后没有第二个经销商愿意接。</a:t>
-            </a:r>
-            <a:endParaRPr lang="en-US" dirty="0"/>
-          </a:p>
-        </p:txBody>
-      </p:sp>
-      <p:sp>
-        <p:nvSpPr>
-          <p:cNvPr id="4" name="Slide Number Placeholder 3"/>
-          <p:cNvSpPr>
-            <a:spLocks noGrp="1"/>
-          </p:cNvSpPr>
-          <p:nvPr>
-            <p:ph type="sldNum" sz="quarter" idx="10"/>
-          </p:nvPr>
-        </p:nvSpPr>
-        <p:spPr/>
-        <p:txBody>
-          <a:bodyPr/>
-          <a:lstStyle/>
-          <a:p>
-            <a:fld id="{F7021451-1387-4CA6-816F-3879F97B5CBC}" type="slidenum">
-              <a:rPr lang="en-US"/>
-              <a:t>5</a:t>
-            </a:fld>
-            <a:endParaRPr lang="en-US"/>
-          </a:p>
-        </p:txBody>
-      </p:sp>
-    </p:spTree>
-    <p:extLst>
-      <p:ext uri="{BB962C8B-B14F-4D97-AF65-F5344CB8AC3E}">
-        <p14:creationId xmlns:p14="http://schemas.microsoft.com/office/powerpoint/2010/main" val="1024086991"/>
-      </p:ext>
-    </p:extLst>
-  </p:cSld>
-  <p:clrMapOvr>
-    <a:masterClrMapping/>
-  </p:clrMapOvr>
-</p:notes>
+<file path=ppt/notesSlides/notesSlide5.xml><?xml version="1.0" encoding="UTF-8" standalone="yes"?>
+<p:notes xmlns:a="http://schemas.openxmlformats.org/drawingml/2006/main" xmlns:r="http://schemas.openxmlformats.org/officeDocument/2006/relationships" xmlns:p="http://schemas.openxmlformats.org/presentationml/2006/main"><p:cSld><p:spTree><p:nvGrpSpPr><p:cNvPr id="1" name=""/><p:cNvGrpSpPr/><p:nvPr/></p:nvGrpSpPr><p:grpSpPr><a:xfrm><a:off x="0" y="0"/><a:ext cx="0" cy="0"/><a:chOff x="0" y="0"/><a:chExt cx="0" cy="0"/></a:xfrm></p:grpSpPr><p:sp><p:nvSpPr><p:cNvPr id="2" name="Slide Image Placeholder 1"/><p:cNvSpPr><a:spLocks noGrp="1" noRot="1" noChangeAspect="1"/></p:cNvSpPr><p:nvPr><p:ph type="sldImg"/></p:nvPr></p:nvSpPr><p:spPr/></p:sp><p:sp><p:nvSpPr><p:cNvPr id="3" name="Notes Placeholder 2"/><p:cNvSpPr><a:spLocks noGrp="1"/></p:cNvSpPr><p:nvPr><p:ph type="body" idx="1"/></p:nvPr></p:nvSpPr><p:spPr/><p:txBody><a:bodyPr/><a:lstStyle/><a:p><a:r><a:rPr lang="en-US" dirty="0"/><a:t>（1:55–2:20）+判断错了，代价是多少。+一柜货值两百六十一万，卖不掉折价倒回国内，亏七十八万。+更贵的是——当地价格体系被打乱之后，+你再也找不到第二个愿意接的经销商。+而这些，你要到九十天之后才会知道。</a:t></a:r><a:endParaRPr lang="en-US" dirty="0"/></a:p></p:txBody></p:sp><p:sp><p:nvSpPr><p:cNvPr id="4" name="Slide Number Placeholder 3"/><p:cNvSpPr><a:spLocks noGrp="1"/></p:cNvSpPr><p:nvPr><p:ph type="sldNum" sz="quarter" idx="10"/></p:nvPr></p:nvSpPr><p:spPr/><p:txBody><a:bodyPr/><a:lstStyle/><a:p><a:fld id="{F7021451-1387-4CA6-816F-3879F97B5CBC}" type="slidenum"><a:rPr lang="en-US"/><a:t>5</a:t></a:fld><a:endParaRPr lang="en-US"/></a:p></p:txBody></p:sp></p:spTree><p:extLst><p:ext uri="{BB962C8B-B14F-4D97-AF65-F5344CB8AC3E}"><p14:creationId xmlns:p14="http://schemas.microsoft.com/office/powerpoint/2010/main" val="1024086991"/></p:ext></p:extLst></p:cSld><p:clrMapOvr><a:masterClrMapping/></p:clrMapOvr></p:notes>
 </file>
 
-<file path=ppt/notesSlides/notesSlide6.xml><?xml version="1.0" encoding="utf-8"?>
-<p:notes xmlns:a="http://schemas.openxmlformats.org/drawingml/2006/main" xmlns:r="http://schemas.openxmlformats.org/officeDocument/2006/relationships" xmlns:p="http://schemas.openxmlformats.org/presentationml/2006/main">
-  <p:cSld>
-    <p:spTree>
-      <p:nvGrpSpPr>
-        <p:cNvPr id="1" name=""/>
-        <p:cNvGrpSpPr/>
-        <p:nvPr/>
-      </p:nvGrpSpPr>
-      <p:grpSpPr>
-        <a:xfrm>
-          <a:off x="0" y="0"/>
-          <a:ext cx="0" cy="0"/>
-          <a:chOff x="0" y="0"/>
-          <a:chExt cx="0" cy="0"/>
-        </a:xfrm>
-      </p:grpSpPr>
-      <p:sp>
-        <p:nvSpPr>
-          <p:cNvPr id="2" name="Slide Image Placeholder 1"/>
-          <p:cNvSpPr>
-            <a:spLocks noGrp="1" noRot="1" noChangeAspect="1"/>
-          </p:cNvSpPr>
-          <p:nvPr>
-            <p:ph type="sldImg"/>
-          </p:nvPr>
-        </p:nvSpPr>
-        <p:spPr/>
-      </p:sp>
-      <p:sp>
-        <p:nvSpPr>
-          <p:cNvPr id="3" name="Notes Placeholder 2"/>
-          <p:cNvSpPr>
-            <a:spLocks noGrp="1"/>
-          </p:cNvSpPr>
-          <p:nvPr>
-            <p:ph type="body" idx="1"/>
-          </p:nvPr>
-        </p:nvSpPr>
-        <p:spPr/>
-        <p:txBody>
-          <a:bodyPr/>
-          <a:lstStyle/>
-          <a:p>
-            <a:r>
-              <a:rPr lang="en-US" dirty="0"/>
-              <a:t>（2:15–2:40）产品登场。贴一段微信对话进去，八秒出一份决策简报。
-模型只做一件事——把这段话读成结构。判定不归它管。</a:t>
-            </a:r>
-            <a:endParaRPr lang="en-US" dirty="0"/>
-          </a:p>
-        </p:txBody>
-      </p:sp>
-      <p:sp>
-        <p:nvSpPr>
-          <p:cNvPr id="4" name="Slide Number Placeholder 3"/>
-          <p:cNvSpPr>
-            <a:spLocks noGrp="1"/>
-          </p:cNvSpPr>
-          <p:nvPr>
-            <p:ph type="sldNum" sz="quarter" idx="10"/>
-          </p:nvPr>
-        </p:nvSpPr>
-        <p:spPr/>
-        <p:txBody>
-          <a:bodyPr/>
-          <a:lstStyle/>
-          <a:p>
-            <a:fld id="{F7021451-1387-4CA6-816F-3879F97B5CBC}" type="slidenum">
-              <a:rPr lang="en-US"/>
-              <a:t>6</a:t>
-            </a:fld>
-            <a:endParaRPr lang="en-US"/>
-          </a:p>
-        </p:txBody>
-      </p:sp>
-    </p:spTree>
-    <p:extLst>
-      <p:ext uri="{BB962C8B-B14F-4D97-AF65-F5344CB8AC3E}">
-        <p14:creationId xmlns:p14="http://schemas.microsoft.com/office/powerpoint/2010/main" val="1024086991"/>
-      </p:ext>
-    </p:extLst>
-  </p:cSld>
-  <p:clrMapOvr>
-    <a:masterClrMapping/>
-  </p:clrMapOvr>
-</p:notes>
+<file path=ppt/notesSlides/notesSlide6.xml><?xml version="1.0" encoding="UTF-8" standalone="yes"?>
+<p:notes xmlns:a="http://schemas.openxmlformats.org/drawingml/2006/main" xmlns:r="http://schemas.openxmlformats.org/officeDocument/2006/relationships" xmlns:p="http://schemas.openxmlformats.org/presentationml/2006/main"><p:cSld><p:spTree><p:nvGrpSpPr><p:cNvPr id="1" name=""/><p:cNvGrpSpPr/><p:nvPr/></p:nvGrpSpPr><p:grpSpPr><a:xfrm><a:off x="0" y="0"/><a:ext cx="0" cy="0"/><a:chOff x="0" y="0"/><a:chExt cx="0" cy="0"/></a:xfrm></p:grpSpPr><p:sp><p:nvSpPr><p:cNvPr id="2" name="Slide Image Placeholder 1"/><p:cNvSpPr><a:spLocks noGrp="1" noRot="1" noChangeAspect="1"/></p:cNvSpPr><p:nvPr><p:ph type="sldImg"/></p:nvPr></p:nvSpPr><p:spPr/></p:sp><p:sp><p:nvSpPr><p:cNvPr id="3" name="Notes Placeholder 2"/><p:cNvSpPr><a:spLocks noGrp="1"/></p:cNvSpPr><p:nvPr><p:ph type="body" idx="1"/></p:nvPr></p:nvSpPr><p:spPr/><p:txBody><a:bodyPr/><a:lstStyle/><a:p><a:r><a:rPr lang="en-US" dirty="0"/><a:t>（2:20–2:45）+所以我们做了这个工具。+把展会上那段微信对话，原样贴进去。+八秒钟，出一份可以直接给老板看的决策简报。+[指流程]+模型只做一件事：把这段乱七八糟的话读成结构。+判定不归它管。</a:t></a:r><a:endParaRPr lang="en-US" dirty="0"/></a:p></p:txBody></p:sp><p:sp><p:nvSpPr><p:cNvPr id="4" name="Slide Number Placeholder 3"/><p:cNvSpPr><a:spLocks noGrp="1"/></p:cNvSpPr><p:nvPr><p:ph type="sldNum" sz="quarter" idx="10"/></p:nvPr></p:nvSpPr><p:spPr/><p:txBody><a:bodyPr/><a:lstStyle/><a:p><a:fld id="{F7021451-1387-4CA6-816F-3879F97B5CBC}" type="slidenum"><a:rPr lang="en-US"/><a:t>6</a:t></a:fld><a:endParaRPr lang="en-US"/></a:p></p:txBody></p:sp></p:spTree><p:extLst><p:ext uri="{BB962C8B-B14F-4D97-AF65-F5344CB8AC3E}"><p14:creationId xmlns:p14="http://schemas.microsoft.com/office/powerpoint/2010/main" val="1024086991"/></p:ext></p:extLst></p:cSld><p:clrMapOvr><a:masterClrMapping/></p:clrMapOvr></p:notes>
 </file>
 
-<file path=ppt/notesSlides/notesSlide7.xml><?xml version="1.0" encoding="utf-8"?>
-<p:notes xmlns:a="http://schemas.openxmlformats.org/drawingml/2006/main" xmlns:r="http://schemas.openxmlformats.org/officeDocument/2006/relationships" xmlns:p="http://schemas.openxmlformats.org/presentationml/2006/main">
-  <p:cSld>
-    <p:spTree>
-      <p:nvGrpSpPr>
-        <p:cNvPr id="1" name=""/>
-        <p:cNvGrpSpPr/>
-        <p:nvPr/>
-      </p:nvGrpSpPr>
-      <p:grpSpPr>
-        <a:xfrm>
-          <a:off x="0" y="0"/>
-          <a:ext cx="0" cy="0"/>
-          <a:chOff x="0" y="0"/>
-          <a:chExt cx="0" cy="0"/>
-        </a:xfrm>
-      </p:grpSpPr>
-      <p:sp>
-        <p:nvSpPr>
-          <p:cNvPr id="2" name="Slide Image Placeholder 1"/>
-          <p:cNvSpPr>
-            <a:spLocks noGrp="1" noRot="1" noChangeAspect="1"/>
-          </p:cNvSpPr>
-          <p:nvPr>
-            <p:ph type="sldImg"/>
-          </p:nvPr>
-        </p:nvSpPr>
-        <p:spPr/>
-      </p:sp>
-      <p:sp>
-        <p:nvSpPr>
-          <p:cNvPr id="3" name="Notes Placeholder 2"/>
-          <p:cNvSpPr>
-            <a:spLocks noGrp="1"/>
-          </p:cNvSpPr>
-          <p:nvPr>
-            <p:ph type="body" idx="1"/>
-          </p:nvPr>
-        </p:nvSpPr>
-        <p:spPr/>
-        <p:txBody>
-          <a:bodyPr/>
-          <a:lstStyle/>
-          <a:p>
-            <a:r>
-              <a:rPr lang="en-US" dirty="0"/>
-              <a:t>（2:40–3:05）我们的判定用一瓶酒表示。
-瓶子永远是满的，变的是里面装什么。琥珀是酒，红色是税差，从瓶底把酒顶上来。</a:t>
-            </a:r>
-            <a:endParaRPr lang="en-US" dirty="0"/>
-          </a:p>
-        </p:txBody>
-      </p:sp>
-      <p:sp>
-        <p:nvSpPr>
-          <p:cNvPr id="4" name="Slide Number Placeholder 3"/>
-          <p:cNvSpPr>
-            <a:spLocks noGrp="1"/>
-          </p:cNvSpPr>
-          <p:nvPr>
-            <p:ph type="sldNum" sz="quarter" idx="10"/>
-          </p:nvPr>
-        </p:nvSpPr>
-        <p:spPr/>
-        <p:txBody>
-          <a:bodyPr/>
-          <a:lstStyle/>
-          <a:p>
-            <a:fld id="{F7021451-1387-4CA6-816F-3879F97B5CBC}" type="slidenum">
-              <a:rPr lang="en-US"/>
-              <a:t>7</a:t>
-            </a:fld>
-            <a:endParaRPr lang="en-US"/>
-          </a:p>
-        </p:txBody>
-      </p:sp>
-    </p:spTree>
-    <p:extLst>
-      <p:ext uri="{BB962C8B-B14F-4D97-AF65-F5344CB8AC3E}">
-        <p14:creationId xmlns:p14="http://schemas.microsoft.com/office/powerpoint/2010/main" val="1024086991"/>
-      </p:ext>
-    </p:extLst>
-  </p:cSld>
-  <p:clrMapOvr>
-    <a:masterClrMapping/>
-  </p:clrMapOvr>
-</p:notes>
+<file path=ppt/notesSlides/notesSlide7.xml><?xml version="1.0" encoding="UTF-8" standalone="yes"?>
+<p:notes xmlns:a="http://schemas.openxmlformats.org/drawingml/2006/main" xmlns:r="http://schemas.openxmlformats.org/officeDocument/2006/relationships" xmlns:p="http://schemas.openxmlformats.org/presentationml/2006/main"><p:cSld><p:spTree><p:nvGrpSpPr><p:cNvPr id="1" name=""/><p:cNvGrpSpPr/><p:nvPr/></p:nvGrpSpPr><p:grpSpPr><a:xfrm><a:off x="0" y="0"/><a:ext cx="0" cy="0"/><a:chOff x="0" y="0"/><a:chExt cx="0" cy="0"/></a:xfrm></p:grpSpPr><p:sp><p:nvSpPr><p:cNvPr id="2" name="Slide Image Placeholder 1"/><p:cNvSpPr><a:spLocks noGrp="1" noRot="1" noChangeAspect="1"/></p:cNvSpPr><p:nvPr><p:ph type="sldImg"/></p:nvPr></p:nvSpPr><p:spPr/></p:sp><p:sp><p:nvSpPr><p:cNvPr id="3" name="Notes Placeholder 2"/><p:cNvSpPr><a:spLocks noGrp="1"/></p:cNvSpPr><p:nvPr><p:ph type="body" idx="1"/></p:nvPr></p:nvSpPr><p:spPr/><p:txBody><a:bodyPr/><a:lstStyle/><a:p><a:r><a:rPr lang="en-US" dirty="0"/><a:t>（2:45–3:10）+我们的判定，用一瓶酒来表示。+[指两瓶]+瓶子永远是满的。变的是里面装什么。+左边这瓶装的是酒——他是来买酒的，可以谈。+右边这瓶，红的是税差，从瓶底把酒顶上来了。+这一瓶，不是酒。</a:t></a:r><a:endParaRPr lang="en-US" dirty="0"/></a:p></p:txBody></p:sp><p:sp><p:nvSpPr><p:cNvPr id="4" name="Slide Number Placeholder 3"/><p:cNvSpPr><a:spLocks noGrp="1"/></p:cNvSpPr><p:nvPr><p:ph type="sldNum" sz="quarter" idx="10"/></p:nvPr></p:nvSpPr><p:spPr/><p:txBody><a:bodyPr/><a:lstStyle/><a:p><a:fld id="{F7021451-1387-4CA6-816F-3879F97B5CBC}" type="slidenum"><a:rPr lang="en-US"/><a:t>7</a:t></a:fld><a:endParaRPr lang="en-US"/></a:p></p:txBody></p:sp></p:spTree><p:extLst><p:ext uri="{BB962C8B-B14F-4D97-AF65-F5344CB8AC3E}"><p14:creationId xmlns:p14="http://schemas.microsoft.com/office/powerpoint/2010/main" val="1024086991"/></p:ext></p:extLst></p:cSld><p:clrMapOvr><a:masterClrMapping/></p:clrMapOvr></p:notes>
 </file>
 
-<file path=ppt/notesSlides/notesSlide8.xml><?xml version="1.0" encoding="utf-8"?>
-<p:notes xmlns:a="http://schemas.openxmlformats.org/drawingml/2006/main" xmlns:r="http://schemas.openxmlformats.org/officeDocument/2006/relationships" xmlns:p="http://schemas.openxmlformats.org/presentationml/2006/main">
-  <p:cSld>
-    <p:spTree>
-      <p:nvGrpSpPr>
-        <p:cNvPr id="1" name=""/>
-        <p:cNvGrpSpPr/>
-        <p:nvPr/>
-      </p:nvGrpSpPr>
-      <p:grpSpPr>
-        <a:xfrm>
-          <a:off x="0" y="0"/>
-          <a:ext cx="0" cy="0"/>
-          <a:chOff x="0" y="0"/>
-          <a:chExt cx="0" cy="0"/>
-        </a:xfrm>
-      </p:grpSpPr>
-      <p:sp>
-        <p:nvSpPr>
-          <p:cNvPr id="2" name="Slide Image Placeholder 1"/>
-          <p:cNvSpPr>
-            <a:spLocks noGrp="1" noRot="1" noChangeAspect="1"/>
-          </p:cNvSpPr>
-          <p:nvPr>
-            <p:ph type="sldImg"/>
-          </p:nvPr>
-        </p:nvSpPr>
-        <p:spPr/>
-      </p:sp>
-      <p:sp>
-        <p:nvSpPr>
-          <p:cNvPr id="3" name="Notes Placeholder 2"/>
-          <p:cNvSpPr>
-            <a:spLocks noGrp="1"/>
-          </p:cNvSpPr>
-          <p:nvPr>
-            <p:ph type="body" idx="1"/>
-          </p:nvPr>
-        </p:nvSpPr>
-        <p:spPr/>
-        <p:txBody>
-          <a:bodyPr/>
-          <a:lstStyle/>
-          <a:p>
-            <a:r>
-              <a:rPr lang="en-US" dirty="0"/>
-              <a:t>（3:05–3:30）六个页签，一页回答一个问题。业务员站在展位上，需要的是六个答案，不是一篇文章。
-（现场 demo 就走这六页）</a:t>
-            </a:r>
-            <a:endParaRPr lang="en-US" dirty="0"/>
-          </a:p>
-        </p:txBody>
-      </p:sp>
-      <p:sp>
-        <p:nvSpPr>
-          <p:cNvPr id="4" name="Slide Number Placeholder 3"/>
-          <p:cNvSpPr>
-            <a:spLocks noGrp="1"/>
-          </p:cNvSpPr>
-          <p:nvPr>
-            <p:ph type="sldNum" sz="quarter" idx="10"/>
-          </p:nvPr>
-        </p:nvSpPr>
-        <p:spPr/>
-        <p:txBody>
-          <a:bodyPr/>
-          <a:lstStyle/>
-          <a:p>
-            <a:fld id="{F7021451-1387-4CA6-816F-3879F97B5CBC}" type="slidenum">
-              <a:rPr lang="en-US"/>
-              <a:t>8</a:t>
-            </a:fld>
-            <a:endParaRPr lang="en-US"/>
-          </a:p>
-        </p:txBody>
-      </p:sp>
-    </p:spTree>
-    <p:extLst>
-      <p:ext uri="{BB962C8B-B14F-4D97-AF65-F5344CB8AC3E}">
-        <p14:creationId xmlns:p14="http://schemas.microsoft.com/office/powerpoint/2010/main" val="1024086991"/>
-      </p:ext>
-    </p:extLst>
-  </p:cSld>
-  <p:clrMapOvr>
-    <a:masterClrMapping/>
-  </p:clrMapOvr>
-</p:notes>
+<file path=ppt/notesSlides/notesSlide8.xml><?xml version="1.0" encoding="UTF-8" standalone="yes"?>
+<p:notes xmlns:a="http://schemas.openxmlformats.org/drawingml/2006/main" xmlns:r="http://schemas.openxmlformats.org/officeDocument/2006/relationships" xmlns:p="http://schemas.openxmlformats.org/presentationml/2006/main"><p:cSld><p:spTree><p:nvGrpSpPr><p:cNvPr id="1" name=""/><p:cNvGrpSpPr/><p:nvPr/></p:nvGrpSpPr><p:grpSpPr><a:xfrm><a:off x="0" y="0"/><a:ext cx="0" cy="0"/><a:chOff x="0" y="0"/><a:chExt cx="0" cy="0"/></a:xfrm></p:grpSpPr><p:sp><p:nvSpPr><p:cNvPr id="2" name="Slide Image Placeholder 1"/><p:cNvSpPr><a:spLocks noGrp="1" noRot="1" noChangeAspect="1"/></p:cNvSpPr><p:nvPr><p:ph type="sldImg"/></p:nvPr></p:nvSpPr><p:spPr/></p:sp><p:sp><p:nvSpPr><p:cNvPr id="3" name="Notes Placeholder 2"/><p:cNvSpPr><a:spLocks noGrp="1"/></p:cNvSpPr><p:nvPr><p:ph type="body" idx="1"/></p:nvPr></p:nvSpPr><p:spPr/><p:txBody><a:bodyPr/><a:lstStyle/><a:p><a:r><a:rPr lang="en-US" dirty="0"/><a:t>（3:10–3:35）+展开是六个页签，一页回答一个问题。+[逐个点]+该不该做、凭什么这么判、这瓶酒卖多少钱、+他有没有牌照、怎么跟他讲、合同和之后九十天怎么盯。+业务员站在展位上，需要的是六个答案，不是一篇报告。+[这里切到现场 demo]</a:t></a:r><a:endParaRPr lang="en-US" dirty="0"/></a:p></p:txBody></p:sp><p:sp><p:nvSpPr><p:cNvPr id="4" name="Slide Number Placeholder 3"/><p:cNvSpPr><a:spLocks noGrp="1"/></p:cNvSpPr><p:nvPr><p:ph type="sldNum" sz="quarter" idx="10"/></p:nvPr></p:nvSpPr><p:spPr/><p:txBody><a:bodyPr/><a:lstStyle/><a:p><a:fld id="{F7021451-1387-4CA6-816F-3879F97B5CBC}" type="slidenum"><a:rPr lang="en-US"/><a:t>8</a:t></a:fld><a:endParaRPr lang="en-US"/></a:p></p:txBody></p:sp></p:spTree><p:extLst><p:ext uri="{BB962C8B-B14F-4D97-AF65-F5344CB8AC3E}"><p14:creationId xmlns:p14="http://schemas.microsoft.com/office/powerpoint/2010/main" val="1024086991"/></p:ext></p:extLst></p:cSld><p:clrMapOvr><a:masterClrMapping/></p:clrMapOvr></p:notes>
 </file>
 
-<file path=ppt/notesSlides/notesSlide9.xml><?xml version="1.0" encoding="utf-8"?>
-<p:notes xmlns:a="http://schemas.openxmlformats.org/drawingml/2006/main" xmlns:r="http://schemas.openxmlformats.org/officeDocument/2006/relationships" xmlns:p="http://schemas.openxmlformats.org/presentationml/2006/main">
-  <p:cSld>
-    <p:spTree>
-      <p:nvGrpSpPr>
-        <p:cNvPr id="1" name=""/>
-        <p:cNvGrpSpPr/>
-        <p:nvPr/>
-      </p:nvGrpSpPr>
-      <p:grpSpPr>
-        <a:xfrm>
-          <a:off x="0" y="0"/>
-          <a:ext cx="0" cy="0"/>
-          <a:chOff x="0" y="0"/>
-          <a:chExt cx="0" cy="0"/>
-        </a:xfrm>
-      </p:grpSpPr>
-      <p:sp>
-        <p:nvSpPr>
-          <p:cNvPr id="2" name="Slide Image Placeholder 1"/>
-          <p:cNvSpPr>
-            <a:spLocks noGrp="1" noRot="1" noChangeAspect="1"/>
-          </p:cNvSpPr>
-          <p:nvPr>
-            <p:ph type="sldImg"/>
-          </p:nvPr>
-        </p:nvSpPr>
-        <p:spPr/>
-      </p:sp>
-      <p:sp>
-        <p:nvSpPr>
-          <p:cNvPr id="3" name="Notes Placeholder 2"/>
-          <p:cNvSpPr>
-            <a:spLocks noGrp="1"/>
-          </p:cNvSpPr>
-          <p:nvPr>
-            <p:ph type="body" idx="1"/>
-          </p:nvPr>
-        </p:nvSpPr>
-        <p:spPr/>
-        <p:txBody>
-          <a:bodyPr/>
-          <a:lstStyle/>
-          <a:p>
-            <a:r>
-              <a:rPr lang="en-US" dirty="0"/>
-              <a:t>（3:30–4:00）三个通用大模型不会告诉你的细节，全是我们翻税则翻出来的：
-香港减税只减 200 港币以上那部分；新加坡按纯酒精量收，降度数等于直接少缴税；
-美国 CBMA 额度必须由中国生产商主动指派，进口商自己拿不到——约 10.7 元一瓶，一柜十几万，不花你一毛钱。</a:t>
-            </a:r>
-            <a:endParaRPr lang="en-US" dirty="0"/>
-          </a:p>
-        </p:txBody>
-      </p:sp>
-      <p:sp>
-        <p:nvSpPr>
-          <p:cNvPr id="4" name="Slide Number Placeholder 3"/>
-          <p:cNvSpPr>
-            <a:spLocks noGrp="1"/>
-          </p:cNvSpPr>
-          <p:nvPr>
-            <p:ph type="sldNum" sz="quarter" idx="10"/>
-          </p:nvPr>
-        </p:nvSpPr>
-        <p:spPr/>
-        <p:txBody>
-          <a:bodyPr/>
-          <a:lstStyle/>
-          <a:p>
-            <a:fld id="{F7021451-1387-4CA6-816F-3879F97B5CBC}" type="slidenum">
-              <a:rPr lang="en-US"/>
-              <a:t>9</a:t>
-            </a:fld>
-            <a:endParaRPr lang="en-US"/>
-          </a:p>
-        </p:txBody>
-      </p:sp>
-    </p:spTree>
-    <p:extLst>
-      <p:ext uri="{BB962C8B-B14F-4D97-AF65-F5344CB8AC3E}">
-        <p14:creationId xmlns:p14="http://schemas.microsoft.com/office/powerpoint/2010/main" val="1024086991"/>
-      </p:ext>
-    </p:extLst>
-  </p:cSld>
-  <p:clrMapOvr>
-    <a:masterClrMapping/>
-  </p:clrMapOvr>
-</p:notes>
+<file path=ppt/notesSlides/notesSlide9.xml><?xml version="1.0" encoding="UTF-8" standalone="yes"?>
+<p:notes xmlns:a="http://schemas.openxmlformats.org/drawingml/2006/main" xmlns:r="http://schemas.openxmlformats.org/officeDocument/2006/relationships" xmlns:p="http://schemas.openxmlformats.org/presentationml/2006/main"><p:cSld><p:spTree><p:nvGrpSpPr><p:cNvPr id="1" name=""/><p:cNvGrpSpPr/><p:nvPr/></p:nvGrpSpPr><p:grpSpPr><a:xfrm><a:off x="0" y="0"/><a:ext cx="0" cy="0"/><a:chOff x="0" y="0"/><a:chExt cx="0" cy="0"/></a:xfrm></p:grpSpPr><p:sp><p:nvSpPr><p:cNvPr id="2" name="Slide Image Placeholder 1"/><p:cNvSpPr><a:spLocks noGrp="1" noRot="1" noChangeAspect="1"/></p:cNvSpPr><p:nvPr><p:ph type="sldImg"/></p:nvPr></p:nvSpPr><p:spPr/></p:sp><p:sp><p:nvSpPr><p:cNvPr id="3" name="Notes Placeholder 2"/><p:cNvSpPr><a:spLocks noGrp="1"/></p:cNvSpPr><p:nvPr><p:ph type="body" idx="1"/></p:nvPr></p:nvSpPr><p:spPr/><p:txBody><a:bodyPr/><a:lstStyle/><a:p><a:r><a:rPr lang="en-US" dirty="0"/><a:t>（3:35–4:05）+为什么不直接问通用大模型？+因为这三条它不会告诉你，是我们逐条翻税则翻出来的：+香港烈酒减税，只减两百港币以上的那一部分。+新加坡按纯酒精量课税——降度数，等于直接少缴税。+美国的 CBMA 额度，必须由中国生产商主动指派，进口商自己拿不到。+一瓶差十块七，一柜十几万，不花你一毛钱。</a:t></a:r><a:endParaRPr lang="en-US" dirty="0"/></a:p></p:txBody></p:sp><p:sp><p:nvSpPr><p:cNvPr id="4" name="Slide Number Placeholder 3"/><p:cNvSpPr><a:spLocks noGrp="1"/></p:cNvSpPr><p:nvPr><p:ph type="sldNum" sz="quarter" idx="10"/></p:nvPr></p:nvSpPr><p:spPr/><p:txBody><a:bodyPr/><a:lstStyle/><a:p><a:fld id="{F7021451-1387-4CA6-816F-3879F97B5CBC}" type="slidenum"><a:rPr lang="en-US"/><a:t>9</a:t></a:fld><a:endParaRPr lang="en-US"/></a:p></p:txBody></p:sp></p:spTree><p:extLst><p:ext uri="{BB962C8B-B14F-4D97-AF65-F5344CB8AC3E}"><p14:creationId xmlns:p14="http://schemas.microsoft.com/office/powerpoint/2010/main" val="1024086991"/></p:ext></p:extLst></p:cSld><p:clrMapOvr><a:masterClrMapping/></p:clrMapOvr></p:notes>
 </file>
 
 <file path=ppt/slideLayouts/slideLayout1.xml><?xml version="1.0" encoding="utf-8"?>

</xml_diff>

<commit_message>
docs: write the roadshow script as an argument, not a list of bullets
The previous notes said what each slide was about; they did not give
anyone something to say. This is the real thing: 1,320 spoken characters
timed at roughly 260 a minute, which is 5:04, with a per-slide budget so
nobody discovers on stage that slide two runs long.

The substance comes from material already in the repo but absent from
the script — the two demo conversations quoted verbatim, so the
arbitrage buyer and the real distributor are contrasted in their own
words rather than described; the barrier 遵义 itself named (spirits are
a controlled good, the importer needs a licence), which is why the pool
of prospects is closed rather than merely small; and why 33% is the
number a buyer chases even when the wine never reaches a shelf.

Each slide also carries an optional paragraph to drop in when the clock
allows, and the Q&A pages now say how to answer and which trap to avoid,
rather than restating the slide.
</commit_message>
<xml_diff>
--- a/docs/第二单_SecondOrder_路演.pptx
+++ b/docs/第二单_SecondOrder_路演.pptx
@@ -477,36 +477,47 @@
 </file>
 
 <file path=ppt/notesSlides/notesSlide1.xml><?xml version="1.0" encoding="UTF-8" standalone="yes"?>
-<p:notes xmlns:a="http://schemas.openxmlformats.org/drawingml/2006/main" xmlns:r="http://schemas.openxmlformats.org/officeDocument/2006/relationships" xmlns:p="http://schemas.openxmlformats.org/presentationml/2006/main"><p:cSld><p:spTree><p:nvGrpSpPr><p:cNvPr id="1" name=""/><p:cNvGrpSpPr/><p:nvPr/></p:nvGrpSpPr><p:grpSpPr><a:xfrm><a:off x="0" y="0"/><a:ext cx="0" cy="0"/><a:chOff x="0" y="0"/><a:chExt cx="0" cy="0"/></a:xfrm></p:grpSpPr><p:sp><p:nvSpPr><p:cNvPr id="2" name="Slide Image Placeholder 1"/><p:cNvSpPr><a:spLocks noGrp="1" noRot="1" noChangeAspect="1"/></p:cNvSpPr><p:nvPr><p:ph type="sldImg"/></p:nvPr></p:nvSpPr><p:spPr/></p:sp><p:sp><p:nvSpPr><p:cNvPr id="3" name="Notes Placeholder 2"/><p:cNvSpPr><a:spLocks noGrp="1"/></p:cNvSpPr><p:nvPr><p:ph type="body" idx="1"/></p:nvPr></p:nvSpPr><p:spPr/><p:txBody><a:bodyPr/><a:lstStyle/><a:p><a:r><a:rPr lang="en-US" dirty="0"/><a:t>（0:00–0:20）-[停两秒，让大家先看到标题]+<p:notes xmlns:a="http://schemas.openxmlformats.org/drawingml/2006/main" xmlns:r="http://schemas.openxmlformats.org/officeDocument/2006/relationships" xmlns:p="http://schemas.openxmlformats.org/presentationml/2006/main"><p:cSld><p:spTree><p:nvGrpSpPr><p:cNvPr id="1" name=""/><p:cNvGrpSpPr/><p:nvPr/></p:nvGrpSpPr><p:grpSpPr><a:xfrm><a:off x="0" y="0"/><a:ext cx="0" cy="0"/><a:chOff x="0" y="0"/><a:chExt cx="0" cy="0"/></a:xfrm></p:grpSpPr><p:sp><p:nvSpPr><p:cNvPr id="2" name="Slide Image Placeholder 1"/><p:cNvSpPr><a:spLocks noGrp="1" noRot="1" noChangeAspect="1"/></p:cNvSpPr><p:nvPr><p:ph type="sldImg"/></p:nvPr></p:nvSpPr><p:spPr/></p:sp><p:sp><p:nvSpPr><p:cNvPr id="3" name="Notes Placeholder 2"/><p:cNvSpPr><a:spLocks noGrp="1"/></p:cNvSpPr><p:nvPr><p:ph type="body" idx="1"/></p:nvPr></p:nvSpPr><p:spPr/><p:txBody><a:bodyPr/><a:lstStyle/><a:p><a:r><a:rPr lang="en-US" dirty="0"/><a:t>（0:00–0:18　18 秒　79 字）++[停两秒，让评委先看完标题] 各位评委好。-扫码验茅台真假，大家都会。-[停一拍]-我们做的这个东西，扫的不是酒，是买家。-它叫「第二单」，是给贵州中小酒企外贸专员用的首单决策副驾。</a:t></a:r><a:endParaRPr lang="en-US" dirty="0"/></a:p></p:txBody></p:sp><p:sp><p:nvSpPr><p:cNvPr id="4" name="Slide Number Placeholder 3"/><p:cNvSpPr><a:spLocks noGrp="1"/></p:cNvSpPr><p:nvPr><p:ph type="sldNum" sz="quarter" idx="10"/></p:nvPr></p:nvSpPr><p:spPr/><p:txBody><a:bodyPr/><a:lstStyle/><a:p><a:fld id="{F7021451-1387-4CA6-816F-3879F97B5CBC}" type="slidenum"><a:rPr lang="en-US"/><a:t>1</a:t></a:fld><a:endParaRPr lang="en-US"/></a:p></p:txBody></p:sp></p:spTree><p:extLst><p:ext uri="{BB962C8B-B14F-4D97-AF65-F5344CB8AC3E}"><p14:creationId xmlns:p14="http://schemas.microsoft.com/office/powerpoint/2010/main" val="1024086991"/></p:ext></p:extLst></p:cSld><p:clrMapOvr><a:masterClrMapping/></p:clrMapOvr></p:notes>
+扫码验茅台真假，大家都会。我们做的是同一个动作，方向反过来——+扫的不是酒，是买家。+它叫「第二单」，用户是贵州仁怀、遵义那些没有海外团队的中小酒企。++───── 时间充裕可加 ─────+为什么不是第一单，最后一页会回答。</a:t></a:r><a:endParaRPr lang="en-US" dirty="0"/></a:p></p:txBody></p:sp><p:sp><p:nvSpPr><p:cNvPr id="4" name="Slide Number Placeholder 3"/><p:cNvSpPr><a:spLocks noGrp="1"/></p:cNvSpPr><p:nvPr><p:ph type="sldNum" sz="quarter" idx="10"/></p:nvPr></p:nvSpPr><p:spPr/><p:txBody><a:bodyPr/><a:lstStyle/><a:p><a:fld id="{F7021451-1387-4CA6-816F-3879F97B5CBC}" type="slidenum"><a:rPr lang="en-US"/><a:t>1</a:t></a:fld><a:endParaRPr lang="en-US"/></a:p></p:txBody></p:sp></p:spTree><p:extLst><p:ext uri="{BB962C8B-B14F-4D97-AF65-F5344CB8AC3E}"><p14:creationId xmlns:p14="http://schemas.microsoft.com/office/powerpoint/2010/main" val="1024086991"/></p:ext></p:extLst></p:cSld><p:clrMapOvr><a:masterClrMapping/></p:clrMapOvr></p:notes>
 </file>
 
 <file path=ppt/notesSlides/notesSlide10.xml><?xml version="1.0" encoding="UTF-8" standalone="yes"?>
-<p:notes xmlns:a="http://schemas.openxmlformats.org/drawingml/2006/main" xmlns:r="http://schemas.openxmlformats.org/officeDocument/2006/relationships" xmlns:p="http://schemas.openxmlformats.org/presentationml/2006/main"><p:cSld><p:spTree><p:nvGrpSpPr><p:cNvPr id="1" name=""/><p:cNvGrpSpPr/><p:nvPr/></p:nvGrpSpPr><p:grpSpPr><a:xfrm><a:off x="0" y="0"/><a:ext cx="0" cy="0"/><a:chOff x="0" y="0"/><a:chExt cx="0" cy="0"/></a:xfrm></p:grpSpPr><p:sp><p:nvSpPr><p:cNvPr id="2" name="Slide Image Placeholder 1"/><p:cNvSpPr><a:spLocks noGrp="1" noRot="1" noChangeAspect="1"/></p:cNvSpPr><p:nvPr><p:ph type="sldImg"/></p:nvPr></p:nvSpPr><p:spPr/></p:sp><p:sp><p:nvSpPr><p:cNvPr id="3" name="Notes Placeholder 2"/><p:cNvSpPr><a:spLocks noGrp="1"/></p:cNvSpPr><p:nvPr><p:ph type="body" idx="1"/></p:nvPr></p:nvSpPr><p:spPr/><p:txBody><a:bodyPr/><a:lstStyle/><a:p><a:r><a:rPr lang="en-US" dirty="0"/><a:t>（4:05–4:30）-技术上我们只坚持一件事：规则算账，模型说人话。-税则、牌照、风险评分、合同条款，全部是可审计的纯函数，-同样输入永远同样输出，每一条都带来源和生效日期。-模型只负责它真正擅长的两件事——读懂对话，和写成人话。-所以模型挂了，主链路照样跑完。现场断网也能演示。</a:t></a:r><a:endParaRPr lang="en-US" dirty="0"/></a:p></p:txBody></p:sp><p:sp><p:nvSpPr><p:cNvPr id="4" name="Slide Number Placeholder 3"/><p:cNvSpPr><a:spLocks noGrp="1"/></p:cNvSpPr><p:nvPr><p:ph type="sldNum" sz="quarter" idx="10"/></p:nvPr></p:nvSpPr><p:spPr/><p:txBody><a:bodyPr/><a:lstStyle/><a:p><a:fld id="{F7021451-1387-4CA6-816F-3879F97B5CBC}" type="slidenum"><a:rPr lang="en-US"/><a:t>10</a:t></a:fld><a:endParaRPr lang="en-US"/></a:p></p:txBody></p:sp></p:spTree><p:extLst><p:ext uri="{BB962C8B-B14F-4D97-AF65-F5344CB8AC3E}"><p14:creationId xmlns:p14="http://schemas.microsoft.com/office/powerpoint/2010/main" val="1024086991"/></p:ext></p:extLst></p:cSld><p:clrMapOvr><a:masterClrMapping/></p:clrMapOvr></p:notes>
+<p:notes xmlns:a="http://schemas.openxmlformats.org/drawingml/2006/main" xmlns:r="http://schemas.openxmlformats.org/officeDocument/2006/relationships" xmlns:p="http://schemas.openxmlformats.org/presentationml/2006/main"><p:cSld><p:spTree><p:nvGrpSpPr><p:cNvPr id="1" name=""/><p:cNvGrpSpPr/><p:nvPr/></p:nvGrpSpPr><p:grpSpPr><a:xfrm><a:off x="0" y="0"/><a:ext cx="0" cy="0"/><a:chOff x="0" y="0"/><a:chExt cx="0" cy="0"/></a:xfrm></p:grpSpPr><p:sp><p:nvSpPr><p:cNvPr id="2" name="Slide Image Placeholder 1"/><p:cNvSpPr><a:spLocks noGrp="1" noRot="1" noChangeAspect="1"/></p:cNvSpPr><p:nvPr><p:ph type="sldImg"/></p:nvPr></p:nvSpPr><p:spPr/></p:sp><p:sp><p:nvSpPr><p:cNvPr id="3" name="Notes Placeholder 2"/><p:cNvSpPr><a:spLocks noGrp="1"/></p:cNvSpPr><p:nvPr><p:ph type="body" idx="1"/></p:nvPr></p:nvSpPr><p:spPr/><p:txBody><a:bodyPr/><a:lstStyle/><a:p><a:r><a:rPr lang="en-US" dirty="0"/><a:t>（4:04–4:30　26 秒　121 字）++技术上只坚持一件事：规则算账，模型说人话。+税则、牌照、风险评分、合同条款全是可审计的纯函数，+同样输入永远同样输出，每条都带来源和生效日期。+模型只负责两件事：读懂对话，把结论写成一封能寄出去的信。+所以模型挂了主链路照样跑完，现场断网也演示得完。++───── 时间充裕可加 ─────+日本原本在候选名单里，但公开资料对烈酒税率的表述不够明确，我们宁可不收——收一条不确定的税率，赔上的是整个规则库的可信度。</a:t></a:r><a:endParaRPr lang="en-US" dirty="0"/></a:p></p:txBody></p:sp><p:sp><p:nvSpPr><p:cNvPr id="4" name="Slide Number Placeholder 3"/><p:cNvSpPr><a:spLocks noGrp="1"/></p:cNvSpPr><p:nvPr><p:ph type="sldNum" sz="quarter" idx="10"/></p:nvPr></p:nvSpPr><p:spPr/><p:txBody><a:bodyPr/><a:lstStyle/><a:p><a:fld id="{F7021451-1387-4CA6-816F-3879F97B5CBC}" type="slidenum"><a:rPr lang="en-US"/><a:t>10</a:t></a:fld><a:endParaRPr lang="en-US"/></a:p></p:txBody></p:sp></p:spTree><p:extLst><p:ext uri="{BB962C8B-B14F-4D97-AF65-F5344CB8AC3E}"><p14:creationId xmlns:p14="http://schemas.microsoft.com/office/powerpoint/2010/main" val="1024086991"/></p:ext></p:extLst></p:cSld><p:clrMapOvr><a:masterClrMapping/></p:clrMapOvr></p:notes>
 </file>
 
 <file path=ppt/notesSlides/notesSlide11.xml><?xml version="1.0" encoding="UTF-8" standalone="yes"?>
-<p:notes xmlns:a="http://schemas.openxmlformats.org/drawingml/2006/main" xmlns:r="http://schemas.openxmlformats.org/officeDocument/2006/relationships" xmlns:p="http://schemas.openxmlformats.org/presentationml/2006/main"><p:cSld><p:spTree><p:nvGrpSpPr><p:cNvPr id="1" name=""/><p:cNvGrpSpPr/><p:nvPr/></p:nvGrpSpPr><p:grpSpPr><a:xfrm><a:off x="0" y="0"/><a:ext cx="0" cy="0"/><a:chOff x="0" y="0"/><a:chExt cx="0" cy="0"/></a:xfrm></p:grpSpPr><p:sp><p:nvSpPr><p:cNvPr id="2" name="Slide Image Placeholder 1"/><p:cNvSpPr><a:spLocks noGrp="1" noRot="1" noChangeAspect="1"/></p:cNvSpPr><p:nvPr><p:ph type="sldImg"/></p:nvPr></p:nvSpPr><p:spPr/></p:sp><p:sp><p:nvSpPr><p:cNvPr id="3" name="Notes Placeholder 2"/><p:cNvSpPr><a:spLocks noGrp="1"/></p:cNvSpPr><p:nvPr><p:ph type="body" idx="1"/></p:nvPr></p:nvSpPr><p:spPr/><p:txBody><a:bodyPr/><a:lstStyle/><a:p><a:r><a:rPr lang="en-US" dirty="0"/><a:t>（4:30–4:48）+<p:notes xmlns:a="http://schemas.openxmlformats.org/drawingml/2006/main" xmlns:r="http://schemas.openxmlformats.org/officeDocument/2006/relationships" xmlns:p="http://schemas.openxmlformats.org/presentationml/2006/main"><p:cSld><p:spTree><p:nvGrpSpPr><p:cNvPr id="1" name=""/><p:cNvGrpSpPr/><p:nvPr/></p:nvGrpSpPr><p:grpSpPr><a:xfrm><a:off x="0" y="0"/><a:ext cx="0" cy="0"/><a:chOff x="0" y="0"/><a:chExt cx="0" cy="0"/></a:xfrm></p:grpSpPr><p:sp><p:nvSpPr><p:cNvPr id="2" name="Slide Image Placeholder 1"/><p:cNvSpPr><a:spLocks noGrp="1" noRot="1" noChangeAspect="1"/></p:cNvSpPr><p:nvPr><p:ph type="sldImg"/></p:nvPr></p:nvSpPr><p:spPr/></p:sp><p:sp><p:nvSpPr><p:cNvPr id="3" name="Notes Placeholder 2"/><p:cNvSpPr><a:spLocks noGrp="1"/></p:cNvSpPr><p:nvPr><p:ph type="body" idx="1"/></p:nvPr></p:nvSpPr><p:spPr/><p:txBody><a:bodyPr/><a:lstStyle/><a:p><a:r><a:rPr lang="en-US" dirty="0"/><a:t>（4:30–4:46　16 秒　74 字）+ 接下来一百天，第三步是设计来证伪我们自己的：-跟三家走完一次首单，拿报关单回来验落地价。-误差百分之五以内这工具就能用，-差到百分之二十，税则模型就得重做。</a:t></a:r><a:endParaRPr lang="en-US" dirty="0"/></a:p></p:txBody></p:sp><p:sp><p:nvSpPr><p:cNvPr id="4" name="Slide Number Placeholder 3"/><p:cNvSpPr><a:spLocks noGrp="1"/></p:cNvSpPr><p:nvPr><p:ph type="sldNum" sz="quarter" idx="10"/></p:nvPr></p:nvSpPr><p:spPr/><p:txBody><a:bodyPr/><a:lstStyle/><a:p><a:fld id="{F7021451-1387-4CA6-816F-3879F97B5CBC}" type="slidenum"><a:rPr lang="en-US"/><a:t>11</a:t></a:fld><a:endParaRPr lang="en-US"/></a:p></p:txBody></p:sp></p:spTree><p:extLst><p:ext uri="{BB962C8B-B14F-4D97-AF65-F5344CB8AC3E}"><p14:creationId xmlns:p14="http://schemas.microsoft.com/office/powerpoint/2010/main" val="1024086991"/></p:ext></p:extLst></p:cSld><p:clrMapOvr><a:masterClrMapping/></p:clrMapOvr></p:notes>
+跟三家酒厂走完一次真实首单，拿报关单核对落地价。+误差百分之五以内就能用，差到百分之二十，税则模型得重做。++───── 时间充裕可加 ─────+我们不打算先谈商业模式。先证明能让八十九家里搭上线的从五家变成十家，再谈谁付钱。</a:t></a:r><a:endParaRPr lang="en-US" dirty="0"/></a:p></p:txBody></p:sp><p:sp><p:nvSpPr><p:cNvPr id="4" name="Slide Number Placeholder 3"/><p:cNvSpPr><a:spLocks noGrp="1"/></p:cNvSpPr><p:nvPr><p:ph type="sldNum" sz="quarter" idx="10"/></p:nvPr></p:nvSpPr><p:spPr/><p:txBody><a:bodyPr/><a:lstStyle/><a:p><a:fld id="{F7021451-1387-4CA6-816F-3879F97B5CBC}" type="slidenum"><a:rPr lang="en-US"/><a:t>11</a:t></a:fld><a:endParaRPr lang="en-US"/></a:p></p:txBody></p:sp></p:spTree><p:extLst><p:ext uri="{BB962C8B-B14F-4D97-AF65-F5344CB8AC3E}"><p14:creationId xmlns:p14="http://schemas.microsoft.com/office/powerpoint/2010/main" val="1024086991"/></p:ext></p:extLst></p:cSld><p:clrMapOvr><a:masterClrMapping/></p:clrMapOvr></p:notes>
 </file>
 
 <file path=ppt/notesSlides/notesSlide12.xml><?xml version="1.0" encoding="UTF-8" standalone="yes"?>
-<p:notes xmlns:a="http://schemas.openxmlformats.org/drawingml/2006/main" xmlns:r="http://schemas.openxmlformats.org/officeDocument/2006/relationships" xmlns:p="http://schemas.openxmlformats.org/presentationml/2006/main"><p:cSld><p:spTree><p:nvGrpSpPr><p:cNvPr id="1" name=""/><p:cNvGrpSpPr/><p:nvPr/></p:nvGrpSpPr><p:grpSpPr><a:xfrm><a:off x="0" y="0"/><a:ext cx="0" cy="0"/><a:chOff x="0" y="0"/><a:chExt cx="0" cy="0"/></a:xfrm></p:grpSpPr><p:sp><p:nvSpPr><p:cNvPr id="2" name="Slide Image Placeholder 1"/><p:cNvSpPr><a:spLocks noGrp="1" noRot="1" noChangeAspect="1"/></p:cNvSpPr><p:nvPr><p:ph type="sldImg"/></p:nvPr></p:nvSpPr><p:spPr/></p:sp><p:sp><p:nvSpPr><p:cNvPr id="3" name="Notes Placeholder 2"/><p:cNvSpPr><a:spLocks noGrp="1"/></p:cNvSpPr><p:nvPr><p:ph type="body" idx="1"/></p:nvPr></p:nvSpPr><p:spPr/><p:txBody><a:bodyPr/><a:lstStyle/><a:p><a:r><a:rPr lang="en-US" dirty="0"/><a:t>（4:48–5:00）-最后一句话。-出海不缺第一单。缺的是第二单。+<p:notes xmlns:a="http://schemas.openxmlformats.org/drawingml/2006/main" xmlns:r="http://schemas.openxmlformats.org/officeDocument/2006/relationships" xmlns:p="http://schemas.openxmlformats.org/presentationml/2006/main"><p:cSld><p:spTree><p:nvGrpSpPr><p:cNvPr id="1" name=""/><p:cNvGrpSpPr/><p:nvPr/></p:nvGrpSpPr><p:grpSpPr><a:xfrm><a:off x="0" y="0"/><a:ext cx="0" cy="0"/><a:chOff x="0" y="0"/><a:chExt cx="0" cy="0"/></a:xfrm></p:grpSpPr><p:sp><p:nvSpPr><p:cNvPr id="2" name="Slide Image Placeholder 1"/><p:cNvSpPr><a:spLocks noGrp="1" noRot="1" noChangeAspect="1"/></p:cNvSpPr><p:nvPr><p:ph type="sldImg"/></p:nvPr></p:nvSpPr><p:spPr/></p:sp><p:sp><p:nvSpPr><p:cNvPr id="3" name="Notes Placeholder 2"/><p:cNvSpPr><a:spLocks noGrp="1"/></p:cNvSpPr><p:nvPr><p:ph type="body" idx="1"/></p:nvPr></p:nvSpPr><p:spPr/><p:txBody><a:bodyPr/><a:lstStyle/><a:p><a:r><a:rPr lang="en-US" dirty="0"/><a:t>（4:46–5:00　14 秒　57 字）++最后一句。+出海不缺第一单，缺的是第二单。 货在他仓里没动，他就不会再下单—— 而你到那时才知道，已经晚了九十天。 谢谢。</a:t></a:r><a:endParaRPr lang="en-US" dirty="0"/></a:p></p:txBody></p:sp><p:sp><p:nvSpPr><p:cNvPr id="4" name="Slide Number Placeholder 3"/><p:cNvSpPr><a:spLocks noGrp="1"/></p:cNvSpPr><p:nvPr><p:ph type="sldNum" sz="quarter" idx="10"/></p:nvPr></p:nvSpPr><p:spPr/><p:txBody><a:bodyPr/><a:lstStyle/><a:p><a:fld id="{F7021451-1387-4CA6-816F-3879F97B5CBC}" type="slidenum"><a:rPr lang="en-US"/><a:t>12</a:t></a:fld><a:endParaRPr lang="en-US"/></a:p></p:txBody></p:sp></p:spTree><p:extLst><p:ext uri="{BB962C8B-B14F-4D97-AF65-F5344CB8AC3E}"><p14:creationId xmlns:p14="http://schemas.microsoft.com/office/powerpoint/2010/main" val="1024086991"/></p:ext></p:extLst></p:cSld><p:clrMapOvr><a:masterClrMapping/></p:clrMapOvr></p:notes>
@@ -558,7 +569,7 @@
           <a:p>
             <a:r>
               <a:rPr lang="en-US" dirty="0"/>
-              <a:t>以下不参与五分钟路演。评委提问时直接跳到对应页。</a:t>
+              <a:t>以下九页不参与五分钟路演，评委提问时直接跳到对应页。</a:t>
             </a:r>
             <a:endParaRPr lang="en-US" dirty="0"/>
           </a:p>
@@ -601,293 +612,183 @@
 </file>
 
 <file path=ppt/notesSlides/notesSlide14.xml><?xml version="1.0" encoding="UTF-8" standalone="yes"?>
-<p:notes xmlns:a="http://schemas.openxmlformats.org/drawingml/2006/main" xmlns:r="http://schemas.openxmlformats.org/officeDocument/2006/relationships" xmlns:p="http://schemas.openxmlformats.org/presentationml/2006/main"><p:cSld><p:spTree><p:nvGrpSpPr><p:cNvPr id="1" name=""/><p:cNvGrpSpPr/><p:nvPr/></p:nvGrpSpPr><p:grpSpPr><a:xfrm><a:off x="0" y="0"/><a:ext cx="0" cy="0"/><a:chOff x="0" y="0"/><a:chExt cx="0" cy="0"/></a:xfrm></p:grpSpPr><p:sp><p:nvSpPr><p:cNvPr id="2" name="Slide Image Placeholder 1"/><p:cNvSpPr><a:spLocks noGrp="1" noRot="1" noChangeAspect="1"/></p:cNvSpPr><p:nvPr><p:ph type="sldImg"/></p:nvPr></p:nvSpPr><p:spPr/></p:sp><p:sp><p:nvSpPr><p:cNvPr id="3" name="Notes Placeholder 2"/><p:cNvSpPr><a:spLocks noGrp="1"/></p:cNvSpPr><p:nvPr><p:ph type="body" idx="1"/></p:nvPr></p:nvSpPr><p:spPr/><p:txBody><a:bodyPr/><a:lstStyle/><a:p><a:r><a:rPr lang="en-US" dirty="0"/><a:t>怎么答：不要辩护「我们的数字很准」，直接说「不保证对，保证可查」，然后当场演示 ⓘ 弹出的来源与生效日期。-如果被追问日本／欧盟：坦白说没收，因为公开资料表述不够明确，收一条不确定的税率会毁掉整个规则库的可信度。</a:t></a:r><a:endParaRPr lang="en-US" dirty="0"/></a:p></p:txBody></p:sp><p:sp><p:nvSpPr><p:cNvPr id="4" name="Slide Number Placeholder 3"/><p:cNvSpPr><a:spLocks noGrp="1"/></p:cNvSpPr><p:nvPr><p:ph type="sldNum" sz="quarter" idx="10"/></p:nvPr></p:nvSpPr><p:spPr/><p:txBody><a:bodyPr/><a:lstStyle/><a:p><a:fld id="{F7021451-1387-4CA6-816F-3879F97B5CBC}" type="slidenum"><a:rPr lang="en-US"/><a:t>14</a:t></a:fld><a:endParaRPr lang="en-US"/></a:p></p:txBody></p:sp></p:spTree><p:extLst><p:ext uri="{BB962C8B-B14F-4D97-AF65-F5344CB8AC3E}"><p14:creationId xmlns:p14="http://schemas.microsoft.com/office/powerpoint/2010/main" val="1024086991"/></p:ext></p:extLst></p:cSld><p:clrMapOvr><a:masterClrMapping/></p:clrMapOvr></p:notes>
+<p:notes xmlns:a="http://schemas.openxmlformats.org/drawingml/2006/main" xmlns:r="http://schemas.openxmlformats.org/officeDocument/2006/relationships" xmlns:p="http://schemas.openxmlformats.org/presentationml/2006/main"><p:cSld><p:spTree><p:nvGrpSpPr><p:cNvPr id="1" name=""/><p:cNvGrpSpPr/><p:nvPr/></p:nvGrpSpPr><p:grpSpPr><a:xfrm><a:off x="0" y="0"/><a:ext cx="0" cy="0"/><a:chOff x="0" y="0"/><a:chExt cx="0" cy="0"/></a:xfrm></p:grpSpPr><p:sp><p:nvSpPr><p:cNvPr id="2" name="Slide Image Placeholder 1"/><p:cNvSpPr><a:spLocks noGrp="1" noRot="1" noChangeAspect="1"/></p:cNvSpPr><p:nvPr><p:ph type="sldImg"/></p:nvPr></p:nvSpPr><p:spPr/></p:sp><p:sp><p:nvSpPr><p:cNvPr id="3" name="Notes Placeholder 2"/><p:cNvSpPr><a:spLocks noGrp="1"/></p:cNvSpPr><p:nvPr><p:ph type="body" idx="1"/></p:nvPr></p:nvSpPr><p:spPr/><p:txBody><a:bodyPr/><a:lstStyle/><a:p><a:r><a:rPr lang="en-US" dirty="0"/><a:t>怎么答：不要辩护「我们的数字很准」。+第一句就说「不保证对，保证可查」，然后当场把鼠标移到 ⓘ 上，让他看到来源和生效日期。+如果被追问为什么没收日本或欧盟：公开资料对烈酒税率的表述不够明确，宁可不收——+收一条不确定的税率，赔上的是整个规则库的可信度。这句话本身就是答案。</a:t></a:r><a:endParaRPr lang="en-US" dirty="0"/></a:p></p:txBody></p:sp><p:sp><p:nvSpPr><p:cNvPr id="4" name="Slide Number Placeholder 3"/><p:cNvSpPr><a:spLocks noGrp="1"/></p:cNvSpPr><p:nvPr><p:ph type="sldNum" sz="quarter" idx="10"/></p:nvPr></p:nvSpPr><p:spPr/><p:txBody><a:bodyPr/><a:lstStyle/><a:p><a:fld id="{F7021451-1387-4CA6-816F-3879F97B5CBC}" type="slidenum"><a:rPr lang="en-US"/><a:t>14</a:t></a:fld><a:endParaRPr lang="en-US"/></a:p></p:txBody></p:sp></p:spTree><p:extLst><p:ext uri="{BB962C8B-B14F-4D97-AF65-F5344CB8AC3E}"><p14:creationId xmlns:p14="http://schemas.microsoft.com/office/powerpoint/2010/main" val="1024086991"/></p:ext></p:extLst></p:cSld><p:clrMapOvr><a:masterClrMapping/></p:clrMapOvr></p:notes>
 </file>
 
 <file path=ppt/notesSlides/notesSlide15.xml><?xml version="1.0" encoding="UTF-8" standalone="yes"?>
-<p:notes xmlns:a="http://schemas.openxmlformats.org/drawingml/2006/main" xmlns:r="http://schemas.openxmlformats.org/officeDocument/2006/relationships" xmlns:p="http://schemas.openxmlformats.org/presentationml/2006/main"><p:cSld><p:spTree><p:nvGrpSpPr><p:cNvPr id="1" name=""/><p:cNvGrpSpPr/><p:nvPr/></p:nvGrpSpPr><p:grpSpPr><a:xfrm><a:off x="0" y="0"/><a:ext cx="0" cy="0"/><a:chOff x="0" y="0"/><a:chExt cx="0" cy="0"/></a:xfrm></p:grpSpPr><p:sp><p:nvSpPr><p:cNvPr id="2" name="Slide Image Placeholder 1"/><p:cNvSpPr><a:spLocks noGrp="1" noRot="1" noChangeAspect="1"/></p:cNvSpPr><p:nvPr><p:ph type="sldImg"/></p:nvPr></p:nvSpPr><p:spPr/></p:sp><p:sp><p:nvSpPr><p:cNvPr id="3" name="Notes Placeholder 2"/><p:cNvSpPr><a:spLocks noGrp="1"/></p:cNvSpPr><p:nvPr><p:ph type="body" idx="1"/></p:nvPr></p:nvSpPr><p:spPr/><p:txBody><a:bodyPr/><a:lstStyle/><a:p><a:r><a:rPr lang="en-US" dirty="0"/><a:t>怎么答：这题几乎一定会被问。三个字回答——细节、稳定、可追溯。-最有杀伤力的是当场对比：让评委用手机问通用模型「白酒出口新加坡税负多少」，多半会得到一个区间；我们给的是按纯酒精量算出来的具体数字，附税则出处。</a:t></a:r><a:endParaRPr lang="en-US" dirty="0"/></a:p></p:txBody></p:sp><p:sp><p:nvSpPr><p:cNvPr id="4" name="Slide Number Placeholder 3"/><p:cNvSpPr><a:spLocks noGrp="1"/></p:cNvSpPr><p:nvPr><p:ph type="sldNum" sz="quarter" idx="10"/></p:nvPr></p:nvSpPr><p:spPr/><p:txBody><a:bodyPr/><a:lstStyle/><a:p><a:fld id="{F7021451-1387-4CA6-816F-3879F97B5CBC}" type="slidenum"><a:rPr lang="en-US"/><a:t>15</a:t></a:fld><a:endParaRPr lang="en-US"/></a:p></p:txBody></p:sp></p:spTree><p:extLst><p:ext uri="{BB962C8B-B14F-4D97-AF65-F5344CB8AC3E}"><p14:creationId xmlns:p14="http://schemas.microsoft.com/office/powerpoint/2010/main" val="1024086991"/></p:ext></p:extLst></p:cSld><p:clrMapOvr><a:masterClrMapping/></p:clrMapOvr></p:notes>
+<p:notes xmlns:a="http://schemas.openxmlformats.org/drawingml/2006/main" xmlns:r="http://schemas.openxmlformats.org/officeDocument/2006/relationships" xmlns:p="http://schemas.openxmlformats.org/presentationml/2006/main"><p:cSld><p:spTree><p:nvGrpSpPr><p:cNvPr id="1" name=""/><p:cNvGrpSpPr/><p:nvPr/></p:nvGrpSpPr><p:grpSpPr><a:xfrm><a:off x="0" y="0"/><a:ext cx="0" cy="0"/><a:chOff x="0" y="0"/><a:chExt cx="0" cy="0"/></a:xfrm></p:grpSpPr><p:sp><p:nvSpPr><p:cNvPr id="2" name="Slide Image Placeholder 1"/><p:cNvSpPr><a:spLocks noGrp="1" noRot="1" noChangeAspect="1"/></p:cNvSpPr><p:nvPr><p:ph type="sldImg"/></p:nvPr></p:nvSpPr><p:spPr/></p:sp><p:sp><p:nvSpPr><p:cNvPr id="3" name="Notes Placeholder 2"/><p:cNvSpPr><a:spLocks noGrp="1"/></p:cNvSpPr><p:nvPr><p:ph type="body" idx="1"/></p:nvPr></p:nvSpPr><p:spPr/><p:txBody><a:bodyPr/><a:lstStyle/><a:p><a:r><a:rPr lang="en-US" dirty="0"/><a:t>怎么答：这题几乎一定会被问，准备好三个字——细节、稳定、可追溯。+最有杀伤力的是当场对比：请评委用手机问通用模型「白酒出口新加坡税负多少」，+他多半会得到一个百分之三十到五十的区间；我们给的是按纯酒精量算出的具体数字，附税则出处。+补充：我们不是在跟通用模型比谁更会讲话，是把一个垂直领域的规则翻出来、写死、标上出处。</a:t></a:r><a:endParaRPr lang="en-US" dirty="0"/></a:p></p:txBody></p:sp><p:sp><p:nvSpPr><p:cNvPr id="4" name="Slide Number Placeholder 3"/><p:cNvSpPr><a:spLocks noGrp="1"/></p:cNvSpPr><p:nvPr><p:ph type="sldNum" sz="quarter" idx="10"/></p:nvPr></p:nvSpPr><p:spPr/><p:txBody><a:bodyPr/><a:lstStyle/><a:p><a:fld id="{F7021451-1387-4CA6-816F-3879F97B5CBC}" type="slidenum"><a:rPr lang="en-US"/><a:t>15</a:t></a:fld><a:endParaRPr lang="en-US"/></a:p></p:txBody></p:sp></p:spTree><p:extLst><p:ext uri="{BB962C8B-B14F-4D97-AF65-F5344CB8AC3E}"><p14:creationId xmlns:p14="http://schemas.microsoft.com/office/powerpoint/2010/main" val="1024086991"/></p:ext></p:extLst></p:cSld><p:clrMapOvr><a:masterClrMapping/></p:clrMapOvr></p:notes>
 </file>
 
 <file path=ppt/notesSlides/notesSlide16.xml><?xml version="1.0" encoding="UTF-8" standalone="yes"?>
-<p:notes xmlns:a="http://schemas.openxmlformats.org/drawingml/2006/main" xmlns:r="http://schemas.openxmlformats.org/officeDocument/2006/relationships" xmlns:p="http://schemas.openxmlformats.org/presentationml/2006/main"><p:cSld><p:spTree><p:nvGrpSpPr><p:cNvPr id="1" name=""/><p:cNvGrpSpPr/><p:nvPr/></p:nvGrpSpPr><p:grpSpPr><a:xfrm><a:off x="0" y="0"/><a:ext cx="0" cy="0"/><a:chOff x="0" y="0"/><a:chExt cx="0" cy="0"/></a:xfrm></p:grpSpPr><p:sp><p:nvSpPr><p:cNvPr id="2" name="Slide Image Placeholder 1"/><p:cNvSpPr><a:spLocks noGrp="1" noRot="1" noChangeAspect="1"/></p:cNvSpPr><p:nvPr><p:ph type="sldImg"/></p:nvPr></p:nvSpPr><p:spPr/></p:sp><p:sp><p:nvSpPr><p:cNvPr id="3" name="Notes Placeholder 2"/><p:cNvSpPr><a:spLocks noGrp="1"/></p:cNvSpPr><p:nvPr><p:ph type="body" idx="1"/></p:nvPr></p:nvSpPr><p:spPr/><p:txBody><a:bodyPr/><a:lstStyle/><a:p><a:r><a:rPr lang="en-US" dirty="0"/><a:t>怎么答：不要硬编商业模式。先承认「现在谈还太早」，再给唯一现实的入口——产区服务平台。-如果评委追问「那你们靠什么活」：中小酒企不会为网页付费，会为「少亏一柜」付费，所以第一步是把误差验出来。</a:t></a:r><a:endParaRPr lang="en-US" dirty="0"/></a:p></p:txBody></p:sp><p:sp><p:nvSpPr><p:cNvPr id="4" name="Slide Number Placeholder 3"/><p:cNvSpPr><a:spLocks noGrp="1"/></p:cNvSpPr><p:nvPr><p:ph type="sldNum" sz="quarter" idx="10"/></p:nvPr></p:nvSpPr><p:spPr/><p:txBody><a:bodyPr/><a:lstStyle/><a:p><a:fld id="{F7021451-1387-4CA6-816F-3879F97B5CBC}" type="slidenum"><a:rPr lang="en-US"/><a:t>16</a:t></a:fld><a:endParaRPr lang="en-US"/></a:p></p:txBody></p:sp></p:spTree><p:extLst><p:ext uri="{BB962C8B-B14F-4D97-AF65-F5344CB8AC3E}"><p14:creationId xmlns:p14="http://schemas.microsoft.com/office/powerpoint/2010/main" val="1024086991"/></p:ext></p:extLst></p:cSld><p:clrMapOvr><a:masterClrMapping/></p:clrMapOvr></p:notes>
+<p:notes xmlns:a="http://schemas.openxmlformats.org/drawingml/2006/main" xmlns:r="http://schemas.openxmlformats.org/officeDocument/2006/relationships" xmlns:p="http://schemas.openxmlformats.org/presentationml/2006/main"><p:cSld><p:spTree><p:nvGrpSpPr><p:cNvPr id="1" name=""/><p:cNvGrpSpPr/><p:nvPr/></p:nvGrpSpPr><p:grpSpPr><a:xfrm><a:off x="0" y="0"/><a:ext cx="0" cy="0"/><a:chOff x="0" y="0"/><a:chExt cx="0" cy="0"/></a:xfrm></p:grpSpPr><p:sp><p:nvSpPr><p:cNvPr id="2" name="Slide Image Placeholder 1"/><p:cNvSpPr><a:spLocks noGrp="1" noRot="1" noChangeAspect="1"/></p:cNvSpPr><p:nvPr><p:ph type="sldImg"/></p:nvPr></p:nvSpPr><p:spPr/></p:sp><p:sp><p:nvSpPr><p:cNvPr id="3" name="Notes Placeholder 2"/><p:cNvSpPr><a:spLocks noGrp="1"/></p:cNvSpPr><p:nvPr><p:ph type="body" idx="1"/></p:nvPr></p:nvSpPr><p:spPr/><p:txBody><a:bodyPr/><a:lstStyle/><a:p><a:r><a:rPr lang="en-US" dirty="0"/><a:t>怎么答：不要硬编商业模式，那会显得不诚实。+先承认「现在谈还太早」，再给唯一现实的入口——产区服务平台。+综保区本来就在做外贸陪跑，有预算、有台账、有企业名单，这个工具作为其中一个模块，+比单独卖 SaaS 给中小酒企现实得多。+如果追问「那你们靠什么活」：中小酒企不会为一个网页付费，会为「少亏一柜」付费，+所以第一步是把落地价误差验出来，不是先做定价页。</a:t></a:r><a:endParaRPr lang="en-US" dirty="0"/></a:p></p:txBody></p:sp><p:sp><p:nvSpPr><p:cNvPr id="4" name="Slide Number Placeholder 3"/><p:cNvSpPr><a:spLocks noGrp="1"/></p:cNvSpPr><p:nvPr><p:ph type="sldNum" sz="quarter" idx="10"/></p:nvPr></p:nvSpPr><p:spPr/><p:txBody><a:bodyPr/><a:lstStyle/><a:p><a:fld id="{F7021451-1387-4CA6-816F-3879F97B5CBC}" type="slidenum"><a:rPr lang="en-US"/><a:t>16</a:t></a:fld><a:endParaRPr lang="en-US"/></a:p></p:txBody></p:sp></p:spTree><p:extLst><p:ext uri="{BB962C8B-B14F-4D97-AF65-F5344CB8AC3E}"><p14:creationId xmlns:p14="http://schemas.microsoft.com/office/powerpoint/2010/main" val="1024086991"/></p:ext></p:extLst></p:cSld><p:clrMapOvr><a:masterClrMapping/></p:clrMapOvr></p:notes>
 </file>
 
 <file path=ppt/notesSlides/notesSlide17.xml><?xml version="1.0" encoding="UTF-8" standalone="yes"?>
-<p:notes xmlns:a="http://schemas.openxmlformats.org/drawingml/2006/main" xmlns:r="http://schemas.openxmlformats.org/officeDocument/2006/relationships" xmlns:p="http://schemas.openxmlformats.org/presentationml/2006/main"><p:cSld><p:spTree><p:nvGrpSpPr><p:cNvPr id="1" name=""/><p:cNvGrpSpPr/><p:nvPr/></p:nvGrpSpPr><p:grpSpPr><a:xfrm><a:off x="0" y="0"/><a:ext cx="0" cy="0"/><a:chOff x="0" y="0"/><a:chExt cx="0" cy="0"/></a:xfrm></p:grpSpPr><p:sp><p:nvSpPr><p:cNvPr id="2" name="Slide Image Placeholder 1"/><p:cNvSpPr><a:spLocks noGrp="1" noRot="1" noChangeAspect="1"/></p:cNvSpPr><p:nvPr><p:ph type="sldImg"/></p:nvPr></p:nvSpPr><p:spPr/></p:sp><p:sp><p:nvSpPr><p:cNvPr id="3" name="Notes Placeholder 2"/><p:cNvSpPr><a:spLocks noGrp="1"/></p:cNvSpPr><p:nvPr><p:ph type="body" idx="1"/></p:nvPr></p:nvSpPr><p:spPr/><p:txBody><a:bodyPr/><a:lstStyle/><a:p><a:r><a:rPr lang="en-US" dirty="0"/><a:t>怎么答：分两层——官方公开资料（税则牌照）和团队自建数据库（品项与用法，每条标注证据强度）。-强调五十六支贵州白酒是逐支核过的，不是抓的。</a:t></a:r><a:endParaRPr lang="en-US" dirty="0"/></a:p></p:txBody></p:sp><p:sp><p:nvSpPr><p:cNvPr id="4" name="Slide Number Placeholder 3"/><p:cNvSpPr><a:spLocks noGrp="1"/></p:cNvSpPr><p:nvPr><p:ph type="sldNum" sz="quarter" idx="10"/></p:nvPr></p:nvSpPr><p:spPr/><p:txBody><a:bodyPr/><a:lstStyle/><a:p><a:fld id="{F7021451-1387-4CA6-816F-3879F97B5CBC}" type="slidenum"><a:rPr lang="en-US"/><a:t>17</a:t></a:fld><a:endParaRPr lang="en-US"/></a:p></p:txBody></p:sp></p:spTree><p:extLst><p:ext uri="{BB962C8B-B14F-4D97-AF65-F5344CB8AC3E}"><p14:creationId xmlns:p14="http://schemas.microsoft.com/office/powerpoint/2010/main" val="1024086991"/></p:ext></p:extLst></p:cSld><p:clrMapOvr><a:masterClrMapping/></p:clrMapOvr></p:notes>
+<p:notes xmlns:a="http://schemas.openxmlformats.org/drawingml/2006/main" xmlns:r="http://schemas.openxmlformats.org/officeDocument/2006/relationships" xmlns:p="http://schemas.openxmlformats.org/presentationml/2006/main"><p:cSld><p:spTree><p:nvGrpSpPr><p:cNvPr id="1" name=""/><p:cNvGrpSpPr/><p:nvPr/></p:nvGrpSpPr><p:grpSpPr><a:xfrm><a:off x="0" y="0"/><a:ext cx="0" cy="0"/><a:chOff x="0" y="0"/><a:chExt cx="0" cy="0"/></a:xfrm></p:grpSpPr><p:sp><p:nvSpPr><p:cNvPr id="2" name="Slide Image Placeholder 1"/><p:cNvSpPr><a:spLocks noGrp="1" noRot="1" noChangeAspect="1"/></p:cNvSpPr><p:nvPr><p:ph type="sldImg"/></p:nvPr></p:nvSpPr><p:spPr/></p:sp><p:sp><p:nvSpPr><p:cNvPr id="3" name="Notes Placeholder 2"/><p:cNvSpPr><a:spLocks noGrp="1"/></p:cNvSpPr><p:nvPr><p:ph type="body" idx="1"/></p:nvPr></p:nvSpPr><p:spPr/><p:txBody><a:bodyPr/><a:lstStyle/><a:p><a:r><a:rPr lang="en-US" dirty="0"/><a:t>怎么答：分两层说。+一层是官方公开资料——香港政府新闻公报、新加坡海关、越南 2025 年新版特别消费税法、+美国 TTB 与 FDA、中国财政部与税务总局的出口退税公告。+另一层是团队自建的两份数据库：五十六支贵州白酒逐支核过、每支标注资料可信度；+海外用法每条标注证据强度，来源是 World Baijiu Day、品牌方推广和商家页面。+强调「逐支核过」，不是抓的。</a:t></a:r><a:endParaRPr lang="en-US" dirty="0"/></a:p></p:txBody></p:sp><p:sp><p:nvSpPr><p:cNvPr id="4" name="Slide Number Placeholder 3"/><p:cNvSpPr><a:spLocks noGrp="1"/></p:cNvSpPr><p:nvPr><p:ph type="sldNum" sz="quarter" idx="10"/></p:nvPr></p:nvSpPr><p:spPr/><p:txBody><a:bodyPr/><a:lstStyle/><a:p><a:fld id="{F7021451-1387-4CA6-816F-3879F97B5CBC}" type="slidenum"><a:rPr lang="en-US"/><a:t>17</a:t></a:fld><a:endParaRPr lang="en-US"/></a:p></p:txBody></p:sp></p:spTree><p:extLst><p:ext uri="{BB962C8B-B14F-4D97-AF65-F5344CB8AC3E}"><p14:creationId xmlns:p14="http://schemas.microsoft.com/office/powerpoint/2010/main" val="1024086991"/></p:ext></p:extLst></p:cSld><p:clrMapOvr><a:masterClrMapping/></p:clrMapOvr></p:notes>
 </file>
 
-<file path=ppt/notesSlides/notesSlide18.xml><?xml version="1.0" encoding="utf-8"?>
-<p:notes xmlns:a="http://schemas.openxmlformats.org/drawingml/2006/main" xmlns:r="http://schemas.openxmlformats.org/officeDocument/2006/relationships" xmlns:p="http://schemas.openxmlformats.org/presentationml/2006/main">
-  <p:cSld>
-    <p:spTree>
-      <p:nvGrpSpPr>
-        <p:cNvPr id="1" name=""/>
-        <p:cNvGrpSpPr/>
-        <p:nvPr/>
-      </p:nvGrpSpPr>
-      <p:grpSpPr>
-        <a:xfrm>
-          <a:off x="0" y="0"/>
-          <a:ext cx="0" cy="0"/>
-          <a:chOff x="0" y="0"/>
-          <a:chExt cx="0" cy="0"/>
-        </a:xfrm>
-      </p:grpSpPr>
-      <p:sp>
-        <p:nvSpPr>
-          <p:cNvPr id="2" name="Slide Image Placeholder 1"/>
-          <p:cNvSpPr>
-            <a:spLocks noGrp="1" noRot="1" noChangeAspect="1"/>
-          </p:cNvSpPr>
-          <p:nvPr>
-            <p:ph type="sldImg"/>
-          </p:nvPr>
-        </p:nvSpPr>
-        <p:spPr/>
-      </p:sp>
-      <p:sp>
-        <p:nvSpPr>
-          <p:cNvPr id="3" name="Notes Placeholder 2"/>
-          <p:cNvSpPr>
-            <a:spLocks noGrp="1"/>
-          </p:cNvSpPr>
-          <p:nvPr>
-            <p:ph type="body" idx="1"/>
-          </p:nvPr>
-        </p:nvSpPr>
-        <p:spPr/>
-        <p:txBody>
-          <a:bodyPr/>
-          <a:lstStyle/>
-          <a:p>
-            <a:r>
-              <a:rPr lang="en-US" dirty="0"/>
-              <a:t>怎么答：承认网页不是终态。但要说清楚为什么先做网页——规则库、信号权重、落地价误差这三件事没验完之前，做成机器人只是把还没校准的答案推给更多人。</a:t>
-            </a:r>
-            <a:endParaRPr lang="en-US" dirty="0"/>
-          </a:p>
-        </p:txBody>
-      </p:sp>
-      <p:sp>
-        <p:nvSpPr>
-          <p:cNvPr id="4" name="Slide Number Placeholder 3"/>
-          <p:cNvSpPr>
-            <a:spLocks noGrp="1"/>
-          </p:cNvSpPr>
-          <p:nvPr>
-            <p:ph type="sldNum" sz="quarter" idx="10"/>
-          </p:nvPr>
-        </p:nvSpPr>
-        <p:spPr/>
-        <p:txBody>
-          <a:bodyPr/>
-          <a:lstStyle/>
-          <a:p>
-            <a:fld id="{F7021451-1387-4CA6-816F-3879F97B5CBC}" type="slidenum">
-              <a:rPr lang="en-US"/>
-              <a:t>18</a:t>
-            </a:fld>
-            <a:endParaRPr lang="en-US"/>
-          </a:p>
-        </p:txBody>
-      </p:sp>
-    </p:spTree>
-    <p:extLst>
-      <p:ext uri="{BB962C8B-B14F-4D97-AF65-F5344CB8AC3E}">
-        <p14:creationId xmlns:p14="http://schemas.microsoft.com/office/powerpoint/2010/main" val="1024086991"/>
-      </p:ext>
-    </p:extLst>
-  </p:cSld>
-  <p:clrMapOvr>
-    <a:masterClrMapping/>
-  </p:clrMapOvr>
-</p:notes>
+<file path=ppt/notesSlides/notesSlide18.xml><?xml version="1.0" encoding="UTF-8" standalone="yes"?>
+<p:notes xmlns:a="http://schemas.openxmlformats.org/drawingml/2006/main" xmlns:r="http://schemas.openxmlformats.org/officeDocument/2006/relationships" xmlns:p="http://schemas.openxmlformats.org/presentationml/2006/main"><p:cSld><p:spTree><p:nvGrpSpPr><p:cNvPr id="1" name=""/><p:cNvGrpSpPr/><p:nvPr/></p:nvGrpSpPr><p:grpSpPr><a:xfrm><a:off x="0" y="0"/><a:ext cx="0" cy="0"/><a:chOff x="0" y="0"/><a:chExt cx="0" cy="0"/></a:xfrm></p:grpSpPr><p:sp><p:nvSpPr><p:cNvPr id="2" name="Slide Image Placeholder 1"/><p:cNvSpPr><a:spLocks noGrp="1" noRot="1" noChangeAspect="1"/></p:cNvSpPr><p:nvPr><p:ph type="sldImg"/></p:nvPr></p:nvSpPr><p:spPr/></p:sp><p:sp><p:nvSpPr><p:cNvPr id="3" name="Notes Placeholder 2"/><p:cNvSpPr><a:spLocks noGrp="1"/></p:cNvSpPr><p:nvPr><p:ph type="body" idx="1"/></p:nvPr></p:nvSpPr><p:spPr/><p:txBody><a:bodyPr/><a:lstStyle/><a:p><a:r><a:rPr lang="en-US" dirty="0"/><a:t>怎么答：承认网页不是终态，这一点不要回避。+外贸专员整天在微信里，不会为了判断一个买家去开网页——真正会被用起来的是企业微信机器人，+转发一段对话给它，回一份决策简报。这件事写在一百天计划的第四步。+但要说清楚为什么先做网页：规则库、信号权重、落地价误差这三件事没验完之前，+做成机器人只是把一个还没校准的答案推到更多人面前。</a:t></a:r><a:endParaRPr lang="en-US" dirty="0"/></a:p></p:txBody></p:sp><p:sp><p:nvSpPr><p:cNvPr id="4" name="Slide Number Placeholder 3"/><p:cNvSpPr><a:spLocks noGrp="1"/></p:cNvSpPr><p:nvPr><p:ph type="sldNum" sz="quarter" idx="10"/></p:nvPr></p:nvSpPr><p:spPr/><p:txBody><a:bodyPr/><a:lstStyle/><a:p><a:fld id="{F7021451-1387-4CA6-816F-3879F97B5CBC}" type="slidenum"><a:rPr lang="en-US"/><a:t>18</a:t></a:fld><a:endParaRPr lang="en-US"/></a:p></p:txBody></p:sp></p:spTree><p:extLst><p:ext uri="{BB962C8B-B14F-4D97-AF65-F5344CB8AC3E}"><p14:creationId xmlns:p14="http://schemas.microsoft.com/office/powerpoint/2010/main" val="1024086991"/></p:ext></p:extLst></p:cSld><p:clrMapOvr><a:masterClrMapping/></p:clrMapOvr></p:notes>
 </file>
 
 <file path=ppt/notesSlides/notesSlide19.xml><?xml version="1.0" encoding="UTF-8" standalone="yes"?>
-<p:notes xmlns:a="http://schemas.openxmlformats.org/drawingml/2006/main" xmlns:r="http://schemas.openxmlformats.org/officeDocument/2006/relationships" xmlns:p="http://schemas.openxmlformats.org/presentationml/2006/main"><p:cSld><p:spTree><p:nvGrpSpPr><p:cNvPr id="1" name=""/><p:cNvGrpSpPr/><p:nvPr/></p:nvGrpSpPr><p:grpSpPr><a:xfrm><a:off x="0" y="0"/><a:ext cx="0" cy="0"/><a:chOff x="0" y="0"/><a:chExt cx="0" cy="0"/></a:xfrm></p:grpSpPr><p:sp><p:nvSpPr><p:cNvPr id="2" name="Slide Image Placeholder 1"/><p:cNvSpPr><a:spLocks noGrp="1" noRot="1" noChangeAspect="1"/></p:cNvSpPr><p:nvPr><p:ph type="sldImg"/></p:nvPr></p:nvSpPr><p:spPr/></p:sp><p:sp><p:nvSpPr><p:cNvPr id="3" name="Notes Placeholder 2"/><p:cNvSpPr><a:spLocks noGrp="1"/></p:cNvSpPr><p:nvPr><p:ph type="body" idx="1"/></p:nvPr></p:nvSpPr><p:spPr/><p:txBody><a:bodyPr/><a:lstStyle/><a:p><a:r><a:rPr lang="en-US" dirty="0"/><a:t>怎么答：主动说，不等被问。这一页的作用是把可信度拉起来——一个肯讲自己边界的团队，前面说的话才值得信。-最重要的一条是「信号权重还没用真实案例校准」，这也正好是一百天计划的第二步。</a:t></a:r><a:endParaRPr lang="en-US" dirty="0"/></a:p></p:txBody></p:sp><p:sp><p:nvSpPr><p:cNvPr id="4" name="Slide Number Placeholder 3"/><p:cNvSpPr><a:spLocks noGrp="1"/></p:cNvSpPr><p:nvPr><p:ph type="sldNum" sz="quarter" idx="10"/></p:nvPr></p:nvSpPr><p:spPr/><p:txBody><a:bodyPr/><a:lstStyle/><a:p><a:fld id="{F7021451-1387-4CA6-816F-3879F97B5CBC}" type="slidenum"><a:rPr lang="en-US"/><a:t>19</a:t></a:fld><a:endParaRPr lang="en-US"/></a:p></p:txBody></p:sp></p:spTree><p:extLst><p:ext uri="{BB962C8B-B14F-4D97-AF65-F5344CB8AC3E}"><p14:creationId xmlns:p14="http://schemas.microsoft.com/office/powerpoint/2010/main" val="1024086991"/></p:ext></p:extLst></p:cSld><p:clrMapOvr><a:masterClrMapping/></p:clrMapOvr></p:notes>
+<p:notes xmlns:a="http://schemas.openxmlformats.org/drawingml/2006/main" xmlns:r="http://schemas.openxmlformats.org/officeDocument/2006/relationships" xmlns:p="http://schemas.openxmlformats.org/presentationml/2006/main"><p:cSld><p:spTree><p:nvGrpSpPr><p:cNvPr id="1" name=""/><p:cNvGrpSpPr/><p:nvPr/></p:nvGrpSpPr><p:grpSpPr><a:xfrm><a:off x="0" y="0"/><a:ext cx="0" cy="0"/><a:chOff x="0" y="0"/><a:chExt cx="0" cy="0"/></a:xfrm></p:grpSpPr><p:sp><p:nvSpPr><p:cNvPr id="2" name="Slide Image Placeholder 1"/><p:cNvSpPr><a:spLocks noGrp="1" noRot="1" noChangeAspect="1"/></p:cNvSpPr><p:nvPr><p:ph type="sldImg"/></p:nvPr></p:nvSpPr><p:spPr/></p:sp><p:sp><p:nvSpPr><p:cNvPr id="3" name="Notes Placeholder 2"/><p:cNvSpPr><a:spLocks noGrp="1"/></p:cNvSpPr><p:nvPr><p:ph type="body" idx="1"/></p:nvPr></p:nvSpPr><p:spPr/><p:txBody><a:bodyPr/><a:lstStyle/><a:p><a:r><a:rPr lang="en-US" dirty="0"/><a:t>怎么答：主动说，不等被问。+这一页的作用是把可信度拉起来——一个肯讲自己边界的团队，前面说的话才值得信。+最重要的一条是「信号权重还没用真实案例校准」，目前是团队设定值，+这也正好是一百天计划的第二步，前后是接得上的。</a:t></a:r><a:endParaRPr lang="en-US" dirty="0"/></a:p></p:txBody></p:sp><p:sp><p:nvSpPr><p:cNvPr id="4" name="Slide Number Placeholder 3"/><p:cNvSpPr><a:spLocks noGrp="1"/></p:cNvSpPr><p:nvPr><p:ph type="sldNum" sz="quarter" idx="10"/></p:nvPr></p:nvSpPr><p:spPr/><p:txBody><a:bodyPr/><a:lstStyle/><a:p><a:fld id="{F7021451-1387-4CA6-816F-3879F97B5CBC}" type="slidenum"><a:rPr lang="en-US"/><a:t>19</a:t></a:fld><a:endParaRPr lang="en-US"/></a:p></p:txBody></p:sp></p:spTree><p:extLst><p:ext uri="{BB962C8B-B14F-4D97-AF65-F5344CB8AC3E}"><p14:creationId xmlns:p14="http://schemas.microsoft.com/office/powerpoint/2010/main" val="1024086991"/></p:ext></p:extLst></p:cSld><p:clrMapOvr><a:masterClrMapping/></p:clrMapOvr></p:notes>
 </file>
 
 <file path=ppt/notesSlides/notesSlide2.xml><?xml version="1.0" encoding="UTF-8" standalone="yes"?>
-<p:notes xmlns:a="http://schemas.openxmlformats.org/drawingml/2006/main" xmlns:r="http://schemas.openxmlformats.org/officeDocument/2006/relationships" xmlns:p="http://schemas.openxmlformats.org/presentationml/2006/main"><p:cSld><p:spTree><p:nvGrpSpPr><p:cNvPr id="1" name=""/><p:cNvGrpSpPr/><p:nvPr/></p:nvGrpSpPr><p:grpSpPr><a:xfrm><a:off x="0" y="0"/><a:ext cx="0" cy="0"/><a:chOff x="0" y="0"/><a:chExt cx="0" cy="0"/></a:xfrm></p:grpSpPr><p:sp><p:nvSpPr><p:cNvPr id="2" name="Slide Image Placeholder 1"/><p:cNvSpPr><a:spLocks noGrp="1" noRot="1" noChangeAspect="1"/></p:cNvSpPr><p:nvPr><p:ph type="sldImg"/></p:nvPr></p:nvSpPr><p:spPr/></p:sp><p:sp><p:nvSpPr><p:cNvPr id="3" name="Notes Placeholder 2"/><p:cNvSpPr><a:spLocks noGrp="1"/></p:cNvSpPr><p:nvPr><p:ph type="body" idx="1"/></p:nvPr></p:nvSpPr><p:spPr/><p:txBody><a:bodyPr/><a:lstStyle/><a:p><a:r><a:rPr lang="en-US" dirty="0"/><a:t>（0:20–0:55）-先说我们为什么做这个。-遵义综合保税区二〇二五年的工作总结里，有一组很诚实的数字：-八十九家酒企完成出口备案，三十五家有意向，十一家真的出了海，-最后——五家和东南亚经销商「建立初步联系」。-转化率百分之五点六。-[指最后一级]-请注意最后一级的措辞，是「建立初步联系」，不是签约，更不是复购。-公开资料在这里就断了。</a:t></a:r><a:endParaRPr lang="en-US" dirty="0"/></a:p></p:txBody></p:sp><p:sp><p:nvSpPr><p:cNvPr id="4" name="Slide Number Placeholder 3"/><p:cNvSpPr><a:spLocks noGrp="1"/></p:cNvSpPr><p:nvPr><p:ph type="sldNum" sz="quarter" idx="10"/></p:nvPr></p:nvSpPr><p:spPr/><p:txBody><a:bodyPr/><a:lstStyle/><a:p><a:fld id="{F7021451-1387-4CA6-816F-3879F97B5CBC}" type="slidenum"><a:rPr lang="en-US"/><a:t>2</a:t></a:fld><a:endParaRPr lang="en-US"/></a:p></p:txBody></p:sp></p:spTree><p:extLst><p:ext uri="{BB962C8B-B14F-4D97-AF65-F5344CB8AC3E}"><p14:creationId xmlns:p14="http://schemas.microsoft.com/office/powerpoint/2010/main" val="1024086991"/></p:ext></p:extLst></p:cSld><p:clrMapOvr><a:masterClrMapping/></p:clrMapOvr></p:notes>
+<p:notes xmlns:a="http://schemas.openxmlformats.org/drawingml/2006/main" xmlns:r="http://schemas.openxmlformats.org/officeDocument/2006/relationships" xmlns:p="http://schemas.openxmlformats.org/presentationml/2006/main"><p:cSld><p:spTree><p:nvGrpSpPr><p:cNvPr id="1" name=""/><p:cNvGrpSpPr/><p:nvPr/></p:nvGrpSpPr><p:grpSpPr><a:xfrm><a:off x="0" y="0"/><a:ext cx="0" cy="0"/><a:chOff x="0" y="0"/><a:chExt cx="0" cy="0"/></a:xfrm></p:grpSpPr><p:sp><p:nvSpPr><p:cNvPr id="2" name="Slide Image Placeholder 1"/><p:cNvSpPr><a:spLocks noGrp="1" noRot="1" noChangeAspect="1"/></p:cNvSpPr><p:nvPr><p:ph type="sldImg"/></p:nvPr></p:nvSpPr><p:spPr/></p:sp><p:sp><p:nvSpPr><p:cNvPr id="3" name="Notes Placeholder 2"/><p:cNvSpPr><a:spLocks noGrp="1"/></p:cNvSpPr><p:nvPr><p:ph type="body" idx="1"/></p:nvPr></p:nvSpPr><p:spPr/><p:txBody><a:bodyPr/><a:lstStyle/><a:p><a:r><a:rPr lang="en-US" dirty="0"/><a:t>（0:18–0:56　38 秒　178 字）++遵义综保区去年的工作总结里，有一组很诚实的数字：+八十九家完成出口备案，三十五家有意向，十一家真的出了海，+最后五家和东南亚经销商「建立初步联系」。+[停一拍]+注意这个措辞——不是签约，更不是复购。公开资料到这里就断了。+遵义自己列的第一个障碍是：白酒属管制商品，进口方需酒牌资质。+所以你要找的不是想卖酒的人，是已经持牌的人。+这个池子在任何国家都有限、封闭，早被洋酒喂饱了。++───── 时间充裕可加 ─────+所以问题从来不是「白酒怎么出海」这种大词，是一家没有海外团队的酒厂，怎么让第一个海外经销商愿意下第二单。</a:t></a:r><a:endParaRPr lang="en-US" dirty="0"/></a:p></p:txBody></p:sp><p:sp><p:nvSpPr><p:cNvPr id="4" name="Slide Number Placeholder 3"/><p:cNvSpPr><a:spLocks noGrp="1"/></p:cNvSpPr><p:nvPr><p:ph type="sldNum" sz="quarter" idx="10"/></p:nvPr></p:nvSpPr><p:spPr/><p:txBody><a:bodyPr/><a:lstStyle/><a:p><a:fld id="{F7021451-1387-4CA6-816F-3879F97B5CBC}" type="slidenum"><a:rPr lang="en-US"/><a:t>2</a:t></a:fld><a:endParaRPr lang="en-US"/></a:p></p:txBody></p:sp></p:spTree><p:extLst><p:ext uri="{BB962C8B-B14F-4D97-AF65-F5344CB8AC3E}"><p14:creationId xmlns:p14="http://schemas.microsoft.com/office/powerpoint/2010/main" val="1024086991"/></p:ext></p:extLst></p:cSld><p:clrMapOvr><a:masterClrMapping/></p:clrMapOvr></p:notes>
 </file>
 
 <file path=ppt/notesSlides/notesSlide20.xml><?xml version="1.0" encoding="UTF-8" standalone="yes"?>
-<p:notes xmlns:a="http://schemas.openxmlformats.org/drawingml/2006/main" xmlns:r="http://schemas.openxmlformats.org/officeDocument/2006/relationships" xmlns:p="http://schemas.openxmlformats.org/presentationml/2006/main"><p:cSld><p:spTree><p:nvGrpSpPr><p:cNvPr id="1" name=""/><p:cNvGrpSpPr/><p:nvPr/></p:nvGrpSpPr><p:grpSpPr><a:xfrm><a:off x="0" y="0"/><a:ext cx="0" cy="0"/><a:chOff x="0" y="0"/><a:chExt cx="0" cy="0"/></a:xfrm></p:grpSpPr><p:sp><p:nvSpPr><p:cNvPr id="2" name="Slide Image Placeholder 1"/><p:cNvSpPr><a:spLocks noGrp="1" noRot="1" noChangeAspect="1"/></p:cNvSpPr><p:nvPr><p:ph type="sldImg"/></p:nvPr></p:nvSpPr><p:spPr/></p:sp><p:sp><p:nvSpPr><p:cNvPr id="3" name="Notes Placeholder 2"/><p:cNvSpPr><a:spLocks noGrp="1"/></p:cNvSpPr><p:nvPr><p:ph type="body" idx="1"/></p:nvPr></p:nvSpPr><p:spPr/><p:txBody><a:bodyPr/><a:lstStyle/><a:p><a:r><a:rPr lang="en-US" dirty="0"/><a:t>技术选型。如果评委是技术背景，重点讲那条分界线：规则是纯函数、模型只做抽取与措辞。-另外可以提「刻意没引入」那一行——不用图表库、不用组件库、不用数据库，税则是编译期常量，比数据库更适合审计与 diff。</a:t></a:r><a:endParaRPr lang="en-US" dirty="0"/></a:p></p:txBody></p:sp><p:sp><p:nvSpPr><p:cNvPr id="4" name="Slide Number Placeholder 3"/><p:cNvSpPr><a:spLocks noGrp="1"/></p:cNvSpPr><p:nvPr><p:ph type="sldNum" sz="quarter" idx="10"/></p:nvPr></p:nvSpPr><p:spPr/><p:txBody><a:bodyPr/><a:lstStyle/><a:p><a:fld id="{F7021451-1387-4CA6-816F-3879F97B5CBC}" type="slidenum"><a:rPr lang="en-US"/><a:t>20</a:t></a:fld><a:endParaRPr lang="en-US"/></a:p></p:txBody></p:sp></p:spTree><p:extLst><p:ext uri="{BB962C8B-B14F-4D97-AF65-F5344CB8AC3E}"><p14:creationId xmlns:p14="http://schemas.microsoft.com/office/powerpoint/2010/main" val="1024086991"/></p:ext></p:extLst></p:cSld><p:clrMapOvr><a:masterClrMapping/></p:clrMapOvr></p:notes>
+<p:notes xmlns:a="http://schemas.openxmlformats.org/drawingml/2006/main" xmlns:r="http://schemas.openxmlformats.org/officeDocument/2006/relationships" xmlns:p="http://schemas.openxmlformats.org/presentationml/2006/main"><p:cSld><p:spTree><p:nvGrpSpPr><p:cNvPr id="1" name=""/><p:cNvGrpSpPr/><p:nvPr/></p:nvGrpSpPr><p:grpSpPr><a:xfrm><a:off x="0" y="0"/><a:ext cx="0" cy="0"/><a:chOff x="0" y="0"/><a:chExt cx="0" cy="0"/></a:xfrm></p:grpSpPr><p:sp><p:nvSpPr><p:cNvPr id="2" name="Slide Image Placeholder 1"/><p:cNvSpPr><a:spLocks noGrp="1" noRot="1" noChangeAspect="1"/></p:cNvSpPr><p:nvPr><p:ph type="sldImg"/></p:nvPr></p:nvSpPr><p:spPr/></p:sp><p:sp><p:nvSpPr><p:cNvPr id="3" name="Notes Placeholder 2"/><p:cNvSpPr><a:spLocks noGrp="1"/></p:cNvSpPr><p:nvPr><p:ph type="body" idx="1"/></p:nvPr></p:nvSpPr><p:spPr/><p:txBody><a:bodyPr/><a:lstStyle/><a:p><a:r><a:rPr lang="en-US" dirty="0"/><a:t>技术选型。评委是技术背景时，重点讲那条分界线：+规则是纯函数、模型只做抽取与措辞，这不是偷懒，是因为算错一个税率就是真金白银的亏损。+另外可以提「刻意没引入」那一行——不用图表库（瀑布图、酒瓶液面全是手写 SVG 与 shader）、+不用组件库、不用数据库，税则是编译期常量，比数据库更适合审计与 diff。+判定页那瓶酒是 three.js 实时渲染的，液面高度就是套利风险分。</a:t></a:r><a:endParaRPr lang="en-US" dirty="0"/></a:p></p:txBody></p:sp><p:sp><p:nvSpPr><p:cNvPr id="4" name="Slide Number Placeholder 3"/><p:cNvSpPr><a:spLocks noGrp="1"/></p:cNvSpPr><p:nvPr><p:ph type="sldNum" sz="quarter" idx="10"/></p:nvPr></p:nvSpPr><p:spPr/><p:txBody><a:bodyPr/><a:lstStyle/><a:p><a:fld id="{F7021451-1387-4CA6-816F-3879F97B5CBC}" type="slidenum"><a:rPr lang="en-US"/><a:t>20</a:t></a:fld><a:endParaRPr lang="en-US"/></a:p></p:txBody></p:sp></p:spTree><p:extLst><p:ext uri="{BB962C8B-B14F-4D97-AF65-F5344CB8AC3E}"><p14:creationId xmlns:p14="http://schemas.microsoft.com/office/powerpoint/2010/main" val="1024086991"/></p:ext></p:extLst></p:cSld><p:clrMapOvr><a:masterClrMapping/></p:clrMapOvr></p:notes>
 </file>
 
-<file path=ppt/notesSlides/notesSlide21.xml><?xml version="1.0" encoding="utf-8"?>
-<p:notes xmlns:a="http://schemas.openxmlformats.org/drawingml/2006/main" xmlns:r="http://schemas.openxmlformats.org/officeDocument/2006/relationships" xmlns:p="http://schemas.openxmlformats.org/presentationml/2006/main">
-  <p:cSld>
-    <p:spTree>
-      <p:nvGrpSpPr>
-        <p:cNvPr id="1" name=""/>
-        <p:cNvGrpSpPr/>
-        <p:nvPr/>
-      </p:nvGrpSpPr>
-      <p:grpSpPr>
-        <a:xfrm>
-          <a:off x="0" y="0"/>
-          <a:ext cx="0" cy="0"/>
-          <a:chOff x="0" y="0"/>
-          <a:chExt cx="0" cy="0"/>
-        </a:xfrm>
-      </p:grpSpPr>
-      <p:sp>
-        <p:nvSpPr>
-          <p:cNvPr id="2" name="Slide Image Placeholder 1"/>
-          <p:cNvSpPr>
-            <a:spLocks noGrp="1" noRot="1" noChangeAspect="1"/>
-          </p:cNvSpPr>
-          <p:nvPr>
-            <p:ph type="sldImg"/>
-          </p:nvPr>
-        </p:nvSpPr>
-        <p:spPr/>
-      </p:sp>
-      <p:sp>
-        <p:nvSpPr>
-          <p:cNvPr id="3" name="Notes Placeholder 2"/>
-          <p:cNvSpPr>
-            <a:spLocks noGrp="1"/>
-          </p:cNvSpPr>
-          <p:nvPr>
-            <p:ph type="body" idx="1"/>
-          </p:nvPr>
-        </p:nvSpPr>
-        <p:spPr/>
-        <p:txBody>
-          <a:bodyPr/>
-          <a:lstStyle/>
-          <a:p>
-            <a:r>
-              <a:rPr lang="en-US" dirty="0"/>
-              <a:t>线上体验可以直接让评委扫码打开自己点。仓库是公开的，Topic 是 #Guikesong。</a:t>
-            </a:r>
-            <a:endParaRPr lang="en-US" dirty="0"/>
-          </a:p>
-        </p:txBody>
-      </p:sp>
-      <p:sp>
-        <p:nvSpPr>
-          <p:cNvPr id="4" name="Slide Number Placeholder 3"/>
-          <p:cNvSpPr>
-            <a:spLocks noGrp="1"/>
-          </p:cNvSpPr>
-          <p:nvPr>
-            <p:ph type="sldNum" sz="quarter" idx="10"/>
-          </p:nvPr>
-        </p:nvSpPr>
-        <p:spPr/>
-        <p:txBody>
-          <a:bodyPr/>
-          <a:lstStyle/>
-          <a:p>
-            <a:fld id="{F7021451-1387-4CA6-816F-3879F97B5CBC}" type="slidenum">
-              <a:rPr lang="en-US"/>
-              <a:t>21</a:t>
-            </a:fld>
-            <a:endParaRPr lang="en-US"/>
-          </a:p>
-        </p:txBody>
-      </p:sp>
-    </p:spTree>
-    <p:extLst>
-      <p:ext uri="{BB962C8B-B14F-4D97-AF65-F5344CB8AC3E}">
-        <p14:creationId xmlns:p14="http://schemas.microsoft.com/office/powerpoint/2010/main" val="1024086991"/>
-      </p:ext>
-    </p:extLst>
-  </p:cSld>
-  <p:clrMapOvr>
-    <a:masterClrMapping/>
-  </p:clrMapOvr>
-</p:notes>
+<file path=ppt/notesSlides/notesSlide21.xml><?xml version="1.0" encoding="UTF-8" standalone="yes"?>
+<p:notes xmlns:a="http://schemas.openxmlformats.org/drawingml/2006/main" xmlns:r="http://schemas.openxmlformats.org/officeDocument/2006/relationships" xmlns:p="http://schemas.openxmlformats.org/presentationml/2006/main"><p:cSld><p:spTree><p:nvGrpSpPr><p:cNvPr id="1" name=""/><p:cNvGrpSpPr/><p:nvPr/></p:nvGrpSpPr><p:grpSpPr><a:xfrm><a:off x="0" y="0"/><a:ext cx="0" cy="0"/><a:chOff x="0" y="0"/><a:chExt cx="0" cy="0"/></a:xfrm></p:grpSpPr><p:sp><p:nvSpPr><p:cNvPr id="2" name="Slide Image Placeholder 1"/><p:cNvSpPr><a:spLocks noGrp="1" noRot="1" noChangeAspect="1"/></p:cNvSpPr><p:nvPr><p:ph type="sldImg"/></p:nvPr></p:nvSpPr><p:spPr/></p:sp><p:sp><p:nvSpPr><p:cNvPr id="3" name="Notes Placeholder 2"/><p:cNvSpPr><a:spLocks noGrp="1"/></p:cNvSpPr><p:nvPr><p:ph type="body" idx="1"/></p:nvPr></p:nvSpPr><p:spPr/><p:txBody><a:bodyPr/><a:lstStyle/><a:p><a:r><a:rPr lang="en-US" dirty="0"/><a:t>线上体验可以直接请评委自己打开点，不用注册。+仓库是公开的，Topic 是 #Guikesong，README 顶部就是技术栈表。+如果还有时间，可以回到 demo 现场再跑一个越南的案例做对照——+同样八秒，出来的是「可谈」，让他们看到这工具不是只会说不。</a:t></a:r><a:endParaRPr lang="en-US" dirty="0"/></a:p></p:txBody></p:sp><p:sp><p:nvSpPr><p:cNvPr id="4" name="Slide Number Placeholder 3"/><p:cNvSpPr><a:spLocks noGrp="1"/></p:cNvSpPr><p:nvPr><p:ph type="sldNum" sz="quarter" idx="10"/></p:nvPr></p:nvSpPr><p:spPr/><p:txBody><a:bodyPr/><a:lstStyle/><a:p><a:fld id="{F7021451-1387-4CA6-816F-3879F97B5CBC}" type="slidenum"><a:rPr lang="en-US"/><a:t>21</a:t></a:fld><a:endParaRPr lang="en-US"/></a:p></p:txBody></p:sp></p:spTree><p:extLst><p:ext uri="{BB962C8B-B14F-4D97-AF65-F5344CB8AC3E}"><p14:creationId xmlns:p14="http://schemas.microsoft.com/office/powerpoint/2010/main" val="1024086991"/></p:ext></p:extLst></p:cSld><p:clrMapOvr><a:masterClrMapping/></p:clrMapOvr></p:notes>
 </file>
 
 <file path=ppt/notesSlides/notesSlide3.xml><?xml version="1.0" encoding="UTF-8" standalone="yes"?>
-<p:notes xmlns:a="http://schemas.openxmlformats.org/drawingml/2006/main" xmlns:r="http://schemas.openxmlformats.org/officeDocument/2006/relationships" xmlns:p="http://schemas.openxmlformats.org/presentationml/2006/main"><p:cSld><p:spTree><p:nvGrpSpPr><p:cNvPr id="1" name=""/><p:cNvGrpSpPr/><p:nvPr/></p:nvGrpSpPr><p:grpSpPr><a:xfrm><a:off x="0" y="0"/><a:ext cx="0" cy="0"/><a:chOff x="0" y="0"/><a:chExt cx="0" cy="0"/></a:xfrm></p:grpSpPr><p:sp><p:nvSpPr><p:cNvPr id="2" name="Slide Image Placeholder 1"/><p:cNvSpPr><a:spLocks noGrp="1" noRot="1" noChangeAspect="1"/></p:cNvSpPr><p:nvPr><p:ph type="sldImg"/></p:nvPr></p:nvSpPr><p:spPr/></p:sp><p:sp><p:nvSpPr><p:cNvPr id="3" name="Notes Placeholder 2"/><p:cNvSpPr><a:spLocks noGrp="1"/></p:cNvSpPr><p:nvPr><p:ph type="body" idx="1"/></p:nvPr></p:nvSpPr><p:spPr/><p:txBody><a:bodyPr/><a:lstStyle/><a:p><a:r><a:rPr lang="en-US" dirty="0"/><a:t>（0:55–1:20）-卡住的地方不在酿酒，在酿完之后。-中小酒企没有海外团队。展会散场，业务员手上十几张名片，-他真正的问题只有三个：-这个买家是真想卖酒，还是在做税差？-这瓶酒到他货架上要卖多少钱？-第一份合同该写死哪几条？-这三个问题，市面上的工具一个都没答。</a:t></a:r><a:endParaRPr lang="en-US" dirty="0"/></a:p></p:txBody></p:sp><p:sp><p:nvSpPr><p:cNvPr id="4" name="Slide Number Placeholder 3"/><p:cNvSpPr><a:spLocks noGrp="1"/></p:cNvSpPr><p:nvPr><p:ph type="sldNum" sz="quarter" idx="10"/></p:nvPr></p:nvSpPr><p:spPr/><p:txBody><a:bodyPr/><a:lstStyle/><a:p><a:fld id="{F7021451-1387-4CA6-816F-3879F97B5CBC}" type="slidenum"><a:rPr lang="en-US"/><a:t>3</a:t></a:fld><a:endParaRPr lang="en-US"/></a:p></p:txBody></p:sp></p:spTree><p:extLst><p:ext uri="{BB962C8B-B14F-4D97-AF65-F5344CB8AC3E}"><p14:creationId xmlns:p14="http://schemas.microsoft.com/office/powerpoint/2010/main" val="1024086991"/></p:ext></p:extLst></p:cSld><p:clrMapOvr><a:masterClrMapping/></p:clrMapOvr></p:notes>
+<p:notes xmlns:a="http://schemas.openxmlformats.org/drawingml/2006/main" xmlns:r="http://schemas.openxmlformats.org/officeDocument/2006/relationships" xmlns:p="http://schemas.openxmlformats.org/presentationml/2006/main"><p:cSld><p:spTree><p:nvGrpSpPr><p:cNvPr id="1" name=""/><p:cNvGrpSpPr/><p:nvPr/></p:nvGrpSpPr><p:grpSpPr><a:xfrm><a:off x="0" y="0"/><a:ext cx="0" cy="0"/><a:chOff x="0" y="0"/><a:chExt cx="0" cy="0"/></a:xfrm></p:grpSpPr><p:sp><p:nvSpPr><p:cNvPr id="2" name="Slide Image Placeholder 1"/><p:cNvSpPr><a:spLocks noGrp="1" noRot="1" noChangeAspect="1"/></p:cNvSpPr><p:nvPr><p:ph type="sldImg"/></p:nvPr></p:nvSpPr><p:spPr/></p:sp><p:sp><p:nvSpPr><p:cNvPr id="3" name="Notes Placeholder 2"/><p:cNvSpPr><a:spLocks noGrp="1"/></p:cNvSpPr><p:nvPr><p:ph type="body" idx="1"/></p:nvPr></p:nvSpPr><p:spPr/><p:txBody><a:bodyPr/><a:lstStyle/><a:p><a:r><a:rPr lang="en-US" dirty="0"/><a:t>（0:56–1:20　24 秒　111 字）++卡住的不在酿酒，在酿完之后。+展会散场，业务员手上十几张名片，+却分不清哪个是真经销商，哪个是来做别的事的。+他真正的问题只有三个：这人是真想卖酒还是在做税差？+这瓶酒到他货架上卖多少钱、卖得动吗？合同该写死哪几条？+现在只能靠猜。++───── 时间充裕可加 ─────+因为答案分散在五个国家的税则、牌照制度和渠道结构里，他连从哪查起都不知道。</a:t></a:r><a:endParaRPr lang="en-US" dirty="0"/></a:p></p:txBody></p:sp><p:sp><p:nvSpPr><p:cNvPr id="4" name="Slide Number Placeholder 3"/><p:cNvSpPr><a:spLocks noGrp="1"/></p:cNvSpPr><p:nvPr><p:ph type="sldNum" sz="quarter" idx="10"/></p:nvPr></p:nvSpPr><p:spPr/><p:txBody><a:bodyPr/><a:lstStyle/><a:p><a:fld id="{F7021451-1387-4CA6-816F-3879F97B5CBC}" type="slidenum"><a:rPr lang="en-US"/><a:t>3</a:t></a:fld><a:endParaRPr lang="en-US"/></a:p></p:txBody></p:sp></p:spTree><p:extLst><p:ext uri="{BB962C8B-B14F-4D97-AF65-F5344CB8AC3E}"><p14:creationId xmlns:p14="http://schemas.microsoft.com/office/powerpoint/2010/main" val="1024086991"/></p:ext></p:extLst></p:cSld><p:clrMapOvr><a:masterClrMapping/></p:clrMapOvr></p:notes>
 </file>
 
 <file path=ppt/notesSlides/notesSlide4.xml><?xml version="1.0" encoding="UTF-8" standalone="yes"?>
-<p:notes xmlns:a="http://schemas.openxmlformats.org/drawingml/2006/main" xmlns:r="http://schemas.openxmlformats.org/officeDocument/2006/relationships" xmlns:p="http://schemas.openxmlformats.org/presentationml/2006/main"><p:cSld><p:spTree><p:nvGrpSpPr><p:cNvPr id="1" name=""/><p:cNvGrpSpPr/><p:nvPr/></p:nvGrpSpPr><p:grpSpPr><a:xfrm><a:off x="0" y="0"/><a:ext cx="0" cy="0"/><a:chOff x="0" y="0"/><a:chExt cx="0" cy="0"/></a:xfrm></p:grpSpPr><p:sp><p:nvSpPr><p:cNvPr id="2" name="Slide Image Placeholder 1"/><p:cNvSpPr><a:spLocks noGrp="1" noRot="1" noChangeAspect="1"/></p:cNvSpPr><p:nvPr><p:ph type="sldImg"/></p:nvPr></p:nvSpPr><p:spPr/></p:sp><p:sp><p:nvSpPr><p:cNvPr id="3" name="Notes Placeholder 2"/><p:cNvSpPr><a:spLocks noGrp="1"/></p:cNvSpPr><p:nvPr><p:ph type="body" idx="1"/></p:nvPr></p:nvSpPr><p:spPr/><p:txBody><a:bodyPr/><a:lstStyle/><a:p><a:r><a:rPr lang="en-US" dirty="0"/><a:t>（1:20–1:55）-先说第一个问题，也是最要命的一个。+<p:notes xmlns:a="http://schemas.openxmlformats.org/drawingml/2006/main" xmlns:r="http://schemas.openxmlformats.org/officeDocument/2006/relationships" xmlns:p="http://schemas.openxmlformats.org/presentationml/2006/main"><p:cSld><p:spTree><p:nvGrpSpPr><p:cNvPr id="1" name=""/><p:cNvGrpSpPr/><p:nvPr/></p:nvGrpSpPr><p:grpSpPr><a:xfrm><a:off x="0" y="0"/><a:ext cx="0" cy="0"/><a:chOff x="0" y="0"/><a:chExt cx="0" cy="0"/></a:xfrm></p:grpSpPr><p:sp><p:nvSpPr><p:cNvPr id="2" name="Slide Image Placeholder 1"/><p:cNvSpPr><a:spLocks noGrp="1" noRot="1" noChangeAspect="1"/></p:cNvSpPr><p:nvPr><p:ph type="sldImg"/></p:nvPr></p:nvSpPr><p:spPr/></p:sp><p:sp><p:nvSpPr><p:cNvPr id="3" name="Notes Placeholder 2"/><p:cNvSpPr><a:spLocks noGrp="1"/></p:cNvSpPr><p:nvPr><p:ph type="body" idx="1"/></p:nvPr></p:nvSpPr><p:spPr/><p:txBody><a:bodyPr/><a:lstStyle/><a:p><a:r><a:rPr lang="en-US" dirty="0"/><a:t>（1:20–1:58　38 秒　159 字）++看一张真实的名片。 [指瓶子]-套利型买家要的，从来不是这瓶酒。-白酒出口，消费税百分之二十从价免征，再加增值税退税百分之十三。-他要的是这百分之三十三。-货囤进自贸仓，转手就走，酒根本没上过货架。-[停一拍]-而你以为你签下了第一个海外经销商。</a:t></a:r><a:endParaRPr lang="en-US" dirty="0"/></a:p></p:txBody></p:sp><p:sp><p:nvSpPr><p:cNvPr id="4" name="Slide Number Placeholder 3"/><p:cNvSpPr><a:spLocks noGrp="1"/></p:cNvSpPr><p:nvPr><p:ph type="sldNum" sz="quarter" idx="10"/></p:nvPr></p:nvSpPr><p:spPr/><p:txBody><a:bodyPr/><a:lstStyle/><a:p><a:fld id="{F7021451-1387-4CA6-816F-3879F97B5CBC}" type="slidenum"><a:rPr lang="en-US"/><a:t>4</a:t></a:fld><a:endParaRPr lang="en-US"/></a:p></p:txBody></p:sp></p:spTree><p:extLst><p:ext uri="{BB962C8B-B14F-4D97-AF65-F5344CB8AC3E}"><p14:creationId xmlns:p14="http://schemas.microsoft.com/office/powerpoint/2010/main" val="1024086991"/></p:ext></p:extLst></p:cSld><p:clrMapOvr><a:masterClrMapping/></p:clrMapOvr></p:notes>
+他说：出厂价最低多少，我们要最低的，先来三个柜；+标签不用改，我们自己处理；货先放自贸仓；动销数据是商业机密。+每一句单独看都不算离谱，合起来是另一回事。+他要的不是这瓶酒。+白酒出口，消费税百分之二十从价免征，加增值税退税百分之十三——+他要的是这百分之三十三。囤进自贸仓转手就走，+酒有没有上过货架跟他无关。++───── 时间充裕可加 ─────+第二个买家问的是：有没有三十八度的，因为越南特别消费税以二十度分界；标签要越南文；+先做一百五十箱放十二家中餐厅试销；能不能给品鉴小样，我们要培训服务生。+这个人是来卖酒的。差别不在语气，在他关心什么。</a:t></a:r><a:endParaRPr lang="en-US" dirty="0"/></a:p></p:txBody></p:sp><p:sp><p:nvSpPr><p:cNvPr id="4" name="Slide Number Placeholder 3"/><p:cNvSpPr><a:spLocks noGrp="1"/></p:cNvSpPr><p:nvPr><p:ph type="sldNum" sz="quarter" idx="10"/></p:nvPr></p:nvSpPr><p:spPr/><p:txBody><a:bodyPr/><a:lstStyle/><a:p><a:fld id="{F7021451-1387-4CA6-816F-3879F97B5CBC}" type="slidenum"><a:rPr lang="en-US"/><a:t>4</a:t></a:fld><a:endParaRPr lang="en-US"/></a:p></p:txBody></p:sp></p:spTree><p:extLst><p:ext uri="{BB962C8B-B14F-4D97-AF65-F5344CB8AC3E}"><p14:creationId xmlns:p14="http://schemas.microsoft.com/office/powerpoint/2010/main" val="1024086991"/></p:ext></p:extLst></p:cSld><p:clrMapOvr><a:masterClrMapping/></p:clrMapOvr></p:notes>
 </file>
 
 <file path=ppt/notesSlides/notesSlide5.xml><?xml version="1.0" encoding="UTF-8" standalone="yes"?>
-<p:notes xmlns:a="http://schemas.openxmlformats.org/drawingml/2006/main" xmlns:r="http://schemas.openxmlformats.org/officeDocument/2006/relationships" xmlns:p="http://schemas.openxmlformats.org/presentationml/2006/main"><p:cSld><p:spTree><p:nvGrpSpPr><p:cNvPr id="1" name=""/><p:cNvGrpSpPr/><p:nvPr/></p:nvGrpSpPr><p:grpSpPr><a:xfrm><a:off x="0" y="0"/><a:ext cx="0" cy="0"/><a:chOff x="0" y="0"/><a:chExt cx="0" cy="0"/></a:xfrm></p:grpSpPr><p:sp><p:nvSpPr><p:cNvPr id="2" name="Slide Image Placeholder 1"/><p:cNvSpPr><a:spLocks noGrp="1" noRot="1" noChangeAspect="1"/></p:cNvSpPr><p:nvPr><p:ph type="sldImg"/></p:nvPr></p:nvSpPr><p:spPr/></p:sp><p:sp><p:nvSpPr><p:cNvPr id="3" name="Notes Placeholder 2"/><p:cNvSpPr><a:spLocks noGrp="1"/></p:cNvSpPr><p:nvPr><p:ph type="body" idx="1"/></p:nvPr></p:nvSpPr><p:spPr/><p:txBody><a:bodyPr/><a:lstStyle/><a:p><a:r><a:rPr lang="en-US" dirty="0"/><a:t>（1:55–2:20）+<p:notes xmlns:a="http://schemas.openxmlformats.org/drawingml/2006/main" xmlns:r="http://schemas.openxmlformats.org/officeDocument/2006/relationships" xmlns:p="http://schemas.openxmlformats.org/presentationml/2006/main"><p:cSld><p:spTree><p:nvGrpSpPr><p:cNvPr id="1" name=""/><p:cNvGrpSpPr/><p:nvPr/></p:nvGrpSpPr><p:grpSpPr><a:xfrm><a:off x="0" y="0"/><a:ext cx="0" cy="0"/><a:chOff x="0" y="0"/><a:chExt cx="0" cy="0"/></a:xfrm></p:grpSpPr><p:sp><p:nvSpPr><p:cNvPr id="2" name="Slide Image Placeholder 1"/><p:cNvSpPr><a:spLocks noGrp="1" noRot="1" noChangeAspect="1"/></p:cNvSpPr><p:nvPr><p:ph type="sldImg"/></p:nvPr></p:nvSpPr><p:spPr/></p:sp><p:sp><p:nvSpPr><p:cNvPr id="3" name="Notes Placeholder 2"/><p:cNvSpPr><a:spLocks noGrp="1"/></p:cNvSpPr><p:nvPr><p:ph type="body" idx="1"/></p:nvPr></p:nvSpPr><p:spPr/><p:txBody><a:bodyPr/><a:lstStyle/><a:p><a:r><a:rPr lang="en-US" dirty="0"/><a:t>（1:58–2:20　22 秒　91 字）+ 判断错了，代价是多少。-一柜货值两百六十一万，卖不掉折价倒回国内，亏七十八万。-更贵的是——当地价格体系被打乱之后，+一柜货值两百六十一万；卖不掉折价倒回国内，亏七十八万。+但更贵的不是这笔钱，是当地价格烂掉之后， 你再也找不到第二个愿意接的经销商。-而这些，你要到九十天之后才会知道。</a:t></a:r><a:endParaRPr lang="en-US" dirty="0"/></a:p></p:txBody></p:sp><p:sp><p:nvSpPr><p:cNvPr id="4" name="Slide Number Placeholder 3"/><p:cNvSpPr><a:spLocks noGrp="1"/></p:cNvSpPr><p:nvPr><p:ph type="sldNum" sz="quarter" idx="10"/></p:nvPr></p:nvSpPr><p:spPr/><p:txBody><a:bodyPr/><a:lstStyle/><a:p><a:fld id="{F7021451-1387-4CA6-816F-3879F97B5CBC}" type="slidenum"><a:rPr lang="en-US"/><a:t>5</a:t></a:fld><a:endParaRPr lang="en-US"/></a:p></p:txBody></p:sp></p:spTree><p:extLst><p:ext uri="{BB962C8B-B14F-4D97-AF65-F5344CB8AC3E}"><p14:creationId xmlns:p14="http://schemas.microsoft.com/office/powerpoint/2010/main" val="1024086991"/></p:ext></p:extLst></p:cSld><p:clrMapOvr><a:masterClrMapping/></p:clrMapOvr></p:notes>
+而这些，你要九十天以后才会知道。++───── 时间充裕可加 ─────+这就是为什么这个判断必须发生在签约之前，不是发生在报关那一天。</a:t></a:r><a:endParaRPr lang="en-US" dirty="0"/></a:p></p:txBody></p:sp><p:sp><p:nvSpPr><p:cNvPr id="4" name="Slide Number Placeholder 3"/><p:cNvSpPr><a:spLocks noGrp="1"/></p:cNvSpPr><p:nvPr><p:ph type="sldNum" sz="quarter" idx="10"/></p:nvPr></p:nvSpPr><p:spPr/><p:txBody><a:bodyPr/><a:lstStyle/><a:p><a:fld id="{F7021451-1387-4CA6-816F-3879F97B5CBC}" type="slidenum"><a:rPr lang="en-US"/><a:t>5</a:t></a:fld><a:endParaRPr lang="en-US"/></a:p></p:txBody></p:sp></p:spTree><p:extLst><p:ext uri="{BB962C8B-B14F-4D97-AF65-F5344CB8AC3E}"><p14:creationId xmlns:p14="http://schemas.microsoft.com/office/powerpoint/2010/main" val="1024086991"/></p:ext></p:extLst></p:cSld><p:clrMapOvr><a:masterClrMapping/></p:clrMapOvr></p:notes>
 </file>
 
 <file path=ppt/notesSlides/notesSlide6.xml><?xml version="1.0" encoding="UTF-8" standalone="yes"?>
-<p:notes xmlns:a="http://schemas.openxmlformats.org/drawingml/2006/main" xmlns:r="http://schemas.openxmlformats.org/officeDocument/2006/relationships" xmlns:p="http://schemas.openxmlformats.org/presentationml/2006/main"><p:cSld><p:spTree><p:nvGrpSpPr><p:cNvPr id="1" name=""/><p:cNvGrpSpPr/><p:nvPr/></p:nvGrpSpPr><p:grpSpPr><a:xfrm><a:off x="0" y="0"/><a:ext cx="0" cy="0"/><a:chOff x="0" y="0"/><a:chExt cx="0" cy="0"/></a:xfrm></p:grpSpPr><p:sp><p:nvSpPr><p:cNvPr id="2" name="Slide Image Placeholder 1"/><p:cNvSpPr><a:spLocks noGrp="1" noRot="1" noChangeAspect="1"/></p:cNvSpPr><p:nvPr><p:ph type="sldImg"/></p:nvPr></p:nvSpPr><p:spPr/></p:sp><p:sp><p:nvSpPr><p:cNvPr id="3" name="Notes Placeholder 2"/><p:cNvSpPr><a:spLocks noGrp="1"/></p:cNvSpPr><p:nvPr><p:ph type="body" idx="1"/></p:nvPr></p:nvSpPr><p:spPr/><p:txBody><a:bodyPr/><a:lstStyle/><a:p><a:r><a:rPr lang="en-US" dirty="0"/><a:t>（2:20–2:45）+<p:notes xmlns:a="http://schemas.openxmlformats.org/drawingml/2006/main" xmlns:r="http://schemas.openxmlformats.org/officeDocument/2006/relationships" xmlns:p="http://schemas.openxmlformats.org/presentationml/2006/main"><p:cSld><p:spTree><p:nvGrpSpPr><p:cNvPr id="1" name=""/><p:cNvGrpSpPr/><p:nvPr/></p:nvGrpSpPr><p:grpSpPr><a:xfrm><a:off x="0" y="0"/><a:ext cx="0" cy="0"/><a:chOff x="0" y="0"/><a:chExt cx="0" cy="0"/></a:xfrm></p:grpSpPr><p:sp><p:nvSpPr><p:cNvPr id="2" name="Slide Image Placeholder 1"/><p:cNvSpPr><a:spLocks noGrp="1" noRot="1" noChangeAspect="1"/></p:cNvSpPr><p:nvPr><p:ph type="sldImg"/></p:nvPr></p:nvSpPr><p:spPr/></p:sp><p:sp><p:nvSpPr><p:cNvPr id="3" name="Notes Placeholder 2"/><p:cNvSpPr><a:spLocks noGrp="1"/></p:cNvSpPr><p:nvPr><p:ph type="body" idx="1"/></p:nvPr></p:nvSpPr><p:spPr/><p:txBody><a:bodyPr/><a:lstStyle/><a:p><a:r><a:rPr lang="en-US" dirty="0"/><a:t>（2:20–2:42　22 秒　89 字）+ 所以我们做了这个工具。-把展会上那段微信对话，原样贴进去。-八秒钟，出一份可以直接给老板看的决策简报。+把那段微信对话原样贴进去，不用整理，八秒出一份决策简报。 [指流程]-模型只做一件事：把这段乱七八糟的话读成结构。-判定不归它管。</a:t></a:r><a:endParaRPr lang="en-US" dirty="0"/></a:p></p:txBody></p:sp><p:sp><p:nvSpPr><p:cNvPr id="4" name="Slide Number Placeholder 3"/><p:cNvSpPr><a:spLocks noGrp="1"/></p:cNvSpPr><p:nvPr><p:ph type="sldNum" sz="quarter" idx="10"/></p:nvPr></p:nvSpPr><p:spPr/><p:txBody><a:bodyPr/><a:lstStyle/><a:p><a:fld id="{F7021451-1387-4CA6-816F-3879F97B5CBC}" type="slidenum"><a:rPr lang="en-US"/><a:t>6</a:t></a:fld><a:endParaRPr lang="en-US"/></a:p></p:txBody></p:sp></p:spTree><p:extLst><p:ext uri="{BB962C8B-B14F-4D97-AF65-F5344CB8AC3E}"><p14:creationId xmlns:p14="http://schemas.microsoft.com/office/powerpoint/2010/main" val="1024086991"/></p:ext></p:extLst></p:cSld><p:clrMapOvr><a:masterClrMapping/></p:clrMapOvr></p:notes>
+分工要说清楚：模型只做一件事，把这段乱七八糟的话读成结构。+该不该做、算多少钱、写哪几条，都不归它管。++───── 时间充裕可加 ─────+因为算错一个税率就是真金白银的亏损，这种事不能交给一个每次回答都可能不一样的东西。</a:t></a:r><a:endParaRPr lang="en-US" dirty="0"/></a:p></p:txBody></p:sp><p:sp><p:nvSpPr><p:cNvPr id="4" name="Slide Number Placeholder 3"/><p:cNvSpPr><a:spLocks noGrp="1"/></p:cNvSpPr><p:nvPr><p:ph type="sldNum" sz="quarter" idx="10"/></p:nvPr></p:nvSpPr><p:spPr/><p:txBody><a:bodyPr/><a:lstStyle/><a:p><a:fld id="{F7021451-1387-4CA6-816F-3879F97B5CBC}" type="slidenum"><a:rPr lang="en-US"/><a:t>6</a:t></a:fld><a:endParaRPr lang="en-US"/></a:p></p:txBody></p:sp></p:spTree><p:extLst><p:ext uri="{BB962C8B-B14F-4D97-AF65-F5344CB8AC3E}"><p14:creationId xmlns:p14="http://schemas.microsoft.com/office/powerpoint/2010/main" val="1024086991"/></p:ext></p:extLst></p:cSld><p:clrMapOvr><a:masterClrMapping/></p:clrMapOvr></p:notes>
 </file>
 
 <file path=ppt/notesSlides/notesSlide7.xml><?xml version="1.0" encoding="UTF-8" standalone="yes"?>
-<p:notes xmlns:a="http://schemas.openxmlformats.org/drawingml/2006/main" xmlns:r="http://schemas.openxmlformats.org/officeDocument/2006/relationships" xmlns:p="http://schemas.openxmlformats.org/presentationml/2006/main"><p:cSld><p:spTree><p:nvGrpSpPr><p:cNvPr id="1" name=""/><p:cNvGrpSpPr/><p:nvPr/></p:nvGrpSpPr><p:grpSpPr><a:xfrm><a:off x="0" y="0"/><a:ext cx="0" cy="0"/><a:chOff x="0" y="0"/><a:chExt cx="0" cy="0"/></a:xfrm></p:grpSpPr><p:sp><p:nvSpPr><p:cNvPr id="2" name="Slide Image Placeholder 1"/><p:cNvSpPr><a:spLocks noGrp="1" noRot="1" noChangeAspect="1"/></p:cNvSpPr><p:nvPr><p:ph type="sldImg"/></p:nvPr></p:nvSpPr><p:spPr/></p:sp><p:sp><p:nvSpPr><p:cNvPr id="3" name="Notes Placeholder 2"/><p:cNvSpPr><a:spLocks noGrp="1"/></p:cNvSpPr><p:nvPr><p:ph type="body" idx="1"/></p:nvPr></p:nvSpPr><p:spPr/><p:txBody><a:bodyPr/><a:lstStyle/><a:p><a:r><a:rPr lang="en-US" dirty="0"/><a:t>（2:45–3:10）-我们的判定，用一瓶酒来表示。+<p:notes xmlns:a="http://schemas.openxmlformats.org/drawingml/2006/main" xmlns:r="http://schemas.openxmlformats.org/officeDocument/2006/relationships" xmlns:p="http://schemas.openxmlformats.org/presentationml/2006/main"><p:cSld><p:spTree><p:nvGrpSpPr><p:cNvPr id="1" name=""/><p:cNvGrpSpPr/><p:nvPr/></p:nvGrpSpPr><p:grpSpPr><a:xfrm><a:off x="0" y="0"/><a:ext cx="0" cy="0"/><a:chOff x="0" y="0"/><a:chExt cx="0" cy="0"/></a:xfrm></p:grpSpPr><p:sp><p:nvSpPr><p:cNvPr id="2" name="Slide Image Placeholder 1"/><p:cNvSpPr><a:spLocks noGrp="1" noRot="1" noChangeAspect="1"/></p:cNvSpPr><p:nvPr><p:ph type="sldImg"/></p:nvPr></p:nvSpPr><p:spPr/></p:sp><p:sp><p:nvSpPr><p:cNvPr id="3" name="Notes Placeholder 2"/><p:cNvSpPr><a:spLocks noGrp="1"/></p:cNvSpPr><p:nvPr><p:ph type="body" idx="1"/></p:nvPr></p:nvSpPr><p:spPr/><p:txBody><a:bodyPr/><a:lstStyle/><a:p><a:r><a:rPr lang="en-US" dirty="0"/><a:t>（2:42–3:06　24 秒　104 字）++判定我们用一瓶酒表示。 [指两瓶]-瓶子永远是满的。变的是里面装什么。-左边这瓶装的是酒——他是来买酒的，可以谈。+瓶子永远是满的，变的是里面装什么。+左边装的是酒，他是来买酒的，可以谈。 右边这瓶，红的是税差，从瓶底把酒顶上来了。-这一瓶，不是酒。</a:t></a:r><a:endParaRPr lang="en-US" dirty="0"/></a:p></p:txBody></p:sp><p:sp><p:nvSpPr><p:cNvPr id="4" name="Slide Number Placeholder 3"/><p:cNvSpPr><a:spLocks noGrp="1"/></p:cNvSpPr><p:nvPr><p:ph type="sldNum" sz="quarter" idx="10"/></p:nvPr></p:nvSpPr><p:spPr/><p:txBody><a:bodyPr/><a:lstStyle/><a:p><a:fld id="{F7021451-1387-4CA6-816F-3879F97B5CBC}" type="slidenum"><a:rPr lang="en-US"/><a:t>7</a:t></a:fld><a:endParaRPr lang="en-US"/></a:p></p:txBody></p:sp></p:spTree><p:extLst><p:ext uri="{BB962C8B-B14F-4D97-AF65-F5344CB8AC3E}"><p14:creationId xmlns:p14="http://schemas.microsoft.com/office/powerpoint/2010/main" val="1024086991"/></p:ext></p:extLst></p:cSld><p:clrMapOvr><a:masterClrMapping/></p:clrMapOvr></p:notes>
+这一瓶里装的不是酒。+业务员不必看懂评分模型，看一眼瓶子就知道该不该往下谈。++───── 时间充裕可加 ─────+红色占多高，就是套利风险分是多少——这两件事在界面上是同一个东西。</a:t></a:r><a:endParaRPr lang="en-US" dirty="0"/></a:p></p:txBody></p:sp><p:sp><p:nvSpPr><p:cNvPr id="4" name="Slide Number Placeholder 3"/><p:cNvSpPr><a:spLocks noGrp="1"/></p:cNvSpPr><p:nvPr><p:ph type="sldNum" sz="quarter" idx="10"/></p:nvPr></p:nvSpPr><p:spPr/><p:txBody><a:bodyPr/><a:lstStyle/><a:p><a:fld id="{F7021451-1387-4CA6-816F-3879F97B5CBC}" type="slidenum"><a:rPr lang="en-US"/><a:t>7</a:t></a:fld><a:endParaRPr lang="en-US"/></a:p></p:txBody></p:sp></p:spTree><p:extLst><p:ext uri="{BB962C8B-B14F-4D97-AF65-F5344CB8AC3E}"><p14:creationId xmlns:p14="http://schemas.microsoft.com/office/powerpoint/2010/main" val="1024086991"/></p:ext></p:extLst></p:cSld><p:clrMapOvr><a:masterClrMapping/></p:clrMapOvr></p:notes>
 </file>
 
 <file path=ppt/notesSlides/notesSlide8.xml><?xml version="1.0" encoding="UTF-8" standalone="yes"?>
-<p:notes xmlns:a="http://schemas.openxmlformats.org/drawingml/2006/main" xmlns:r="http://schemas.openxmlformats.org/officeDocument/2006/relationships" xmlns:p="http://schemas.openxmlformats.org/presentationml/2006/main"><p:cSld><p:spTree><p:nvGrpSpPr><p:cNvPr id="1" name=""/><p:cNvGrpSpPr/><p:nvPr/></p:nvGrpSpPr><p:grpSpPr><a:xfrm><a:off x="0" y="0"/><a:ext cx="0" cy="0"/><a:chOff x="0" y="0"/><a:chExt cx="0" cy="0"/></a:xfrm></p:grpSpPr><p:sp><p:nvSpPr><p:cNvPr id="2" name="Slide Image Placeholder 1"/><p:cNvSpPr><a:spLocks noGrp="1" noRot="1" noChangeAspect="1"/></p:cNvSpPr><p:nvPr><p:ph type="sldImg"/></p:nvPr></p:nvSpPr><p:spPr/></p:sp><p:sp><p:nvSpPr><p:cNvPr id="3" name="Notes Placeholder 2"/><p:cNvSpPr><a:spLocks noGrp="1"/></p:cNvSpPr><p:nvPr><p:ph type="body" idx="1"/></p:nvPr></p:nvSpPr><p:spPr/><p:txBody><a:bodyPr/><a:lstStyle/><a:p><a:r><a:rPr lang="en-US" dirty="0"/><a:t>（3:10–3:35）-展开是六个页签，一页回答一个问题。-[逐个点]-该不该做、凭什么这么判、这瓶酒卖多少钱、+<p:notes xmlns:a="http://schemas.openxmlformats.org/drawingml/2006/main" xmlns:r="http://schemas.openxmlformats.org/officeDocument/2006/relationships" xmlns:p="http://schemas.openxmlformats.org/presentationml/2006/main"><p:cSld><p:spTree><p:nvGrpSpPr><p:cNvPr id="1" name=""/><p:cNvGrpSpPr/><p:nvPr/></p:nvGrpSpPr><p:grpSpPr><a:xfrm><a:off x="0" y="0"/><a:ext cx="0" cy="0"/><a:chOff x="0" y="0"/><a:chExt cx="0" cy="0"/></a:xfrm></p:grpSpPr><p:sp><p:nvSpPr><p:cNvPr id="2" name="Slide Image Placeholder 1"/><p:cNvSpPr><a:spLocks noGrp="1" noRot="1" noChangeAspect="1"/></p:cNvSpPr><p:nvPr><p:ph type="sldImg"/></p:nvPr></p:nvSpPr><p:spPr/></p:sp><p:sp><p:nvSpPr><p:cNvPr id="3" name="Notes Placeholder 2"/><p:cNvSpPr><a:spLocks noGrp="1"/></p:cNvSpPr><p:nvPr><p:ph type="body" idx="1"/></p:nvPr></p:nvSpPr><p:spPr/><p:txBody><a:bodyPr/><a:lstStyle/><a:p><a:r><a:rPr lang="en-US" dirty="0"/><a:t>（3:06–3:32　26 秒　110 字）++展开是六个页签，一页回答一个问题：+该不该做、凭什么这么判、卖多少钱、 他有没有牌照、怎么跟他讲、合同和之后九十天怎么盯。-业务员站在展位上，需要的是六个答案，不是一篇报告。-[这里切到现场 demo]</a:t></a:r><a:endParaRPr lang="en-US" dirty="0"/></a:p></p:txBody></p:sp><p:sp><p:nvSpPr><p:cNvPr id="4" name="Slide Number Placeholder 3"/><p:cNvSpPr><a:spLocks noGrp="1"/></p:cNvSpPr><p:nvPr><p:ph type="sldNum" sz="quarter" idx="10"/></p:nvPr></p:nvSpPr><p:spPr/><p:txBody><a:bodyPr/><a:lstStyle/><a:p><a:fld id="{F7021451-1387-4CA6-816F-3879F97B5CBC}" type="slidenum"><a:rPr lang="en-US"/><a:t>8</a:t></a:fld><a:endParaRPr lang="en-US"/></a:p></p:txBody></p:sp></p:spTree><p:extLst><p:ext uri="{BB962C8B-B14F-4D97-AF65-F5344CB8AC3E}"><p14:creationId xmlns:p14="http://schemas.microsoft.com/office/powerpoint/2010/main" val="1024086991"/></p:ext></p:extLst></p:cSld><p:clrMapOvr><a:masterClrMapping/></p:clrMapOvr></p:notes>
+六项信号是模型给的初判，但最后一票在人手上——+AI 看得到文字，看不到展位上他说「标签不用改」时的表情。+[切到现场 demo]++───── 时间充裕可加 ─────+改任何一项，判定、必问清单、合同条款会立刻跟着重算。</a:t></a:r><a:endParaRPr lang="en-US" dirty="0"/></a:p></p:txBody></p:sp><p:sp><p:nvSpPr><p:cNvPr id="4" name="Slide Number Placeholder 3"/><p:cNvSpPr><a:spLocks noGrp="1"/></p:cNvSpPr><p:nvPr><p:ph type="sldNum" sz="quarter" idx="10"/></p:nvPr></p:nvSpPr><p:spPr/><p:txBody><a:bodyPr/><a:lstStyle/><a:p><a:fld id="{F7021451-1387-4CA6-816F-3879F97B5CBC}" type="slidenum"><a:rPr lang="en-US"/><a:t>8</a:t></a:fld><a:endParaRPr lang="en-US"/></a:p></p:txBody></p:sp></p:spTree><p:extLst><p:ext uri="{BB962C8B-B14F-4D97-AF65-F5344CB8AC3E}"><p14:creationId xmlns:p14="http://schemas.microsoft.com/office/powerpoint/2010/main" val="1024086991"/></p:ext></p:extLst></p:cSld><p:clrMapOvr><a:masterClrMapping/></p:clrMapOvr></p:notes>
 </file>
 
 <file path=ppt/notesSlides/notesSlide9.xml><?xml version="1.0" encoding="UTF-8" standalone="yes"?>
-<p:notes xmlns:a="http://schemas.openxmlformats.org/drawingml/2006/main" xmlns:r="http://schemas.openxmlformats.org/officeDocument/2006/relationships" xmlns:p="http://schemas.openxmlformats.org/presentationml/2006/main"><p:cSld><p:spTree><p:nvGrpSpPr><p:cNvPr id="1" name=""/><p:cNvGrpSpPr/><p:nvPr/></p:nvGrpSpPr><p:grpSpPr><a:xfrm><a:off x="0" y="0"/><a:ext cx="0" cy="0"/><a:chOff x="0" y="0"/><a:chExt cx="0" cy="0"/></a:xfrm></p:grpSpPr><p:sp><p:nvSpPr><p:cNvPr id="2" name="Slide Image Placeholder 1"/><p:cNvSpPr><a:spLocks noGrp="1" noRot="1" noChangeAspect="1"/></p:cNvSpPr><p:nvPr><p:ph type="sldImg"/></p:nvPr></p:nvSpPr><p:spPr/></p:sp><p:sp><p:nvSpPr><p:cNvPr id="3" name="Notes Placeholder 2"/><p:cNvSpPr><a:spLocks noGrp="1"/></p:cNvSpPr><p:nvPr><p:ph type="body" idx="1"/></p:nvPr></p:nvSpPr><p:spPr/><p:txBody><a:bodyPr/><a:lstStyle/><a:p><a:r><a:rPr lang="en-US" dirty="0"/><a:t>（3:35–4:05）+<p:notes xmlns:a="http://schemas.openxmlformats.org/drawingml/2006/main" xmlns:r="http://schemas.openxmlformats.org/officeDocument/2006/relationships" xmlns:p="http://schemas.openxmlformats.org/presentationml/2006/main"><p:cSld><p:spTree><p:nvGrpSpPr><p:cNvPr id="1" name=""/><p:cNvGrpSpPr/><p:nvPr/></p:nvGrpSpPr><p:grpSpPr><a:xfrm><a:off x="0" y="0"/><a:ext cx="0" cy="0"/><a:chOff x="0" y="0"/><a:chExt cx="0" cy="0"/></a:xfrm></p:grpSpPr><p:sp><p:nvSpPr><p:cNvPr id="2" name="Slide Image Placeholder 1"/><p:cNvSpPr><a:spLocks noGrp="1" noRot="1" noChangeAspect="1"/></p:cNvSpPr><p:nvPr><p:ph type="sldImg"/></p:nvPr></p:nvSpPr><p:spPr/></p:sp><p:sp><p:nvSpPr><p:cNvPr id="3" name="Notes Placeholder 2"/><p:cNvSpPr><a:spLocks noGrp="1"/></p:cNvSpPr><p:nvPr><p:ph type="body" idx="1"/></p:nvPr></p:nvSpPr><p:spPr/><p:txBody><a:bodyPr/><a:lstStyle/><a:p><a:r><a:rPr lang="en-US" dirty="0"/><a:t>（3:32–4:04　32 秒　147 字）+ 为什么不直接问通用大模型？ 因为这三条它不会告诉你，是我们逐条翻税则翻出来的：-香港烈酒减税，只减两百港币以上的那一部分。-新加坡按纯酒精量课税——降度数，等于直接少缴税。-美国的 CBMA 额度，必须由中国生产商主动指派，进口商自己拿不到。-一瓶差十块七，一柜十几万，不花你一毛钱。</a:t></a:r><a:endParaRPr lang="en-US" dirty="0"/></a:p></p:txBody></p:sp><p:sp><p:nvSpPr><p:cNvPr id="4" name="Slide Number Placeholder 3"/><p:cNvSpPr><a:spLocks noGrp="1"/></p:cNvSpPr><p:nvPr><p:ph type="sldNum" sz="quarter" idx="10"/></p:nvPr></p:nvSpPr><p:spPr/><p:txBody><a:bodyPr/><a:lstStyle/><a:p><a:fld id="{F7021451-1387-4CA6-816F-3879F97B5CBC}" type="slidenum"><a:rPr lang="en-US"/><a:t>9</a:t></a:fld><a:endParaRPr lang="en-US"/></a:p></p:txBody></p:sp></p:spTree><p:extLst><p:ext uri="{BB962C8B-B14F-4D97-AF65-F5344CB8AC3E}"><p14:creationId xmlns:p14="http://schemas.microsoft.com/office/powerpoint/2010/main" val="1024086991"/></p:ext></p:extLst></p:cSld><p:clrMapOvr><a:masterClrMapping/></p:clrMapOvr></p:notes>
+香港烈酒减税只减两百港币以上那一部分，低价酒完全享受不到。+新加坡按纯酒精量课税，不看瓶数，降度数等于直接少缴税。+美国的 CBMA 额度必须由中国生产商主动指派，进口商自己拿不到；+一瓶差十块七，一柜十几万，而且不花你一毛钱。++───── 时间充裕可加 ─────+通用模型给你的多半是「约百分之三十到五十综合税负」这种区间。拿这个去跟老板报价，是会出事的。</a:t></a:r><a:endParaRPr lang="en-US" dirty="0"/></a:p></p:txBody></p:sp><p:sp><p:nvSpPr><p:cNvPr id="4" name="Slide Number Placeholder 3"/><p:cNvSpPr><a:spLocks noGrp="1"/></p:cNvSpPr><p:nvPr><p:ph type="sldNum" sz="quarter" idx="10"/></p:nvPr></p:nvSpPr><p:spPr/><p:txBody><a:bodyPr/><a:lstStyle/><a:p><a:fld id="{F7021451-1387-4CA6-816F-3879F97B5CBC}" type="slidenum"><a:rPr lang="en-US"/><a:t>9</a:t></a:fld><a:endParaRPr lang="en-US"/></a:p></p:txBody></p:sp></p:spTree><p:extLst><p:ext uri="{BB962C8B-B14F-4D97-AF65-F5344CB8AC3E}"><p14:creationId xmlns:p14="http://schemas.microsoft.com/office/powerpoint/2010/main" val="1024086991"/></p:ext></p:extLst></p:cSld><p:clrMapOvr><a:masterClrMapping/></p:clrMapOvr></p:notes>
 </file>
 
 <file path=ppt/slideLayouts/slideLayout1.xml><?xml version="1.0" encoding="utf-8"?>

</xml_diff>

<commit_message>
fix(deck): stop writing an illegal control character into the notes XML
Using a vertical tab as the line break made PowerPoint declare the file
damaged and, on repair, throw every note away — 0x0B is not a legal
character in XML 1.0, so the notes parts were malformed the moment they
were written. It only looked like it worked because the zip still opened
and LibreOffice was lenient.

Notes now carry a sentinel through pptxgenjs and a post-pass splits them
into real <a:p> paragraphs, which is how PowerPoint represents a line
break. The pass also validates every XML part in the package and fails
loudly on any control character, so this cannot regress silently again.
</commit_message>
<xml_diff>
--- a/docs/第二单_SecondOrder_路演.pptx
+++ b/docs/第二单_SecondOrder_路演.pptx
@@ -476,51 +476,542 @@
 </p:notesMaster>
 </file>
 
-<file path=ppt/notesSlides/notesSlide1.xml><?xml version="1.0" encoding="UTF-8" standalone="yes"?>
-<p:notes xmlns:a="http://schemas.openxmlformats.org/drawingml/2006/main" xmlns:r="http://schemas.openxmlformats.org/officeDocument/2006/relationships" xmlns:p="http://schemas.openxmlformats.org/presentationml/2006/main"><p:cSld><p:spTree><p:nvGrpSpPr><p:cNvPr id="1" name=""/><p:cNvGrpSpPr/><p:nvPr/></p:nvGrpSpPr><p:grpSpPr><a:xfrm><a:off x="0" y="0"/><a:ext cx="0" cy="0"/><a:chOff x="0" y="0"/><a:chExt cx="0" cy="0"/></a:xfrm></p:grpSpPr><p:sp><p:nvSpPr><p:cNvPr id="2" name="Slide Image Placeholder 1"/><p:cNvSpPr><a:spLocks noGrp="1" noRot="1" noChangeAspect="1"/></p:cNvSpPr><p:nvPr><p:ph type="sldImg"/></p:nvPr></p:nvSpPr><p:spPr/></p:sp><p:sp><p:nvSpPr><p:cNvPr id="3" name="Notes Placeholder 2"/><p:cNvSpPr><a:spLocks noGrp="1"/></p:cNvSpPr><p:nvPr><p:ph type="body" idx="1"/></p:nvPr></p:nvSpPr><p:spPr/><p:txBody><a:bodyPr/><a:lstStyle/><a:p><a:r><a:rPr lang="en-US" dirty="0"/><a:t>（0:00–0:18　18 秒　79 字）--[停两秒，让评委先看完标题]-各位评委好。-扫码验茅台真假，大家都会。我们做的是同一个动作，方向反过来——-扫的不是酒，是买家。-它叫「第二单」，用户是贵州仁怀、遵义那些没有海外团队的中小酒企。--───── 时间充裕可加 ─────-为什么不是第一单，最后一页会回答。</a:t></a:r><a:endParaRPr lang="en-US" dirty="0"/></a:p></p:txBody></p:sp><p:sp><p:nvSpPr><p:cNvPr id="4" name="Slide Number Placeholder 3"/><p:cNvSpPr><a:spLocks noGrp="1"/></p:cNvSpPr><p:nvPr><p:ph type="sldNum" sz="quarter" idx="10"/></p:nvPr></p:nvSpPr><p:spPr/><p:txBody><a:bodyPr/><a:lstStyle/><a:p><a:fld id="{F7021451-1387-4CA6-816F-3879F97B5CBC}" type="slidenum"><a:rPr lang="en-US"/><a:t>1</a:t></a:fld><a:endParaRPr lang="en-US"/></a:p></p:txBody></p:sp></p:spTree><p:extLst><p:ext uri="{BB962C8B-B14F-4D97-AF65-F5344CB8AC3E}"><p14:creationId xmlns:p14="http://schemas.microsoft.com/office/powerpoint/2010/main" val="1024086991"/></p:ext></p:extLst></p:cSld><p:clrMapOvr><a:masterClrMapping/></p:clrMapOvr></p:notes>
+<file path=ppt/notesSlides/notesSlide1.xml><?xml version="1.0" encoding="utf-8"?>
+<p:notes xmlns:a="http://schemas.openxmlformats.org/drawingml/2006/main" xmlns:r="http://schemas.openxmlformats.org/officeDocument/2006/relationships" xmlns:p="http://schemas.openxmlformats.org/presentationml/2006/main">
+  <p:cSld>
+    <p:spTree>
+      <p:nvGrpSpPr>
+        <p:cNvPr id="1" name=""/>
+        <p:cNvGrpSpPr/>
+        <p:nvPr/>
+      </p:nvGrpSpPr>
+      <p:grpSpPr>
+        <a:xfrm>
+          <a:off x="0" y="0"/>
+          <a:ext cx="0" cy="0"/>
+          <a:chOff x="0" y="0"/>
+          <a:chExt cx="0" cy="0"/>
+        </a:xfrm>
+      </p:grpSpPr>
+      <p:sp>
+        <p:nvSpPr>
+          <p:cNvPr id="2" name="Slide Image Placeholder 1"/>
+          <p:cNvSpPr>
+            <a:spLocks noGrp="1" noRot="1" noChangeAspect="1"/>
+          </p:cNvSpPr>
+          <p:nvPr>
+            <p:ph type="sldImg"/>
+          </p:nvPr>
+        </p:nvSpPr>
+        <p:spPr/>
+      </p:sp>
+      <p:sp>
+        <p:nvSpPr>
+          <p:cNvPr id="3" name="Notes Placeholder 2"/>
+          <p:cNvSpPr>
+            <a:spLocks noGrp="1"/>
+          </p:cNvSpPr>
+          <p:nvPr>
+            <p:ph type="body" idx="1"/>
+          </p:nvPr>
+        </p:nvSpPr>
+        <p:spPr/>
+        <p:txBody>
+          <a:bodyPr/>
+          <a:lstStyle/>
+          <a:p>
+            <a:r>
+              <a:rPr lang="en-US" dirty="0"/>
+              <a:t>（0:00–0:18　18 秒　79 字）</a:t>
+            </a:r>
+          </a:p>
+          <a:p>
+            <a:r>
+              <a:rPr lang="zh-CN" altLang="en-US" dirty="0"/>
+              <a:t/>
+            </a:r>
+          </a:p>
+          <a:p>
+            <a:r>
+              <a:rPr lang="zh-CN" altLang="en-US" dirty="0"/>
+              <a:t>[停两秒，让评委先看完标题]</a:t>
+            </a:r>
+          </a:p>
+          <a:p>
+            <a:r>
+              <a:rPr lang="zh-CN" altLang="en-US" dirty="0"/>
+              <a:t>各位评委好。</a:t>
+            </a:r>
+          </a:p>
+          <a:p>
+            <a:r>
+              <a:rPr lang="zh-CN" altLang="en-US" dirty="0"/>
+              <a:t>扫码验茅台真假，大家都会。我们做的是同一个动作，方向反过来——</a:t>
+            </a:r>
+          </a:p>
+          <a:p>
+            <a:r>
+              <a:rPr lang="zh-CN" altLang="en-US" dirty="0"/>
+              <a:t>扫的不是酒，是买家。</a:t>
+            </a:r>
+          </a:p>
+          <a:p>
+            <a:r>
+              <a:rPr lang="zh-CN" altLang="en-US" dirty="0"/>
+              <a:t>它叫「第二单」，用户是贵州仁怀、遵义那些没有海外团队的中小酒企。</a:t>
+            </a:r>
+          </a:p>
+          <a:p>
+            <a:r>
+              <a:rPr lang="zh-CN" altLang="en-US" dirty="0"/>
+              <a:t/>
+            </a:r>
+          </a:p>
+          <a:p>
+            <a:r>
+              <a:rPr lang="zh-CN" altLang="en-US" dirty="0"/>
+              <a:t>───── 时间充裕可加 ─────</a:t>
+            </a:r>
+          </a:p>
+          <a:p>
+            <a:r>
+              <a:rPr lang="zh-CN" altLang="en-US" dirty="0"/>
+              <a:t>为什么不是第一单，最后一页会回答。</a:t>
+            </a:r>
+            <a:endParaRPr lang="en-US" dirty="0"/>
+          </a:p>
+        </p:txBody>
+      </p:sp>
+      <p:sp>
+        <p:nvSpPr>
+          <p:cNvPr id="4" name="Slide Number Placeholder 3"/>
+          <p:cNvSpPr>
+            <a:spLocks noGrp="1"/>
+          </p:cNvSpPr>
+          <p:nvPr>
+            <p:ph type="sldNum" sz="quarter" idx="10"/>
+          </p:nvPr>
+        </p:nvSpPr>
+        <p:spPr/>
+        <p:txBody>
+          <a:bodyPr/>
+          <a:lstStyle/>
+          <a:p>
+            <a:fld id="{F7021451-1387-4CA6-816F-3879F97B5CBC}" type="slidenum">
+              <a:rPr lang="en-US"/>
+              <a:t>1</a:t>
+            </a:fld>
+            <a:endParaRPr lang="en-US"/>
+          </a:p>
+        </p:txBody>
+      </p:sp>
+    </p:spTree>
+    <p:extLst>
+      <p:ext uri="{BB962C8B-B14F-4D97-AF65-F5344CB8AC3E}">
+        <p14:creationId xmlns:p14="http://schemas.microsoft.com/office/powerpoint/2010/main" val="1024086991"/>
+      </p:ext>
+    </p:extLst>
+  </p:cSld>
+  <p:clrMapOvr>
+    <a:masterClrMapping/>
+  </p:clrMapOvr>
+</p:notes>
 </file>
 
-<file path=ppt/notesSlides/notesSlide10.xml><?xml version="1.0" encoding="UTF-8" standalone="yes"?>
-<p:notes xmlns:a="http://schemas.openxmlformats.org/drawingml/2006/main" xmlns:r="http://schemas.openxmlformats.org/officeDocument/2006/relationships" xmlns:p="http://schemas.openxmlformats.org/presentationml/2006/main"><p:cSld><p:spTree><p:nvGrpSpPr><p:cNvPr id="1" name=""/><p:cNvGrpSpPr/><p:nvPr/></p:nvGrpSpPr><p:grpSpPr><a:xfrm><a:off x="0" y="0"/><a:ext cx="0" cy="0"/><a:chOff x="0" y="0"/><a:chExt cx="0" cy="0"/></a:xfrm></p:grpSpPr><p:sp><p:nvSpPr><p:cNvPr id="2" name="Slide Image Placeholder 1"/><p:cNvSpPr><a:spLocks noGrp="1" noRot="1" noChangeAspect="1"/></p:cNvSpPr><p:nvPr><p:ph type="sldImg"/></p:nvPr></p:nvSpPr><p:spPr/></p:sp><p:sp><p:nvSpPr><p:cNvPr id="3" name="Notes Placeholder 2"/><p:cNvSpPr><a:spLocks noGrp="1"/></p:cNvSpPr><p:nvPr><p:ph type="body" idx="1"/></p:nvPr></p:nvSpPr><p:spPr/><p:txBody><a:bodyPr/><a:lstStyle/><a:p><a:r><a:rPr lang="en-US" dirty="0"/><a:t>（4:04–4:30　26 秒　121 字）--技术上只坚持一件事：规则算账，模型说人话。-税则、牌照、风险评分、合同条款全是可审计的纯函数，-同样输入永远同样输出，每条都带来源和生效日期。-模型只负责两件事：读懂对话，把结论写成一封能寄出去的信。-所以模型挂了主链路照样跑完，现场断网也演示得完。--───── 时间充裕可加 ─────-日本原本在候选名单里，但公开资料对烈酒税率的表述不够明确，我们宁可不收——收一条不确定的税率，赔上的是整个规则库的可信度。</a:t></a:r><a:endParaRPr lang="en-US" dirty="0"/></a:p></p:txBody></p:sp><p:sp><p:nvSpPr><p:cNvPr id="4" name="Slide Number Placeholder 3"/><p:cNvSpPr><a:spLocks noGrp="1"/></p:cNvSpPr><p:nvPr><p:ph type="sldNum" sz="quarter" idx="10"/></p:nvPr></p:nvSpPr><p:spPr/><p:txBody><a:bodyPr/><a:lstStyle/><a:p><a:fld id="{F7021451-1387-4CA6-816F-3879F97B5CBC}" type="slidenum"><a:rPr lang="en-US"/><a:t>10</a:t></a:fld><a:endParaRPr lang="en-US"/></a:p></p:txBody></p:sp></p:spTree><p:extLst><p:ext uri="{BB962C8B-B14F-4D97-AF65-F5344CB8AC3E}"><p14:creationId xmlns:p14="http://schemas.microsoft.com/office/powerpoint/2010/main" val="1024086991"/></p:ext></p:extLst></p:cSld><p:clrMapOvr><a:masterClrMapping/></p:clrMapOvr></p:notes>
+<file path=ppt/notesSlides/notesSlide10.xml><?xml version="1.0" encoding="utf-8"?>
+<p:notes xmlns:a="http://schemas.openxmlformats.org/drawingml/2006/main" xmlns:r="http://schemas.openxmlformats.org/officeDocument/2006/relationships" xmlns:p="http://schemas.openxmlformats.org/presentationml/2006/main">
+  <p:cSld>
+    <p:spTree>
+      <p:nvGrpSpPr>
+        <p:cNvPr id="1" name=""/>
+        <p:cNvGrpSpPr/>
+        <p:nvPr/>
+      </p:nvGrpSpPr>
+      <p:grpSpPr>
+        <a:xfrm>
+          <a:off x="0" y="0"/>
+          <a:ext cx="0" cy="0"/>
+          <a:chOff x="0" y="0"/>
+          <a:chExt cx="0" cy="0"/>
+        </a:xfrm>
+      </p:grpSpPr>
+      <p:sp>
+        <p:nvSpPr>
+          <p:cNvPr id="2" name="Slide Image Placeholder 1"/>
+          <p:cNvSpPr>
+            <a:spLocks noGrp="1" noRot="1" noChangeAspect="1"/>
+          </p:cNvSpPr>
+          <p:nvPr>
+            <p:ph type="sldImg"/>
+          </p:nvPr>
+        </p:nvSpPr>
+        <p:spPr/>
+      </p:sp>
+      <p:sp>
+        <p:nvSpPr>
+          <p:cNvPr id="3" name="Notes Placeholder 2"/>
+          <p:cNvSpPr>
+            <a:spLocks noGrp="1"/>
+          </p:cNvSpPr>
+          <p:nvPr>
+            <p:ph type="body" idx="1"/>
+          </p:nvPr>
+        </p:nvSpPr>
+        <p:spPr/>
+        <p:txBody>
+          <a:bodyPr/>
+          <a:lstStyle/>
+          <a:p>
+            <a:r>
+              <a:rPr lang="en-US" dirty="0"/>
+              <a:t>（4:04–4:30　26 秒　121 字）</a:t>
+            </a:r>
+          </a:p>
+          <a:p>
+            <a:r>
+              <a:rPr lang="zh-CN" altLang="en-US" dirty="0"/>
+              <a:t/>
+            </a:r>
+          </a:p>
+          <a:p>
+            <a:r>
+              <a:rPr lang="zh-CN" altLang="en-US" dirty="0"/>
+              <a:t>技术上只坚持一件事：规则算账，模型说人话。</a:t>
+            </a:r>
+          </a:p>
+          <a:p>
+            <a:r>
+              <a:rPr lang="zh-CN" altLang="en-US" dirty="0"/>
+              <a:t>税则、牌照、风险评分、合同条款全是可审计的纯函数，</a:t>
+            </a:r>
+          </a:p>
+          <a:p>
+            <a:r>
+              <a:rPr lang="zh-CN" altLang="en-US" dirty="0"/>
+              <a:t>同样输入永远同样输出，每条都带来源和生效日期。</a:t>
+            </a:r>
+          </a:p>
+          <a:p>
+            <a:r>
+              <a:rPr lang="zh-CN" altLang="en-US" dirty="0"/>
+              <a:t>模型只负责两件事：读懂对话，把结论写成一封能寄出去的信。</a:t>
+            </a:r>
+          </a:p>
+          <a:p>
+            <a:r>
+              <a:rPr lang="zh-CN" altLang="en-US" dirty="0"/>
+              <a:t>所以模型挂了主链路照样跑完，现场断网也演示得完。</a:t>
+            </a:r>
+          </a:p>
+          <a:p>
+            <a:r>
+              <a:rPr lang="zh-CN" altLang="en-US" dirty="0"/>
+              <a:t/>
+            </a:r>
+          </a:p>
+          <a:p>
+            <a:r>
+              <a:rPr lang="zh-CN" altLang="en-US" dirty="0"/>
+              <a:t>───── 时间充裕可加 ─────</a:t>
+            </a:r>
+          </a:p>
+          <a:p>
+            <a:r>
+              <a:rPr lang="zh-CN" altLang="en-US" dirty="0"/>
+              <a:t>日本原本在候选名单里，但公开资料对烈酒税率的表述不够明确，我们宁可不收——收一条不确定的税率，赔上的是整个规则库的可信度。</a:t>
+            </a:r>
+            <a:endParaRPr lang="en-US" dirty="0"/>
+          </a:p>
+        </p:txBody>
+      </p:sp>
+      <p:sp>
+        <p:nvSpPr>
+          <p:cNvPr id="4" name="Slide Number Placeholder 3"/>
+          <p:cNvSpPr>
+            <a:spLocks noGrp="1"/>
+          </p:cNvSpPr>
+          <p:nvPr>
+            <p:ph type="sldNum" sz="quarter" idx="10"/>
+          </p:nvPr>
+        </p:nvSpPr>
+        <p:spPr/>
+        <p:txBody>
+          <a:bodyPr/>
+          <a:lstStyle/>
+          <a:p>
+            <a:fld id="{F7021451-1387-4CA6-816F-3879F97B5CBC}" type="slidenum">
+              <a:rPr lang="en-US"/>
+              <a:t>10</a:t>
+            </a:fld>
+            <a:endParaRPr lang="en-US"/>
+          </a:p>
+        </p:txBody>
+      </p:sp>
+    </p:spTree>
+    <p:extLst>
+      <p:ext uri="{BB962C8B-B14F-4D97-AF65-F5344CB8AC3E}">
+        <p14:creationId xmlns:p14="http://schemas.microsoft.com/office/powerpoint/2010/main" val="1024086991"/>
+      </p:ext>
+    </p:extLst>
+  </p:cSld>
+  <p:clrMapOvr>
+    <a:masterClrMapping/>
+  </p:clrMapOvr>
+</p:notes>
 </file>
 
-<file path=ppt/notesSlides/notesSlide11.xml><?xml version="1.0" encoding="UTF-8" standalone="yes"?>
-<p:notes xmlns:a="http://schemas.openxmlformats.org/drawingml/2006/main" xmlns:r="http://schemas.openxmlformats.org/officeDocument/2006/relationships" xmlns:p="http://schemas.openxmlformats.org/presentationml/2006/main"><p:cSld><p:spTree><p:nvGrpSpPr><p:cNvPr id="1" name=""/><p:cNvGrpSpPr/><p:nvPr/></p:nvGrpSpPr><p:grpSpPr><a:xfrm><a:off x="0" y="0"/><a:ext cx="0" cy="0"/><a:chOff x="0" y="0"/><a:chExt cx="0" cy="0"/></a:xfrm></p:grpSpPr><p:sp><p:nvSpPr><p:cNvPr id="2" name="Slide Image Placeholder 1"/><p:cNvSpPr><a:spLocks noGrp="1" noRot="1" noChangeAspect="1"/></p:cNvSpPr><p:nvPr><p:ph type="sldImg"/></p:nvPr></p:nvSpPr><p:spPr/></p:sp><p:sp><p:nvSpPr><p:cNvPr id="3" name="Notes Placeholder 2"/><p:cNvSpPr><a:spLocks noGrp="1"/></p:cNvSpPr><p:nvPr><p:ph type="body" idx="1"/></p:nvPr></p:nvSpPr><p:spPr/><p:txBody><a:bodyPr/><a:lstStyle/><a:p><a:r><a:rPr lang="en-US" dirty="0"/><a:t>（4:30–4:46　16 秒　74 字）--接下来一百天，第三步是设计来证伪我们自己的：-跟三家酒厂走完一次真实首单，拿报关单核对落地价。-误差百分之五以内就能用，差到百分之二十，税则模型得重做。--───── 时间充裕可加 ─────-我们不打算先谈商业模式。先证明能让八十九家里搭上线的从五家变成十家，再谈谁付钱。</a:t></a:r><a:endParaRPr lang="en-US" dirty="0"/></a:p></p:txBody></p:sp><p:sp><p:nvSpPr><p:cNvPr id="4" name="Slide Number Placeholder 3"/><p:cNvSpPr><a:spLocks noGrp="1"/></p:cNvSpPr><p:nvPr><p:ph type="sldNum" sz="quarter" idx="10"/></p:nvPr></p:nvSpPr><p:spPr/><p:txBody><a:bodyPr/><a:lstStyle/><a:p><a:fld id="{F7021451-1387-4CA6-816F-3879F97B5CBC}" type="slidenum"><a:rPr lang="en-US"/><a:t>11</a:t></a:fld><a:endParaRPr lang="en-US"/></a:p></p:txBody></p:sp></p:spTree><p:extLst><p:ext uri="{BB962C8B-B14F-4D97-AF65-F5344CB8AC3E}"><p14:creationId xmlns:p14="http://schemas.microsoft.com/office/powerpoint/2010/main" val="1024086991"/></p:ext></p:extLst></p:cSld><p:clrMapOvr><a:masterClrMapping/></p:clrMapOvr></p:notes>
+<file path=ppt/notesSlides/notesSlide11.xml><?xml version="1.0" encoding="utf-8"?>
+<p:notes xmlns:a="http://schemas.openxmlformats.org/drawingml/2006/main" xmlns:r="http://schemas.openxmlformats.org/officeDocument/2006/relationships" xmlns:p="http://schemas.openxmlformats.org/presentationml/2006/main">
+  <p:cSld>
+    <p:spTree>
+      <p:nvGrpSpPr>
+        <p:cNvPr id="1" name=""/>
+        <p:cNvGrpSpPr/>
+        <p:nvPr/>
+      </p:nvGrpSpPr>
+      <p:grpSpPr>
+        <a:xfrm>
+          <a:off x="0" y="0"/>
+          <a:ext cx="0" cy="0"/>
+          <a:chOff x="0" y="0"/>
+          <a:chExt cx="0" cy="0"/>
+        </a:xfrm>
+      </p:grpSpPr>
+      <p:sp>
+        <p:nvSpPr>
+          <p:cNvPr id="2" name="Slide Image Placeholder 1"/>
+          <p:cNvSpPr>
+            <a:spLocks noGrp="1" noRot="1" noChangeAspect="1"/>
+          </p:cNvSpPr>
+          <p:nvPr>
+            <p:ph type="sldImg"/>
+          </p:nvPr>
+        </p:nvSpPr>
+        <p:spPr/>
+      </p:sp>
+      <p:sp>
+        <p:nvSpPr>
+          <p:cNvPr id="3" name="Notes Placeholder 2"/>
+          <p:cNvSpPr>
+            <a:spLocks noGrp="1"/>
+          </p:cNvSpPr>
+          <p:nvPr>
+            <p:ph type="body" idx="1"/>
+          </p:nvPr>
+        </p:nvSpPr>
+        <p:spPr/>
+        <p:txBody>
+          <a:bodyPr/>
+          <a:lstStyle/>
+          <a:p>
+            <a:r>
+              <a:rPr lang="en-US" dirty="0"/>
+              <a:t>（4:30–4:46　16 秒　74 字）</a:t>
+            </a:r>
+          </a:p>
+          <a:p>
+            <a:r>
+              <a:rPr lang="zh-CN" altLang="en-US" dirty="0"/>
+              <a:t/>
+            </a:r>
+          </a:p>
+          <a:p>
+            <a:r>
+              <a:rPr lang="zh-CN" altLang="en-US" dirty="0"/>
+              <a:t>接下来一百天，第三步是设计来证伪我们自己的：</a:t>
+            </a:r>
+          </a:p>
+          <a:p>
+            <a:r>
+              <a:rPr lang="zh-CN" altLang="en-US" dirty="0"/>
+              <a:t>跟三家酒厂走完一次真实首单，拿报关单核对落地价。</a:t>
+            </a:r>
+          </a:p>
+          <a:p>
+            <a:r>
+              <a:rPr lang="zh-CN" altLang="en-US" dirty="0"/>
+              <a:t>误差百分之五以内就能用，差到百分之二十，税则模型得重做。</a:t>
+            </a:r>
+          </a:p>
+          <a:p>
+            <a:r>
+              <a:rPr lang="zh-CN" altLang="en-US" dirty="0"/>
+              <a:t/>
+            </a:r>
+          </a:p>
+          <a:p>
+            <a:r>
+              <a:rPr lang="zh-CN" altLang="en-US" dirty="0"/>
+              <a:t>───── 时间充裕可加 ─────</a:t>
+            </a:r>
+          </a:p>
+          <a:p>
+            <a:r>
+              <a:rPr lang="zh-CN" altLang="en-US" dirty="0"/>
+              <a:t>我们不打算先谈商业模式。先证明能让八十九家里搭上线的从五家变成十家，再谈谁付钱。</a:t>
+            </a:r>
+            <a:endParaRPr lang="en-US" dirty="0"/>
+          </a:p>
+        </p:txBody>
+      </p:sp>
+      <p:sp>
+        <p:nvSpPr>
+          <p:cNvPr id="4" name="Slide Number Placeholder 3"/>
+          <p:cNvSpPr>
+            <a:spLocks noGrp="1"/>
+          </p:cNvSpPr>
+          <p:nvPr>
+            <p:ph type="sldNum" sz="quarter" idx="10"/>
+          </p:nvPr>
+        </p:nvSpPr>
+        <p:spPr/>
+        <p:txBody>
+          <a:bodyPr/>
+          <a:lstStyle/>
+          <a:p>
+            <a:fld id="{F7021451-1387-4CA6-816F-3879F97B5CBC}" type="slidenum">
+              <a:rPr lang="en-US"/>
+              <a:t>11</a:t>
+            </a:fld>
+            <a:endParaRPr lang="en-US"/>
+          </a:p>
+        </p:txBody>
+      </p:sp>
+    </p:spTree>
+    <p:extLst>
+      <p:ext uri="{BB962C8B-B14F-4D97-AF65-F5344CB8AC3E}">
+        <p14:creationId xmlns:p14="http://schemas.microsoft.com/office/powerpoint/2010/main" val="1024086991"/>
+      </p:ext>
+    </p:extLst>
+  </p:cSld>
+  <p:clrMapOvr>
+    <a:masterClrMapping/>
+  </p:clrMapOvr>
+</p:notes>
 </file>
 
-<file path=ppt/notesSlides/notesSlide12.xml><?xml version="1.0" encoding="UTF-8" standalone="yes"?>
-<p:notes xmlns:a="http://schemas.openxmlformats.org/drawingml/2006/main" xmlns:r="http://schemas.openxmlformats.org/officeDocument/2006/relationships" xmlns:p="http://schemas.openxmlformats.org/presentationml/2006/main"><p:cSld><p:spTree><p:nvGrpSpPr><p:cNvPr id="1" name=""/><p:cNvGrpSpPr/><p:nvPr/></p:nvGrpSpPr><p:grpSpPr><a:xfrm><a:off x="0" y="0"/><a:ext cx="0" cy="0"/><a:chOff x="0" y="0"/><a:chExt cx="0" cy="0"/></a:xfrm></p:grpSpPr><p:sp><p:nvSpPr><p:cNvPr id="2" name="Slide Image Placeholder 1"/><p:cNvSpPr><a:spLocks noGrp="1" noRot="1" noChangeAspect="1"/></p:cNvSpPr><p:nvPr><p:ph type="sldImg"/></p:nvPr></p:nvSpPr><p:spPr/></p:sp><p:sp><p:nvSpPr><p:cNvPr id="3" name="Notes Placeholder 2"/><p:cNvSpPr><a:spLocks noGrp="1"/></p:cNvSpPr><p:nvPr><p:ph type="body" idx="1"/></p:nvPr></p:nvSpPr><p:spPr/><p:txBody><a:bodyPr/><a:lstStyle/><a:p><a:r><a:rPr lang="en-US" dirty="0"/><a:t>（4:46–5:00　14 秒　57 字）--最后一句。-出海不缺第一单，缺的是第二单。-货在他仓里没动，他就不会再下单——-而你到那时才知道，已经晚了九十天。-谢谢。</a:t></a:r><a:endParaRPr lang="en-US" dirty="0"/></a:p></p:txBody></p:sp><p:sp><p:nvSpPr><p:cNvPr id="4" name="Slide Number Placeholder 3"/><p:cNvSpPr><a:spLocks noGrp="1"/></p:cNvSpPr><p:nvPr><p:ph type="sldNum" sz="quarter" idx="10"/></p:nvPr></p:nvSpPr><p:spPr/><p:txBody><a:bodyPr/><a:lstStyle/><a:p><a:fld id="{F7021451-1387-4CA6-816F-3879F97B5CBC}" type="slidenum"><a:rPr lang="en-US"/><a:t>12</a:t></a:fld><a:endParaRPr lang="en-US"/></a:p></p:txBody></p:sp></p:spTree><p:extLst><p:ext uri="{BB962C8B-B14F-4D97-AF65-F5344CB8AC3E}"><p14:creationId xmlns:p14="http://schemas.microsoft.com/office/powerpoint/2010/main" val="1024086991"/></p:ext></p:extLst></p:cSld><p:clrMapOvr><a:masterClrMapping/></p:clrMapOvr></p:notes>
+<file path=ppt/notesSlides/notesSlide12.xml><?xml version="1.0" encoding="utf-8"?>
+<p:notes xmlns:a="http://schemas.openxmlformats.org/drawingml/2006/main" xmlns:r="http://schemas.openxmlformats.org/officeDocument/2006/relationships" xmlns:p="http://schemas.openxmlformats.org/presentationml/2006/main">
+  <p:cSld>
+    <p:spTree>
+      <p:nvGrpSpPr>
+        <p:cNvPr id="1" name=""/>
+        <p:cNvGrpSpPr/>
+        <p:nvPr/>
+      </p:nvGrpSpPr>
+      <p:grpSpPr>
+        <a:xfrm>
+          <a:off x="0" y="0"/>
+          <a:ext cx="0" cy="0"/>
+          <a:chOff x="0" y="0"/>
+          <a:chExt cx="0" cy="0"/>
+        </a:xfrm>
+      </p:grpSpPr>
+      <p:sp>
+        <p:nvSpPr>
+          <p:cNvPr id="2" name="Slide Image Placeholder 1"/>
+          <p:cNvSpPr>
+            <a:spLocks noGrp="1" noRot="1" noChangeAspect="1"/>
+          </p:cNvSpPr>
+          <p:nvPr>
+            <p:ph type="sldImg"/>
+          </p:nvPr>
+        </p:nvSpPr>
+        <p:spPr/>
+      </p:sp>
+      <p:sp>
+        <p:nvSpPr>
+          <p:cNvPr id="3" name="Notes Placeholder 2"/>
+          <p:cNvSpPr>
+            <a:spLocks noGrp="1"/>
+          </p:cNvSpPr>
+          <p:nvPr>
+            <p:ph type="body" idx="1"/>
+          </p:nvPr>
+        </p:nvSpPr>
+        <p:spPr/>
+        <p:txBody>
+          <a:bodyPr/>
+          <a:lstStyle/>
+          <a:p>
+            <a:r>
+              <a:rPr lang="en-US" dirty="0"/>
+              <a:t>（4:46–5:00　14 秒　57 字）</a:t>
+            </a:r>
+          </a:p>
+          <a:p>
+            <a:r>
+              <a:rPr lang="zh-CN" altLang="en-US" dirty="0"/>
+              <a:t/>
+            </a:r>
+          </a:p>
+          <a:p>
+            <a:r>
+              <a:rPr lang="zh-CN" altLang="en-US" dirty="0"/>
+              <a:t>最后一句。</a:t>
+            </a:r>
+          </a:p>
+          <a:p>
+            <a:r>
+              <a:rPr lang="zh-CN" altLang="en-US" dirty="0"/>
+              <a:t>出海不缺第一单，缺的是第二单。</a:t>
+            </a:r>
+          </a:p>
+          <a:p>
+            <a:r>
+              <a:rPr lang="zh-CN" altLang="en-US" dirty="0"/>
+              <a:t>货在他仓里没动，他就不会再下单——</a:t>
+            </a:r>
+          </a:p>
+          <a:p>
+            <a:r>
+              <a:rPr lang="zh-CN" altLang="en-US" dirty="0"/>
+              <a:t>而你到那时才知道，已经晚了九十天。</a:t>
+            </a:r>
+          </a:p>
+          <a:p>
+            <a:r>
+              <a:rPr lang="zh-CN" altLang="en-US" dirty="0"/>
+              <a:t>谢谢。</a:t>
+            </a:r>
+            <a:endParaRPr lang="en-US" dirty="0"/>
+          </a:p>
+        </p:txBody>
+      </p:sp>
+      <p:sp>
+        <p:nvSpPr>
+          <p:cNvPr id="4" name="Slide Number Placeholder 3"/>
+          <p:cNvSpPr>
+            <a:spLocks noGrp="1"/>
+          </p:cNvSpPr>
+          <p:nvPr>
+            <p:ph type="sldNum" sz="quarter" idx="10"/>
+          </p:nvPr>
+        </p:nvSpPr>
+        <p:spPr/>
+        <p:txBody>
+          <a:bodyPr/>
+          <a:lstStyle/>
+          <a:p>
+            <a:fld id="{F7021451-1387-4CA6-816F-3879F97B5CBC}" type="slidenum">
+              <a:rPr lang="en-US"/>
+              <a:t>12</a:t>
+            </a:fld>
+            <a:endParaRPr lang="en-US"/>
+          </a:p>
+        </p:txBody>
+      </p:sp>
+    </p:spTree>
+    <p:extLst>
+      <p:ext uri="{BB962C8B-B14F-4D97-AF65-F5344CB8AC3E}">
+        <p14:creationId xmlns:p14="http://schemas.microsoft.com/office/powerpoint/2010/main" val="1024086991"/>
+      </p:ext>
+    </p:extLst>
+  </p:cSld>
+  <p:clrMapOvr>
+    <a:masterClrMapping/>
+  </p:clrMapOvr>
+</p:notes>
 </file>
 
 <file path=ppt/notesSlides/notesSlide13.xml><?xml version="1.0" encoding="utf-8"?>
@@ -611,184 +1102,2108 @@
 </p:notes>
 </file>
 
-<file path=ppt/notesSlides/notesSlide14.xml><?xml version="1.0" encoding="UTF-8" standalone="yes"?>
-<p:notes xmlns:a="http://schemas.openxmlformats.org/drawingml/2006/main" xmlns:r="http://schemas.openxmlformats.org/officeDocument/2006/relationships" xmlns:p="http://schemas.openxmlformats.org/presentationml/2006/main"><p:cSld><p:spTree><p:nvGrpSpPr><p:cNvPr id="1" name=""/><p:cNvGrpSpPr/><p:nvPr/></p:nvGrpSpPr><p:grpSpPr><a:xfrm><a:off x="0" y="0"/><a:ext cx="0" cy="0"/><a:chOff x="0" y="0"/><a:chExt cx="0" cy="0"/></a:xfrm></p:grpSpPr><p:sp><p:nvSpPr><p:cNvPr id="2" name="Slide Image Placeholder 1"/><p:cNvSpPr><a:spLocks noGrp="1" noRot="1" noChangeAspect="1"/></p:cNvSpPr><p:nvPr><p:ph type="sldImg"/></p:nvPr></p:nvSpPr><p:spPr/></p:sp><p:sp><p:nvSpPr><p:cNvPr id="3" name="Notes Placeholder 2"/><p:cNvSpPr><a:spLocks noGrp="1"/></p:cNvSpPr><p:nvPr><p:ph type="body" idx="1"/></p:nvPr></p:nvSpPr><p:spPr/><p:txBody><a:bodyPr/><a:lstStyle/><a:p><a:r><a:rPr lang="en-US" dirty="0"/><a:t>怎么答：不要辩护「我们的数字很准」。-第一句就说「不保证对，保证可查」，然后当场把鼠标移到 ⓘ 上，让他看到来源和生效日期。-如果被追问为什么没收日本或欧盟：公开资料对烈酒税率的表述不够明确，宁可不收——-收一条不确定的税率，赔上的是整个规则库的可信度。这句话本身就是答案。</a:t></a:r><a:endParaRPr lang="en-US" dirty="0"/></a:p></p:txBody></p:sp><p:sp><p:nvSpPr><p:cNvPr id="4" name="Slide Number Placeholder 3"/><p:cNvSpPr><a:spLocks noGrp="1"/></p:cNvSpPr><p:nvPr><p:ph type="sldNum" sz="quarter" idx="10"/></p:nvPr></p:nvSpPr><p:spPr/><p:txBody><a:bodyPr/><a:lstStyle/><a:p><a:fld id="{F7021451-1387-4CA6-816F-3879F97B5CBC}" type="slidenum"><a:rPr lang="en-US"/><a:t>14</a:t></a:fld><a:endParaRPr lang="en-US"/></a:p></p:txBody></p:sp></p:spTree><p:extLst><p:ext uri="{BB962C8B-B14F-4D97-AF65-F5344CB8AC3E}"><p14:creationId xmlns:p14="http://schemas.microsoft.com/office/powerpoint/2010/main" val="1024086991"/></p:ext></p:extLst></p:cSld><p:clrMapOvr><a:masterClrMapping/></p:clrMapOvr></p:notes>
+<file path=ppt/notesSlides/notesSlide14.xml><?xml version="1.0" encoding="utf-8"?>
+<p:notes xmlns:a="http://schemas.openxmlformats.org/drawingml/2006/main" xmlns:r="http://schemas.openxmlformats.org/officeDocument/2006/relationships" xmlns:p="http://schemas.openxmlformats.org/presentationml/2006/main">
+  <p:cSld>
+    <p:spTree>
+      <p:nvGrpSpPr>
+        <p:cNvPr id="1" name=""/>
+        <p:cNvGrpSpPr/>
+        <p:nvPr/>
+      </p:nvGrpSpPr>
+      <p:grpSpPr>
+        <a:xfrm>
+          <a:off x="0" y="0"/>
+          <a:ext cx="0" cy="0"/>
+          <a:chOff x="0" y="0"/>
+          <a:chExt cx="0" cy="0"/>
+        </a:xfrm>
+      </p:grpSpPr>
+      <p:sp>
+        <p:nvSpPr>
+          <p:cNvPr id="2" name="Slide Image Placeholder 1"/>
+          <p:cNvSpPr>
+            <a:spLocks noGrp="1" noRot="1" noChangeAspect="1"/>
+          </p:cNvSpPr>
+          <p:nvPr>
+            <p:ph type="sldImg"/>
+          </p:nvPr>
+        </p:nvSpPr>
+        <p:spPr/>
+      </p:sp>
+      <p:sp>
+        <p:nvSpPr>
+          <p:cNvPr id="3" name="Notes Placeholder 2"/>
+          <p:cNvSpPr>
+            <a:spLocks noGrp="1"/>
+          </p:cNvSpPr>
+          <p:nvPr>
+            <p:ph type="body" idx="1"/>
+          </p:nvPr>
+        </p:nvSpPr>
+        <p:spPr/>
+        <p:txBody>
+          <a:bodyPr/>
+          <a:lstStyle/>
+          <a:p>
+            <a:r>
+              <a:rPr lang="en-US" dirty="0"/>
+              <a:t>怎么答：不要辩护「我们的数字很准」。</a:t>
+            </a:r>
+          </a:p>
+          <a:p>
+            <a:r>
+              <a:rPr lang="zh-CN" altLang="en-US" dirty="0"/>
+              <a:t>第一句就说「不保证对，保证可查」，然后当场把鼠标移到 ⓘ 上，让他看到来源和生效日期。</a:t>
+            </a:r>
+          </a:p>
+          <a:p>
+            <a:r>
+              <a:rPr lang="zh-CN" altLang="en-US" dirty="0"/>
+              <a:t>如果被追问为什么没收日本或欧盟：公开资料对烈酒税率的表述不够明确，宁可不收——</a:t>
+            </a:r>
+          </a:p>
+          <a:p>
+            <a:r>
+              <a:rPr lang="zh-CN" altLang="en-US" dirty="0"/>
+              <a:t>收一条不确定的税率，赔上的是整个规则库的可信度。这句话本身就是答案。</a:t>
+            </a:r>
+            <a:endParaRPr lang="en-US" dirty="0"/>
+          </a:p>
+        </p:txBody>
+      </p:sp>
+      <p:sp>
+        <p:nvSpPr>
+          <p:cNvPr id="4" name="Slide Number Placeholder 3"/>
+          <p:cNvSpPr>
+            <a:spLocks noGrp="1"/>
+          </p:cNvSpPr>
+          <p:nvPr>
+            <p:ph type="sldNum" sz="quarter" idx="10"/>
+          </p:nvPr>
+        </p:nvSpPr>
+        <p:spPr/>
+        <p:txBody>
+          <a:bodyPr/>
+          <a:lstStyle/>
+          <a:p>
+            <a:fld id="{F7021451-1387-4CA6-816F-3879F97B5CBC}" type="slidenum">
+              <a:rPr lang="en-US"/>
+              <a:t>14</a:t>
+            </a:fld>
+            <a:endParaRPr lang="en-US"/>
+          </a:p>
+        </p:txBody>
+      </p:sp>
+    </p:spTree>
+    <p:extLst>
+      <p:ext uri="{BB962C8B-B14F-4D97-AF65-F5344CB8AC3E}">
+        <p14:creationId xmlns:p14="http://schemas.microsoft.com/office/powerpoint/2010/main" val="1024086991"/>
+      </p:ext>
+    </p:extLst>
+  </p:cSld>
+  <p:clrMapOvr>
+    <a:masterClrMapping/>
+  </p:clrMapOvr>
+</p:notes>
 </file>
 
-<file path=ppt/notesSlides/notesSlide15.xml><?xml version="1.0" encoding="UTF-8" standalone="yes"?>
-<p:notes xmlns:a="http://schemas.openxmlformats.org/drawingml/2006/main" xmlns:r="http://schemas.openxmlformats.org/officeDocument/2006/relationships" xmlns:p="http://schemas.openxmlformats.org/presentationml/2006/main"><p:cSld><p:spTree><p:nvGrpSpPr><p:cNvPr id="1" name=""/><p:cNvGrpSpPr/><p:nvPr/></p:nvGrpSpPr><p:grpSpPr><a:xfrm><a:off x="0" y="0"/><a:ext cx="0" cy="0"/><a:chOff x="0" y="0"/><a:chExt cx="0" cy="0"/></a:xfrm></p:grpSpPr><p:sp><p:nvSpPr><p:cNvPr id="2" name="Slide Image Placeholder 1"/><p:cNvSpPr><a:spLocks noGrp="1" noRot="1" noChangeAspect="1"/></p:cNvSpPr><p:nvPr><p:ph type="sldImg"/></p:nvPr></p:nvSpPr><p:spPr/></p:sp><p:sp><p:nvSpPr><p:cNvPr id="3" name="Notes Placeholder 2"/><p:cNvSpPr><a:spLocks noGrp="1"/></p:cNvSpPr><p:nvPr><p:ph type="body" idx="1"/></p:nvPr></p:nvSpPr><p:spPr/><p:txBody><a:bodyPr/><a:lstStyle/><a:p><a:r><a:rPr lang="en-US" dirty="0"/><a:t>怎么答：这题几乎一定会被问，准备好三个字——细节、稳定、可追溯。-最有杀伤力的是当场对比：请评委用手机问通用模型「白酒出口新加坡税负多少」，-他多半会得到一个百分之三十到五十的区间；我们给的是按纯酒精量算出的具体数字，附税则出处。-补充：我们不是在跟通用模型比谁更会讲话，是把一个垂直领域的规则翻出来、写死、标上出处。</a:t></a:r><a:endParaRPr lang="en-US" dirty="0"/></a:p></p:txBody></p:sp><p:sp><p:nvSpPr><p:cNvPr id="4" name="Slide Number Placeholder 3"/><p:cNvSpPr><a:spLocks noGrp="1"/></p:cNvSpPr><p:nvPr><p:ph type="sldNum" sz="quarter" idx="10"/></p:nvPr></p:nvSpPr><p:spPr/><p:txBody><a:bodyPr/><a:lstStyle/><a:p><a:fld id="{F7021451-1387-4CA6-816F-3879F97B5CBC}" type="slidenum"><a:rPr lang="en-US"/><a:t>15</a:t></a:fld><a:endParaRPr lang="en-US"/></a:p></p:txBody></p:sp></p:spTree><p:extLst><p:ext uri="{BB962C8B-B14F-4D97-AF65-F5344CB8AC3E}"><p14:creationId xmlns:p14="http://schemas.microsoft.com/office/powerpoint/2010/main" val="1024086991"/></p:ext></p:extLst></p:cSld><p:clrMapOvr><a:masterClrMapping/></p:clrMapOvr></p:notes>
+<file path=ppt/notesSlides/notesSlide15.xml><?xml version="1.0" encoding="utf-8"?>
+<p:notes xmlns:a="http://schemas.openxmlformats.org/drawingml/2006/main" xmlns:r="http://schemas.openxmlformats.org/officeDocument/2006/relationships" xmlns:p="http://schemas.openxmlformats.org/presentationml/2006/main">
+  <p:cSld>
+    <p:spTree>
+      <p:nvGrpSpPr>
+        <p:cNvPr id="1" name=""/>
+        <p:cNvGrpSpPr/>
+        <p:nvPr/>
+      </p:nvGrpSpPr>
+      <p:grpSpPr>
+        <a:xfrm>
+          <a:off x="0" y="0"/>
+          <a:ext cx="0" cy="0"/>
+          <a:chOff x="0" y="0"/>
+          <a:chExt cx="0" cy="0"/>
+        </a:xfrm>
+      </p:grpSpPr>
+      <p:sp>
+        <p:nvSpPr>
+          <p:cNvPr id="2" name="Slide Image Placeholder 1"/>
+          <p:cNvSpPr>
+            <a:spLocks noGrp="1" noRot="1" noChangeAspect="1"/>
+          </p:cNvSpPr>
+          <p:nvPr>
+            <p:ph type="sldImg"/>
+          </p:nvPr>
+        </p:nvSpPr>
+        <p:spPr/>
+      </p:sp>
+      <p:sp>
+        <p:nvSpPr>
+          <p:cNvPr id="3" name="Notes Placeholder 2"/>
+          <p:cNvSpPr>
+            <a:spLocks noGrp="1"/>
+          </p:cNvSpPr>
+          <p:nvPr>
+            <p:ph type="body" idx="1"/>
+          </p:nvPr>
+        </p:nvSpPr>
+        <p:spPr/>
+        <p:txBody>
+          <a:bodyPr/>
+          <a:lstStyle/>
+          <a:p>
+            <a:r>
+              <a:rPr lang="en-US" dirty="0"/>
+              <a:t>怎么答：这题几乎一定会被问，准备好三个字——细节、稳定、可追溯。</a:t>
+            </a:r>
+          </a:p>
+          <a:p>
+            <a:r>
+              <a:rPr lang="zh-CN" altLang="en-US" dirty="0"/>
+              <a:t>最有杀伤力的是当场对比：请评委用手机问通用模型「白酒出口新加坡税负多少」，</a:t>
+            </a:r>
+          </a:p>
+          <a:p>
+            <a:r>
+              <a:rPr lang="zh-CN" altLang="en-US" dirty="0"/>
+              <a:t>他多半会得到一个百分之三十到五十的区间；我们给的是按纯酒精量算出的具体数字，附税则出处。</a:t>
+            </a:r>
+          </a:p>
+          <a:p>
+            <a:r>
+              <a:rPr lang="zh-CN" altLang="en-US" dirty="0"/>
+              <a:t>补充：我们不是在跟通用模型比谁更会讲话，是把一个垂直领域的规则翻出来、写死、标上出处。</a:t>
+            </a:r>
+            <a:endParaRPr lang="en-US" dirty="0"/>
+          </a:p>
+        </p:txBody>
+      </p:sp>
+      <p:sp>
+        <p:nvSpPr>
+          <p:cNvPr id="4" name="Slide Number Placeholder 3"/>
+          <p:cNvSpPr>
+            <a:spLocks noGrp="1"/>
+          </p:cNvSpPr>
+          <p:nvPr>
+            <p:ph type="sldNum" sz="quarter" idx="10"/>
+          </p:nvPr>
+        </p:nvSpPr>
+        <p:spPr/>
+        <p:txBody>
+          <a:bodyPr/>
+          <a:lstStyle/>
+          <a:p>
+            <a:fld id="{F7021451-1387-4CA6-816F-3879F97B5CBC}" type="slidenum">
+              <a:rPr lang="en-US"/>
+              <a:t>15</a:t>
+            </a:fld>
+            <a:endParaRPr lang="en-US"/>
+          </a:p>
+        </p:txBody>
+      </p:sp>
+    </p:spTree>
+    <p:extLst>
+      <p:ext uri="{BB962C8B-B14F-4D97-AF65-F5344CB8AC3E}">
+        <p14:creationId xmlns:p14="http://schemas.microsoft.com/office/powerpoint/2010/main" val="1024086991"/>
+      </p:ext>
+    </p:extLst>
+  </p:cSld>
+  <p:clrMapOvr>
+    <a:masterClrMapping/>
+  </p:clrMapOvr>
+</p:notes>
 </file>
 
-<file path=ppt/notesSlides/notesSlide16.xml><?xml version="1.0" encoding="UTF-8" standalone="yes"?>
-<p:notes xmlns:a="http://schemas.openxmlformats.org/drawingml/2006/main" xmlns:r="http://schemas.openxmlformats.org/officeDocument/2006/relationships" xmlns:p="http://schemas.openxmlformats.org/presentationml/2006/main"><p:cSld><p:spTree><p:nvGrpSpPr><p:cNvPr id="1" name=""/><p:cNvGrpSpPr/><p:nvPr/></p:nvGrpSpPr><p:grpSpPr><a:xfrm><a:off x="0" y="0"/><a:ext cx="0" cy="0"/><a:chOff x="0" y="0"/><a:chExt cx="0" cy="0"/></a:xfrm></p:grpSpPr><p:sp><p:nvSpPr><p:cNvPr id="2" name="Slide Image Placeholder 1"/><p:cNvSpPr><a:spLocks noGrp="1" noRot="1" noChangeAspect="1"/></p:cNvSpPr><p:nvPr><p:ph type="sldImg"/></p:nvPr></p:nvSpPr><p:spPr/></p:sp><p:sp><p:nvSpPr><p:cNvPr id="3" name="Notes Placeholder 2"/><p:cNvSpPr><a:spLocks noGrp="1"/></p:cNvSpPr><p:nvPr><p:ph type="body" idx="1"/></p:nvPr></p:nvSpPr><p:spPr/><p:txBody><a:bodyPr/><a:lstStyle/><a:p><a:r><a:rPr lang="en-US" dirty="0"/><a:t>怎么答：不要硬编商业模式，那会显得不诚实。-先承认「现在谈还太早」，再给唯一现实的入口——产区服务平台。-综保区本来就在做外贸陪跑，有预算、有台账、有企业名单，这个工具作为其中一个模块，-比单独卖 SaaS 给中小酒企现实得多。-如果追问「那你们靠什么活」：中小酒企不会为一个网页付费，会为「少亏一柜」付费，-所以第一步是把落地价误差验出来，不是先做定价页。</a:t></a:r><a:endParaRPr lang="en-US" dirty="0"/></a:p></p:txBody></p:sp><p:sp><p:nvSpPr><p:cNvPr id="4" name="Slide Number Placeholder 3"/><p:cNvSpPr><a:spLocks noGrp="1"/></p:cNvSpPr><p:nvPr><p:ph type="sldNum" sz="quarter" idx="10"/></p:nvPr></p:nvSpPr><p:spPr/><p:txBody><a:bodyPr/><a:lstStyle/><a:p><a:fld id="{F7021451-1387-4CA6-816F-3879F97B5CBC}" type="slidenum"><a:rPr lang="en-US"/><a:t>16</a:t></a:fld><a:endParaRPr lang="en-US"/></a:p></p:txBody></p:sp></p:spTree><p:extLst><p:ext uri="{BB962C8B-B14F-4D97-AF65-F5344CB8AC3E}"><p14:creationId xmlns:p14="http://schemas.microsoft.com/office/powerpoint/2010/main" val="1024086991"/></p:ext></p:extLst></p:cSld><p:clrMapOvr><a:masterClrMapping/></p:clrMapOvr></p:notes>
+<file path=ppt/notesSlides/notesSlide16.xml><?xml version="1.0" encoding="utf-8"?>
+<p:notes xmlns:a="http://schemas.openxmlformats.org/drawingml/2006/main" xmlns:r="http://schemas.openxmlformats.org/officeDocument/2006/relationships" xmlns:p="http://schemas.openxmlformats.org/presentationml/2006/main">
+  <p:cSld>
+    <p:spTree>
+      <p:nvGrpSpPr>
+        <p:cNvPr id="1" name=""/>
+        <p:cNvGrpSpPr/>
+        <p:nvPr/>
+      </p:nvGrpSpPr>
+      <p:grpSpPr>
+        <a:xfrm>
+          <a:off x="0" y="0"/>
+          <a:ext cx="0" cy="0"/>
+          <a:chOff x="0" y="0"/>
+          <a:chExt cx="0" cy="0"/>
+        </a:xfrm>
+      </p:grpSpPr>
+      <p:sp>
+        <p:nvSpPr>
+          <p:cNvPr id="2" name="Slide Image Placeholder 1"/>
+          <p:cNvSpPr>
+            <a:spLocks noGrp="1" noRot="1" noChangeAspect="1"/>
+          </p:cNvSpPr>
+          <p:nvPr>
+            <p:ph type="sldImg"/>
+          </p:nvPr>
+        </p:nvSpPr>
+        <p:spPr/>
+      </p:sp>
+      <p:sp>
+        <p:nvSpPr>
+          <p:cNvPr id="3" name="Notes Placeholder 2"/>
+          <p:cNvSpPr>
+            <a:spLocks noGrp="1"/>
+          </p:cNvSpPr>
+          <p:nvPr>
+            <p:ph type="body" idx="1"/>
+          </p:nvPr>
+        </p:nvSpPr>
+        <p:spPr/>
+        <p:txBody>
+          <a:bodyPr/>
+          <a:lstStyle/>
+          <a:p>
+            <a:r>
+              <a:rPr lang="en-US" dirty="0"/>
+              <a:t>怎么答：不要硬编商业模式，那会显得不诚实。</a:t>
+            </a:r>
+          </a:p>
+          <a:p>
+            <a:r>
+              <a:rPr lang="zh-CN" altLang="en-US" dirty="0"/>
+              <a:t>先承认「现在谈还太早」，再给唯一现实的入口——产区服务平台。</a:t>
+            </a:r>
+          </a:p>
+          <a:p>
+            <a:r>
+              <a:rPr lang="zh-CN" altLang="en-US" dirty="0"/>
+              <a:t>综保区本来就在做外贸陪跑，有预算、有台账、有企业名单，这个工具作为其中一个模块，</a:t>
+            </a:r>
+          </a:p>
+          <a:p>
+            <a:r>
+              <a:rPr lang="zh-CN" altLang="en-US" dirty="0"/>
+              <a:t>比单独卖 SaaS 给中小酒企现实得多。</a:t>
+            </a:r>
+          </a:p>
+          <a:p>
+            <a:r>
+              <a:rPr lang="zh-CN" altLang="en-US" dirty="0"/>
+              <a:t>如果追问「那你们靠什么活」：中小酒企不会为一个网页付费，会为「少亏一柜」付费，</a:t>
+            </a:r>
+          </a:p>
+          <a:p>
+            <a:r>
+              <a:rPr lang="zh-CN" altLang="en-US" dirty="0"/>
+              <a:t>所以第一步是把落地价误差验出来，不是先做定价页。</a:t>
+            </a:r>
+            <a:endParaRPr lang="en-US" dirty="0"/>
+          </a:p>
+        </p:txBody>
+      </p:sp>
+      <p:sp>
+        <p:nvSpPr>
+          <p:cNvPr id="4" name="Slide Number Placeholder 3"/>
+          <p:cNvSpPr>
+            <a:spLocks noGrp="1"/>
+          </p:cNvSpPr>
+          <p:nvPr>
+            <p:ph type="sldNum" sz="quarter" idx="10"/>
+          </p:nvPr>
+        </p:nvSpPr>
+        <p:spPr/>
+        <p:txBody>
+          <a:bodyPr/>
+          <a:lstStyle/>
+          <a:p>
+            <a:fld id="{F7021451-1387-4CA6-816F-3879F97B5CBC}" type="slidenum">
+              <a:rPr lang="en-US"/>
+              <a:t>16</a:t>
+            </a:fld>
+            <a:endParaRPr lang="en-US"/>
+          </a:p>
+        </p:txBody>
+      </p:sp>
+    </p:spTree>
+    <p:extLst>
+      <p:ext uri="{BB962C8B-B14F-4D97-AF65-F5344CB8AC3E}">
+        <p14:creationId xmlns:p14="http://schemas.microsoft.com/office/powerpoint/2010/main" val="1024086991"/>
+      </p:ext>
+    </p:extLst>
+  </p:cSld>
+  <p:clrMapOvr>
+    <a:masterClrMapping/>
+  </p:clrMapOvr>
+</p:notes>
 </file>
 
-<file path=ppt/notesSlides/notesSlide17.xml><?xml version="1.0" encoding="UTF-8" standalone="yes"?>
-<p:notes xmlns:a="http://schemas.openxmlformats.org/drawingml/2006/main" xmlns:r="http://schemas.openxmlformats.org/officeDocument/2006/relationships" xmlns:p="http://schemas.openxmlformats.org/presentationml/2006/main"><p:cSld><p:spTree><p:nvGrpSpPr><p:cNvPr id="1" name=""/><p:cNvGrpSpPr/><p:nvPr/></p:nvGrpSpPr><p:grpSpPr><a:xfrm><a:off x="0" y="0"/><a:ext cx="0" cy="0"/><a:chOff x="0" y="0"/><a:chExt cx="0" cy="0"/></a:xfrm></p:grpSpPr><p:sp><p:nvSpPr><p:cNvPr id="2" name="Slide Image Placeholder 1"/><p:cNvSpPr><a:spLocks noGrp="1" noRot="1" noChangeAspect="1"/></p:cNvSpPr><p:nvPr><p:ph type="sldImg"/></p:nvPr></p:nvSpPr><p:spPr/></p:sp><p:sp><p:nvSpPr><p:cNvPr id="3" name="Notes Placeholder 2"/><p:cNvSpPr><a:spLocks noGrp="1"/></p:cNvSpPr><p:nvPr><p:ph type="body" idx="1"/></p:nvPr></p:nvSpPr><p:spPr/><p:txBody><a:bodyPr/><a:lstStyle/><a:p><a:r><a:rPr lang="en-US" dirty="0"/><a:t>怎么答：分两层说。-一层是官方公开资料——香港政府新闻公报、新加坡海关、越南 2025 年新版特别消费税法、-美国 TTB 与 FDA、中国财政部与税务总局的出口退税公告。-另一层是团队自建的两份数据库：五十六支贵州白酒逐支核过、每支标注资料可信度；-海外用法每条标注证据强度，来源是 World Baijiu Day、品牌方推广和商家页面。-强调「逐支核过」，不是抓的。</a:t></a:r><a:endParaRPr lang="en-US" dirty="0"/></a:p></p:txBody></p:sp><p:sp><p:nvSpPr><p:cNvPr id="4" name="Slide Number Placeholder 3"/><p:cNvSpPr><a:spLocks noGrp="1"/></p:cNvSpPr><p:nvPr><p:ph type="sldNum" sz="quarter" idx="10"/></p:nvPr></p:nvSpPr><p:spPr/><p:txBody><a:bodyPr/><a:lstStyle/><a:p><a:fld id="{F7021451-1387-4CA6-816F-3879F97B5CBC}" type="slidenum"><a:rPr lang="en-US"/><a:t>17</a:t></a:fld><a:endParaRPr lang="en-US"/></a:p></p:txBody></p:sp></p:spTree><p:extLst><p:ext uri="{BB962C8B-B14F-4D97-AF65-F5344CB8AC3E}"><p14:creationId xmlns:p14="http://schemas.microsoft.com/office/powerpoint/2010/main" val="1024086991"/></p:ext></p:extLst></p:cSld><p:clrMapOvr><a:masterClrMapping/></p:clrMapOvr></p:notes>
+<file path=ppt/notesSlides/notesSlide17.xml><?xml version="1.0" encoding="utf-8"?>
+<p:notes xmlns:a="http://schemas.openxmlformats.org/drawingml/2006/main" xmlns:r="http://schemas.openxmlformats.org/officeDocument/2006/relationships" xmlns:p="http://schemas.openxmlformats.org/presentationml/2006/main">
+  <p:cSld>
+    <p:spTree>
+      <p:nvGrpSpPr>
+        <p:cNvPr id="1" name=""/>
+        <p:cNvGrpSpPr/>
+        <p:nvPr/>
+      </p:nvGrpSpPr>
+      <p:grpSpPr>
+        <a:xfrm>
+          <a:off x="0" y="0"/>
+          <a:ext cx="0" cy="0"/>
+          <a:chOff x="0" y="0"/>
+          <a:chExt cx="0" cy="0"/>
+        </a:xfrm>
+      </p:grpSpPr>
+      <p:sp>
+        <p:nvSpPr>
+          <p:cNvPr id="2" name="Slide Image Placeholder 1"/>
+          <p:cNvSpPr>
+            <a:spLocks noGrp="1" noRot="1" noChangeAspect="1"/>
+          </p:cNvSpPr>
+          <p:nvPr>
+            <p:ph type="sldImg"/>
+          </p:nvPr>
+        </p:nvSpPr>
+        <p:spPr/>
+      </p:sp>
+      <p:sp>
+        <p:nvSpPr>
+          <p:cNvPr id="3" name="Notes Placeholder 2"/>
+          <p:cNvSpPr>
+            <a:spLocks noGrp="1"/>
+          </p:cNvSpPr>
+          <p:nvPr>
+            <p:ph type="body" idx="1"/>
+          </p:nvPr>
+        </p:nvSpPr>
+        <p:spPr/>
+        <p:txBody>
+          <a:bodyPr/>
+          <a:lstStyle/>
+          <a:p>
+            <a:r>
+              <a:rPr lang="en-US" dirty="0"/>
+              <a:t>怎么答：分两层说。</a:t>
+            </a:r>
+          </a:p>
+          <a:p>
+            <a:r>
+              <a:rPr lang="zh-CN" altLang="en-US" dirty="0"/>
+              <a:t>一层是官方公开资料——香港政府新闻公报、新加坡海关、越南 2025 年新版特别消费税法、</a:t>
+            </a:r>
+          </a:p>
+          <a:p>
+            <a:r>
+              <a:rPr lang="zh-CN" altLang="en-US" dirty="0"/>
+              <a:t>美国 TTB 与 FDA、中国财政部与税务总局的出口退税公告。</a:t>
+            </a:r>
+          </a:p>
+          <a:p>
+            <a:r>
+              <a:rPr lang="zh-CN" altLang="en-US" dirty="0"/>
+              <a:t>另一层是团队自建的两份数据库：五十六支贵州白酒逐支核过、每支标注资料可信度；</a:t>
+            </a:r>
+          </a:p>
+          <a:p>
+            <a:r>
+              <a:rPr lang="zh-CN" altLang="en-US" dirty="0"/>
+              <a:t>海外用法每条标注证据强度，来源是 World Baijiu Day、品牌方推广和商家页面。</a:t>
+            </a:r>
+          </a:p>
+          <a:p>
+            <a:r>
+              <a:rPr lang="zh-CN" altLang="en-US" dirty="0"/>
+              <a:t>强调「逐支核过」，不是抓的。</a:t>
+            </a:r>
+            <a:endParaRPr lang="en-US" dirty="0"/>
+          </a:p>
+        </p:txBody>
+      </p:sp>
+      <p:sp>
+        <p:nvSpPr>
+          <p:cNvPr id="4" name="Slide Number Placeholder 3"/>
+          <p:cNvSpPr>
+            <a:spLocks noGrp="1"/>
+          </p:cNvSpPr>
+          <p:nvPr>
+            <p:ph type="sldNum" sz="quarter" idx="10"/>
+          </p:nvPr>
+        </p:nvSpPr>
+        <p:spPr/>
+        <p:txBody>
+          <a:bodyPr/>
+          <a:lstStyle/>
+          <a:p>
+            <a:fld id="{F7021451-1387-4CA6-816F-3879F97B5CBC}" type="slidenum">
+              <a:rPr lang="en-US"/>
+              <a:t>17</a:t>
+            </a:fld>
+            <a:endParaRPr lang="en-US"/>
+          </a:p>
+        </p:txBody>
+      </p:sp>
+    </p:spTree>
+    <p:extLst>
+      <p:ext uri="{BB962C8B-B14F-4D97-AF65-F5344CB8AC3E}">
+        <p14:creationId xmlns:p14="http://schemas.microsoft.com/office/powerpoint/2010/main" val="1024086991"/>
+      </p:ext>
+    </p:extLst>
+  </p:cSld>
+  <p:clrMapOvr>
+    <a:masterClrMapping/>
+  </p:clrMapOvr>
+</p:notes>
 </file>
 
-<file path=ppt/notesSlides/notesSlide18.xml><?xml version="1.0" encoding="UTF-8" standalone="yes"?>
-<p:notes xmlns:a="http://schemas.openxmlformats.org/drawingml/2006/main" xmlns:r="http://schemas.openxmlformats.org/officeDocument/2006/relationships" xmlns:p="http://schemas.openxmlformats.org/presentationml/2006/main"><p:cSld><p:spTree><p:nvGrpSpPr><p:cNvPr id="1" name=""/><p:cNvGrpSpPr/><p:nvPr/></p:nvGrpSpPr><p:grpSpPr><a:xfrm><a:off x="0" y="0"/><a:ext cx="0" cy="0"/><a:chOff x="0" y="0"/><a:chExt cx="0" cy="0"/></a:xfrm></p:grpSpPr><p:sp><p:nvSpPr><p:cNvPr id="2" name="Slide Image Placeholder 1"/><p:cNvSpPr><a:spLocks noGrp="1" noRot="1" noChangeAspect="1"/></p:cNvSpPr><p:nvPr><p:ph type="sldImg"/></p:nvPr></p:nvSpPr><p:spPr/></p:sp><p:sp><p:nvSpPr><p:cNvPr id="3" name="Notes Placeholder 2"/><p:cNvSpPr><a:spLocks noGrp="1"/></p:cNvSpPr><p:nvPr><p:ph type="body" idx="1"/></p:nvPr></p:nvSpPr><p:spPr/><p:txBody><a:bodyPr/><a:lstStyle/><a:p><a:r><a:rPr lang="en-US" dirty="0"/><a:t>怎么答：承认网页不是终态，这一点不要回避。-外贸专员整天在微信里，不会为了判断一个买家去开网页——真正会被用起来的是企业微信机器人，-转发一段对话给它，回一份决策简报。这件事写在一百天计划的第四步。-但要说清楚为什么先做网页：规则库、信号权重、落地价误差这三件事没验完之前，-做成机器人只是把一个还没校准的答案推到更多人面前。</a:t></a:r><a:endParaRPr lang="en-US" dirty="0"/></a:p></p:txBody></p:sp><p:sp><p:nvSpPr><p:cNvPr id="4" name="Slide Number Placeholder 3"/><p:cNvSpPr><a:spLocks noGrp="1"/></p:cNvSpPr><p:nvPr><p:ph type="sldNum" sz="quarter" idx="10"/></p:nvPr></p:nvSpPr><p:spPr/><p:txBody><a:bodyPr/><a:lstStyle/><a:p><a:fld id="{F7021451-1387-4CA6-816F-3879F97B5CBC}" type="slidenum"><a:rPr lang="en-US"/><a:t>18</a:t></a:fld><a:endParaRPr lang="en-US"/></a:p></p:txBody></p:sp></p:spTree><p:extLst><p:ext uri="{BB962C8B-B14F-4D97-AF65-F5344CB8AC3E}"><p14:creationId xmlns:p14="http://schemas.microsoft.com/office/powerpoint/2010/main" val="1024086991"/></p:ext></p:extLst></p:cSld><p:clrMapOvr><a:masterClrMapping/></p:clrMapOvr></p:notes>
+<file path=ppt/notesSlides/notesSlide18.xml><?xml version="1.0" encoding="utf-8"?>
+<p:notes xmlns:a="http://schemas.openxmlformats.org/drawingml/2006/main" xmlns:r="http://schemas.openxmlformats.org/officeDocument/2006/relationships" xmlns:p="http://schemas.openxmlformats.org/presentationml/2006/main">
+  <p:cSld>
+    <p:spTree>
+      <p:nvGrpSpPr>
+        <p:cNvPr id="1" name=""/>
+        <p:cNvGrpSpPr/>
+        <p:nvPr/>
+      </p:nvGrpSpPr>
+      <p:grpSpPr>
+        <a:xfrm>
+          <a:off x="0" y="0"/>
+          <a:ext cx="0" cy="0"/>
+          <a:chOff x="0" y="0"/>
+          <a:chExt cx="0" cy="0"/>
+        </a:xfrm>
+      </p:grpSpPr>
+      <p:sp>
+        <p:nvSpPr>
+          <p:cNvPr id="2" name="Slide Image Placeholder 1"/>
+          <p:cNvSpPr>
+            <a:spLocks noGrp="1" noRot="1" noChangeAspect="1"/>
+          </p:cNvSpPr>
+          <p:nvPr>
+            <p:ph type="sldImg"/>
+          </p:nvPr>
+        </p:nvSpPr>
+        <p:spPr/>
+      </p:sp>
+      <p:sp>
+        <p:nvSpPr>
+          <p:cNvPr id="3" name="Notes Placeholder 2"/>
+          <p:cNvSpPr>
+            <a:spLocks noGrp="1"/>
+          </p:cNvSpPr>
+          <p:nvPr>
+            <p:ph type="body" idx="1"/>
+          </p:nvPr>
+        </p:nvSpPr>
+        <p:spPr/>
+        <p:txBody>
+          <a:bodyPr/>
+          <a:lstStyle/>
+          <a:p>
+            <a:r>
+              <a:rPr lang="en-US" dirty="0"/>
+              <a:t>怎么答：承认网页不是终态，这一点不要回避。</a:t>
+            </a:r>
+          </a:p>
+          <a:p>
+            <a:r>
+              <a:rPr lang="zh-CN" altLang="en-US" dirty="0"/>
+              <a:t>外贸专员整天在微信里，不会为了判断一个买家去开网页——真正会被用起来的是企业微信机器人，</a:t>
+            </a:r>
+          </a:p>
+          <a:p>
+            <a:r>
+              <a:rPr lang="zh-CN" altLang="en-US" dirty="0"/>
+              <a:t>转发一段对话给它，回一份决策简报。这件事写在一百天计划的第四步。</a:t>
+            </a:r>
+          </a:p>
+          <a:p>
+            <a:r>
+              <a:rPr lang="zh-CN" altLang="en-US" dirty="0"/>
+              <a:t>但要说清楚为什么先做网页：规则库、信号权重、落地价误差这三件事没验完之前，</a:t>
+            </a:r>
+          </a:p>
+          <a:p>
+            <a:r>
+              <a:rPr lang="zh-CN" altLang="en-US" dirty="0"/>
+              <a:t>做成机器人只是把一个还没校准的答案推到更多人面前。</a:t>
+            </a:r>
+            <a:endParaRPr lang="en-US" dirty="0"/>
+          </a:p>
+        </p:txBody>
+      </p:sp>
+      <p:sp>
+        <p:nvSpPr>
+          <p:cNvPr id="4" name="Slide Number Placeholder 3"/>
+          <p:cNvSpPr>
+            <a:spLocks noGrp="1"/>
+          </p:cNvSpPr>
+          <p:nvPr>
+            <p:ph type="sldNum" sz="quarter" idx="10"/>
+          </p:nvPr>
+        </p:nvSpPr>
+        <p:spPr/>
+        <p:txBody>
+          <a:bodyPr/>
+          <a:lstStyle/>
+          <a:p>
+            <a:fld id="{F7021451-1387-4CA6-816F-3879F97B5CBC}" type="slidenum">
+              <a:rPr lang="en-US"/>
+              <a:t>18</a:t>
+            </a:fld>
+            <a:endParaRPr lang="en-US"/>
+          </a:p>
+        </p:txBody>
+      </p:sp>
+    </p:spTree>
+    <p:extLst>
+      <p:ext uri="{BB962C8B-B14F-4D97-AF65-F5344CB8AC3E}">
+        <p14:creationId xmlns:p14="http://schemas.microsoft.com/office/powerpoint/2010/main" val="1024086991"/>
+      </p:ext>
+    </p:extLst>
+  </p:cSld>
+  <p:clrMapOvr>
+    <a:masterClrMapping/>
+  </p:clrMapOvr>
+</p:notes>
 </file>
 
-<file path=ppt/notesSlides/notesSlide19.xml><?xml version="1.0" encoding="UTF-8" standalone="yes"?>
-<p:notes xmlns:a="http://schemas.openxmlformats.org/drawingml/2006/main" xmlns:r="http://schemas.openxmlformats.org/officeDocument/2006/relationships" xmlns:p="http://schemas.openxmlformats.org/presentationml/2006/main"><p:cSld><p:spTree><p:nvGrpSpPr><p:cNvPr id="1" name=""/><p:cNvGrpSpPr/><p:nvPr/></p:nvGrpSpPr><p:grpSpPr><a:xfrm><a:off x="0" y="0"/><a:ext cx="0" cy="0"/><a:chOff x="0" y="0"/><a:chExt cx="0" cy="0"/></a:xfrm></p:grpSpPr><p:sp><p:nvSpPr><p:cNvPr id="2" name="Slide Image Placeholder 1"/><p:cNvSpPr><a:spLocks noGrp="1" noRot="1" noChangeAspect="1"/></p:cNvSpPr><p:nvPr><p:ph type="sldImg"/></p:nvPr></p:nvSpPr><p:spPr/></p:sp><p:sp><p:nvSpPr><p:cNvPr id="3" name="Notes Placeholder 2"/><p:cNvSpPr><a:spLocks noGrp="1"/></p:cNvSpPr><p:nvPr><p:ph type="body" idx="1"/></p:nvPr></p:nvSpPr><p:spPr/><p:txBody><a:bodyPr/><a:lstStyle/><a:p><a:r><a:rPr lang="en-US" dirty="0"/><a:t>怎么答：主动说，不等被问。-这一页的作用是把可信度拉起来——一个肯讲自己边界的团队，前面说的话才值得信。-最重要的一条是「信号权重还没用真实案例校准」，目前是团队设定值，-这也正好是一百天计划的第二步，前后是接得上的。</a:t></a:r><a:endParaRPr lang="en-US" dirty="0"/></a:p></p:txBody></p:sp><p:sp><p:nvSpPr><p:cNvPr id="4" name="Slide Number Placeholder 3"/><p:cNvSpPr><a:spLocks noGrp="1"/></p:cNvSpPr><p:nvPr><p:ph type="sldNum" sz="quarter" idx="10"/></p:nvPr></p:nvSpPr><p:spPr/><p:txBody><a:bodyPr/><a:lstStyle/><a:p><a:fld id="{F7021451-1387-4CA6-816F-3879F97B5CBC}" type="slidenum"><a:rPr lang="en-US"/><a:t>19</a:t></a:fld><a:endParaRPr lang="en-US"/></a:p></p:txBody></p:sp></p:spTree><p:extLst><p:ext uri="{BB962C8B-B14F-4D97-AF65-F5344CB8AC3E}"><p14:creationId xmlns:p14="http://schemas.microsoft.com/office/powerpoint/2010/main" val="1024086991"/></p:ext></p:extLst></p:cSld><p:clrMapOvr><a:masterClrMapping/></p:clrMapOvr></p:notes>
+<file path=ppt/notesSlides/notesSlide19.xml><?xml version="1.0" encoding="utf-8"?>
+<p:notes xmlns:a="http://schemas.openxmlformats.org/drawingml/2006/main" xmlns:r="http://schemas.openxmlformats.org/officeDocument/2006/relationships" xmlns:p="http://schemas.openxmlformats.org/presentationml/2006/main">
+  <p:cSld>
+    <p:spTree>
+      <p:nvGrpSpPr>
+        <p:cNvPr id="1" name=""/>
+        <p:cNvGrpSpPr/>
+        <p:nvPr/>
+      </p:nvGrpSpPr>
+      <p:grpSpPr>
+        <a:xfrm>
+          <a:off x="0" y="0"/>
+          <a:ext cx="0" cy="0"/>
+          <a:chOff x="0" y="0"/>
+          <a:chExt cx="0" cy="0"/>
+        </a:xfrm>
+      </p:grpSpPr>
+      <p:sp>
+        <p:nvSpPr>
+          <p:cNvPr id="2" name="Slide Image Placeholder 1"/>
+          <p:cNvSpPr>
+            <a:spLocks noGrp="1" noRot="1" noChangeAspect="1"/>
+          </p:cNvSpPr>
+          <p:nvPr>
+            <p:ph type="sldImg"/>
+          </p:nvPr>
+        </p:nvSpPr>
+        <p:spPr/>
+      </p:sp>
+      <p:sp>
+        <p:nvSpPr>
+          <p:cNvPr id="3" name="Notes Placeholder 2"/>
+          <p:cNvSpPr>
+            <a:spLocks noGrp="1"/>
+          </p:cNvSpPr>
+          <p:nvPr>
+            <p:ph type="body" idx="1"/>
+          </p:nvPr>
+        </p:nvSpPr>
+        <p:spPr/>
+        <p:txBody>
+          <a:bodyPr/>
+          <a:lstStyle/>
+          <a:p>
+            <a:r>
+              <a:rPr lang="en-US" dirty="0"/>
+              <a:t>怎么答：主动说，不等被问。</a:t>
+            </a:r>
+          </a:p>
+          <a:p>
+            <a:r>
+              <a:rPr lang="zh-CN" altLang="en-US" dirty="0"/>
+              <a:t>这一页的作用是把可信度拉起来——一个肯讲自己边界的团队，前面说的话才值得信。</a:t>
+            </a:r>
+          </a:p>
+          <a:p>
+            <a:r>
+              <a:rPr lang="zh-CN" altLang="en-US" dirty="0"/>
+              <a:t>最重要的一条是「信号权重还没用真实案例校准」，目前是团队设定值，</a:t>
+            </a:r>
+          </a:p>
+          <a:p>
+            <a:r>
+              <a:rPr lang="zh-CN" altLang="en-US" dirty="0"/>
+              <a:t>这也正好是一百天计划的第二步，前后是接得上的。</a:t>
+            </a:r>
+            <a:endParaRPr lang="en-US" dirty="0"/>
+          </a:p>
+        </p:txBody>
+      </p:sp>
+      <p:sp>
+        <p:nvSpPr>
+          <p:cNvPr id="4" name="Slide Number Placeholder 3"/>
+          <p:cNvSpPr>
+            <a:spLocks noGrp="1"/>
+          </p:cNvSpPr>
+          <p:nvPr>
+            <p:ph type="sldNum" sz="quarter" idx="10"/>
+          </p:nvPr>
+        </p:nvSpPr>
+        <p:spPr/>
+        <p:txBody>
+          <a:bodyPr/>
+          <a:lstStyle/>
+          <a:p>
+            <a:fld id="{F7021451-1387-4CA6-816F-3879F97B5CBC}" type="slidenum">
+              <a:rPr lang="en-US"/>
+              <a:t>19</a:t>
+            </a:fld>
+            <a:endParaRPr lang="en-US"/>
+          </a:p>
+        </p:txBody>
+      </p:sp>
+    </p:spTree>
+    <p:extLst>
+      <p:ext uri="{BB962C8B-B14F-4D97-AF65-F5344CB8AC3E}">
+        <p14:creationId xmlns:p14="http://schemas.microsoft.com/office/powerpoint/2010/main" val="1024086991"/>
+      </p:ext>
+    </p:extLst>
+  </p:cSld>
+  <p:clrMapOvr>
+    <a:masterClrMapping/>
+  </p:clrMapOvr>
+</p:notes>
 </file>
 
-<file path=ppt/notesSlides/notesSlide2.xml><?xml version="1.0" encoding="UTF-8" standalone="yes"?>
-<p:notes xmlns:a="http://schemas.openxmlformats.org/drawingml/2006/main" xmlns:r="http://schemas.openxmlformats.org/officeDocument/2006/relationships" xmlns:p="http://schemas.openxmlformats.org/presentationml/2006/main"><p:cSld><p:spTree><p:nvGrpSpPr><p:cNvPr id="1" name=""/><p:cNvGrpSpPr/><p:nvPr/></p:nvGrpSpPr><p:grpSpPr><a:xfrm><a:off x="0" y="0"/><a:ext cx="0" cy="0"/><a:chOff x="0" y="0"/><a:chExt cx="0" cy="0"/></a:xfrm></p:grpSpPr><p:sp><p:nvSpPr><p:cNvPr id="2" name="Slide Image Placeholder 1"/><p:cNvSpPr><a:spLocks noGrp="1" noRot="1" noChangeAspect="1"/></p:cNvSpPr><p:nvPr><p:ph type="sldImg"/></p:nvPr></p:nvSpPr><p:spPr/></p:sp><p:sp><p:nvSpPr><p:cNvPr id="3" name="Notes Placeholder 2"/><p:cNvSpPr><a:spLocks noGrp="1"/></p:cNvSpPr><p:nvPr><p:ph type="body" idx="1"/></p:nvPr></p:nvSpPr><p:spPr/><p:txBody><a:bodyPr/><a:lstStyle/><a:p><a:r><a:rPr lang="en-US" dirty="0"/><a:t>（0:18–0:56　38 秒　178 字）--遵义综保区去年的工作总结里，有一组很诚实的数字：-八十九家完成出口备案，三十五家有意向，十一家真的出了海，-最后五家和东南亚经销商「建立初步联系」。-[停一拍]-注意这个措辞——不是签约，更不是复购。公开资料到这里就断了。-遵义自己列的第一个障碍是：白酒属管制商品，进口方需酒牌资质。-所以你要找的不是想卖酒的人，是已经持牌的人。-这个池子在任何国家都有限、封闭，早被洋酒喂饱了。--───── 时间充裕可加 ─────-所以问题从来不是「白酒怎么出海」这种大词，是一家没有海外团队的酒厂，怎么让第一个海外经销商愿意下第二单。</a:t></a:r><a:endParaRPr lang="en-US" dirty="0"/></a:p></p:txBody></p:sp><p:sp><p:nvSpPr><p:cNvPr id="4" name="Slide Number Placeholder 3"/><p:cNvSpPr><a:spLocks noGrp="1"/></p:cNvSpPr><p:nvPr><p:ph type="sldNum" sz="quarter" idx="10"/></p:nvPr></p:nvSpPr><p:spPr/><p:txBody><a:bodyPr/><a:lstStyle/><a:p><a:fld id="{F7021451-1387-4CA6-816F-3879F97B5CBC}" type="slidenum"><a:rPr lang="en-US"/><a:t>2</a:t></a:fld><a:endParaRPr lang="en-US"/></a:p></p:txBody></p:sp></p:spTree><p:extLst><p:ext uri="{BB962C8B-B14F-4D97-AF65-F5344CB8AC3E}"><p14:creationId xmlns:p14="http://schemas.microsoft.com/office/powerpoint/2010/main" val="1024086991"/></p:ext></p:extLst></p:cSld><p:clrMapOvr><a:masterClrMapping/></p:clrMapOvr></p:notes>
+<file path=ppt/notesSlides/notesSlide2.xml><?xml version="1.0" encoding="utf-8"?>
+<p:notes xmlns:a="http://schemas.openxmlformats.org/drawingml/2006/main" xmlns:r="http://schemas.openxmlformats.org/officeDocument/2006/relationships" xmlns:p="http://schemas.openxmlformats.org/presentationml/2006/main">
+  <p:cSld>
+    <p:spTree>
+      <p:nvGrpSpPr>
+        <p:cNvPr id="1" name=""/>
+        <p:cNvGrpSpPr/>
+        <p:nvPr/>
+      </p:nvGrpSpPr>
+      <p:grpSpPr>
+        <a:xfrm>
+          <a:off x="0" y="0"/>
+          <a:ext cx="0" cy="0"/>
+          <a:chOff x="0" y="0"/>
+          <a:chExt cx="0" cy="0"/>
+        </a:xfrm>
+      </p:grpSpPr>
+      <p:sp>
+        <p:nvSpPr>
+          <p:cNvPr id="2" name="Slide Image Placeholder 1"/>
+          <p:cNvSpPr>
+            <a:spLocks noGrp="1" noRot="1" noChangeAspect="1"/>
+          </p:cNvSpPr>
+          <p:nvPr>
+            <p:ph type="sldImg"/>
+          </p:nvPr>
+        </p:nvSpPr>
+        <p:spPr/>
+      </p:sp>
+      <p:sp>
+        <p:nvSpPr>
+          <p:cNvPr id="3" name="Notes Placeholder 2"/>
+          <p:cNvSpPr>
+            <a:spLocks noGrp="1"/>
+          </p:cNvSpPr>
+          <p:nvPr>
+            <p:ph type="body" idx="1"/>
+          </p:nvPr>
+        </p:nvSpPr>
+        <p:spPr/>
+        <p:txBody>
+          <a:bodyPr/>
+          <a:lstStyle/>
+          <a:p>
+            <a:r>
+              <a:rPr lang="en-US" dirty="0"/>
+              <a:t>（0:18–0:56　38 秒　178 字）</a:t>
+            </a:r>
+          </a:p>
+          <a:p>
+            <a:r>
+              <a:rPr lang="zh-CN" altLang="en-US" dirty="0"/>
+              <a:t/>
+            </a:r>
+          </a:p>
+          <a:p>
+            <a:r>
+              <a:rPr lang="zh-CN" altLang="en-US" dirty="0"/>
+              <a:t>遵义综保区去年的工作总结里，有一组很诚实的数字：</a:t>
+            </a:r>
+          </a:p>
+          <a:p>
+            <a:r>
+              <a:rPr lang="zh-CN" altLang="en-US" dirty="0"/>
+              <a:t>八十九家完成出口备案，三十五家有意向，十一家真的出了海，</a:t>
+            </a:r>
+          </a:p>
+          <a:p>
+            <a:r>
+              <a:rPr lang="zh-CN" altLang="en-US" dirty="0"/>
+              <a:t>最后五家和东南亚经销商「建立初步联系」。</a:t>
+            </a:r>
+          </a:p>
+          <a:p>
+            <a:r>
+              <a:rPr lang="zh-CN" altLang="en-US" dirty="0"/>
+              <a:t>[停一拍]</a:t>
+            </a:r>
+          </a:p>
+          <a:p>
+            <a:r>
+              <a:rPr lang="zh-CN" altLang="en-US" dirty="0"/>
+              <a:t>注意这个措辞——不是签约，更不是复购。公开资料到这里就断了。</a:t>
+            </a:r>
+          </a:p>
+          <a:p>
+            <a:r>
+              <a:rPr lang="zh-CN" altLang="en-US" dirty="0"/>
+              <a:t>遵义自己列的第一个障碍是：白酒属管制商品，进口方需酒牌资质。</a:t>
+            </a:r>
+          </a:p>
+          <a:p>
+            <a:r>
+              <a:rPr lang="zh-CN" altLang="en-US" dirty="0"/>
+              <a:t>所以你要找的不是想卖酒的人，是已经持牌的人。</a:t>
+            </a:r>
+          </a:p>
+          <a:p>
+            <a:r>
+              <a:rPr lang="zh-CN" altLang="en-US" dirty="0"/>
+              <a:t>这个池子在任何国家都有限、封闭，早被洋酒喂饱了。</a:t>
+            </a:r>
+          </a:p>
+          <a:p>
+            <a:r>
+              <a:rPr lang="zh-CN" altLang="en-US" dirty="0"/>
+              <a:t/>
+            </a:r>
+          </a:p>
+          <a:p>
+            <a:r>
+              <a:rPr lang="zh-CN" altLang="en-US" dirty="0"/>
+              <a:t>───── 时间充裕可加 ─────</a:t>
+            </a:r>
+          </a:p>
+          <a:p>
+            <a:r>
+              <a:rPr lang="zh-CN" altLang="en-US" dirty="0"/>
+              <a:t>所以问题从来不是「白酒怎么出海」这种大词，是一家没有海外团队的酒厂，怎么让第一个海外经销商愿意下第二单。</a:t>
+            </a:r>
+            <a:endParaRPr lang="en-US" dirty="0"/>
+          </a:p>
+        </p:txBody>
+      </p:sp>
+      <p:sp>
+        <p:nvSpPr>
+          <p:cNvPr id="4" name="Slide Number Placeholder 3"/>
+          <p:cNvSpPr>
+            <a:spLocks noGrp="1"/>
+          </p:cNvSpPr>
+          <p:nvPr>
+            <p:ph type="sldNum" sz="quarter" idx="10"/>
+          </p:nvPr>
+        </p:nvSpPr>
+        <p:spPr/>
+        <p:txBody>
+          <a:bodyPr/>
+          <a:lstStyle/>
+          <a:p>
+            <a:fld id="{F7021451-1387-4CA6-816F-3879F97B5CBC}" type="slidenum">
+              <a:rPr lang="en-US"/>
+              <a:t>2</a:t>
+            </a:fld>
+            <a:endParaRPr lang="en-US"/>
+          </a:p>
+        </p:txBody>
+      </p:sp>
+    </p:spTree>
+    <p:extLst>
+      <p:ext uri="{BB962C8B-B14F-4D97-AF65-F5344CB8AC3E}">
+        <p14:creationId xmlns:p14="http://schemas.microsoft.com/office/powerpoint/2010/main" val="1024086991"/>
+      </p:ext>
+    </p:extLst>
+  </p:cSld>
+  <p:clrMapOvr>
+    <a:masterClrMapping/>
+  </p:clrMapOvr>
+</p:notes>
 </file>
 
-<file path=ppt/notesSlides/notesSlide20.xml><?xml version="1.0" encoding="UTF-8" standalone="yes"?>
-<p:notes xmlns:a="http://schemas.openxmlformats.org/drawingml/2006/main" xmlns:r="http://schemas.openxmlformats.org/officeDocument/2006/relationships" xmlns:p="http://schemas.openxmlformats.org/presentationml/2006/main"><p:cSld><p:spTree><p:nvGrpSpPr><p:cNvPr id="1" name=""/><p:cNvGrpSpPr/><p:nvPr/></p:nvGrpSpPr><p:grpSpPr><a:xfrm><a:off x="0" y="0"/><a:ext cx="0" cy="0"/><a:chOff x="0" y="0"/><a:chExt cx="0" cy="0"/></a:xfrm></p:grpSpPr><p:sp><p:nvSpPr><p:cNvPr id="2" name="Slide Image Placeholder 1"/><p:cNvSpPr><a:spLocks noGrp="1" noRot="1" noChangeAspect="1"/></p:cNvSpPr><p:nvPr><p:ph type="sldImg"/></p:nvPr></p:nvSpPr><p:spPr/></p:sp><p:sp><p:nvSpPr><p:cNvPr id="3" name="Notes Placeholder 2"/><p:cNvSpPr><a:spLocks noGrp="1"/></p:cNvSpPr><p:nvPr><p:ph type="body" idx="1"/></p:nvPr></p:nvSpPr><p:spPr/><p:txBody><a:bodyPr/><a:lstStyle/><a:p><a:r><a:rPr lang="en-US" dirty="0"/><a:t>技术选型。评委是技术背景时，重点讲那条分界线：-规则是纯函数、模型只做抽取与措辞，这不是偷懒，是因为算错一个税率就是真金白银的亏损。-另外可以提「刻意没引入」那一行——不用图表库（瀑布图、酒瓶液面全是手写 SVG 与 shader）、-不用组件库、不用数据库，税则是编译期常量，比数据库更适合审计与 diff。-判定页那瓶酒是 three.js 实时渲染的，液面高度就是套利风险分。</a:t></a:r><a:endParaRPr lang="en-US" dirty="0"/></a:p></p:txBody></p:sp><p:sp><p:nvSpPr><p:cNvPr id="4" name="Slide Number Placeholder 3"/><p:cNvSpPr><a:spLocks noGrp="1"/></p:cNvSpPr><p:nvPr><p:ph type="sldNum" sz="quarter" idx="10"/></p:nvPr></p:nvSpPr><p:spPr/><p:txBody><a:bodyPr/><a:lstStyle/><a:p><a:fld id="{F7021451-1387-4CA6-816F-3879F97B5CBC}" type="slidenum"><a:rPr lang="en-US"/><a:t>20</a:t></a:fld><a:endParaRPr lang="en-US"/></a:p></p:txBody></p:sp></p:spTree><p:extLst><p:ext uri="{BB962C8B-B14F-4D97-AF65-F5344CB8AC3E}"><p14:creationId xmlns:p14="http://schemas.microsoft.com/office/powerpoint/2010/main" val="1024086991"/></p:ext></p:extLst></p:cSld><p:clrMapOvr><a:masterClrMapping/></p:clrMapOvr></p:notes>
+<file path=ppt/notesSlides/notesSlide20.xml><?xml version="1.0" encoding="utf-8"?>
+<p:notes xmlns:a="http://schemas.openxmlformats.org/drawingml/2006/main" xmlns:r="http://schemas.openxmlformats.org/officeDocument/2006/relationships" xmlns:p="http://schemas.openxmlformats.org/presentationml/2006/main">
+  <p:cSld>
+    <p:spTree>
+      <p:nvGrpSpPr>
+        <p:cNvPr id="1" name=""/>
+        <p:cNvGrpSpPr/>
+        <p:nvPr/>
+      </p:nvGrpSpPr>
+      <p:grpSpPr>
+        <a:xfrm>
+          <a:off x="0" y="0"/>
+          <a:ext cx="0" cy="0"/>
+          <a:chOff x="0" y="0"/>
+          <a:chExt cx="0" cy="0"/>
+        </a:xfrm>
+      </p:grpSpPr>
+      <p:sp>
+        <p:nvSpPr>
+          <p:cNvPr id="2" name="Slide Image Placeholder 1"/>
+          <p:cNvSpPr>
+            <a:spLocks noGrp="1" noRot="1" noChangeAspect="1"/>
+          </p:cNvSpPr>
+          <p:nvPr>
+            <p:ph type="sldImg"/>
+          </p:nvPr>
+        </p:nvSpPr>
+        <p:spPr/>
+      </p:sp>
+      <p:sp>
+        <p:nvSpPr>
+          <p:cNvPr id="3" name="Notes Placeholder 2"/>
+          <p:cNvSpPr>
+            <a:spLocks noGrp="1"/>
+          </p:cNvSpPr>
+          <p:nvPr>
+            <p:ph type="body" idx="1"/>
+          </p:nvPr>
+        </p:nvSpPr>
+        <p:spPr/>
+        <p:txBody>
+          <a:bodyPr/>
+          <a:lstStyle/>
+          <a:p>
+            <a:r>
+              <a:rPr lang="en-US" dirty="0"/>
+              <a:t>技术选型。评委是技术背景时，重点讲那条分界线：</a:t>
+            </a:r>
+          </a:p>
+          <a:p>
+            <a:r>
+              <a:rPr lang="zh-CN" altLang="en-US" dirty="0"/>
+              <a:t>规则是纯函数、模型只做抽取与措辞，这不是偷懒，是因为算错一个税率就是真金白银的亏损。</a:t>
+            </a:r>
+          </a:p>
+          <a:p>
+            <a:r>
+              <a:rPr lang="zh-CN" altLang="en-US" dirty="0"/>
+              <a:t>另外可以提「刻意没引入」那一行——不用图表库（瀑布图、酒瓶液面全是手写 SVG 与 shader）、</a:t>
+            </a:r>
+          </a:p>
+          <a:p>
+            <a:r>
+              <a:rPr lang="zh-CN" altLang="en-US" dirty="0"/>
+              <a:t>不用组件库、不用数据库，税则是编译期常量，比数据库更适合审计与 diff。</a:t>
+            </a:r>
+          </a:p>
+          <a:p>
+            <a:r>
+              <a:rPr lang="zh-CN" altLang="en-US" dirty="0"/>
+              <a:t>判定页那瓶酒是 three.js 实时渲染的，液面高度就是套利风险分。</a:t>
+            </a:r>
+            <a:endParaRPr lang="en-US" dirty="0"/>
+          </a:p>
+        </p:txBody>
+      </p:sp>
+      <p:sp>
+        <p:nvSpPr>
+          <p:cNvPr id="4" name="Slide Number Placeholder 3"/>
+          <p:cNvSpPr>
+            <a:spLocks noGrp="1"/>
+          </p:cNvSpPr>
+          <p:nvPr>
+            <p:ph type="sldNum" sz="quarter" idx="10"/>
+          </p:nvPr>
+        </p:nvSpPr>
+        <p:spPr/>
+        <p:txBody>
+          <a:bodyPr/>
+          <a:lstStyle/>
+          <a:p>
+            <a:fld id="{F7021451-1387-4CA6-816F-3879F97B5CBC}" type="slidenum">
+              <a:rPr lang="en-US"/>
+              <a:t>20</a:t>
+            </a:fld>
+            <a:endParaRPr lang="en-US"/>
+          </a:p>
+        </p:txBody>
+      </p:sp>
+    </p:spTree>
+    <p:extLst>
+      <p:ext uri="{BB962C8B-B14F-4D97-AF65-F5344CB8AC3E}">
+        <p14:creationId xmlns:p14="http://schemas.microsoft.com/office/powerpoint/2010/main" val="1024086991"/>
+      </p:ext>
+    </p:extLst>
+  </p:cSld>
+  <p:clrMapOvr>
+    <a:masterClrMapping/>
+  </p:clrMapOvr>
+</p:notes>
 </file>
 
-<file path=ppt/notesSlides/notesSlide21.xml><?xml version="1.0" encoding="UTF-8" standalone="yes"?>
-<p:notes xmlns:a="http://schemas.openxmlformats.org/drawingml/2006/main" xmlns:r="http://schemas.openxmlformats.org/officeDocument/2006/relationships" xmlns:p="http://schemas.openxmlformats.org/presentationml/2006/main"><p:cSld><p:spTree><p:nvGrpSpPr><p:cNvPr id="1" name=""/><p:cNvGrpSpPr/><p:nvPr/></p:nvGrpSpPr><p:grpSpPr><a:xfrm><a:off x="0" y="0"/><a:ext cx="0" cy="0"/><a:chOff x="0" y="0"/><a:chExt cx="0" cy="0"/></a:xfrm></p:grpSpPr><p:sp><p:nvSpPr><p:cNvPr id="2" name="Slide Image Placeholder 1"/><p:cNvSpPr><a:spLocks noGrp="1" noRot="1" noChangeAspect="1"/></p:cNvSpPr><p:nvPr><p:ph type="sldImg"/></p:nvPr></p:nvSpPr><p:spPr/></p:sp><p:sp><p:nvSpPr><p:cNvPr id="3" name="Notes Placeholder 2"/><p:cNvSpPr><a:spLocks noGrp="1"/></p:cNvSpPr><p:nvPr><p:ph type="body" idx="1"/></p:nvPr></p:nvSpPr><p:spPr/><p:txBody><a:bodyPr/><a:lstStyle/><a:p><a:r><a:rPr lang="en-US" dirty="0"/><a:t>线上体验可以直接请评委自己打开点，不用注册。-仓库是公开的，Topic 是 #Guikesong，README 顶部就是技术栈表。-如果还有时间，可以回到 demo 现场再跑一个越南的案例做对照——-同样八秒，出来的是「可谈」，让他们看到这工具不是只会说不。</a:t></a:r><a:endParaRPr lang="en-US" dirty="0"/></a:p></p:txBody></p:sp><p:sp><p:nvSpPr><p:cNvPr id="4" name="Slide Number Placeholder 3"/><p:cNvSpPr><a:spLocks noGrp="1"/></p:cNvSpPr><p:nvPr><p:ph type="sldNum" sz="quarter" idx="10"/></p:nvPr></p:nvSpPr><p:spPr/><p:txBody><a:bodyPr/><a:lstStyle/><a:p><a:fld id="{F7021451-1387-4CA6-816F-3879F97B5CBC}" type="slidenum"><a:rPr lang="en-US"/><a:t>21</a:t></a:fld><a:endParaRPr lang="en-US"/></a:p></p:txBody></p:sp></p:spTree><p:extLst><p:ext uri="{BB962C8B-B14F-4D97-AF65-F5344CB8AC3E}"><p14:creationId xmlns:p14="http://schemas.microsoft.com/office/powerpoint/2010/main" val="1024086991"/></p:ext></p:extLst></p:cSld><p:clrMapOvr><a:masterClrMapping/></p:clrMapOvr></p:notes>
+<file path=ppt/notesSlides/notesSlide21.xml><?xml version="1.0" encoding="utf-8"?>
+<p:notes xmlns:a="http://schemas.openxmlformats.org/drawingml/2006/main" xmlns:r="http://schemas.openxmlformats.org/officeDocument/2006/relationships" xmlns:p="http://schemas.openxmlformats.org/presentationml/2006/main">
+  <p:cSld>
+    <p:spTree>
+      <p:nvGrpSpPr>
+        <p:cNvPr id="1" name=""/>
+        <p:cNvGrpSpPr/>
+        <p:nvPr/>
+      </p:nvGrpSpPr>
+      <p:grpSpPr>
+        <a:xfrm>
+          <a:off x="0" y="0"/>
+          <a:ext cx="0" cy="0"/>
+          <a:chOff x="0" y="0"/>
+          <a:chExt cx="0" cy="0"/>
+        </a:xfrm>
+      </p:grpSpPr>
+      <p:sp>
+        <p:nvSpPr>
+          <p:cNvPr id="2" name="Slide Image Placeholder 1"/>
+          <p:cNvSpPr>
+            <a:spLocks noGrp="1" noRot="1" noChangeAspect="1"/>
+          </p:cNvSpPr>
+          <p:nvPr>
+            <p:ph type="sldImg"/>
+          </p:nvPr>
+        </p:nvSpPr>
+        <p:spPr/>
+      </p:sp>
+      <p:sp>
+        <p:nvSpPr>
+          <p:cNvPr id="3" name="Notes Placeholder 2"/>
+          <p:cNvSpPr>
+            <a:spLocks noGrp="1"/>
+          </p:cNvSpPr>
+          <p:nvPr>
+            <p:ph type="body" idx="1"/>
+          </p:nvPr>
+        </p:nvSpPr>
+        <p:spPr/>
+        <p:txBody>
+          <a:bodyPr/>
+          <a:lstStyle/>
+          <a:p>
+            <a:r>
+              <a:rPr lang="en-US" dirty="0"/>
+              <a:t>线上体验可以直接请评委自己打开点，不用注册。</a:t>
+            </a:r>
+          </a:p>
+          <a:p>
+            <a:r>
+              <a:rPr lang="zh-CN" altLang="en-US" dirty="0"/>
+              <a:t>仓库是公开的，Topic 是 #Guikesong，README 顶部就是技术栈表。</a:t>
+            </a:r>
+          </a:p>
+          <a:p>
+            <a:r>
+              <a:rPr lang="zh-CN" altLang="en-US" dirty="0"/>
+              <a:t>如果还有时间，可以回到 demo 现场再跑一个越南的案例做对照——</a:t>
+            </a:r>
+          </a:p>
+          <a:p>
+            <a:r>
+              <a:rPr lang="zh-CN" altLang="en-US" dirty="0"/>
+              <a:t>同样八秒，出来的是「可谈」，让他们看到这工具不是只会说不。</a:t>
+            </a:r>
+            <a:endParaRPr lang="en-US" dirty="0"/>
+          </a:p>
+        </p:txBody>
+      </p:sp>
+      <p:sp>
+        <p:nvSpPr>
+          <p:cNvPr id="4" name="Slide Number Placeholder 3"/>
+          <p:cNvSpPr>
+            <a:spLocks noGrp="1"/>
+          </p:cNvSpPr>
+          <p:nvPr>
+            <p:ph type="sldNum" sz="quarter" idx="10"/>
+          </p:nvPr>
+        </p:nvSpPr>
+        <p:spPr/>
+        <p:txBody>
+          <a:bodyPr/>
+          <a:lstStyle/>
+          <a:p>
+            <a:fld id="{F7021451-1387-4CA6-816F-3879F97B5CBC}" type="slidenum">
+              <a:rPr lang="en-US"/>
+              <a:t>21</a:t>
+            </a:fld>
+            <a:endParaRPr lang="en-US"/>
+          </a:p>
+        </p:txBody>
+      </p:sp>
+    </p:spTree>
+    <p:extLst>
+      <p:ext uri="{BB962C8B-B14F-4D97-AF65-F5344CB8AC3E}">
+        <p14:creationId xmlns:p14="http://schemas.microsoft.com/office/powerpoint/2010/main" val="1024086991"/>
+      </p:ext>
+    </p:extLst>
+  </p:cSld>
+  <p:clrMapOvr>
+    <a:masterClrMapping/>
+  </p:clrMapOvr>
+</p:notes>
 </file>
 
-<file path=ppt/notesSlides/notesSlide3.xml><?xml version="1.0" encoding="UTF-8" standalone="yes"?>
-<p:notes xmlns:a="http://schemas.openxmlformats.org/drawingml/2006/main" xmlns:r="http://schemas.openxmlformats.org/officeDocument/2006/relationships" xmlns:p="http://schemas.openxmlformats.org/presentationml/2006/main"><p:cSld><p:spTree><p:nvGrpSpPr><p:cNvPr id="1" name=""/><p:cNvGrpSpPr/><p:nvPr/></p:nvGrpSpPr><p:grpSpPr><a:xfrm><a:off x="0" y="0"/><a:ext cx="0" cy="0"/><a:chOff x="0" y="0"/><a:chExt cx="0" cy="0"/></a:xfrm></p:grpSpPr><p:sp><p:nvSpPr><p:cNvPr id="2" name="Slide Image Placeholder 1"/><p:cNvSpPr><a:spLocks noGrp="1" noRot="1" noChangeAspect="1"/></p:cNvSpPr><p:nvPr><p:ph type="sldImg"/></p:nvPr></p:nvSpPr><p:spPr/></p:sp><p:sp><p:nvSpPr><p:cNvPr id="3" name="Notes Placeholder 2"/><p:cNvSpPr><a:spLocks noGrp="1"/></p:cNvSpPr><p:nvPr><p:ph type="body" idx="1"/></p:nvPr></p:nvSpPr><p:spPr/><p:txBody><a:bodyPr/><a:lstStyle/><a:p><a:r><a:rPr lang="en-US" dirty="0"/><a:t>（0:56–1:20　24 秒　111 字）--卡住的不在酿酒，在酿完之后。-展会散场，业务员手上十几张名片，-却分不清哪个是真经销商，哪个是来做别的事的。-他真正的问题只有三个：这人是真想卖酒还是在做税差？-这瓶酒到他货架上卖多少钱、卖得动吗？合同该写死哪几条？-现在只能靠猜。--───── 时间充裕可加 ─────-因为答案分散在五个国家的税则、牌照制度和渠道结构里，他连从哪查起都不知道。</a:t></a:r><a:endParaRPr lang="en-US" dirty="0"/></a:p></p:txBody></p:sp><p:sp><p:nvSpPr><p:cNvPr id="4" name="Slide Number Placeholder 3"/><p:cNvSpPr><a:spLocks noGrp="1"/></p:cNvSpPr><p:nvPr><p:ph type="sldNum" sz="quarter" idx="10"/></p:nvPr></p:nvSpPr><p:spPr/><p:txBody><a:bodyPr/><a:lstStyle/><a:p><a:fld id="{F7021451-1387-4CA6-816F-3879F97B5CBC}" type="slidenum"><a:rPr lang="en-US"/><a:t>3</a:t></a:fld><a:endParaRPr lang="en-US"/></a:p></p:txBody></p:sp></p:spTree><p:extLst><p:ext uri="{BB962C8B-B14F-4D97-AF65-F5344CB8AC3E}"><p14:creationId xmlns:p14="http://schemas.microsoft.com/office/powerpoint/2010/main" val="1024086991"/></p:ext></p:extLst></p:cSld><p:clrMapOvr><a:masterClrMapping/></p:clrMapOvr></p:notes>
+<file path=ppt/notesSlides/notesSlide3.xml><?xml version="1.0" encoding="utf-8"?>
+<p:notes xmlns:a="http://schemas.openxmlformats.org/drawingml/2006/main" xmlns:r="http://schemas.openxmlformats.org/officeDocument/2006/relationships" xmlns:p="http://schemas.openxmlformats.org/presentationml/2006/main">
+  <p:cSld>
+    <p:spTree>
+      <p:nvGrpSpPr>
+        <p:cNvPr id="1" name=""/>
+        <p:cNvGrpSpPr/>
+        <p:nvPr/>
+      </p:nvGrpSpPr>
+      <p:grpSpPr>
+        <a:xfrm>
+          <a:off x="0" y="0"/>
+          <a:ext cx="0" cy="0"/>
+          <a:chOff x="0" y="0"/>
+          <a:chExt cx="0" cy="0"/>
+        </a:xfrm>
+      </p:grpSpPr>
+      <p:sp>
+        <p:nvSpPr>
+          <p:cNvPr id="2" name="Slide Image Placeholder 1"/>
+          <p:cNvSpPr>
+            <a:spLocks noGrp="1" noRot="1" noChangeAspect="1"/>
+          </p:cNvSpPr>
+          <p:nvPr>
+            <p:ph type="sldImg"/>
+          </p:nvPr>
+        </p:nvSpPr>
+        <p:spPr/>
+      </p:sp>
+      <p:sp>
+        <p:nvSpPr>
+          <p:cNvPr id="3" name="Notes Placeholder 2"/>
+          <p:cNvSpPr>
+            <a:spLocks noGrp="1"/>
+          </p:cNvSpPr>
+          <p:nvPr>
+            <p:ph type="body" idx="1"/>
+          </p:nvPr>
+        </p:nvSpPr>
+        <p:spPr/>
+        <p:txBody>
+          <a:bodyPr/>
+          <a:lstStyle/>
+          <a:p>
+            <a:r>
+              <a:rPr lang="en-US" dirty="0"/>
+              <a:t>（0:56–1:20　24 秒　111 字）</a:t>
+            </a:r>
+          </a:p>
+          <a:p>
+            <a:r>
+              <a:rPr lang="zh-CN" altLang="en-US" dirty="0"/>
+              <a:t/>
+            </a:r>
+          </a:p>
+          <a:p>
+            <a:r>
+              <a:rPr lang="zh-CN" altLang="en-US" dirty="0"/>
+              <a:t>卡住的不在酿酒，在酿完之后。</a:t>
+            </a:r>
+          </a:p>
+          <a:p>
+            <a:r>
+              <a:rPr lang="zh-CN" altLang="en-US" dirty="0"/>
+              <a:t>展会散场，业务员手上十几张名片，</a:t>
+            </a:r>
+          </a:p>
+          <a:p>
+            <a:r>
+              <a:rPr lang="zh-CN" altLang="en-US" dirty="0"/>
+              <a:t>却分不清哪个是真经销商，哪个是来做别的事的。</a:t>
+            </a:r>
+          </a:p>
+          <a:p>
+            <a:r>
+              <a:rPr lang="zh-CN" altLang="en-US" dirty="0"/>
+              <a:t>他真正的问题只有三个：这人是真想卖酒还是在做税差？</a:t>
+            </a:r>
+          </a:p>
+          <a:p>
+            <a:r>
+              <a:rPr lang="zh-CN" altLang="en-US" dirty="0"/>
+              <a:t>这瓶酒到他货架上卖多少钱、卖得动吗？合同该写死哪几条？</a:t>
+            </a:r>
+          </a:p>
+          <a:p>
+            <a:r>
+              <a:rPr lang="zh-CN" altLang="en-US" dirty="0"/>
+              <a:t>现在只能靠猜。</a:t>
+            </a:r>
+          </a:p>
+          <a:p>
+            <a:r>
+              <a:rPr lang="zh-CN" altLang="en-US" dirty="0"/>
+              <a:t/>
+            </a:r>
+          </a:p>
+          <a:p>
+            <a:r>
+              <a:rPr lang="zh-CN" altLang="en-US" dirty="0"/>
+              <a:t>───── 时间充裕可加 ─────</a:t>
+            </a:r>
+          </a:p>
+          <a:p>
+            <a:r>
+              <a:rPr lang="zh-CN" altLang="en-US" dirty="0"/>
+              <a:t>因为答案分散在五个国家的税则、牌照制度和渠道结构里，他连从哪查起都不知道。</a:t>
+            </a:r>
+            <a:endParaRPr lang="en-US" dirty="0"/>
+          </a:p>
+        </p:txBody>
+      </p:sp>
+      <p:sp>
+        <p:nvSpPr>
+          <p:cNvPr id="4" name="Slide Number Placeholder 3"/>
+          <p:cNvSpPr>
+            <a:spLocks noGrp="1"/>
+          </p:cNvSpPr>
+          <p:nvPr>
+            <p:ph type="sldNum" sz="quarter" idx="10"/>
+          </p:nvPr>
+        </p:nvSpPr>
+        <p:spPr/>
+        <p:txBody>
+          <a:bodyPr/>
+          <a:lstStyle/>
+          <a:p>
+            <a:fld id="{F7021451-1387-4CA6-816F-3879F97B5CBC}" type="slidenum">
+              <a:rPr lang="en-US"/>
+              <a:t>3</a:t>
+            </a:fld>
+            <a:endParaRPr lang="en-US"/>
+          </a:p>
+        </p:txBody>
+      </p:sp>
+    </p:spTree>
+    <p:extLst>
+      <p:ext uri="{BB962C8B-B14F-4D97-AF65-F5344CB8AC3E}">
+        <p14:creationId xmlns:p14="http://schemas.microsoft.com/office/powerpoint/2010/main" val="1024086991"/>
+      </p:ext>
+    </p:extLst>
+  </p:cSld>
+  <p:clrMapOvr>
+    <a:masterClrMapping/>
+  </p:clrMapOvr>
+</p:notes>
 </file>
 
-<file path=ppt/notesSlides/notesSlide4.xml><?xml version="1.0" encoding="UTF-8" standalone="yes"?>
-<p:notes xmlns:a="http://schemas.openxmlformats.org/drawingml/2006/main" xmlns:r="http://schemas.openxmlformats.org/officeDocument/2006/relationships" xmlns:p="http://schemas.openxmlformats.org/presentationml/2006/main"><p:cSld><p:spTree><p:nvGrpSpPr><p:cNvPr id="1" name=""/><p:cNvGrpSpPr/><p:nvPr/></p:nvGrpSpPr><p:grpSpPr><a:xfrm><a:off x="0" y="0"/><a:ext cx="0" cy="0"/><a:chOff x="0" y="0"/><a:chExt cx="0" cy="0"/></a:xfrm></p:grpSpPr><p:sp><p:nvSpPr><p:cNvPr id="2" name="Slide Image Placeholder 1"/><p:cNvSpPr><a:spLocks noGrp="1" noRot="1" noChangeAspect="1"/></p:cNvSpPr><p:nvPr><p:ph type="sldImg"/></p:nvPr></p:nvSpPr><p:spPr/></p:sp><p:sp><p:nvSpPr><p:cNvPr id="3" name="Notes Placeholder 2"/><p:cNvSpPr><a:spLocks noGrp="1"/></p:cNvSpPr><p:nvPr><p:ph type="body" idx="1"/></p:nvPr></p:nvSpPr><p:spPr/><p:txBody><a:bodyPr/><a:lstStyle/><a:p><a:r><a:rPr lang="en-US" dirty="0"/><a:t>（1:20–1:58　38 秒　159 字）--看一张真实的名片。-[指瓶子]-他说：出厂价最低多少，我们要最低的，先来三个柜；-标签不用改，我们自己处理；货先放自贸仓；动销数据是商业机密。-每一句单独看都不算离谱，合起来是另一回事。-他要的不是这瓶酒。-白酒出口，消费税百分之二十从价免征，加增值税退税百分之十三——-他要的是这百分之三十三。囤进自贸仓转手就走，-酒有没有上过货架跟他无关。--───── 时间充裕可加 ─────-第二个买家问的是：有没有三十八度的，因为越南特别消费税以二十度分界；标签要越南文；-先做一百五十箱放十二家中餐厅试销；能不能给品鉴小样，我们要培训服务生。-这个人是来卖酒的。差别不在语气，在他关心什么。</a:t></a:r><a:endParaRPr lang="en-US" dirty="0"/></a:p></p:txBody></p:sp><p:sp><p:nvSpPr><p:cNvPr id="4" name="Slide Number Placeholder 3"/><p:cNvSpPr><a:spLocks noGrp="1"/></p:cNvSpPr><p:nvPr><p:ph type="sldNum" sz="quarter" idx="10"/></p:nvPr></p:nvSpPr><p:spPr/><p:txBody><a:bodyPr/><a:lstStyle/><a:p><a:fld id="{F7021451-1387-4CA6-816F-3879F97B5CBC}" type="slidenum"><a:rPr lang="en-US"/><a:t>4</a:t></a:fld><a:endParaRPr lang="en-US"/></a:p></p:txBody></p:sp></p:spTree><p:extLst><p:ext uri="{BB962C8B-B14F-4D97-AF65-F5344CB8AC3E}"><p14:creationId xmlns:p14="http://schemas.microsoft.com/office/powerpoint/2010/main" val="1024086991"/></p:ext></p:extLst></p:cSld><p:clrMapOvr><a:masterClrMapping/></p:clrMapOvr></p:notes>
+<file path=ppt/notesSlides/notesSlide4.xml><?xml version="1.0" encoding="utf-8"?>
+<p:notes xmlns:a="http://schemas.openxmlformats.org/drawingml/2006/main" xmlns:r="http://schemas.openxmlformats.org/officeDocument/2006/relationships" xmlns:p="http://schemas.openxmlformats.org/presentationml/2006/main">
+  <p:cSld>
+    <p:spTree>
+      <p:nvGrpSpPr>
+        <p:cNvPr id="1" name=""/>
+        <p:cNvGrpSpPr/>
+        <p:nvPr/>
+      </p:nvGrpSpPr>
+      <p:grpSpPr>
+        <a:xfrm>
+          <a:off x="0" y="0"/>
+          <a:ext cx="0" cy="0"/>
+          <a:chOff x="0" y="0"/>
+          <a:chExt cx="0" cy="0"/>
+        </a:xfrm>
+      </p:grpSpPr>
+      <p:sp>
+        <p:nvSpPr>
+          <p:cNvPr id="2" name="Slide Image Placeholder 1"/>
+          <p:cNvSpPr>
+            <a:spLocks noGrp="1" noRot="1" noChangeAspect="1"/>
+          </p:cNvSpPr>
+          <p:nvPr>
+            <p:ph type="sldImg"/>
+          </p:nvPr>
+        </p:nvSpPr>
+        <p:spPr/>
+      </p:sp>
+      <p:sp>
+        <p:nvSpPr>
+          <p:cNvPr id="3" name="Notes Placeholder 2"/>
+          <p:cNvSpPr>
+            <a:spLocks noGrp="1"/>
+          </p:cNvSpPr>
+          <p:nvPr>
+            <p:ph type="body" idx="1"/>
+          </p:nvPr>
+        </p:nvSpPr>
+        <p:spPr/>
+        <p:txBody>
+          <a:bodyPr/>
+          <a:lstStyle/>
+          <a:p>
+            <a:r>
+              <a:rPr lang="en-US" dirty="0"/>
+              <a:t>（1:20–1:58　38 秒　159 字）</a:t>
+            </a:r>
+          </a:p>
+          <a:p>
+            <a:r>
+              <a:rPr lang="zh-CN" altLang="en-US" dirty="0"/>
+              <a:t/>
+            </a:r>
+          </a:p>
+          <a:p>
+            <a:r>
+              <a:rPr lang="zh-CN" altLang="en-US" dirty="0"/>
+              <a:t>看一张真实的名片。</a:t>
+            </a:r>
+          </a:p>
+          <a:p>
+            <a:r>
+              <a:rPr lang="zh-CN" altLang="en-US" dirty="0"/>
+              <a:t>[指瓶子]</a:t>
+            </a:r>
+          </a:p>
+          <a:p>
+            <a:r>
+              <a:rPr lang="zh-CN" altLang="en-US" dirty="0"/>
+              <a:t>他说：出厂价最低多少，我们要最低的，先来三个柜；</a:t>
+            </a:r>
+          </a:p>
+          <a:p>
+            <a:r>
+              <a:rPr lang="zh-CN" altLang="en-US" dirty="0"/>
+              <a:t>标签不用改，我们自己处理；货先放自贸仓；动销数据是商业机密。</a:t>
+            </a:r>
+          </a:p>
+          <a:p>
+            <a:r>
+              <a:rPr lang="zh-CN" altLang="en-US" dirty="0"/>
+              <a:t>每一句单独看都不算离谱，合起来是另一回事。</a:t>
+            </a:r>
+          </a:p>
+          <a:p>
+            <a:r>
+              <a:rPr lang="zh-CN" altLang="en-US" dirty="0"/>
+              <a:t>他要的不是这瓶酒。</a:t>
+            </a:r>
+          </a:p>
+          <a:p>
+            <a:r>
+              <a:rPr lang="zh-CN" altLang="en-US" dirty="0"/>
+              <a:t>白酒出口，消费税百分之二十从价免征，加增值税退税百分之十三——</a:t>
+            </a:r>
+          </a:p>
+          <a:p>
+            <a:r>
+              <a:rPr lang="zh-CN" altLang="en-US" dirty="0"/>
+              <a:t>他要的是这百分之三十三。囤进自贸仓转手就走，</a:t>
+            </a:r>
+          </a:p>
+          <a:p>
+            <a:r>
+              <a:rPr lang="zh-CN" altLang="en-US" dirty="0"/>
+              <a:t>酒有没有上过货架跟他无关。</a:t>
+            </a:r>
+          </a:p>
+          <a:p>
+            <a:r>
+              <a:rPr lang="zh-CN" altLang="en-US" dirty="0"/>
+              <a:t/>
+            </a:r>
+          </a:p>
+          <a:p>
+            <a:r>
+              <a:rPr lang="zh-CN" altLang="en-US" dirty="0"/>
+              <a:t>───── 时间充裕可加 ─────</a:t>
+            </a:r>
+          </a:p>
+          <a:p>
+            <a:r>
+              <a:rPr lang="zh-CN" altLang="en-US" dirty="0"/>
+              <a:t>第二个买家问的是：有没有三十八度的，因为越南特别消费税以二十度分界；标签要越南文；</a:t>
+            </a:r>
+          </a:p>
+          <a:p>
+            <a:r>
+              <a:rPr lang="zh-CN" altLang="en-US" dirty="0"/>
+              <a:t>先做一百五十箱放十二家中餐厅试销；能不能给品鉴小样，我们要培训服务生。</a:t>
+            </a:r>
+          </a:p>
+          <a:p>
+            <a:r>
+              <a:rPr lang="zh-CN" altLang="en-US" dirty="0"/>
+              <a:t>这个人是来卖酒的。差别不在语气，在他关心什么。</a:t>
+            </a:r>
+            <a:endParaRPr lang="en-US" dirty="0"/>
+          </a:p>
+        </p:txBody>
+      </p:sp>
+      <p:sp>
+        <p:nvSpPr>
+          <p:cNvPr id="4" name="Slide Number Placeholder 3"/>
+          <p:cNvSpPr>
+            <a:spLocks noGrp="1"/>
+          </p:cNvSpPr>
+          <p:nvPr>
+            <p:ph type="sldNum" sz="quarter" idx="10"/>
+          </p:nvPr>
+        </p:nvSpPr>
+        <p:spPr/>
+        <p:txBody>
+          <a:bodyPr/>
+          <a:lstStyle/>
+          <a:p>
+            <a:fld id="{F7021451-1387-4CA6-816F-3879F97B5CBC}" type="slidenum">
+              <a:rPr lang="en-US"/>
+              <a:t>4</a:t>
+            </a:fld>
+            <a:endParaRPr lang="en-US"/>
+          </a:p>
+        </p:txBody>
+      </p:sp>
+    </p:spTree>
+    <p:extLst>
+      <p:ext uri="{BB962C8B-B14F-4D97-AF65-F5344CB8AC3E}">
+        <p14:creationId xmlns:p14="http://schemas.microsoft.com/office/powerpoint/2010/main" val="1024086991"/>
+      </p:ext>
+    </p:extLst>
+  </p:cSld>
+  <p:clrMapOvr>
+    <a:masterClrMapping/>
+  </p:clrMapOvr>
+</p:notes>
 </file>
 
-<file path=ppt/notesSlides/notesSlide5.xml><?xml version="1.0" encoding="UTF-8" standalone="yes"?>
-<p:notes xmlns:a="http://schemas.openxmlformats.org/drawingml/2006/main" xmlns:r="http://schemas.openxmlformats.org/officeDocument/2006/relationships" xmlns:p="http://schemas.openxmlformats.org/presentationml/2006/main"><p:cSld><p:spTree><p:nvGrpSpPr><p:cNvPr id="1" name=""/><p:cNvGrpSpPr/><p:nvPr/></p:nvGrpSpPr><p:grpSpPr><a:xfrm><a:off x="0" y="0"/><a:ext cx="0" cy="0"/><a:chOff x="0" y="0"/><a:chExt cx="0" cy="0"/></a:xfrm></p:grpSpPr><p:sp><p:nvSpPr><p:cNvPr id="2" name="Slide Image Placeholder 1"/><p:cNvSpPr><a:spLocks noGrp="1" noRot="1" noChangeAspect="1"/></p:cNvSpPr><p:nvPr><p:ph type="sldImg"/></p:nvPr></p:nvSpPr><p:spPr/></p:sp><p:sp><p:nvSpPr><p:cNvPr id="3" name="Notes Placeholder 2"/><p:cNvSpPr><a:spLocks noGrp="1"/></p:cNvSpPr><p:nvPr><p:ph type="body" idx="1"/></p:nvPr></p:nvSpPr><p:spPr/><p:txBody><a:bodyPr/><a:lstStyle/><a:p><a:r><a:rPr lang="en-US" dirty="0"/><a:t>（1:58–2:20　22 秒　91 字）--判断错了，代价是多少。-一柜货值两百六十一万；卖不掉折价倒回国内，亏七十八万。-但更贵的不是这笔钱，是当地价格烂掉之后，-你再也找不到第二个愿意接的经销商。-而这些，你要九十天以后才会知道。--───── 时间充裕可加 ─────-这就是为什么这个判断必须发生在签约之前，不是发生在报关那一天。</a:t></a:r><a:endParaRPr lang="en-US" dirty="0"/></a:p></p:txBody></p:sp><p:sp><p:nvSpPr><p:cNvPr id="4" name="Slide Number Placeholder 3"/><p:cNvSpPr><a:spLocks noGrp="1"/></p:cNvSpPr><p:nvPr><p:ph type="sldNum" sz="quarter" idx="10"/></p:nvPr></p:nvSpPr><p:spPr/><p:txBody><a:bodyPr/><a:lstStyle/><a:p><a:fld id="{F7021451-1387-4CA6-816F-3879F97B5CBC}" type="slidenum"><a:rPr lang="en-US"/><a:t>5</a:t></a:fld><a:endParaRPr lang="en-US"/></a:p></p:txBody></p:sp></p:spTree><p:extLst><p:ext uri="{BB962C8B-B14F-4D97-AF65-F5344CB8AC3E}"><p14:creationId xmlns:p14="http://schemas.microsoft.com/office/powerpoint/2010/main" val="1024086991"/></p:ext></p:extLst></p:cSld><p:clrMapOvr><a:masterClrMapping/></p:clrMapOvr></p:notes>
+<file path=ppt/notesSlides/notesSlide5.xml><?xml version="1.0" encoding="utf-8"?>
+<p:notes xmlns:a="http://schemas.openxmlformats.org/drawingml/2006/main" xmlns:r="http://schemas.openxmlformats.org/officeDocument/2006/relationships" xmlns:p="http://schemas.openxmlformats.org/presentationml/2006/main">
+  <p:cSld>
+    <p:spTree>
+      <p:nvGrpSpPr>
+        <p:cNvPr id="1" name=""/>
+        <p:cNvGrpSpPr/>
+        <p:nvPr/>
+      </p:nvGrpSpPr>
+      <p:grpSpPr>
+        <a:xfrm>
+          <a:off x="0" y="0"/>
+          <a:ext cx="0" cy="0"/>
+          <a:chOff x="0" y="0"/>
+          <a:chExt cx="0" cy="0"/>
+        </a:xfrm>
+      </p:grpSpPr>
+      <p:sp>
+        <p:nvSpPr>
+          <p:cNvPr id="2" name="Slide Image Placeholder 1"/>
+          <p:cNvSpPr>
+            <a:spLocks noGrp="1" noRot="1" noChangeAspect="1"/>
+          </p:cNvSpPr>
+          <p:nvPr>
+            <p:ph type="sldImg"/>
+          </p:nvPr>
+        </p:nvSpPr>
+        <p:spPr/>
+      </p:sp>
+      <p:sp>
+        <p:nvSpPr>
+          <p:cNvPr id="3" name="Notes Placeholder 2"/>
+          <p:cNvSpPr>
+            <a:spLocks noGrp="1"/>
+          </p:cNvSpPr>
+          <p:nvPr>
+            <p:ph type="body" idx="1"/>
+          </p:nvPr>
+        </p:nvSpPr>
+        <p:spPr/>
+        <p:txBody>
+          <a:bodyPr/>
+          <a:lstStyle/>
+          <a:p>
+            <a:r>
+              <a:rPr lang="en-US" dirty="0"/>
+              <a:t>（1:58–2:20　22 秒　91 字）</a:t>
+            </a:r>
+          </a:p>
+          <a:p>
+            <a:r>
+              <a:rPr lang="zh-CN" altLang="en-US" dirty="0"/>
+              <a:t/>
+            </a:r>
+          </a:p>
+          <a:p>
+            <a:r>
+              <a:rPr lang="zh-CN" altLang="en-US" dirty="0"/>
+              <a:t>判断错了，代价是多少。</a:t>
+            </a:r>
+          </a:p>
+          <a:p>
+            <a:r>
+              <a:rPr lang="zh-CN" altLang="en-US" dirty="0"/>
+              <a:t>一柜货值两百六十一万；卖不掉折价倒回国内，亏七十八万。</a:t>
+            </a:r>
+          </a:p>
+          <a:p>
+            <a:r>
+              <a:rPr lang="zh-CN" altLang="en-US" dirty="0"/>
+              <a:t>但更贵的不是这笔钱，是当地价格烂掉之后，</a:t>
+            </a:r>
+          </a:p>
+          <a:p>
+            <a:r>
+              <a:rPr lang="zh-CN" altLang="en-US" dirty="0"/>
+              <a:t>你再也找不到第二个愿意接的经销商。</a:t>
+            </a:r>
+          </a:p>
+          <a:p>
+            <a:r>
+              <a:rPr lang="zh-CN" altLang="en-US" dirty="0"/>
+              <a:t>而这些，你要九十天以后才会知道。</a:t>
+            </a:r>
+          </a:p>
+          <a:p>
+            <a:r>
+              <a:rPr lang="zh-CN" altLang="en-US" dirty="0"/>
+              <a:t/>
+            </a:r>
+          </a:p>
+          <a:p>
+            <a:r>
+              <a:rPr lang="zh-CN" altLang="en-US" dirty="0"/>
+              <a:t>───── 时间充裕可加 ─────</a:t>
+            </a:r>
+          </a:p>
+          <a:p>
+            <a:r>
+              <a:rPr lang="zh-CN" altLang="en-US" dirty="0"/>
+              <a:t>这就是为什么这个判断必须发生在签约之前，不是发生在报关那一天。</a:t>
+            </a:r>
+            <a:endParaRPr lang="en-US" dirty="0"/>
+          </a:p>
+        </p:txBody>
+      </p:sp>
+      <p:sp>
+        <p:nvSpPr>
+          <p:cNvPr id="4" name="Slide Number Placeholder 3"/>
+          <p:cNvSpPr>
+            <a:spLocks noGrp="1"/>
+          </p:cNvSpPr>
+          <p:nvPr>
+            <p:ph type="sldNum" sz="quarter" idx="10"/>
+          </p:nvPr>
+        </p:nvSpPr>
+        <p:spPr/>
+        <p:txBody>
+          <a:bodyPr/>
+          <a:lstStyle/>
+          <a:p>
+            <a:fld id="{F7021451-1387-4CA6-816F-3879F97B5CBC}" type="slidenum">
+              <a:rPr lang="en-US"/>
+              <a:t>5</a:t>
+            </a:fld>
+            <a:endParaRPr lang="en-US"/>
+          </a:p>
+        </p:txBody>
+      </p:sp>
+    </p:spTree>
+    <p:extLst>
+      <p:ext uri="{BB962C8B-B14F-4D97-AF65-F5344CB8AC3E}">
+        <p14:creationId xmlns:p14="http://schemas.microsoft.com/office/powerpoint/2010/main" val="1024086991"/>
+      </p:ext>
+    </p:extLst>
+  </p:cSld>
+  <p:clrMapOvr>
+    <a:masterClrMapping/>
+  </p:clrMapOvr>
+</p:notes>
 </file>
 
-<file path=ppt/notesSlides/notesSlide6.xml><?xml version="1.0" encoding="UTF-8" standalone="yes"?>
-<p:notes xmlns:a="http://schemas.openxmlformats.org/drawingml/2006/main" xmlns:r="http://schemas.openxmlformats.org/officeDocument/2006/relationships" xmlns:p="http://schemas.openxmlformats.org/presentationml/2006/main"><p:cSld><p:spTree><p:nvGrpSpPr><p:cNvPr id="1" name=""/><p:cNvGrpSpPr/><p:nvPr/></p:nvGrpSpPr><p:grpSpPr><a:xfrm><a:off x="0" y="0"/><a:ext cx="0" cy="0"/><a:chOff x="0" y="0"/><a:chExt cx="0" cy="0"/></a:xfrm></p:grpSpPr><p:sp><p:nvSpPr><p:cNvPr id="2" name="Slide Image Placeholder 1"/><p:cNvSpPr><a:spLocks noGrp="1" noRot="1" noChangeAspect="1"/></p:cNvSpPr><p:nvPr><p:ph type="sldImg"/></p:nvPr></p:nvSpPr><p:spPr/></p:sp><p:sp><p:nvSpPr><p:cNvPr id="3" name="Notes Placeholder 2"/><p:cNvSpPr><a:spLocks noGrp="1"/></p:cNvSpPr><p:nvPr><p:ph type="body" idx="1"/></p:nvPr></p:nvSpPr><p:spPr/><p:txBody><a:bodyPr/><a:lstStyle/><a:p><a:r><a:rPr lang="en-US" dirty="0"/><a:t>（2:20–2:42　22 秒　89 字）--所以我们做了这个工具。-把那段微信对话原样贴进去，不用整理，八秒出一份决策简报。-[指流程]-分工要说清楚：模型只做一件事，把这段乱七八糟的话读成结构。-该不该做、算多少钱、写哪几条，都不归它管。--───── 时间充裕可加 ─────-因为算错一个税率就是真金白银的亏损，这种事不能交给一个每次回答都可能不一样的东西。</a:t></a:r><a:endParaRPr lang="en-US" dirty="0"/></a:p></p:txBody></p:sp><p:sp><p:nvSpPr><p:cNvPr id="4" name="Slide Number Placeholder 3"/><p:cNvSpPr><a:spLocks noGrp="1"/></p:cNvSpPr><p:nvPr><p:ph type="sldNum" sz="quarter" idx="10"/></p:nvPr></p:nvSpPr><p:spPr/><p:txBody><a:bodyPr/><a:lstStyle/><a:p><a:fld id="{F7021451-1387-4CA6-816F-3879F97B5CBC}" type="slidenum"><a:rPr lang="en-US"/><a:t>6</a:t></a:fld><a:endParaRPr lang="en-US"/></a:p></p:txBody></p:sp></p:spTree><p:extLst><p:ext uri="{BB962C8B-B14F-4D97-AF65-F5344CB8AC3E}"><p14:creationId xmlns:p14="http://schemas.microsoft.com/office/powerpoint/2010/main" val="1024086991"/></p:ext></p:extLst></p:cSld><p:clrMapOvr><a:masterClrMapping/></p:clrMapOvr></p:notes>
+<file path=ppt/notesSlides/notesSlide6.xml><?xml version="1.0" encoding="utf-8"?>
+<p:notes xmlns:a="http://schemas.openxmlformats.org/drawingml/2006/main" xmlns:r="http://schemas.openxmlformats.org/officeDocument/2006/relationships" xmlns:p="http://schemas.openxmlformats.org/presentationml/2006/main">
+  <p:cSld>
+    <p:spTree>
+      <p:nvGrpSpPr>
+        <p:cNvPr id="1" name=""/>
+        <p:cNvGrpSpPr/>
+        <p:nvPr/>
+      </p:nvGrpSpPr>
+      <p:grpSpPr>
+        <a:xfrm>
+          <a:off x="0" y="0"/>
+          <a:ext cx="0" cy="0"/>
+          <a:chOff x="0" y="0"/>
+          <a:chExt cx="0" cy="0"/>
+        </a:xfrm>
+      </p:grpSpPr>
+      <p:sp>
+        <p:nvSpPr>
+          <p:cNvPr id="2" name="Slide Image Placeholder 1"/>
+          <p:cNvSpPr>
+            <a:spLocks noGrp="1" noRot="1" noChangeAspect="1"/>
+          </p:cNvSpPr>
+          <p:nvPr>
+            <p:ph type="sldImg"/>
+          </p:nvPr>
+        </p:nvSpPr>
+        <p:spPr/>
+      </p:sp>
+      <p:sp>
+        <p:nvSpPr>
+          <p:cNvPr id="3" name="Notes Placeholder 2"/>
+          <p:cNvSpPr>
+            <a:spLocks noGrp="1"/>
+          </p:cNvSpPr>
+          <p:nvPr>
+            <p:ph type="body" idx="1"/>
+          </p:nvPr>
+        </p:nvSpPr>
+        <p:spPr/>
+        <p:txBody>
+          <a:bodyPr/>
+          <a:lstStyle/>
+          <a:p>
+            <a:r>
+              <a:rPr lang="en-US" dirty="0"/>
+              <a:t>（2:20–2:42　22 秒　89 字）</a:t>
+            </a:r>
+          </a:p>
+          <a:p>
+            <a:r>
+              <a:rPr lang="zh-CN" altLang="en-US" dirty="0"/>
+              <a:t/>
+            </a:r>
+          </a:p>
+          <a:p>
+            <a:r>
+              <a:rPr lang="zh-CN" altLang="en-US" dirty="0"/>
+              <a:t>所以我们做了这个工具。</a:t>
+            </a:r>
+          </a:p>
+          <a:p>
+            <a:r>
+              <a:rPr lang="zh-CN" altLang="en-US" dirty="0"/>
+              <a:t>把那段微信对话原样贴进去，不用整理，八秒出一份决策简报。</a:t>
+            </a:r>
+          </a:p>
+          <a:p>
+            <a:r>
+              <a:rPr lang="zh-CN" altLang="en-US" dirty="0"/>
+              <a:t>[指流程]</a:t>
+            </a:r>
+          </a:p>
+          <a:p>
+            <a:r>
+              <a:rPr lang="zh-CN" altLang="en-US" dirty="0"/>
+              <a:t>分工要说清楚：模型只做一件事，把这段乱七八糟的话读成结构。</a:t>
+            </a:r>
+          </a:p>
+          <a:p>
+            <a:r>
+              <a:rPr lang="zh-CN" altLang="en-US" dirty="0"/>
+              <a:t>该不该做、算多少钱、写哪几条，都不归它管。</a:t>
+            </a:r>
+          </a:p>
+          <a:p>
+            <a:r>
+              <a:rPr lang="zh-CN" altLang="en-US" dirty="0"/>
+              <a:t/>
+            </a:r>
+          </a:p>
+          <a:p>
+            <a:r>
+              <a:rPr lang="zh-CN" altLang="en-US" dirty="0"/>
+              <a:t>───── 时间充裕可加 ─────</a:t>
+            </a:r>
+          </a:p>
+          <a:p>
+            <a:r>
+              <a:rPr lang="zh-CN" altLang="en-US" dirty="0"/>
+              <a:t>因为算错一个税率就是真金白银的亏损，这种事不能交给一个每次回答都可能不一样的东西。</a:t>
+            </a:r>
+            <a:endParaRPr lang="en-US" dirty="0"/>
+          </a:p>
+        </p:txBody>
+      </p:sp>
+      <p:sp>
+        <p:nvSpPr>
+          <p:cNvPr id="4" name="Slide Number Placeholder 3"/>
+          <p:cNvSpPr>
+            <a:spLocks noGrp="1"/>
+          </p:cNvSpPr>
+          <p:nvPr>
+            <p:ph type="sldNum" sz="quarter" idx="10"/>
+          </p:nvPr>
+        </p:nvSpPr>
+        <p:spPr/>
+        <p:txBody>
+          <a:bodyPr/>
+          <a:lstStyle/>
+          <a:p>
+            <a:fld id="{F7021451-1387-4CA6-816F-3879F97B5CBC}" type="slidenum">
+              <a:rPr lang="en-US"/>
+              <a:t>6</a:t>
+            </a:fld>
+            <a:endParaRPr lang="en-US"/>
+          </a:p>
+        </p:txBody>
+      </p:sp>
+    </p:spTree>
+    <p:extLst>
+      <p:ext uri="{BB962C8B-B14F-4D97-AF65-F5344CB8AC3E}">
+        <p14:creationId xmlns:p14="http://schemas.microsoft.com/office/powerpoint/2010/main" val="1024086991"/>
+      </p:ext>
+    </p:extLst>
+  </p:cSld>
+  <p:clrMapOvr>
+    <a:masterClrMapping/>
+  </p:clrMapOvr>
+</p:notes>
 </file>
 
-<file path=ppt/notesSlides/notesSlide7.xml><?xml version="1.0" encoding="UTF-8" standalone="yes"?>
-<p:notes xmlns:a="http://schemas.openxmlformats.org/drawingml/2006/main" xmlns:r="http://schemas.openxmlformats.org/officeDocument/2006/relationships" xmlns:p="http://schemas.openxmlformats.org/presentationml/2006/main"><p:cSld><p:spTree><p:nvGrpSpPr><p:cNvPr id="1" name=""/><p:cNvGrpSpPr/><p:nvPr/></p:nvGrpSpPr><p:grpSpPr><a:xfrm><a:off x="0" y="0"/><a:ext cx="0" cy="0"/><a:chOff x="0" y="0"/><a:chExt cx="0" cy="0"/></a:xfrm></p:grpSpPr><p:sp><p:nvSpPr><p:cNvPr id="2" name="Slide Image Placeholder 1"/><p:cNvSpPr><a:spLocks noGrp="1" noRot="1" noChangeAspect="1"/></p:cNvSpPr><p:nvPr><p:ph type="sldImg"/></p:nvPr></p:nvSpPr><p:spPr/></p:sp><p:sp><p:nvSpPr><p:cNvPr id="3" name="Notes Placeholder 2"/><p:cNvSpPr><a:spLocks noGrp="1"/></p:cNvSpPr><p:nvPr><p:ph type="body" idx="1"/></p:nvPr></p:nvSpPr><p:spPr/><p:txBody><a:bodyPr/><a:lstStyle/><a:p><a:r><a:rPr lang="en-US" dirty="0"/><a:t>（2:42–3:06　24 秒　104 字）--判定我们用一瓶酒表示。-[指两瓶]-瓶子永远是满的，变的是里面装什么。-左边装的是酒，他是来买酒的，可以谈。-右边这瓶，红的是税差，从瓶底把酒顶上来了。-这一瓶里装的不是酒。-业务员不必看懂评分模型，看一眼瓶子就知道该不该往下谈。--───── 时间充裕可加 ─────-红色占多高，就是套利风险分是多少——这两件事在界面上是同一个东西。</a:t></a:r><a:endParaRPr lang="en-US" dirty="0"/></a:p></p:txBody></p:sp><p:sp><p:nvSpPr><p:cNvPr id="4" name="Slide Number Placeholder 3"/><p:cNvSpPr><a:spLocks noGrp="1"/></p:cNvSpPr><p:nvPr><p:ph type="sldNum" sz="quarter" idx="10"/></p:nvPr></p:nvSpPr><p:spPr/><p:txBody><a:bodyPr/><a:lstStyle/><a:p><a:fld id="{F7021451-1387-4CA6-816F-3879F97B5CBC}" type="slidenum"><a:rPr lang="en-US"/><a:t>7</a:t></a:fld><a:endParaRPr lang="en-US"/></a:p></p:txBody></p:sp></p:spTree><p:extLst><p:ext uri="{BB962C8B-B14F-4D97-AF65-F5344CB8AC3E}"><p14:creationId xmlns:p14="http://schemas.microsoft.com/office/powerpoint/2010/main" val="1024086991"/></p:ext></p:extLst></p:cSld><p:clrMapOvr><a:masterClrMapping/></p:clrMapOvr></p:notes>
+<file path=ppt/notesSlides/notesSlide7.xml><?xml version="1.0" encoding="utf-8"?>
+<p:notes xmlns:a="http://schemas.openxmlformats.org/drawingml/2006/main" xmlns:r="http://schemas.openxmlformats.org/officeDocument/2006/relationships" xmlns:p="http://schemas.openxmlformats.org/presentationml/2006/main">
+  <p:cSld>
+    <p:spTree>
+      <p:nvGrpSpPr>
+        <p:cNvPr id="1" name=""/>
+        <p:cNvGrpSpPr/>
+        <p:nvPr/>
+      </p:nvGrpSpPr>
+      <p:grpSpPr>
+        <a:xfrm>
+          <a:off x="0" y="0"/>
+          <a:ext cx="0" cy="0"/>
+          <a:chOff x="0" y="0"/>
+          <a:chExt cx="0" cy="0"/>
+        </a:xfrm>
+      </p:grpSpPr>
+      <p:sp>
+        <p:nvSpPr>
+          <p:cNvPr id="2" name="Slide Image Placeholder 1"/>
+          <p:cNvSpPr>
+            <a:spLocks noGrp="1" noRot="1" noChangeAspect="1"/>
+          </p:cNvSpPr>
+          <p:nvPr>
+            <p:ph type="sldImg"/>
+          </p:nvPr>
+        </p:nvSpPr>
+        <p:spPr/>
+      </p:sp>
+      <p:sp>
+        <p:nvSpPr>
+          <p:cNvPr id="3" name="Notes Placeholder 2"/>
+          <p:cNvSpPr>
+            <a:spLocks noGrp="1"/>
+          </p:cNvSpPr>
+          <p:nvPr>
+            <p:ph type="body" idx="1"/>
+          </p:nvPr>
+        </p:nvSpPr>
+        <p:spPr/>
+        <p:txBody>
+          <a:bodyPr/>
+          <a:lstStyle/>
+          <a:p>
+            <a:r>
+              <a:rPr lang="en-US" dirty="0"/>
+              <a:t>（2:42–3:06　24 秒　104 字）</a:t>
+            </a:r>
+          </a:p>
+          <a:p>
+            <a:r>
+              <a:rPr lang="zh-CN" altLang="en-US" dirty="0"/>
+              <a:t/>
+            </a:r>
+          </a:p>
+          <a:p>
+            <a:r>
+              <a:rPr lang="zh-CN" altLang="en-US" dirty="0"/>
+              <a:t>判定我们用一瓶酒表示。</a:t>
+            </a:r>
+          </a:p>
+          <a:p>
+            <a:r>
+              <a:rPr lang="zh-CN" altLang="en-US" dirty="0"/>
+              <a:t>[指两瓶]</a:t>
+            </a:r>
+          </a:p>
+          <a:p>
+            <a:r>
+              <a:rPr lang="zh-CN" altLang="en-US" dirty="0"/>
+              <a:t>瓶子永远是满的，变的是里面装什么。</a:t>
+            </a:r>
+          </a:p>
+          <a:p>
+            <a:r>
+              <a:rPr lang="zh-CN" altLang="en-US" dirty="0"/>
+              <a:t>左边装的是酒，他是来买酒的，可以谈。</a:t>
+            </a:r>
+          </a:p>
+          <a:p>
+            <a:r>
+              <a:rPr lang="zh-CN" altLang="en-US" dirty="0"/>
+              <a:t>右边这瓶，红的是税差，从瓶底把酒顶上来了。</a:t>
+            </a:r>
+          </a:p>
+          <a:p>
+            <a:r>
+              <a:rPr lang="zh-CN" altLang="en-US" dirty="0"/>
+              <a:t>这一瓶里装的不是酒。</a:t>
+            </a:r>
+          </a:p>
+          <a:p>
+            <a:r>
+              <a:rPr lang="zh-CN" altLang="en-US" dirty="0"/>
+              <a:t>业务员不必看懂评分模型，看一眼瓶子就知道该不该往下谈。</a:t>
+            </a:r>
+          </a:p>
+          <a:p>
+            <a:r>
+              <a:rPr lang="zh-CN" altLang="en-US" dirty="0"/>
+              <a:t/>
+            </a:r>
+          </a:p>
+          <a:p>
+            <a:r>
+              <a:rPr lang="zh-CN" altLang="en-US" dirty="0"/>
+              <a:t>───── 时间充裕可加 ─────</a:t>
+            </a:r>
+          </a:p>
+          <a:p>
+            <a:r>
+              <a:rPr lang="zh-CN" altLang="en-US" dirty="0"/>
+              <a:t>红色占多高，就是套利风险分是多少——这两件事在界面上是同一个东西。</a:t>
+            </a:r>
+            <a:endParaRPr lang="en-US" dirty="0"/>
+          </a:p>
+        </p:txBody>
+      </p:sp>
+      <p:sp>
+        <p:nvSpPr>
+          <p:cNvPr id="4" name="Slide Number Placeholder 3"/>
+          <p:cNvSpPr>
+            <a:spLocks noGrp="1"/>
+          </p:cNvSpPr>
+          <p:nvPr>
+            <p:ph type="sldNum" sz="quarter" idx="10"/>
+          </p:nvPr>
+        </p:nvSpPr>
+        <p:spPr/>
+        <p:txBody>
+          <a:bodyPr/>
+          <a:lstStyle/>
+          <a:p>
+            <a:fld id="{F7021451-1387-4CA6-816F-3879F97B5CBC}" type="slidenum">
+              <a:rPr lang="en-US"/>
+              <a:t>7</a:t>
+            </a:fld>
+            <a:endParaRPr lang="en-US"/>
+          </a:p>
+        </p:txBody>
+      </p:sp>
+    </p:spTree>
+    <p:extLst>
+      <p:ext uri="{BB962C8B-B14F-4D97-AF65-F5344CB8AC3E}">
+        <p14:creationId xmlns:p14="http://schemas.microsoft.com/office/powerpoint/2010/main" val="1024086991"/>
+      </p:ext>
+    </p:extLst>
+  </p:cSld>
+  <p:clrMapOvr>
+    <a:masterClrMapping/>
+  </p:clrMapOvr>
+</p:notes>
 </file>
 
-<file path=ppt/notesSlides/notesSlide8.xml><?xml version="1.0" encoding="UTF-8" standalone="yes"?>
-<p:notes xmlns:a="http://schemas.openxmlformats.org/drawingml/2006/main" xmlns:r="http://schemas.openxmlformats.org/officeDocument/2006/relationships" xmlns:p="http://schemas.openxmlformats.org/presentationml/2006/main"><p:cSld><p:spTree><p:nvGrpSpPr><p:cNvPr id="1" name=""/><p:cNvGrpSpPr/><p:nvPr/></p:nvGrpSpPr><p:grpSpPr><a:xfrm><a:off x="0" y="0"/><a:ext cx="0" cy="0"/><a:chOff x="0" y="0"/><a:chExt cx="0" cy="0"/></a:xfrm></p:grpSpPr><p:sp><p:nvSpPr><p:cNvPr id="2" name="Slide Image Placeholder 1"/><p:cNvSpPr><a:spLocks noGrp="1" noRot="1" noChangeAspect="1"/></p:cNvSpPr><p:nvPr><p:ph type="sldImg"/></p:nvPr></p:nvSpPr><p:spPr/></p:sp><p:sp><p:nvSpPr><p:cNvPr id="3" name="Notes Placeholder 2"/><p:cNvSpPr><a:spLocks noGrp="1"/></p:cNvSpPr><p:nvPr><p:ph type="body" idx="1"/></p:nvPr></p:nvSpPr><p:spPr/><p:txBody><a:bodyPr/><a:lstStyle/><a:p><a:r><a:rPr lang="en-US" dirty="0"/><a:t>（3:06–3:32　26 秒　110 字）--展开是六个页签，一页回答一个问题：-该不该做、凭什么这么判、卖多少钱、-他有没有牌照、怎么跟他讲、合同和之后九十天怎么盯。-六项信号是模型给的初判，但最后一票在人手上——-AI 看得到文字，看不到展位上他说「标签不用改」时的表情。-[切到现场 demo]--───── 时间充裕可加 ─────-改任何一项，判定、必问清单、合同条款会立刻跟着重算。</a:t></a:r><a:endParaRPr lang="en-US" dirty="0"/></a:p></p:txBody></p:sp><p:sp><p:nvSpPr><p:cNvPr id="4" name="Slide Number Placeholder 3"/><p:cNvSpPr><a:spLocks noGrp="1"/></p:cNvSpPr><p:nvPr><p:ph type="sldNum" sz="quarter" idx="10"/></p:nvPr></p:nvSpPr><p:spPr/><p:txBody><a:bodyPr/><a:lstStyle/><a:p><a:fld id="{F7021451-1387-4CA6-816F-3879F97B5CBC}" type="slidenum"><a:rPr lang="en-US"/><a:t>8</a:t></a:fld><a:endParaRPr lang="en-US"/></a:p></p:txBody></p:sp></p:spTree><p:extLst><p:ext uri="{BB962C8B-B14F-4D97-AF65-F5344CB8AC3E}"><p14:creationId xmlns:p14="http://schemas.microsoft.com/office/powerpoint/2010/main" val="1024086991"/></p:ext></p:extLst></p:cSld><p:clrMapOvr><a:masterClrMapping/></p:clrMapOvr></p:notes>
+<file path=ppt/notesSlides/notesSlide8.xml><?xml version="1.0" encoding="utf-8"?>
+<p:notes xmlns:a="http://schemas.openxmlformats.org/drawingml/2006/main" xmlns:r="http://schemas.openxmlformats.org/officeDocument/2006/relationships" xmlns:p="http://schemas.openxmlformats.org/presentationml/2006/main">
+  <p:cSld>
+    <p:spTree>
+      <p:nvGrpSpPr>
+        <p:cNvPr id="1" name=""/>
+        <p:cNvGrpSpPr/>
+        <p:nvPr/>
+      </p:nvGrpSpPr>
+      <p:grpSpPr>
+        <a:xfrm>
+          <a:off x="0" y="0"/>
+          <a:ext cx="0" cy="0"/>
+          <a:chOff x="0" y="0"/>
+          <a:chExt cx="0" cy="0"/>
+        </a:xfrm>
+      </p:grpSpPr>
+      <p:sp>
+        <p:nvSpPr>
+          <p:cNvPr id="2" name="Slide Image Placeholder 1"/>
+          <p:cNvSpPr>
+            <a:spLocks noGrp="1" noRot="1" noChangeAspect="1"/>
+          </p:cNvSpPr>
+          <p:nvPr>
+            <p:ph type="sldImg"/>
+          </p:nvPr>
+        </p:nvSpPr>
+        <p:spPr/>
+      </p:sp>
+      <p:sp>
+        <p:nvSpPr>
+          <p:cNvPr id="3" name="Notes Placeholder 2"/>
+          <p:cNvSpPr>
+            <a:spLocks noGrp="1"/>
+          </p:cNvSpPr>
+          <p:nvPr>
+            <p:ph type="body" idx="1"/>
+          </p:nvPr>
+        </p:nvSpPr>
+        <p:spPr/>
+        <p:txBody>
+          <a:bodyPr/>
+          <a:lstStyle/>
+          <a:p>
+            <a:r>
+              <a:rPr lang="en-US" dirty="0"/>
+              <a:t>（3:06–3:32　26 秒　110 字）</a:t>
+            </a:r>
+          </a:p>
+          <a:p>
+            <a:r>
+              <a:rPr lang="zh-CN" altLang="en-US" dirty="0"/>
+              <a:t/>
+            </a:r>
+          </a:p>
+          <a:p>
+            <a:r>
+              <a:rPr lang="zh-CN" altLang="en-US" dirty="0"/>
+              <a:t>展开是六个页签，一页回答一个问题：</a:t>
+            </a:r>
+          </a:p>
+          <a:p>
+            <a:r>
+              <a:rPr lang="zh-CN" altLang="en-US" dirty="0"/>
+              <a:t>该不该做、凭什么这么判、卖多少钱、</a:t>
+            </a:r>
+          </a:p>
+          <a:p>
+            <a:r>
+              <a:rPr lang="zh-CN" altLang="en-US" dirty="0"/>
+              <a:t>他有没有牌照、怎么跟他讲、合同和之后九十天怎么盯。</a:t>
+            </a:r>
+          </a:p>
+          <a:p>
+            <a:r>
+              <a:rPr lang="zh-CN" altLang="en-US" dirty="0"/>
+              <a:t>六项信号是模型给的初判，但最后一票在人手上——</a:t>
+            </a:r>
+          </a:p>
+          <a:p>
+            <a:r>
+              <a:rPr lang="zh-CN" altLang="en-US" dirty="0"/>
+              <a:t>AI 看得到文字，看不到展位上他说「标签不用改」时的表情。</a:t>
+            </a:r>
+          </a:p>
+          <a:p>
+            <a:r>
+              <a:rPr lang="zh-CN" altLang="en-US" dirty="0"/>
+              <a:t>[切到现场 demo]</a:t>
+            </a:r>
+          </a:p>
+          <a:p>
+            <a:r>
+              <a:rPr lang="zh-CN" altLang="en-US" dirty="0"/>
+              <a:t/>
+            </a:r>
+          </a:p>
+          <a:p>
+            <a:r>
+              <a:rPr lang="zh-CN" altLang="en-US" dirty="0"/>
+              <a:t>───── 时间充裕可加 ─────</a:t>
+            </a:r>
+          </a:p>
+          <a:p>
+            <a:r>
+              <a:rPr lang="zh-CN" altLang="en-US" dirty="0"/>
+              <a:t>改任何一项，判定、必问清单、合同条款会立刻跟着重算。</a:t>
+            </a:r>
+            <a:endParaRPr lang="en-US" dirty="0"/>
+          </a:p>
+        </p:txBody>
+      </p:sp>
+      <p:sp>
+        <p:nvSpPr>
+          <p:cNvPr id="4" name="Slide Number Placeholder 3"/>
+          <p:cNvSpPr>
+            <a:spLocks noGrp="1"/>
+          </p:cNvSpPr>
+          <p:nvPr>
+            <p:ph type="sldNum" sz="quarter" idx="10"/>
+          </p:nvPr>
+        </p:nvSpPr>
+        <p:spPr/>
+        <p:txBody>
+          <a:bodyPr/>
+          <a:lstStyle/>
+          <a:p>
+            <a:fld id="{F7021451-1387-4CA6-816F-3879F97B5CBC}" type="slidenum">
+              <a:rPr lang="en-US"/>
+              <a:t>8</a:t>
+            </a:fld>
+            <a:endParaRPr lang="en-US"/>
+          </a:p>
+        </p:txBody>
+      </p:sp>
+    </p:spTree>
+    <p:extLst>
+      <p:ext uri="{BB962C8B-B14F-4D97-AF65-F5344CB8AC3E}">
+        <p14:creationId xmlns:p14="http://schemas.microsoft.com/office/powerpoint/2010/main" val="1024086991"/>
+      </p:ext>
+    </p:extLst>
+  </p:cSld>
+  <p:clrMapOvr>
+    <a:masterClrMapping/>
+  </p:clrMapOvr>
+</p:notes>
 </file>
 
-<file path=ppt/notesSlides/notesSlide9.xml><?xml version="1.0" encoding="UTF-8" standalone="yes"?>
-<p:notes xmlns:a="http://schemas.openxmlformats.org/drawingml/2006/main" xmlns:r="http://schemas.openxmlformats.org/officeDocument/2006/relationships" xmlns:p="http://schemas.openxmlformats.org/presentationml/2006/main"><p:cSld><p:spTree><p:nvGrpSpPr><p:cNvPr id="1" name=""/><p:cNvGrpSpPr/><p:nvPr/></p:nvGrpSpPr><p:grpSpPr><a:xfrm><a:off x="0" y="0"/><a:ext cx="0" cy="0"/><a:chOff x="0" y="0"/><a:chExt cx="0" cy="0"/></a:xfrm></p:grpSpPr><p:sp><p:nvSpPr><p:cNvPr id="2" name="Slide Image Placeholder 1"/><p:cNvSpPr><a:spLocks noGrp="1" noRot="1" noChangeAspect="1"/></p:cNvSpPr><p:nvPr><p:ph type="sldImg"/></p:nvPr></p:nvSpPr><p:spPr/></p:sp><p:sp><p:nvSpPr><p:cNvPr id="3" name="Notes Placeholder 2"/><p:cNvSpPr><a:spLocks noGrp="1"/></p:cNvSpPr><p:nvPr><p:ph type="body" idx="1"/></p:nvPr></p:nvSpPr><p:spPr/><p:txBody><a:bodyPr/><a:lstStyle/><a:p><a:r><a:rPr lang="en-US" dirty="0"/><a:t>（3:32–4:04　32 秒　147 字）--为什么不直接问通用大模型？-因为这三条它不会告诉你，是我们逐条翻税则翻出来的：-香港烈酒减税只减两百港币以上那一部分，低价酒完全享受不到。-新加坡按纯酒精量课税，不看瓶数，降度数等于直接少缴税。-美国的 CBMA 额度必须由中国生产商主动指派，进口商自己拿不到；-一瓶差十块七，一柜十几万，而且不花你一毛钱。--───── 时间充裕可加 ─────-通用模型给你的多半是「约百分之三十到五十综合税负」这种区间。拿这个去跟老板报价，是会出事的。</a:t></a:r><a:endParaRPr lang="en-US" dirty="0"/></a:p></p:txBody></p:sp><p:sp><p:nvSpPr><p:cNvPr id="4" name="Slide Number Placeholder 3"/><p:cNvSpPr><a:spLocks noGrp="1"/></p:cNvSpPr><p:nvPr><p:ph type="sldNum" sz="quarter" idx="10"/></p:nvPr></p:nvSpPr><p:spPr/><p:txBody><a:bodyPr/><a:lstStyle/><a:p><a:fld id="{F7021451-1387-4CA6-816F-3879F97B5CBC}" type="slidenum"><a:rPr lang="en-US"/><a:t>9</a:t></a:fld><a:endParaRPr lang="en-US"/></a:p></p:txBody></p:sp></p:spTree><p:extLst><p:ext uri="{BB962C8B-B14F-4D97-AF65-F5344CB8AC3E}"><p14:creationId xmlns:p14="http://schemas.microsoft.com/office/powerpoint/2010/main" val="1024086991"/></p:ext></p:extLst></p:cSld><p:clrMapOvr><a:masterClrMapping/></p:clrMapOvr></p:notes>
+<file path=ppt/notesSlides/notesSlide9.xml><?xml version="1.0" encoding="utf-8"?>
+<p:notes xmlns:a="http://schemas.openxmlformats.org/drawingml/2006/main" xmlns:r="http://schemas.openxmlformats.org/officeDocument/2006/relationships" xmlns:p="http://schemas.openxmlformats.org/presentationml/2006/main">
+  <p:cSld>
+    <p:spTree>
+      <p:nvGrpSpPr>
+        <p:cNvPr id="1" name=""/>
+        <p:cNvGrpSpPr/>
+        <p:nvPr/>
+      </p:nvGrpSpPr>
+      <p:grpSpPr>
+        <a:xfrm>
+          <a:off x="0" y="0"/>
+          <a:ext cx="0" cy="0"/>
+          <a:chOff x="0" y="0"/>
+          <a:chExt cx="0" cy="0"/>
+        </a:xfrm>
+      </p:grpSpPr>
+      <p:sp>
+        <p:nvSpPr>
+          <p:cNvPr id="2" name="Slide Image Placeholder 1"/>
+          <p:cNvSpPr>
+            <a:spLocks noGrp="1" noRot="1" noChangeAspect="1"/>
+          </p:cNvSpPr>
+          <p:nvPr>
+            <p:ph type="sldImg"/>
+          </p:nvPr>
+        </p:nvSpPr>
+        <p:spPr/>
+      </p:sp>
+      <p:sp>
+        <p:nvSpPr>
+          <p:cNvPr id="3" name="Notes Placeholder 2"/>
+          <p:cNvSpPr>
+            <a:spLocks noGrp="1"/>
+          </p:cNvSpPr>
+          <p:nvPr>
+            <p:ph type="body" idx="1"/>
+          </p:nvPr>
+        </p:nvSpPr>
+        <p:spPr/>
+        <p:txBody>
+          <a:bodyPr/>
+          <a:lstStyle/>
+          <a:p>
+            <a:r>
+              <a:rPr lang="en-US" dirty="0"/>
+              <a:t>（3:32–4:04　32 秒　147 字）</a:t>
+            </a:r>
+          </a:p>
+          <a:p>
+            <a:r>
+              <a:rPr lang="zh-CN" altLang="en-US" dirty="0"/>
+              <a:t/>
+            </a:r>
+          </a:p>
+          <a:p>
+            <a:r>
+              <a:rPr lang="zh-CN" altLang="en-US" dirty="0"/>
+              <a:t>为什么不直接问通用大模型？</a:t>
+            </a:r>
+          </a:p>
+          <a:p>
+            <a:r>
+              <a:rPr lang="zh-CN" altLang="en-US" dirty="0"/>
+              <a:t>因为这三条它不会告诉你，是我们逐条翻税则翻出来的：</a:t>
+            </a:r>
+          </a:p>
+          <a:p>
+            <a:r>
+              <a:rPr lang="zh-CN" altLang="en-US" dirty="0"/>
+              <a:t>香港烈酒减税只减两百港币以上那一部分，低价酒完全享受不到。</a:t>
+            </a:r>
+          </a:p>
+          <a:p>
+            <a:r>
+              <a:rPr lang="zh-CN" altLang="en-US" dirty="0"/>
+              <a:t>新加坡按纯酒精量课税，不看瓶数，降度数等于直接少缴税。</a:t>
+            </a:r>
+          </a:p>
+          <a:p>
+            <a:r>
+              <a:rPr lang="zh-CN" altLang="en-US" dirty="0"/>
+              <a:t>美国的 CBMA 额度必须由中国生产商主动指派，进口商自己拿不到；</a:t>
+            </a:r>
+          </a:p>
+          <a:p>
+            <a:r>
+              <a:rPr lang="zh-CN" altLang="en-US" dirty="0"/>
+              <a:t>一瓶差十块七，一柜十几万，而且不花你一毛钱。</a:t>
+            </a:r>
+          </a:p>
+          <a:p>
+            <a:r>
+              <a:rPr lang="zh-CN" altLang="en-US" dirty="0"/>
+              <a:t/>
+            </a:r>
+          </a:p>
+          <a:p>
+            <a:r>
+              <a:rPr lang="zh-CN" altLang="en-US" dirty="0"/>
+              <a:t>───── 时间充裕可加 ─────</a:t>
+            </a:r>
+          </a:p>
+          <a:p>
+            <a:r>
+              <a:rPr lang="zh-CN" altLang="en-US" dirty="0"/>
+              <a:t>通用模型给你的多半是「约百分之三十到五十综合税负」这种区间。拿这个去跟老板报价，是会出事的。</a:t>
+            </a:r>
+            <a:endParaRPr lang="en-US" dirty="0"/>
+          </a:p>
+        </p:txBody>
+      </p:sp>
+      <p:sp>
+        <p:nvSpPr>
+          <p:cNvPr id="4" name="Slide Number Placeholder 3"/>
+          <p:cNvSpPr>
+            <a:spLocks noGrp="1"/>
+          </p:cNvSpPr>
+          <p:nvPr>
+            <p:ph type="sldNum" sz="quarter" idx="10"/>
+          </p:nvPr>
+        </p:nvSpPr>
+        <p:spPr/>
+        <p:txBody>
+          <a:bodyPr/>
+          <a:lstStyle/>
+          <a:p>
+            <a:fld id="{F7021451-1387-4CA6-816F-3879F97B5CBC}" type="slidenum">
+              <a:rPr lang="en-US"/>
+              <a:t>9</a:t>
+            </a:fld>
+            <a:endParaRPr lang="en-US"/>
+          </a:p>
+        </p:txBody>
+      </p:sp>
+    </p:spTree>
+    <p:extLst>
+      <p:ext uri="{BB962C8B-B14F-4D97-AF65-F5344CB8AC3E}">
+        <p14:creationId xmlns:p14="http://schemas.microsoft.com/office/powerpoint/2010/main" val="1024086991"/>
+      </p:ext>
+    </p:extLst>
+  </p:cSld>
+  <p:clrMapOvr>
+    <a:masterClrMapping/>
+  </p:clrMapOvr>
+</p:notes>
 </file>
 
 <file path=ppt/slideLayouts/slideLayout1.xml><?xml version="1.0" encoding="utf-8"?>

</xml_diff>